<commit_message>
Poster roadmap and HANDOFF: reflect Sprint 5 team progress
Co-Authored-By: Claude Sonnet 5.5 <noreply@anthropic.com>
</commit_message>
<xml_diff>
--- a/docs/poster/Sprint5_Poster_AgentFactory.pptx
+++ b/docs/poster/Sprint5_Poster_AgentFactory.pptx
@@ -2469,7 +2469,7 @@
                 <a:ea typeface="Calibri" pitchFamily="34" charset="-122"/>
                 <a:cs typeface="Calibri" pitchFamily="34" charset="-120"/>
               </a:rPr>
-              <a:t>Done</a:t>
+              <a:t>Live today</a:t>
             </a:r>
             <a:endParaRPr lang="en-US" sz="2800" dirty="0"/>
           </a:p>
@@ -2575,7 +2575,7 @@
                 <a:ea typeface="Calibri" pitchFamily="34" charset="-122"/>
                 <a:cs typeface="Calibri" pitchFamily="34" charset="-120"/>
               </a:rPr>
-              <a:t>Voice receptionist live on Render</a:t>
+              <a:t>Voice receptionist on Render</a:t>
             </a:r>
             <a:endParaRPr lang="en-US" sz="2800" dirty="0"/>
           </a:p>
@@ -2684,7 +2684,7 @@
                 <a:ea typeface="Calibri" pitchFamily="34" charset="-122"/>
                 <a:cs typeface="Calibri" pitchFamily="34" charset="-120"/>
               </a:rPr>
-              <a:t>Post-call summaries</a:t>
+              <a:t>Recurrence, pause, templates</a:t>
             </a:r>
             <a:endParaRPr lang="en-US" sz="2800" dirty="0"/>
           </a:p>
@@ -2705,7 +2705,7 @@
                 <a:ea typeface="Calibri" pitchFamily="34" charset="-122"/>
                 <a:cs typeface="Calibri" pitchFamily="34" charset="-120"/>
               </a:rPr>
-              <a:t>Booking survives side questions</a:t>
+              <a:t>Merge fields, rescheduling</a:t>
             </a:r>
             <a:endParaRPr lang="en-US" sz="2800" dirty="0"/>
           </a:p>
@@ -2726,7 +2726,28 @@
                 <a:ea typeface="Calibri" pitchFamily="34" charset="-122"/>
                 <a:cs typeface="Calibri" pitchFamily="34" charset="-120"/>
               </a:rPr>
-              <a:t>Login and site fixes</a:t>
+              <a:t>Call summaries, booking with FAQ</a:t>
+            </a:r>
+            <a:endParaRPr lang="en-US" sz="2800" dirty="0"/>
+          </a:p>
+          <a:p>
+            <a:pPr marL="342900" indent="-342900">
+              <a:spcAft>
+                <a:spcPts val="600"/>
+              </a:spcAft>
+              <a:buSzPct val="100000"/>
+              <a:buChar char="•"/>
+            </a:pPr>
+            <a:r>
+              <a:rPr lang="en-US" sz="2800" dirty="0">
+                <a:solidFill>
+                  <a:srgbClr val="14213D"/>
+                </a:solidFill>
+                <a:latin typeface="Calibri" pitchFamily="34" charset="0"/>
+                <a:ea typeface="Calibri" pitchFamily="34" charset="-122"/>
+                <a:cs typeface="Calibri" pitchFamily="34" charset="-120"/>
+              </a:rPr>
+              <a:t>Roles, API keys, CSV export</a:t>
             </a:r>
             <a:endParaRPr lang="en-US" sz="2800" dirty="0"/>
           </a:p>
@@ -2835,7 +2856,7 @@
                 <a:ea typeface="Calibri" pitchFamily="34" charset="-122"/>
                 <a:cs typeface="Calibri" pitchFamily="34" charset="-120"/>
               </a:rPr>
-              <a:t>Templates and merge fields</a:t>
+              <a:t>Email and SMS proven end to end</a:t>
             </a:r>
             <a:endParaRPr lang="en-US" sz="2800" dirty="0"/>
           </a:p>
@@ -2856,7 +2877,7 @@
                 <a:ea typeface="Calibri" pitchFamily="34" charset="-122"/>
                 <a:cs typeface="Calibri" pitchFamily="34" charset="-120"/>
               </a:rPr>
-              <a:t>Recurrence and pause in the form</a:t>
+              <a:t>Marketing site rework live</a:t>
             </a:r>
             <a:endParaRPr lang="en-US" sz="2800" dirty="0"/>
           </a:p>
@@ -2877,7 +2898,7 @@
                 <a:ea typeface="Calibri" pitchFamily="34" charset="-122"/>
                 <a:cs typeface="Calibri" pitchFamily="34" charset="-120"/>
               </a:rPr>
-              <a:t>Email live, SMS evidence</a:t>
+              <a:t>Recordings, handover pack</a:t>
             </a:r>
             <a:endParaRPr lang="en-US" sz="2800" dirty="0"/>
           </a:p>
@@ -2898,7 +2919,7 @@
                 <a:ea typeface="Calibri" pitchFamily="34" charset="-122"/>
                 <a:cs typeface="Calibri" pitchFamily="34" charset="-120"/>
               </a:rPr>
-              <a:t>Site rework and use cases</a:t>
+              <a:t>Client feedback on the poster</a:t>
             </a:r>
             <a:endParaRPr lang="en-US" sz="2800" dirty="0"/>
           </a:p>

</xml_diff>

<commit_message>
Poster: follow the Sprint 5 marking rubric section by section
1 Project definition: one-sentence goal, the problem, four checkable sprint goals with status
2 Technical status and demo: five demo steps incl. input refusal, QR, proof strip of results
  we have seen (708 tests, 403 on forged calls, email 7 s after send time, live call)
3 Roadmap and problem solving: finished / built / to do, path to completion with owners,
  problems found and fixed, risk table
4 Team: roles plus 'ask me about' lines so every member can show ownership
Status chips say BUILT vs DONE honestly; test count updated to 708.

Co-Authored-By: Claude Sonnet 5.5 <noreply@anthropic.com>
</commit_message>
<xml_diff>
--- a/docs/poster/Sprint5_Poster_AgentFactory.pptx
+++ b/docs/poster/Sprint5_Poster_AgentFactory.pptx
@@ -884,7 +884,7 @@
         <p:spPr>
           <a:xfrm>
             <a:off x="0" y="0"/>
-            <a:ext cx="21387816" cy="4114800"/>
+            <a:ext cx="21387816" cy="3566160"/>
           </a:xfrm>
           <a:prstGeom prst="rect">
             <a:avLst/>
@@ -903,8 +903,8 @@
         </p:nvSpPr>
         <p:spPr>
           <a:xfrm>
-            <a:off x="914400" y="457200"/>
-            <a:ext cx="12801600" cy="640080"/>
+            <a:off x="914400" y="365760"/>
+            <a:ext cx="12801600" cy="548640"/>
           </a:xfrm>
           <a:prstGeom prst="rect">
             <a:avLst/>
@@ -920,7 +920,7 @@
               <a:buNone/>
             </a:pPr>
             <a:r>
-              <a:rPr lang="en-US" sz="3000" b="1" spc="600" kern="0" dirty="0">
+              <a:rPr lang="en-US" sz="2800" b="1" spc="600" kern="0" dirty="0">
                 <a:solidFill>
                   <a:srgbClr val="C9A227"/>
                 </a:solidFill>
@@ -930,7 +930,7 @@
               </a:rPr>
               <a:t>AGENT FACTORY</a:t>
             </a:r>
-            <a:endParaRPr lang="en-US" sz="3000" dirty="0"/>
+            <a:endParaRPr lang="en-US" sz="2800" dirty="0"/>
           </a:p>
         </p:txBody>
       </p:sp>
@@ -942,8 +942,8 @@
         </p:nvSpPr>
         <p:spPr>
           <a:xfrm>
-            <a:off x="914400" y="1188720"/>
-            <a:ext cx="19568160" cy="2103120"/>
+            <a:off x="914400" y="960120"/>
+            <a:ext cx="19568160" cy="1828800"/>
           </a:xfrm>
           <a:prstGeom prst="rect">
             <a:avLst/>
@@ -959,7 +959,7 @@
               <a:buNone/>
             </a:pPr>
             <a:r>
-              <a:rPr lang="en-US" sz="5600" b="1" dirty="0">
+              <a:rPr lang="en-US" sz="5200" b="1" dirty="0">
                 <a:solidFill>
                   <a:srgbClr val="FFFFFF"/>
                 </a:solidFill>
@@ -969,7 +969,7 @@
               </a:rPr>
               <a:t>Reminders that respect consent, and an AI receptionist that answers the phone</a:t>
             </a:r>
-            <a:endParaRPr lang="en-US" sz="5600" dirty="0"/>
+            <a:endParaRPr lang="en-US" sz="5200" dirty="0"/>
           </a:p>
         </p:txBody>
       </p:sp>
@@ -981,8 +981,8 @@
         </p:nvSpPr>
         <p:spPr>
           <a:xfrm>
-            <a:off x="914400" y="3383280"/>
-            <a:ext cx="19568160" cy="548640"/>
+            <a:off x="914400" y="2880360"/>
+            <a:ext cx="19568160" cy="457200"/>
           </a:xfrm>
           <a:prstGeom prst="rect">
             <a:avLst/>
@@ -998,7 +998,7 @@
               <a:buNone/>
             </a:pPr>
             <a:r>
-              <a:rPr lang="en-US" sz="2600" dirty="0">
+              <a:rPr lang="en-US" sz="2400" dirty="0">
                 <a:solidFill>
                   <a:srgbClr val="D9DEE9"/>
                 </a:solidFill>
@@ -1008,7 +1008,7 @@
               </a:rPr>
               <a:t>ITECH3208 / 3209  ·  Federation University  ·  Client: Zakir Ullah Shah  ·  Sprint 5 poster session</a:t>
             </a:r>
-            <a:endParaRPr lang="en-US" sz="2600" dirty="0"/>
+            <a:endParaRPr lang="en-US" sz="2400" dirty="0"/>
           </a:p>
         </p:txBody>
       </p:sp>
@@ -1020,8 +1020,8 @@
         </p:nvSpPr>
         <p:spPr>
           <a:xfrm>
-            <a:off x="914400" y="4526280"/>
-            <a:ext cx="777240" cy="777240"/>
+            <a:off x="914400" y="3913632"/>
+            <a:ext cx="731520" cy="731520"/>
           </a:xfrm>
           <a:prstGeom prst="ellipse">
             <a:avLst/>
@@ -1040,8 +1040,8 @@
         </p:nvSpPr>
         <p:spPr>
           <a:xfrm>
-            <a:off x="914400" y="4526280"/>
-            <a:ext cx="777240" cy="777240"/>
+            <a:off x="914400" y="3913632"/>
+            <a:ext cx="731520" cy="731520"/>
           </a:xfrm>
           <a:prstGeom prst="rect">
             <a:avLst/>
@@ -1057,7 +1057,7 @@
               <a:buNone/>
             </a:pPr>
             <a:r>
-              <a:rPr lang="en-US" sz="3200" b="1" dirty="0">
+              <a:rPr lang="en-US" sz="3000" b="1" dirty="0">
                 <a:solidFill>
                   <a:srgbClr val="1B2A49"/>
                 </a:solidFill>
@@ -1067,7 +1067,7 @@
               </a:rPr>
               <a:t>1</a:t>
             </a:r>
-            <a:endParaRPr lang="en-US" sz="3200" dirty="0"/>
+            <a:endParaRPr lang="en-US" sz="3000" dirty="0"/>
           </a:p>
         </p:txBody>
       </p:sp>
@@ -1079,8 +1079,8 @@
         </p:nvSpPr>
         <p:spPr>
           <a:xfrm>
-            <a:off x="1920240" y="4480560"/>
-            <a:ext cx="18288000" cy="868680"/>
+            <a:off x="1874520" y="3886200"/>
+            <a:ext cx="18562320" cy="822960"/>
           </a:xfrm>
           <a:prstGeom prst="rect">
             <a:avLst/>
@@ -1096,7 +1096,7 @@
               <a:buNone/>
             </a:pPr>
             <a:r>
-              <a:rPr lang="en-US" sz="4600" b="1" dirty="0">
+              <a:rPr lang="en-US" sz="4200" b="1" dirty="0">
                 <a:solidFill>
                   <a:srgbClr val="1B2A49"/>
                 </a:solidFill>
@@ -1104,9 +1104,9 @@
                 <a:ea typeface="Cambria" pitchFamily="34" charset="-122"/>
                 <a:cs typeface="Cambria" pitchFamily="34" charset="-120"/>
               </a:rPr>
-              <a:t>Project and sprint goals</a:t>
-            </a:r>
-            <a:endParaRPr lang="en-US" sz="4600" dirty="0"/>
+              <a:t>Project definition: goal and sprint goals</a:t>
+            </a:r>
+            <a:endParaRPr lang="en-US" sz="4200" dirty="0"/>
           </a:p>
         </p:txBody>
       </p:sp>
@@ -1118,8 +1118,8 @@
         </p:nvSpPr>
         <p:spPr>
           <a:xfrm>
-            <a:off x="914400" y="5486400"/>
-            <a:ext cx="9509760" cy="548640"/>
+            <a:off x="914400" y="4846320"/>
+            <a:ext cx="8778240" cy="457200"/>
           </a:xfrm>
           <a:prstGeom prst="rect">
             <a:avLst/>
@@ -1135,7 +1135,7 @@
               <a:buNone/>
             </a:pPr>
             <a:r>
-              <a:rPr lang="en-US" sz="3000" b="1" dirty="0">
+              <a:rPr lang="en-US" sz="2800" b="1" dirty="0">
                 <a:solidFill>
                   <a:srgbClr val="C9A227"/>
                 </a:solidFill>
@@ -1145,7 +1145,7 @@
               </a:rPr>
               <a:t>Project goal</a:t>
             </a:r>
-            <a:endParaRPr lang="en-US" sz="3000" dirty="0"/>
+            <a:endParaRPr lang="en-US" sz="2800" dirty="0"/>
           </a:p>
         </p:txBody>
       </p:sp>
@@ -1157,8 +1157,8 @@
         </p:nvSpPr>
         <p:spPr>
           <a:xfrm>
-            <a:off x="914400" y="6080760"/>
-            <a:ext cx="9509760" cy="3017520"/>
+            <a:off x="914400" y="5349240"/>
+            <a:ext cx="8778240" cy="2103120"/>
           </a:xfrm>
           <a:prstGeom prst="rect">
             <a:avLst/>
@@ -1174,7 +1174,7 @@
               <a:buNone/>
             </a:pPr>
             <a:r>
-              <a:rPr lang="en-US" sz="3000" dirty="0">
+              <a:rPr lang="en-US" sz="2700" dirty="0">
                 <a:solidFill>
                   <a:srgbClr val="14213D"/>
                 </a:solidFill>
@@ -1182,9 +1182,9 @@
                 <a:ea typeface="Calibri" pitchFamily="34" charset="-122"/>
                 <a:cs typeface="Calibri" pitchFamily="34" charset="-120"/>
               </a:rPr>
-              <a:t>Intelligent, privacy-first communication for service businesses. An organisation registers, manages contacts who have opted in, and schedules reminders that go out by SMS, voice and email. An AI receptionist answers calls on the same platform.</a:t>
-            </a:r>
-            <a:endParaRPr lang="en-US" sz="3000" dirty="0"/>
+              <a:t>Give clinics, salons and trades reminders that never message anyone who has not opted in, and an AI receptionist that answers their phone, on one platform they control.</a:t>
+            </a:r>
+            <a:endParaRPr lang="en-US" sz="2700" dirty="0"/>
           </a:p>
         </p:txBody>
       </p:sp>
@@ -1196,8 +1196,8 @@
         </p:nvSpPr>
         <p:spPr>
           <a:xfrm>
-            <a:off x="11155680" y="5486400"/>
-            <a:ext cx="9326880" cy="548640"/>
+            <a:off x="914400" y="7315200"/>
+            <a:ext cx="8778240" cy="457200"/>
           </a:xfrm>
           <a:prstGeom prst="rect">
             <a:avLst/>
@@ -1213,7 +1213,7 @@
               <a:buNone/>
             </a:pPr>
             <a:r>
-              <a:rPr lang="en-US" sz="3000" b="1" dirty="0">
+              <a:rPr lang="en-US" sz="2800" b="1" dirty="0">
                 <a:solidFill>
                   <a:srgbClr val="C9A227"/>
                 </a:solidFill>
@@ -1221,9 +1221,9 @@
                 <a:ea typeface="Calibri" pitchFamily="34" charset="-122"/>
                 <a:cs typeface="Calibri" pitchFamily="34" charset="-120"/>
               </a:rPr>
-              <a:t>Sprint 5 goals</a:t>
-            </a:r>
-            <a:endParaRPr lang="en-US" sz="3000" dirty="0"/>
+              <a:t>The problem</a:t>
+            </a:r>
+            <a:endParaRPr lang="en-US" sz="2800" dirty="0"/>
           </a:p>
         </p:txBody>
       </p:sp>
@@ -1235,8 +1235,8 @@
         </p:nvSpPr>
         <p:spPr>
           <a:xfrm>
-            <a:off x="11155680" y="6080760"/>
-            <a:ext cx="9326880" cy="3017520"/>
+            <a:off x="914400" y="7772400"/>
+            <a:ext cx="8778240" cy="1280160"/>
           </a:xfrm>
           <a:prstGeom prst="rect">
             <a:avLst/>
@@ -1248,15 +1248,11 @@
           <a:bodyPr wrap="square" lIns="0" tIns="0" rIns="0" bIns="0" rtlCol="0" anchor="t"/>
           <a:lstStyle/>
           <a:p>
-            <a:pPr marL="342900" indent="-342900">
-              <a:spcAft>
-                <a:spcPts val="600"/>
-              </a:spcAft>
-              <a:buSzPct val="100000"/>
-              <a:buChar char="•"/>
-            </a:pPr>
-            <a:r>
-              <a:rPr lang="en-US" sz="3200" dirty="0">
+            <a:pPr indent="0" marL="0">
+              <a:buNone/>
+            </a:pPr>
+            <a:r>
+              <a:rPr lang="en-US" sz="2400" dirty="0">
                 <a:solidFill>
                   <a:srgbClr val="14213D"/>
                 </a:solidFill>
@@ -1264,20 +1260,77 @@
                 <a:ea typeface="Calibri" pitchFamily="34" charset="-122"/>
                 <a:cs typeface="Calibri" pitchFamily="34" charset="-120"/>
               </a:rPr>
-              <a:t>Put a live, reachable demo online</a:t>
-            </a:r>
-            <a:endParaRPr lang="en-US" sz="3200" dirty="0"/>
-          </a:p>
-          <a:p>
-            <a:pPr marL="342900" indent="-342900">
-              <a:spcAft>
-                <a:spcPts val="600"/>
-              </a:spcAft>
-              <a:buSzPct val="100000"/>
-              <a:buChar char="•"/>
-            </a:pPr>
-            <a:r>
-              <a:rPr lang="en-US" sz="3200" dirty="0">
+              <a:t>Small businesses lose bookings to no-shows and missed calls, and cannot risk messaging people who never agreed to be contacted.</a:t>
+            </a:r>
+            <a:endParaRPr lang="en-US" sz="2400" dirty="0"/>
+          </a:p>
+        </p:txBody>
+      </p:sp>
+      <p:sp>
+        <p:nvSpPr>
+          <p:cNvPr id="13" name="Text 11"/>
+          <p:cNvSpPr/>
+          <p:nvPr/>
+        </p:nvSpPr>
+        <p:spPr>
+          <a:xfrm>
+            <a:off x="10789920" y="4846320"/>
+            <a:ext cx="9692640" cy="457200"/>
+          </a:xfrm>
+          <a:prstGeom prst="rect">
+            <a:avLst/>
+          </a:prstGeom>
+          <a:noFill/>
+          <a:ln/>
+        </p:spPr>
+        <p:txBody>
+          <a:bodyPr wrap="square" lIns="0" tIns="0" rIns="0" bIns="0" rtlCol="0" anchor="ctr"/>
+          <a:lstStyle/>
+          <a:p>
+            <a:pPr indent="0" marL="0">
+              <a:buNone/>
+            </a:pPr>
+            <a:r>
+              <a:rPr lang="en-US" sz="2800" b="1" dirty="0">
+                <a:solidFill>
+                  <a:srgbClr val="C9A227"/>
+                </a:solidFill>
+                <a:latin typeface="Calibri" pitchFamily="34" charset="0"/>
+                <a:ea typeface="Calibri" pitchFamily="34" charset="-122"/>
+                <a:cs typeface="Calibri" pitchFamily="34" charset="-120"/>
+              </a:rPr>
+              <a:t>Sprint 5 goals (each one checkable)</a:t>
+            </a:r>
+            <a:endParaRPr lang="en-US" sz="2800" dirty="0"/>
+          </a:p>
+        </p:txBody>
+      </p:sp>
+      <p:sp>
+        <p:nvSpPr>
+          <p:cNvPr id="14" name="Text 12"/>
+          <p:cNvSpPr/>
+          <p:nvPr/>
+        </p:nvSpPr>
+        <p:spPr>
+          <a:xfrm>
+            <a:off x="10789920" y="5394960"/>
+            <a:ext cx="8138160" cy="777240"/>
+          </a:xfrm>
+          <a:prstGeom prst="rect">
+            <a:avLst/>
+          </a:prstGeom>
+          <a:noFill/>
+          <a:ln/>
+        </p:spPr>
+        <p:txBody>
+          <a:bodyPr wrap="square" lIns="0" tIns="0" rIns="0" bIns="0" rtlCol="0" anchor="ctr"/>
+          <a:lstStyle/>
+          <a:p>
+            <a:pPr indent="0" marL="0">
+              <a:buNone/>
+            </a:pPr>
+            <a:r>
+              <a:rPr lang="en-US" sz="2100" dirty="0">
                 <a:solidFill>
                   <a:srgbClr val="14213D"/>
                 </a:solidFill>
@@ -1285,20 +1338,99 @@
                 <a:ea typeface="Calibri" pitchFamily="34" charset="-122"/>
                 <a:cs typeface="Calibri" pitchFamily="34" charset="-120"/>
               </a:rPr>
-              <a:t>Close the gaps we found against the client brief</a:t>
-            </a:r>
-            <a:endParaRPr lang="en-US" sz="3200" dirty="0"/>
-          </a:p>
-          <a:p>
-            <a:pPr marL="342900" indent="-342900">
-              <a:spcAft>
-                <a:spcPts val="600"/>
-              </a:spcAft>
-              <a:buSzPct val="100000"/>
-              <a:buChar char="•"/>
-            </a:pPr>
-            <a:r>
-              <a:rPr lang="en-US" sz="3200" dirty="0">
+              <a:t>Close the gaps found against the client brief: reminder controls, templates, rescheduling, call summaries, site</a:t>
+            </a:r>
+            <a:endParaRPr lang="en-US" sz="2100" dirty="0"/>
+          </a:p>
+        </p:txBody>
+      </p:sp>
+      <p:sp>
+        <p:nvSpPr>
+          <p:cNvPr id="15" name="Shape 13"/>
+          <p:cNvSpPr/>
+          <p:nvPr/>
+        </p:nvSpPr>
+        <p:spPr>
+          <a:xfrm>
+            <a:off x="19065240" y="5532120"/>
+            <a:ext cx="1417320" cy="502920"/>
+          </a:xfrm>
+          <a:prstGeom prst="roundRect">
+            <a:avLst>
+              <a:gd name="adj" fmla="val 49091"/>
+            </a:avLst>
+          </a:prstGeom>
+          <a:solidFill>
+            <a:srgbClr val="2E7D5B"/>
+          </a:solidFill>
+          <a:ln/>
+        </p:spPr>
+      </p:sp>
+      <p:sp>
+        <p:nvSpPr>
+          <p:cNvPr id="16" name="Text 14"/>
+          <p:cNvSpPr/>
+          <p:nvPr/>
+        </p:nvSpPr>
+        <p:spPr>
+          <a:xfrm>
+            <a:off x="19065240" y="5532120"/>
+            <a:ext cx="1417320" cy="502920"/>
+          </a:xfrm>
+          <a:prstGeom prst="rect">
+            <a:avLst/>
+          </a:prstGeom>
+          <a:noFill/>
+          <a:ln/>
+        </p:spPr>
+        <p:txBody>
+          <a:bodyPr wrap="square" lIns="0" tIns="0" rIns="0" bIns="0" rtlCol="0" anchor="ctr"/>
+          <a:lstStyle/>
+          <a:p>
+            <a:pPr algn="ctr" indent="0" marL="0">
+              <a:buNone/>
+            </a:pPr>
+            <a:r>
+              <a:rPr lang="en-US" sz="1800" b="1" dirty="0">
+                <a:solidFill>
+                  <a:srgbClr val="FFFFFF"/>
+                </a:solidFill>
+                <a:latin typeface="Calibri" pitchFamily="34" charset="0"/>
+                <a:ea typeface="Calibri" pitchFamily="34" charset="-122"/>
+                <a:cs typeface="Calibri" pitchFamily="34" charset="-120"/>
+              </a:rPr>
+              <a:t>BUILT</a:t>
+            </a:r>
+            <a:endParaRPr lang="en-US" sz="1800" dirty="0"/>
+          </a:p>
+        </p:txBody>
+      </p:sp>
+      <p:sp>
+        <p:nvSpPr>
+          <p:cNvPr id="17" name="Text 15"/>
+          <p:cNvSpPr/>
+          <p:nvPr/>
+        </p:nvSpPr>
+        <p:spPr>
+          <a:xfrm>
+            <a:off x="10789920" y="6263640"/>
+            <a:ext cx="8138160" cy="777240"/>
+          </a:xfrm>
+          <a:prstGeom prst="rect">
+            <a:avLst/>
+          </a:prstGeom>
+          <a:noFill/>
+          <a:ln/>
+        </p:spPr>
+        <p:txBody>
+          <a:bodyPr wrap="square" lIns="0" tIns="0" rIns="0" bIns="0" rtlCol="0" anchor="ctr"/>
+          <a:lstStyle/>
+          <a:p>
+            <a:pPr indent="0" marL="0">
+              <a:buNone/>
+            </a:pPr>
+            <a:r>
+              <a:rPr lang="en-US" sz="2100" dirty="0">
                 <a:solidFill>
                   <a:srgbClr val="14213D"/>
                 </a:solidFill>
@@ -1306,22 +1438,283 @@
                 <a:ea typeface="Calibri" pitchFamily="34" charset="-122"/>
                 <a:cs typeface="Calibri" pitchFamily="34" charset="-120"/>
               </a:rPr>
-              <a:t>Show a working demo and an honest roadmap</a:t>
-            </a:r>
-            <a:endParaRPr lang="en-US" sz="3200" dirty="0"/>
-          </a:p>
-        </p:txBody>
-      </p:sp>
-      <p:sp>
-        <p:nvSpPr>
-          <p:cNvPr id="13" name="Shape 11"/>
-          <p:cNvSpPr/>
-          <p:nvPr/>
-        </p:nvSpPr>
-        <p:spPr>
-          <a:xfrm>
-            <a:off x="914400" y="9555480"/>
-            <a:ext cx="777240" cy="777240"/>
+              <a:t>Prove delivery end to end: an email reminder lands on time</a:t>
+            </a:r>
+            <a:endParaRPr lang="en-US" sz="2100" dirty="0"/>
+          </a:p>
+        </p:txBody>
+      </p:sp>
+      <p:sp>
+        <p:nvSpPr>
+          <p:cNvPr id="18" name="Shape 16"/>
+          <p:cNvSpPr/>
+          <p:nvPr/>
+        </p:nvSpPr>
+        <p:spPr>
+          <a:xfrm>
+            <a:off x="19065240" y="6400800"/>
+            <a:ext cx="1417320" cy="502920"/>
+          </a:xfrm>
+          <a:prstGeom prst="roundRect">
+            <a:avLst>
+              <a:gd name="adj" fmla="val 49091"/>
+            </a:avLst>
+          </a:prstGeom>
+          <a:solidFill>
+            <a:srgbClr val="2E7D5B"/>
+          </a:solidFill>
+          <a:ln/>
+        </p:spPr>
+      </p:sp>
+      <p:sp>
+        <p:nvSpPr>
+          <p:cNvPr id="19" name="Text 17"/>
+          <p:cNvSpPr/>
+          <p:nvPr/>
+        </p:nvSpPr>
+        <p:spPr>
+          <a:xfrm>
+            <a:off x="19065240" y="6400800"/>
+            <a:ext cx="1417320" cy="502920"/>
+          </a:xfrm>
+          <a:prstGeom prst="rect">
+            <a:avLst/>
+          </a:prstGeom>
+          <a:noFill/>
+          <a:ln/>
+        </p:spPr>
+        <p:txBody>
+          <a:bodyPr wrap="square" lIns="0" tIns="0" rIns="0" bIns="0" rtlCol="0" anchor="ctr"/>
+          <a:lstStyle/>
+          <a:p>
+            <a:pPr algn="ctr" indent="0" marL="0">
+              <a:buNone/>
+            </a:pPr>
+            <a:r>
+              <a:rPr lang="en-US" sz="1800" b="1" dirty="0">
+                <a:solidFill>
+                  <a:srgbClr val="FFFFFF"/>
+                </a:solidFill>
+                <a:latin typeface="Calibri" pitchFamily="34" charset="0"/>
+                <a:ea typeface="Calibri" pitchFamily="34" charset="-122"/>
+                <a:cs typeface="Calibri" pitchFamily="34" charset="-120"/>
+              </a:rPr>
+              <a:t>DONE</a:t>
+            </a:r>
+            <a:endParaRPr lang="en-US" sz="1800" dirty="0"/>
+          </a:p>
+        </p:txBody>
+      </p:sp>
+      <p:sp>
+        <p:nvSpPr>
+          <p:cNvPr id="20" name="Text 18"/>
+          <p:cNvSpPr/>
+          <p:nvPr/>
+        </p:nvSpPr>
+        <p:spPr>
+          <a:xfrm>
+            <a:off x="10789920" y="7132320"/>
+            <a:ext cx="8138160" cy="777240"/>
+          </a:xfrm>
+          <a:prstGeom prst="rect">
+            <a:avLst/>
+          </a:prstGeom>
+          <a:noFill/>
+          <a:ln/>
+        </p:spPr>
+        <p:txBody>
+          <a:bodyPr wrap="square" lIns="0" tIns="0" rIns="0" bIns="0" rtlCol="0" anchor="ctr"/>
+          <a:lstStyle/>
+          <a:p>
+            <a:pPr indent="0" marL="0">
+              <a:buNone/>
+            </a:pPr>
+            <a:r>
+              <a:rPr lang="en-US" sz="2100" dirty="0">
+                <a:solidFill>
+                  <a:srgbClr val="14213D"/>
+                </a:solidFill>
+                <a:latin typeface="Calibri" pitchFamily="34" charset="0"/>
+                <a:ea typeface="Calibri" pitchFamily="34" charset="-122"/>
+                <a:cs typeface="Calibri" pitchFamily="34" charset="-120"/>
+              </a:rPr>
+              <a:t>Keep each organisation's data separate: activity, analytics, exports</a:t>
+            </a:r>
+            <a:endParaRPr lang="en-US" sz="2100" dirty="0"/>
+          </a:p>
+        </p:txBody>
+      </p:sp>
+      <p:sp>
+        <p:nvSpPr>
+          <p:cNvPr id="21" name="Shape 19"/>
+          <p:cNvSpPr/>
+          <p:nvPr/>
+        </p:nvSpPr>
+        <p:spPr>
+          <a:xfrm>
+            <a:off x="19065240" y="7269480"/>
+            <a:ext cx="1417320" cy="502920"/>
+          </a:xfrm>
+          <a:prstGeom prst="roundRect">
+            <a:avLst>
+              <a:gd name="adj" fmla="val 49091"/>
+            </a:avLst>
+          </a:prstGeom>
+          <a:solidFill>
+            <a:srgbClr val="2E7D5B"/>
+          </a:solidFill>
+          <a:ln/>
+        </p:spPr>
+      </p:sp>
+      <p:sp>
+        <p:nvSpPr>
+          <p:cNvPr id="22" name="Text 20"/>
+          <p:cNvSpPr/>
+          <p:nvPr/>
+        </p:nvSpPr>
+        <p:spPr>
+          <a:xfrm>
+            <a:off x="19065240" y="7269480"/>
+            <a:ext cx="1417320" cy="502920"/>
+          </a:xfrm>
+          <a:prstGeom prst="rect">
+            <a:avLst/>
+          </a:prstGeom>
+          <a:noFill/>
+          <a:ln/>
+        </p:spPr>
+        <p:txBody>
+          <a:bodyPr wrap="square" lIns="0" tIns="0" rIns="0" bIns="0" rtlCol="0" anchor="ctr"/>
+          <a:lstStyle/>
+          <a:p>
+            <a:pPr algn="ctr" indent="0" marL="0">
+              <a:buNone/>
+            </a:pPr>
+            <a:r>
+              <a:rPr lang="en-US" sz="1800" b="1" dirty="0">
+                <a:solidFill>
+                  <a:srgbClr val="FFFFFF"/>
+                </a:solidFill>
+                <a:latin typeface="Calibri" pitchFamily="34" charset="0"/>
+                <a:ea typeface="Calibri" pitchFamily="34" charset="-122"/>
+                <a:cs typeface="Calibri" pitchFamily="34" charset="-120"/>
+              </a:rPr>
+              <a:t>BUILT</a:t>
+            </a:r>
+            <a:endParaRPr lang="en-US" sz="1800" dirty="0"/>
+          </a:p>
+        </p:txBody>
+      </p:sp>
+      <p:sp>
+        <p:nvSpPr>
+          <p:cNvPr id="23" name="Text 21"/>
+          <p:cNvSpPr/>
+          <p:nvPr/>
+        </p:nvSpPr>
+        <p:spPr>
+          <a:xfrm>
+            <a:off x="10789920" y="8001000"/>
+            <a:ext cx="8138160" cy="777240"/>
+          </a:xfrm>
+          <a:prstGeom prst="rect">
+            <a:avLst/>
+          </a:prstGeom>
+          <a:noFill/>
+          <a:ln/>
+        </p:spPr>
+        <p:txBody>
+          <a:bodyPr wrap="square" lIns="0" tIns="0" rIns="0" bIns="0" rtlCol="0" anchor="ctr"/>
+          <a:lstStyle/>
+          <a:p>
+            <a:pPr indent="0" marL="0">
+              <a:buNone/>
+            </a:pPr>
+            <a:r>
+              <a:rPr lang="en-US" sz="2100" dirty="0">
+                <a:solidFill>
+                  <a:srgbClr val="14213D"/>
+                </a:solidFill>
+                <a:latin typeface="Calibri" pitchFamily="34" charset="0"/>
+                <a:ea typeface="Calibri" pitchFamily="34" charset="-122"/>
+                <a:cs typeface="Calibri" pitchFamily="34" charset="-120"/>
+              </a:rPr>
+              <a:t>Prove SMS delivery and host the demo on-premise</a:t>
+            </a:r>
+            <a:endParaRPr lang="en-US" sz="2100" dirty="0"/>
+          </a:p>
+        </p:txBody>
+      </p:sp>
+      <p:sp>
+        <p:nvSpPr>
+          <p:cNvPr id="24" name="Shape 22"/>
+          <p:cNvSpPr/>
+          <p:nvPr/>
+        </p:nvSpPr>
+        <p:spPr>
+          <a:xfrm>
+            <a:off x="19065240" y="8138160"/>
+            <a:ext cx="1417320" cy="502920"/>
+          </a:xfrm>
+          <a:prstGeom prst="roundRect">
+            <a:avLst>
+              <a:gd name="adj" fmla="val 49091"/>
+            </a:avLst>
+          </a:prstGeom>
+          <a:solidFill>
+            <a:srgbClr val="A9701B"/>
+          </a:solidFill>
+          <a:ln/>
+        </p:spPr>
+      </p:sp>
+      <p:sp>
+        <p:nvSpPr>
+          <p:cNvPr id="25" name="Text 23"/>
+          <p:cNvSpPr/>
+          <p:nvPr/>
+        </p:nvSpPr>
+        <p:spPr>
+          <a:xfrm>
+            <a:off x="19065240" y="8138160"/>
+            <a:ext cx="1417320" cy="502920"/>
+          </a:xfrm>
+          <a:prstGeom prst="rect">
+            <a:avLst/>
+          </a:prstGeom>
+          <a:noFill/>
+          <a:ln/>
+        </p:spPr>
+        <p:txBody>
+          <a:bodyPr wrap="square" lIns="0" tIns="0" rIns="0" bIns="0" rtlCol="0" anchor="ctr"/>
+          <a:lstStyle/>
+          <a:p>
+            <a:pPr algn="ctr" indent="0" marL="0">
+              <a:buNone/>
+            </a:pPr>
+            <a:r>
+              <a:rPr lang="en-US" sz="1800" b="1" dirty="0">
+                <a:solidFill>
+                  <a:srgbClr val="FFFFFF"/>
+                </a:solidFill>
+                <a:latin typeface="Calibri" pitchFamily="34" charset="0"/>
+                <a:ea typeface="Calibri" pitchFamily="34" charset="-122"/>
+                <a:cs typeface="Calibri" pitchFamily="34" charset="-120"/>
+              </a:rPr>
+              <a:t>NEXT</a:t>
+            </a:r>
+            <a:endParaRPr lang="en-US" sz="1800" dirty="0"/>
+          </a:p>
+        </p:txBody>
+      </p:sp>
+      <p:sp>
+        <p:nvSpPr>
+          <p:cNvPr id="26" name="Shape 24"/>
+          <p:cNvSpPr/>
+          <p:nvPr/>
+        </p:nvSpPr>
+        <p:spPr>
+          <a:xfrm>
+            <a:off x="914400" y="8942832"/>
+            <a:ext cx="731520" cy="731520"/>
           </a:xfrm>
           <a:prstGeom prst="ellipse">
             <a:avLst/>
@@ -1334,14 +1727,14 @@
       </p:sp>
       <p:sp>
         <p:nvSpPr>
-          <p:cNvPr id="14" name="Text 12"/>
-          <p:cNvSpPr/>
-          <p:nvPr/>
-        </p:nvSpPr>
-        <p:spPr>
-          <a:xfrm>
-            <a:off x="914400" y="9555480"/>
-            <a:ext cx="777240" cy="777240"/>
+          <p:cNvPr id="27" name="Text 25"/>
+          <p:cNvSpPr/>
+          <p:nvPr/>
+        </p:nvSpPr>
+        <p:spPr>
+          <a:xfrm>
+            <a:off x="914400" y="8942832"/>
+            <a:ext cx="731520" cy="731520"/>
           </a:xfrm>
           <a:prstGeom prst="rect">
             <a:avLst/>
@@ -1357,7 +1750,7 @@
               <a:buNone/>
             </a:pPr>
             <a:r>
-              <a:rPr lang="en-US" sz="3200" b="1" dirty="0">
+              <a:rPr lang="en-US" sz="3000" b="1" dirty="0">
                 <a:solidFill>
                   <a:srgbClr val="1B2A49"/>
                 </a:solidFill>
@@ -1367,20 +1760,20 @@
               </a:rPr>
               <a:t>2</a:t>
             </a:r>
-            <a:endParaRPr lang="en-US" sz="3200" dirty="0"/>
-          </a:p>
-        </p:txBody>
-      </p:sp>
-      <p:sp>
-        <p:nvSpPr>
-          <p:cNvPr id="15" name="Text 13"/>
-          <p:cNvSpPr/>
-          <p:nvPr/>
-        </p:nvSpPr>
-        <p:spPr>
-          <a:xfrm>
-            <a:off x="1920240" y="9509760"/>
-            <a:ext cx="18288000" cy="868680"/>
+            <a:endParaRPr lang="en-US" sz="3000" dirty="0"/>
+          </a:p>
+        </p:txBody>
+      </p:sp>
+      <p:sp>
+        <p:nvSpPr>
+          <p:cNvPr id="28" name="Text 26"/>
+          <p:cNvSpPr/>
+          <p:nvPr/>
+        </p:nvSpPr>
+        <p:spPr>
+          <a:xfrm>
+            <a:off x="1874520" y="8915400"/>
+            <a:ext cx="18562320" cy="822960"/>
           </a:xfrm>
           <a:prstGeom prst="rect">
             <a:avLst/>
@@ -1396,7 +1789,7 @@
               <a:buNone/>
             </a:pPr>
             <a:r>
-              <a:rPr lang="en-US" sz="4600" b="1" dirty="0">
+              <a:rPr lang="en-US" sz="4200" b="1" dirty="0">
                 <a:solidFill>
                   <a:srgbClr val="1B2A49"/>
                 </a:solidFill>
@@ -1404,22 +1797,22 @@
                 <a:ea typeface="Cambria" pitchFamily="34" charset="-122"/>
                 <a:cs typeface="Cambria" pitchFamily="34" charset="-120"/>
               </a:rPr>
-              <a:t>Demo: try it now</a:t>
-            </a:r>
-            <a:endParaRPr lang="en-US" sz="4600" dirty="0"/>
-          </a:p>
-        </p:txBody>
-      </p:sp>
-      <p:sp>
-        <p:nvSpPr>
-          <p:cNvPr id="16" name="Text 14"/>
-          <p:cNvSpPr/>
-          <p:nvPr/>
-        </p:nvSpPr>
-        <p:spPr>
-          <a:xfrm>
-            <a:off x="914400" y="10515600"/>
-            <a:ext cx="13624560" cy="4206240"/>
+              <a:t>Technical status and demo: try it now</a:t>
+            </a:r>
+            <a:endParaRPr lang="en-US" sz="4200" dirty="0"/>
+          </a:p>
+        </p:txBody>
+      </p:sp>
+      <p:sp>
+        <p:nvSpPr>
+          <p:cNvPr id="29" name="Text 27"/>
+          <p:cNvSpPr/>
+          <p:nvPr/>
+        </p:nvSpPr>
+        <p:spPr>
+          <a:xfrm>
+            <a:off x="914400" y="9921240"/>
+            <a:ext cx="13990320" cy="4023360"/>
           </a:xfrm>
           <a:prstGeom prst="rect">
             <a:avLst/>
@@ -1433,12 +1826,12 @@
           <a:p>
             <a:pPr indent="0" marL="0">
               <a:spcAft>
-                <a:spcPts val="1000"/>
+                <a:spcPts val="800"/>
               </a:spcAft>
               <a:buNone/>
             </a:pPr>
             <a:r>
-              <a:rPr lang="en-US" sz="3200" dirty="0">
+              <a:rPr lang="en-US" sz="2700" dirty="0">
                 <a:solidFill>
                   <a:srgbClr val="14213D"/>
                 </a:solidFill>
@@ -1448,17 +1841,17 @@
               </a:rPr>
               <a:t>1.  Scan the code and sign in (ask us for the demo login)</a:t>
             </a:r>
-            <a:endParaRPr lang="en-US" sz="3200" dirty="0"/>
+            <a:endParaRPr lang="en-US" sz="2700" dirty="0"/>
           </a:p>
           <a:p>
             <a:pPr indent="0" marL="0">
               <a:spcAft>
-                <a:spcPts val="1000"/>
+                <a:spcPts val="800"/>
               </a:spcAft>
               <a:buNone/>
             </a:pPr>
             <a:r>
-              <a:rPr lang="en-US" sz="3200" dirty="0">
+              <a:rPr lang="en-US" sz="2700" dirty="0">
                 <a:solidFill>
                   <a:srgbClr val="14213D"/>
                 </a:solidFill>
@@ -1466,19 +1859,19 @@
                 <a:ea typeface="Calibri" pitchFamily="34" charset="-122"/>
                 <a:cs typeface="Calibri" pitchFamily="34" charset="-120"/>
               </a:rPr>
-              <a:t>2.  Contacts: see who has opted in and who has opted out</a:t>
-            </a:r>
-            <a:endParaRPr lang="en-US" sz="3200" dirty="0"/>
+              <a:t>2.  Contacts: opted-in and opted-out people</a:t>
+            </a:r>
+            <a:endParaRPr lang="en-US" sz="2700" dirty="0"/>
           </a:p>
           <a:p>
             <a:pPr indent="0" marL="0">
               <a:spcAft>
-                <a:spcPts val="1000"/>
+                <a:spcPts val="800"/>
               </a:spcAft>
               <a:buNone/>
             </a:pPr>
             <a:r>
-              <a:rPr lang="en-US" sz="3200" dirty="0">
+              <a:rPr lang="en-US" sz="2700" dirty="0">
                 <a:solidFill>
                   <a:srgbClr val="14213D"/>
                 </a:solidFill>
@@ -1486,19 +1879,19 @@
                 <a:ea typeface="Calibri" pitchFamily="34" charset="-122"/>
                 <a:cs typeface="Calibri" pitchFamily="34" charset="-120"/>
               </a:rPr>
-              <a:t>3.  Schedule a reminder: the consent gate blocks opted-out contacts</a:t>
-            </a:r>
-            <a:endParaRPr lang="en-US" sz="3200" dirty="0"/>
+              <a:t>3.  Schedule a reminder: opted-out contacts and past dates are refused</a:t>
+            </a:r>
+            <a:endParaRPr lang="en-US" sz="2700" dirty="0"/>
           </a:p>
           <a:p>
             <a:pPr indent="0" marL="0">
               <a:spcAft>
-                <a:spcPts val="1000"/>
+                <a:spcPts val="800"/>
               </a:spcAft>
               <a:buNone/>
             </a:pPr>
             <a:r>
-              <a:rPr lang="en-US" sz="3200" dirty="0">
+              <a:rPr lang="en-US" sz="2700" dirty="0">
                 <a:solidFill>
                   <a:srgbClr val="14213D"/>
                 </a:solidFill>
@@ -1506,15 +1899,35 @@
                 <a:ea typeface="Calibri" pitchFamily="34" charset="-122"/>
                 <a:cs typeface="Calibri" pitchFamily="34" charset="-120"/>
               </a:rPr>
-              <a:t>4.  Call +1 802 444 8729 and ask what we offer</a:t>
-            </a:r>
-            <a:endParaRPr lang="en-US" sz="3200" dirty="0"/>
+              <a:t>4.  Call +1 802 444 8729: ask the hours, then say goodbye</a:t>
+            </a:r>
+            <a:endParaRPr lang="en-US" sz="2700" dirty="0"/>
+          </a:p>
+          <a:p>
+            <a:pPr indent="0" marL="0">
+              <a:spcAft>
+                <a:spcPts val="800"/>
+              </a:spcAft>
+              <a:buNone/>
+            </a:pPr>
+            <a:r>
+              <a:rPr lang="en-US" sz="2700" dirty="0">
+                <a:solidFill>
+                  <a:srgbClr val="14213D"/>
+                </a:solidFill>
+                <a:latin typeface="Calibri" pitchFamily="34" charset="0"/>
+                <a:ea typeface="Calibri" pitchFamily="34" charset="-122"/>
+                <a:cs typeface="Calibri" pitchFamily="34" charset="-120"/>
+              </a:rPr>
+              <a:t>5.  Activity tab: the call, with its summary, sentiment and priority</a:t>
+            </a:r>
+            <a:endParaRPr lang="en-US" sz="2700" dirty="0"/>
           </a:p>
         </p:txBody>
       </p:sp>
       <p:pic>
         <p:nvPicPr>
-          <p:cNvPr id="17" name="Image 0" descr="qr.png">    </p:cNvPr>
+          <p:cNvPr id="30" name="Image 0" descr="qr.png">    </p:cNvPr>
           <p:cNvPicPr>
             <a:picLocks noChangeAspect="1"/>
           </p:cNvPicPr>
@@ -1528,8 +1941,8 @@
         </p:blipFill>
         <p:spPr>
           <a:xfrm>
-            <a:off x="14996160" y="10424160"/>
-            <a:ext cx="3840480" cy="3840480"/>
+            <a:off x="15819120" y="9829800"/>
+            <a:ext cx="3931920" cy="3931920"/>
           </a:xfrm>
           <a:prstGeom prst="rect">
             <a:avLst/>
@@ -1538,14 +1951,14 @@
       </p:pic>
       <p:sp>
         <p:nvSpPr>
-          <p:cNvPr id="18" name="Text 15"/>
-          <p:cNvSpPr/>
-          <p:nvPr/>
-        </p:nvSpPr>
-        <p:spPr>
-          <a:xfrm>
-            <a:off x="14996160" y="14310360"/>
-            <a:ext cx="3840480" cy="457200"/>
+          <p:cNvPr id="31" name="Text 28"/>
+          <p:cNvSpPr/>
+          <p:nvPr/>
+        </p:nvSpPr>
+        <p:spPr>
+          <a:xfrm>
+            <a:off x="15819120" y="13807440"/>
+            <a:ext cx="3931920" cy="457200"/>
           </a:xfrm>
           <a:prstGeom prst="rect">
             <a:avLst/>
@@ -1561,7 +1974,7 @@
               <a:buNone/>
             </a:pPr>
             <a:r>
-              <a:rPr lang="en-US" sz="2400" b="1" dirty="0">
+              <a:rPr lang="en-US" sz="2200" b="1" dirty="0">
                 <a:solidFill>
                   <a:srgbClr val="1B2A49"/>
                 </a:solidFill>
@@ -1571,24 +1984,444 @@
               </a:rPr>
               <a:t>Live demo</a:t>
             </a:r>
-            <a:endParaRPr lang="en-US" sz="2400" dirty="0"/>
-          </a:p>
-        </p:txBody>
-      </p:sp>
-      <p:sp>
-        <p:nvSpPr>
-          <p:cNvPr id="19" name="Shape 16"/>
-          <p:cNvSpPr/>
-          <p:nvPr/>
-        </p:nvSpPr>
-        <p:spPr>
-          <a:xfrm>
-            <a:off x="914400" y="14996160"/>
-            <a:ext cx="3474720" cy="1554480"/>
+            <a:endParaRPr lang="en-US" sz="2200" dirty="0"/>
+          </a:p>
+        </p:txBody>
+      </p:sp>
+      <p:sp>
+        <p:nvSpPr>
+          <p:cNvPr id="32" name="Shape 29"/>
+          <p:cNvSpPr/>
+          <p:nvPr/>
+        </p:nvSpPr>
+        <p:spPr>
+          <a:xfrm>
+            <a:off x="914400" y="14584680"/>
+            <a:ext cx="4663440" cy="1600200"/>
           </a:xfrm>
           <a:prstGeom prst="roundRect">
             <a:avLst>
-              <a:gd name="adj" fmla="val 7059"/>
+              <a:gd name="adj" fmla="val 5714"/>
+            </a:avLst>
+          </a:prstGeom>
+          <a:solidFill>
+            <a:srgbClr val="EEF1F6"/>
+          </a:solidFill>
+          <a:ln w="12700">
+            <a:solidFill>
+              <a:srgbClr val="EEF1F6"/>
+            </a:solidFill>
+            <a:prstDash val="solid"/>
+          </a:ln>
+        </p:spPr>
+      </p:sp>
+      <p:sp>
+        <p:nvSpPr>
+          <p:cNvPr id="33" name="Text 30"/>
+          <p:cNvSpPr/>
+          <p:nvPr/>
+        </p:nvSpPr>
+        <p:spPr>
+          <a:xfrm>
+            <a:off x="1097280" y="14630400"/>
+            <a:ext cx="4297680" cy="777240"/>
+          </a:xfrm>
+          <a:prstGeom prst="rect">
+            <a:avLst/>
+          </a:prstGeom>
+          <a:noFill/>
+          <a:ln/>
+        </p:spPr>
+        <p:txBody>
+          <a:bodyPr wrap="square" lIns="0" tIns="0" rIns="0" bIns="0" rtlCol="0" anchor="ctr"/>
+          <a:lstStyle/>
+          <a:p>
+            <a:pPr indent="0" marL="0">
+              <a:buNone/>
+            </a:pPr>
+            <a:r>
+              <a:rPr lang="en-US" sz="4000" b="1" dirty="0">
+                <a:solidFill>
+                  <a:srgbClr val="1B2A49"/>
+                </a:solidFill>
+                <a:latin typeface="Cambria" pitchFamily="34" charset="0"/>
+                <a:ea typeface="Cambria" pitchFamily="34" charset="-122"/>
+                <a:cs typeface="Cambria" pitchFamily="34" charset="-120"/>
+              </a:rPr>
+              <a:t>708</a:t>
+            </a:r>
+            <a:endParaRPr lang="en-US" sz="4000" dirty="0"/>
+          </a:p>
+        </p:txBody>
+      </p:sp>
+      <p:sp>
+        <p:nvSpPr>
+          <p:cNvPr id="34" name="Text 31"/>
+          <p:cNvSpPr/>
+          <p:nvPr/>
+        </p:nvSpPr>
+        <p:spPr>
+          <a:xfrm>
+            <a:off x="1097280" y="15407640"/>
+            <a:ext cx="4297680" cy="731520"/>
+          </a:xfrm>
+          <a:prstGeom prst="rect">
+            <a:avLst/>
+          </a:prstGeom>
+          <a:noFill/>
+          <a:ln/>
+        </p:spPr>
+        <p:txBody>
+          <a:bodyPr wrap="square" lIns="0" tIns="0" rIns="0" bIns="0" rtlCol="0" anchor="t"/>
+          <a:lstStyle/>
+          <a:p>
+            <a:pPr indent="0" marL="0">
+              <a:buNone/>
+            </a:pPr>
+            <a:r>
+              <a:rPr lang="en-US" sz="1900" dirty="0">
+                <a:solidFill>
+                  <a:srgbClr val="14213D"/>
+                </a:solidFill>
+                <a:latin typeface="Calibri" pitchFamily="34" charset="0"/>
+                <a:ea typeface="Calibri" pitchFamily="34" charset="-122"/>
+                <a:cs typeface="Calibri" pitchFamily="34" charset="-120"/>
+              </a:rPr>
+              <a:t>automated tests, run by CI on every change</a:t>
+            </a:r>
+            <a:endParaRPr lang="en-US" sz="1900" dirty="0"/>
+          </a:p>
+        </p:txBody>
+      </p:sp>
+      <p:sp>
+        <p:nvSpPr>
+          <p:cNvPr id="35" name="Shape 32"/>
+          <p:cNvSpPr/>
+          <p:nvPr/>
+        </p:nvSpPr>
+        <p:spPr>
+          <a:xfrm>
+            <a:off x="5879592" y="14584680"/>
+            <a:ext cx="4663440" cy="1600200"/>
+          </a:xfrm>
+          <a:prstGeom prst="roundRect">
+            <a:avLst>
+              <a:gd name="adj" fmla="val 5714"/>
+            </a:avLst>
+          </a:prstGeom>
+          <a:solidFill>
+            <a:srgbClr val="EEF1F6"/>
+          </a:solidFill>
+          <a:ln w="12700">
+            <a:solidFill>
+              <a:srgbClr val="EEF1F6"/>
+            </a:solidFill>
+            <a:prstDash val="solid"/>
+          </a:ln>
+        </p:spPr>
+      </p:sp>
+      <p:sp>
+        <p:nvSpPr>
+          <p:cNvPr id="36" name="Text 33"/>
+          <p:cNvSpPr/>
+          <p:nvPr/>
+        </p:nvSpPr>
+        <p:spPr>
+          <a:xfrm>
+            <a:off x="6062472" y="14630400"/>
+            <a:ext cx="4297680" cy="777240"/>
+          </a:xfrm>
+          <a:prstGeom prst="rect">
+            <a:avLst/>
+          </a:prstGeom>
+          <a:noFill/>
+          <a:ln/>
+        </p:spPr>
+        <p:txBody>
+          <a:bodyPr wrap="square" lIns="0" tIns="0" rIns="0" bIns="0" rtlCol="0" anchor="ctr"/>
+          <a:lstStyle/>
+          <a:p>
+            <a:pPr indent="0" marL="0">
+              <a:buNone/>
+            </a:pPr>
+            <a:r>
+              <a:rPr lang="en-US" sz="4000" b="1" dirty="0">
+                <a:solidFill>
+                  <a:srgbClr val="1B2A49"/>
+                </a:solidFill>
+                <a:latin typeface="Cambria" pitchFamily="34" charset="0"/>
+                <a:ea typeface="Cambria" pitchFamily="34" charset="-122"/>
+                <a:cs typeface="Cambria" pitchFamily="34" charset="-120"/>
+              </a:rPr>
+              <a:t>403</a:t>
+            </a:r>
+            <a:endParaRPr lang="en-US" sz="4000" dirty="0"/>
+          </a:p>
+        </p:txBody>
+      </p:sp>
+      <p:sp>
+        <p:nvSpPr>
+          <p:cNvPr id="37" name="Text 34"/>
+          <p:cNvSpPr/>
+          <p:nvPr/>
+        </p:nvSpPr>
+        <p:spPr>
+          <a:xfrm>
+            <a:off x="6062472" y="15407640"/>
+            <a:ext cx="4297680" cy="731520"/>
+          </a:xfrm>
+          <a:prstGeom prst="rect">
+            <a:avLst/>
+          </a:prstGeom>
+          <a:noFill/>
+          <a:ln/>
+        </p:spPr>
+        <p:txBody>
+          <a:bodyPr wrap="square" lIns="0" tIns="0" rIns="0" bIns="0" rtlCol="0" anchor="t"/>
+          <a:lstStyle/>
+          <a:p>
+            <a:pPr indent="0" marL="0">
+              <a:buNone/>
+            </a:pPr>
+            <a:r>
+              <a:rPr lang="en-US" sz="1900" dirty="0">
+                <a:solidFill>
+                  <a:srgbClr val="14213D"/>
+                </a:solidFill>
+                <a:latin typeface="Calibri" pitchFamily="34" charset="0"/>
+                <a:ea typeface="Calibri" pitchFamily="34" charset="-122"/>
+                <a:cs typeface="Calibri" pitchFamily="34" charset="-120"/>
+              </a:rPr>
+              <a:t>reply to any forged Twilio call</a:t>
+            </a:r>
+            <a:endParaRPr lang="en-US" sz="1900" dirty="0"/>
+          </a:p>
+        </p:txBody>
+      </p:sp>
+      <p:sp>
+        <p:nvSpPr>
+          <p:cNvPr id="38" name="Shape 35"/>
+          <p:cNvSpPr/>
+          <p:nvPr/>
+        </p:nvSpPr>
+        <p:spPr>
+          <a:xfrm>
+            <a:off x="10844784" y="14584680"/>
+            <a:ext cx="4663440" cy="1600200"/>
+          </a:xfrm>
+          <a:prstGeom prst="roundRect">
+            <a:avLst>
+              <a:gd name="adj" fmla="val 5714"/>
+            </a:avLst>
+          </a:prstGeom>
+          <a:solidFill>
+            <a:srgbClr val="EEF1F6"/>
+          </a:solidFill>
+          <a:ln w="12700">
+            <a:solidFill>
+              <a:srgbClr val="EEF1F6"/>
+            </a:solidFill>
+            <a:prstDash val="solid"/>
+          </a:ln>
+        </p:spPr>
+      </p:sp>
+      <p:sp>
+        <p:nvSpPr>
+          <p:cNvPr id="39" name="Text 36"/>
+          <p:cNvSpPr/>
+          <p:nvPr/>
+        </p:nvSpPr>
+        <p:spPr>
+          <a:xfrm>
+            <a:off x="11027664" y="14630400"/>
+            <a:ext cx="4297680" cy="777240"/>
+          </a:xfrm>
+          <a:prstGeom prst="rect">
+            <a:avLst/>
+          </a:prstGeom>
+          <a:noFill/>
+          <a:ln/>
+        </p:spPr>
+        <p:txBody>
+          <a:bodyPr wrap="square" lIns="0" tIns="0" rIns="0" bIns="0" rtlCol="0" anchor="ctr"/>
+          <a:lstStyle/>
+          <a:p>
+            <a:pPr indent="0" marL="0">
+              <a:buNone/>
+            </a:pPr>
+            <a:r>
+              <a:rPr lang="en-US" sz="4000" b="1" dirty="0">
+                <a:solidFill>
+                  <a:srgbClr val="1B2A49"/>
+                </a:solidFill>
+                <a:latin typeface="Cambria" pitchFamily="34" charset="0"/>
+                <a:ea typeface="Cambria" pitchFamily="34" charset="-122"/>
+                <a:cs typeface="Cambria" pitchFamily="34" charset="-120"/>
+              </a:rPr>
+              <a:t>7 s</a:t>
+            </a:r>
+            <a:endParaRPr lang="en-US" sz="4000" dirty="0"/>
+          </a:p>
+        </p:txBody>
+      </p:sp>
+      <p:sp>
+        <p:nvSpPr>
+          <p:cNvPr id="40" name="Text 37"/>
+          <p:cNvSpPr/>
+          <p:nvPr/>
+        </p:nvSpPr>
+        <p:spPr>
+          <a:xfrm>
+            <a:off x="11027664" y="15407640"/>
+            <a:ext cx="4297680" cy="731520"/>
+          </a:xfrm>
+          <a:prstGeom prst="rect">
+            <a:avLst/>
+          </a:prstGeom>
+          <a:noFill/>
+          <a:ln/>
+        </p:spPr>
+        <p:txBody>
+          <a:bodyPr wrap="square" lIns="0" tIns="0" rIns="0" bIns="0" rtlCol="0" anchor="t"/>
+          <a:lstStyle/>
+          <a:p>
+            <a:pPr indent="0" marL="0">
+              <a:buNone/>
+            </a:pPr>
+            <a:r>
+              <a:rPr lang="en-US" sz="1900" dirty="0">
+                <a:solidFill>
+                  <a:srgbClr val="14213D"/>
+                </a:solidFill>
+                <a:latin typeface="Calibri" pitchFamily="34" charset="0"/>
+                <a:ea typeface="Calibri" pitchFamily="34" charset="-122"/>
+                <a:cs typeface="Calibri" pitchFamily="34" charset="-120"/>
+              </a:rPr>
+              <a:t>email reminder arrived after its send time</a:t>
+            </a:r>
+            <a:endParaRPr lang="en-US" sz="1900" dirty="0"/>
+          </a:p>
+        </p:txBody>
+      </p:sp>
+      <p:sp>
+        <p:nvSpPr>
+          <p:cNvPr id="41" name="Shape 38"/>
+          <p:cNvSpPr/>
+          <p:nvPr/>
+        </p:nvSpPr>
+        <p:spPr>
+          <a:xfrm>
+            <a:off x="15809976" y="14584680"/>
+            <a:ext cx="4663440" cy="1600200"/>
+          </a:xfrm>
+          <a:prstGeom prst="roundRect">
+            <a:avLst>
+              <a:gd name="adj" fmla="val 5714"/>
+            </a:avLst>
+          </a:prstGeom>
+          <a:solidFill>
+            <a:srgbClr val="EEF1F6"/>
+          </a:solidFill>
+          <a:ln w="12700">
+            <a:solidFill>
+              <a:srgbClr val="EEF1F6"/>
+            </a:solidFill>
+            <a:prstDash val="solid"/>
+          </a:ln>
+        </p:spPr>
+      </p:sp>
+      <p:sp>
+        <p:nvSpPr>
+          <p:cNvPr id="42" name="Text 39"/>
+          <p:cNvSpPr/>
+          <p:nvPr/>
+        </p:nvSpPr>
+        <p:spPr>
+          <a:xfrm>
+            <a:off x="15992856" y="14630400"/>
+            <a:ext cx="4297680" cy="777240"/>
+          </a:xfrm>
+          <a:prstGeom prst="rect">
+            <a:avLst/>
+          </a:prstGeom>
+          <a:noFill/>
+          <a:ln/>
+        </p:spPr>
+        <p:txBody>
+          <a:bodyPr wrap="square" lIns="0" tIns="0" rIns="0" bIns="0" rtlCol="0" anchor="ctr"/>
+          <a:lstStyle/>
+          <a:p>
+            <a:pPr indent="0" marL="0">
+              <a:buNone/>
+            </a:pPr>
+            <a:r>
+              <a:rPr lang="en-US" sz="4000" b="1" dirty="0">
+                <a:solidFill>
+                  <a:srgbClr val="1B2A49"/>
+                </a:solidFill>
+                <a:latin typeface="Cambria" pitchFamily="34" charset="0"/>
+                <a:ea typeface="Cambria" pitchFamily="34" charset="-122"/>
+                <a:cs typeface="Cambria" pitchFamily="34" charset="-120"/>
+              </a:rPr>
+              <a:t>Live</a:t>
+            </a:r>
+            <a:endParaRPr lang="en-US" sz="4000" dirty="0"/>
+          </a:p>
+        </p:txBody>
+      </p:sp>
+      <p:sp>
+        <p:nvSpPr>
+          <p:cNvPr id="43" name="Text 40"/>
+          <p:cNvSpPr/>
+          <p:nvPr/>
+        </p:nvSpPr>
+        <p:spPr>
+          <a:xfrm>
+            <a:off x="15992856" y="15407640"/>
+            <a:ext cx="4297680" cy="731520"/>
+          </a:xfrm>
+          <a:prstGeom prst="rect">
+            <a:avLst/>
+          </a:prstGeom>
+          <a:noFill/>
+          <a:ln/>
+        </p:spPr>
+        <p:txBody>
+          <a:bodyPr wrap="square" lIns="0" tIns="0" rIns="0" bIns="0" rtlCol="0" anchor="t"/>
+          <a:lstStyle/>
+          <a:p>
+            <a:pPr indent="0" marL="0">
+              <a:buNone/>
+            </a:pPr>
+            <a:r>
+              <a:rPr lang="en-US" sz="1900" dirty="0">
+                <a:solidFill>
+                  <a:srgbClr val="14213D"/>
+                </a:solidFill>
+                <a:latin typeface="Calibri" pitchFamily="34" charset="0"/>
+                <a:ea typeface="Calibri" pitchFamily="34" charset="-122"/>
+                <a:cs typeface="Calibri" pitchFamily="34" charset="-120"/>
+              </a:rPr>
+              <a:t>a real call answered by voice</a:t>
+            </a:r>
+            <a:endParaRPr lang="en-US" sz="1900" dirty="0"/>
+          </a:p>
+        </p:txBody>
+      </p:sp>
+      <p:sp>
+        <p:nvSpPr>
+          <p:cNvPr id="44" name="Shape 41"/>
+          <p:cNvSpPr/>
+          <p:nvPr/>
+        </p:nvSpPr>
+        <p:spPr>
+          <a:xfrm>
+            <a:off x="914400" y="16596360"/>
+            <a:ext cx="3474720" cy="1417320"/>
+          </a:xfrm>
+          <a:prstGeom prst="roundRect">
+            <a:avLst>
+              <a:gd name="adj" fmla="val 7742"/>
             </a:avLst>
           </a:prstGeom>
           <a:solidFill>
@@ -1604,14 +2437,14 @@
       </p:sp>
       <p:sp>
         <p:nvSpPr>
-          <p:cNvPr id="20" name="Text 17"/>
-          <p:cNvSpPr/>
-          <p:nvPr/>
-        </p:nvSpPr>
-        <p:spPr>
-          <a:xfrm>
-            <a:off x="1051560" y="14996160"/>
-            <a:ext cx="3200400" cy="1554480"/>
+          <p:cNvPr id="45" name="Text 42"/>
+          <p:cNvSpPr/>
+          <p:nvPr/>
+        </p:nvSpPr>
+        <p:spPr>
+          <a:xfrm>
+            <a:off x="1024128" y="16596360"/>
+            <a:ext cx="3255264" cy="1417320"/>
           </a:xfrm>
           <a:prstGeom prst="rect">
             <a:avLst/>
@@ -1627,7 +2460,7 @@
               <a:buNone/>
             </a:pPr>
             <a:r>
-              <a:rPr lang="en-US" sz="2800" b="1" dirty="0">
+              <a:rPr lang="en-US" sz="2500" b="1" dirty="0">
                 <a:solidFill>
                   <a:srgbClr val="1B2A49"/>
                 </a:solidFill>
@@ -1637,14 +2470,14 @@
               </a:rPr>
               <a:t>Web app + CRM</a:t>
             </a:r>
-            <a:endParaRPr lang="en-US" sz="2800" dirty="0"/>
+            <a:endParaRPr lang="en-US" sz="2500" dirty="0"/>
           </a:p>
           <a:p>
             <a:pPr algn="ctr" indent="0" marL="0">
               <a:buNone/>
             </a:pPr>
             <a:r>
-              <a:rPr lang="en-US" sz="2200" dirty="0">
+              <a:rPr lang="en-US" sz="1900" dirty="0">
                 <a:solidFill>
                   <a:srgbClr val="14213D"/>
                 </a:solidFill>
@@ -1654,24 +2487,24 @@
               </a:rPr>
               <a:t>accounts, contacts</a:t>
             </a:r>
-            <a:endParaRPr lang="en-US" sz="2800" dirty="0"/>
-          </a:p>
-        </p:txBody>
-      </p:sp>
-      <p:sp>
-        <p:nvSpPr>
-          <p:cNvPr id="21" name="Shape 18"/>
-          <p:cNvSpPr/>
-          <p:nvPr/>
-        </p:nvSpPr>
-        <p:spPr>
-          <a:xfrm>
-            <a:off x="4937760" y="14996160"/>
-            <a:ext cx="3474720" cy="1554480"/>
+            <a:endParaRPr lang="en-US" sz="2500" dirty="0"/>
+          </a:p>
+        </p:txBody>
+      </p:sp>
+      <p:sp>
+        <p:nvSpPr>
+          <p:cNvPr id="46" name="Shape 43"/>
+          <p:cNvSpPr/>
+          <p:nvPr/>
+        </p:nvSpPr>
+        <p:spPr>
+          <a:xfrm>
+            <a:off x="4937760" y="16596360"/>
+            <a:ext cx="3474720" cy="1417320"/>
           </a:xfrm>
           <a:prstGeom prst="roundRect">
             <a:avLst>
-              <a:gd name="adj" fmla="val 7059"/>
+              <a:gd name="adj" fmla="val 7742"/>
             </a:avLst>
           </a:prstGeom>
           <a:solidFill>
@@ -1687,14 +2520,14 @@
       </p:sp>
       <p:sp>
         <p:nvSpPr>
-          <p:cNvPr id="22" name="Text 19"/>
-          <p:cNvSpPr/>
-          <p:nvPr/>
-        </p:nvSpPr>
-        <p:spPr>
-          <a:xfrm>
-            <a:off x="5074920" y="14996160"/>
-            <a:ext cx="3200400" cy="1554480"/>
+          <p:cNvPr id="47" name="Text 44"/>
+          <p:cNvSpPr/>
+          <p:nvPr/>
+        </p:nvSpPr>
+        <p:spPr>
+          <a:xfrm>
+            <a:off x="5047488" y="16596360"/>
+            <a:ext cx="3255264" cy="1417320"/>
           </a:xfrm>
           <a:prstGeom prst="rect">
             <a:avLst/>
@@ -1710,7 +2543,7 @@
               <a:buNone/>
             </a:pPr>
             <a:r>
-              <a:rPr lang="en-US" sz="2800" b="1" dirty="0">
+              <a:rPr lang="en-US" sz="2500" b="1" dirty="0">
                 <a:solidFill>
                   <a:srgbClr val="1B2A49"/>
                 </a:solidFill>
@@ -1720,14 +2553,14 @@
               </a:rPr>
               <a:t>Consent gate</a:t>
             </a:r>
-            <a:endParaRPr lang="en-US" sz="2800" dirty="0"/>
+            <a:endParaRPr lang="en-US" sz="2500" dirty="0"/>
           </a:p>
           <a:p>
             <a:pPr algn="ctr" indent="0" marL="0">
               <a:buNone/>
             </a:pPr>
             <a:r>
-              <a:rPr lang="en-US" sz="2200" dirty="0">
+              <a:rPr lang="en-US" sz="1900" dirty="0">
                 <a:solidFill>
                   <a:srgbClr val="14213D"/>
                 </a:solidFill>
@@ -1737,24 +2570,24 @@
               </a:rPr>
               <a:t>opt-in, STOP, quiet hours</a:t>
             </a:r>
-            <a:endParaRPr lang="en-US" sz="2800" dirty="0"/>
-          </a:p>
-        </p:txBody>
-      </p:sp>
-      <p:sp>
-        <p:nvSpPr>
-          <p:cNvPr id="23" name="Shape 20"/>
-          <p:cNvSpPr/>
-          <p:nvPr/>
-        </p:nvSpPr>
-        <p:spPr>
-          <a:xfrm>
-            <a:off x="8961120" y="14996160"/>
-            <a:ext cx="3474720" cy="1554480"/>
+            <a:endParaRPr lang="en-US" sz="2500" dirty="0"/>
+          </a:p>
+        </p:txBody>
+      </p:sp>
+      <p:sp>
+        <p:nvSpPr>
+          <p:cNvPr id="48" name="Shape 45"/>
+          <p:cNvSpPr/>
+          <p:nvPr/>
+        </p:nvSpPr>
+        <p:spPr>
+          <a:xfrm>
+            <a:off x="8961120" y="16596360"/>
+            <a:ext cx="3474720" cy="1417320"/>
           </a:xfrm>
           <a:prstGeom prst="roundRect">
             <a:avLst>
-              <a:gd name="adj" fmla="val 7059"/>
+              <a:gd name="adj" fmla="val 7742"/>
             </a:avLst>
           </a:prstGeom>
           <a:solidFill>
@@ -1770,14 +2603,14 @@
       </p:sp>
       <p:sp>
         <p:nvSpPr>
-          <p:cNvPr id="24" name="Text 21"/>
-          <p:cNvSpPr/>
-          <p:nvPr/>
-        </p:nvSpPr>
-        <p:spPr>
-          <a:xfrm>
-            <a:off x="9098280" y="14996160"/>
-            <a:ext cx="3200400" cy="1554480"/>
+          <p:cNvPr id="49" name="Text 46"/>
+          <p:cNvSpPr/>
+          <p:nvPr/>
+        </p:nvSpPr>
+        <p:spPr>
+          <a:xfrm>
+            <a:off x="9070848" y="16596360"/>
+            <a:ext cx="3255264" cy="1417320"/>
           </a:xfrm>
           <a:prstGeom prst="rect">
             <a:avLst/>
@@ -1793,7 +2626,7 @@
               <a:buNone/>
             </a:pPr>
             <a:r>
-              <a:rPr lang="en-US" sz="2800" b="1" dirty="0">
+              <a:rPr lang="en-US" sz="2500" b="1" dirty="0">
                 <a:solidFill>
                   <a:srgbClr val="1B2A49"/>
                 </a:solidFill>
@@ -1803,14 +2636,14 @@
               </a:rPr>
               <a:t>Reminders engine</a:t>
             </a:r>
-            <a:endParaRPr lang="en-US" sz="2800" dirty="0"/>
+            <a:endParaRPr lang="en-US" sz="2500" dirty="0"/>
           </a:p>
           <a:p>
             <a:pPr algn="ctr" indent="0" marL="0">
               <a:buNone/>
             </a:pPr>
             <a:r>
-              <a:rPr lang="en-US" sz="2200" dirty="0">
+              <a:rPr lang="en-US" sz="1900" dirty="0">
                 <a:solidFill>
                   <a:srgbClr val="14213D"/>
                 </a:solidFill>
@@ -1820,24 +2653,24 @@
               </a:rPr>
               <a:t>no double sends</a:t>
             </a:r>
-            <a:endParaRPr lang="en-US" sz="2800" dirty="0"/>
-          </a:p>
-        </p:txBody>
-      </p:sp>
-      <p:sp>
-        <p:nvSpPr>
-          <p:cNvPr id="25" name="Shape 22"/>
-          <p:cNvSpPr/>
-          <p:nvPr/>
-        </p:nvSpPr>
-        <p:spPr>
-          <a:xfrm>
-            <a:off x="12984480" y="14996160"/>
-            <a:ext cx="3474720" cy="1554480"/>
+            <a:endParaRPr lang="en-US" sz="2500" dirty="0"/>
+          </a:p>
+        </p:txBody>
+      </p:sp>
+      <p:sp>
+        <p:nvSpPr>
+          <p:cNvPr id="50" name="Shape 47"/>
+          <p:cNvSpPr/>
+          <p:nvPr/>
+        </p:nvSpPr>
+        <p:spPr>
+          <a:xfrm>
+            <a:off x="12984480" y="16596360"/>
+            <a:ext cx="3474720" cy="1417320"/>
           </a:xfrm>
           <a:prstGeom prst="roundRect">
             <a:avLst>
-              <a:gd name="adj" fmla="val 7059"/>
+              <a:gd name="adj" fmla="val 7742"/>
             </a:avLst>
           </a:prstGeom>
           <a:solidFill>
@@ -1853,14 +2686,14 @@
       </p:sp>
       <p:sp>
         <p:nvSpPr>
-          <p:cNvPr id="26" name="Text 23"/>
-          <p:cNvSpPr/>
-          <p:nvPr/>
-        </p:nvSpPr>
-        <p:spPr>
-          <a:xfrm>
-            <a:off x="13121640" y="14996160"/>
-            <a:ext cx="3200400" cy="1554480"/>
+          <p:cNvPr id="51" name="Text 48"/>
+          <p:cNvSpPr/>
+          <p:nvPr/>
+        </p:nvSpPr>
+        <p:spPr>
+          <a:xfrm>
+            <a:off x="13094208" y="16596360"/>
+            <a:ext cx="3255264" cy="1417320"/>
           </a:xfrm>
           <a:prstGeom prst="rect">
             <a:avLst/>
@@ -1876,7 +2709,7 @@
               <a:buNone/>
             </a:pPr>
             <a:r>
-              <a:rPr lang="en-US" sz="2800" b="1" dirty="0">
+              <a:rPr lang="en-US" sz="2500" b="1" dirty="0">
                 <a:solidFill>
                   <a:srgbClr val="1B2A49"/>
                 </a:solidFill>
@@ -1886,14 +2719,14 @@
               </a:rPr>
               <a:t>SMS, voice, email</a:t>
             </a:r>
-            <a:endParaRPr lang="en-US" sz="2800" dirty="0"/>
+            <a:endParaRPr lang="en-US" sz="2500" dirty="0"/>
           </a:p>
           <a:p>
             <a:pPr algn="ctr" indent="0" marL="0">
               <a:buNone/>
             </a:pPr>
             <a:r>
-              <a:rPr lang="en-US" sz="2200" dirty="0">
+              <a:rPr lang="en-US" sz="1900" dirty="0">
                 <a:solidFill>
                   <a:srgbClr val="14213D"/>
                 </a:solidFill>
@@ -1901,26 +2734,26 @@
                 <a:ea typeface="Calibri" pitchFamily="34" charset="-122"/>
                 <a:cs typeface="Calibri" pitchFamily="34" charset="-120"/>
               </a:rPr>
-              <a:t>via Twilio and SMTP</a:t>
-            </a:r>
-            <a:endParaRPr lang="en-US" sz="2800" dirty="0"/>
-          </a:p>
-        </p:txBody>
-      </p:sp>
-      <p:sp>
-        <p:nvSpPr>
-          <p:cNvPr id="27" name="Shape 24"/>
-          <p:cNvSpPr/>
-          <p:nvPr/>
-        </p:nvSpPr>
-        <p:spPr>
-          <a:xfrm>
-            <a:off x="17007840" y="14996160"/>
-            <a:ext cx="3474720" cy="1554480"/>
+              <a:t>Twilio and SMTP</a:t>
+            </a:r>
+            <a:endParaRPr lang="en-US" sz="2500" dirty="0"/>
+          </a:p>
+        </p:txBody>
+      </p:sp>
+      <p:sp>
+        <p:nvSpPr>
+          <p:cNvPr id="52" name="Shape 49"/>
+          <p:cNvSpPr/>
+          <p:nvPr/>
+        </p:nvSpPr>
+        <p:spPr>
+          <a:xfrm>
+            <a:off x="17007840" y="16596360"/>
+            <a:ext cx="3474720" cy="1417320"/>
           </a:xfrm>
           <a:prstGeom prst="roundRect">
             <a:avLst>
-              <a:gd name="adj" fmla="val 7059"/>
+              <a:gd name="adj" fmla="val 7742"/>
             </a:avLst>
           </a:prstGeom>
           <a:solidFill>
@@ -1936,14 +2769,14 @@
       </p:sp>
       <p:sp>
         <p:nvSpPr>
-          <p:cNvPr id="28" name="Text 25"/>
-          <p:cNvSpPr/>
-          <p:nvPr/>
-        </p:nvSpPr>
-        <p:spPr>
-          <a:xfrm>
-            <a:off x="17145000" y="14996160"/>
-            <a:ext cx="3200400" cy="1554480"/>
+          <p:cNvPr id="53" name="Text 50"/>
+          <p:cNvSpPr/>
+          <p:nvPr/>
+        </p:nvSpPr>
+        <p:spPr>
+          <a:xfrm>
+            <a:off x="17117568" y="16596360"/>
+            <a:ext cx="3255264" cy="1417320"/>
           </a:xfrm>
           <a:prstGeom prst="rect">
             <a:avLst/>
@@ -1959,7 +2792,7 @@
               <a:buNone/>
             </a:pPr>
             <a:r>
-              <a:rPr lang="en-US" sz="2800" b="1" dirty="0">
+              <a:rPr lang="en-US" sz="2500" b="1" dirty="0">
                 <a:solidFill>
                   <a:srgbClr val="1B2A49"/>
                 </a:solidFill>
@@ -1967,16 +2800,16 @@
                 <a:ea typeface="Calibri" pitchFamily="34" charset="-122"/>
                 <a:cs typeface="Calibri" pitchFamily="34" charset="-120"/>
               </a:rPr>
-              <a:t>Dashboard</a:t>
-            </a:r>
-            <a:endParaRPr lang="en-US" sz="2800" dirty="0"/>
+              <a:t>AI receptionist</a:t>
+            </a:r>
+            <a:endParaRPr lang="en-US" sz="2500" dirty="0"/>
           </a:p>
           <a:p>
             <a:pPr algn="ctr" indent="0" marL="0">
               <a:buNone/>
             </a:pPr>
             <a:r>
-              <a:rPr lang="en-US" sz="2200" dirty="0">
+              <a:rPr lang="en-US" sz="1900" dirty="0">
                 <a:solidFill>
                   <a:srgbClr val="14213D"/>
                 </a:solidFill>
@@ -1984,21 +2817,21 @@
                 <a:ea typeface="Calibri" pitchFamily="34" charset="-122"/>
                 <a:cs typeface="Calibri" pitchFamily="34" charset="-120"/>
               </a:rPr>
-              <a:t>status and history</a:t>
-            </a:r>
-            <a:endParaRPr lang="en-US" sz="2800" dirty="0"/>
-          </a:p>
-        </p:txBody>
-      </p:sp>
-      <p:sp>
-        <p:nvSpPr>
-          <p:cNvPr id="29" name="Shape 26"/>
-          <p:cNvSpPr/>
-          <p:nvPr/>
-        </p:nvSpPr>
-        <p:spPr>
-          <a:xfrm>
-            <a:off x="4434840" y="15773400"/>
+              <a:t>FAQ, handoff, booking</a:t>
+            </a:r>
+            <a:endParaRPr lang="en-US" sz="2500" dirty="0"/>
+          </a:p>
+        </p:txBody>
+      </p:sp>
+      <p:sp>
+        <p:nvSpPr>
+          <p:cNvPr id="54" name="Shape 51"/>
+          <p:cNvSpPr/>
+          <p:nvPr/>
+        </p:nvSpPr>
+        <p:spPr>
+          <a:xfrm>
+            <a:off x="4434840" y="17305020"/>
             <a:ext cx="457200" cy="0"/>
           </a:xfrm>
           <a:prstGeom prst="line">
@@ -2016,13 +2849,13 @@
       </p:sp>
       <p:sp>
         <p:nvSpPr>
-          <p:cNvPr id="30" name="Shape 27"/>
-          <p:cNvSpPr/>
-          <p:nvPr/>
-        </p:nvSpPr>
-        <p:spPr>
-          <a:xfrm>
-            <a:off x="8458200" y="15773400"/>
+          <p:cNvPr id="55" name="Shape 52"/>
+          <p:cNvSpPr/>
+          <p:nvPr/>
+        </p:nvSpPr>
+        <p:spPr>
+          <a:xfrm>
+            <a:off x="8458200" y="17305020"/>
             <a:ext cx="457200" cy="0"/>
           </a:xfrm>
           <a:prstGeom prst="line">
@@ -2040,13 +2873,13 @@
       </p:sp>
       <p:sp>
         <p:nvSpPr>
-          <p:cNvPr id="31" name="Shape 28"/>
-          <p:cNvSpPr/>
-          <p:nvPr/>
-        </p:nvSpPr>
-        <p:spPr>
-          <a:xfrm>
-            <a:off x="12481560" y="15773400"/>
+          <p:cNvPr id="56" name="Shape 53"/>
+          <p:cNvSpPr/>
+          <p:nvPr/>
+        </p:nvSpPr>
+        <p:spPr>
+          <a:xfrm>
+            <a:off x="12481560" y="17305020"/>
             <a:ext cx="457200" cy="0"/>
           </a:xfrm>
           <a:prstGeom prst="line">
@@ -2064,13 +2897,13 @@
       </p:sp>
       <p:sp>
         <p:nvSpPr>
-          <p:cNvPr id="32" name="Shape 29"/>
-          <p:cNvSpPr/>
-          <p:nvPr/>
-        </p:nvSpPr>
-        <p:spPr>
-          <a:xfrm>
-            <a:off x="16504920" y="15773400"/>
+          <p:cNvPr id="57" name="Shape 54"/>
+          <p:cNvSpPr/>
+          <p:nvPr/>
+        </p:nvSpPr>
+        <p:spPr>
+          <a:xfrm>
+            <a:off x="16504920" y="17305020"/>
             <a:ext cx="457200" cy="0"/>
           </a:xfrm>
           <a:prstGeom prst="line">
@@ -2088,239 +2921,14 @@
       </p:sp>
       <p:sp>
         <p:nvSpPr>
-          <p:cNvPr id="33" name="Shape 30"/>
-          <p:cNvSpPr/>
-          <p:nvPr/>
-        </p:nvSpPr>
-        <p:spPr>
-          <a:xfrm>
-            <a:off x="914400" y="16916400"/>
-            <a:ext cx="9509760" cy="1371600"/>
-          </a:xfrm>
-          <a:prstGeom prst="roundRect">
-            <a:avLst>
-              <a:gd name="adj" fmla="val 8000"/>
-            </a:avLst>
-          </a:prstGeom>
-          <a:solidFill>
-            <a:srgbClr val="EEF1F6"/>
-          </a:solidFill>
-          <a:ln w="25400">
-            <a:solidFill>
-              <a:srgbClr val="1B2A49"/>
-            </a:solidFill>
-            <a:prstDash val="solid"/>
-          </a:ln>
-        </p:spPr>
-      </p:sp>
-      <p:sp>
-        <p:nvSpPr>
-          <p:cNvPr id="34" name="Text 31"/>
-          <p:cNvSpPr/>
-          <p:nvPr/>
-        </p:nvSpPr>
-        <p:spPr>
-          <a:xfrm>
-            <a:off x="1051560" y="16916400"/>
-            <a:ext cx="9235440" cy="1371600"/>
-          </a:xfrm>
-          <a:prstGeom prst="rect">
-            <a:avLst/>
-          </a:prstGeom>
-          <a:noFill/>
-          <a:ln/>
-        </p:spPr>
-        <p:txBody>
-          <a:bodyPr wrap="square" lIns="0" tIns="0" rIns="0" bIns="0" rtlCol="0" anchor="ctr"/>
-          <a:lstStyle/>
-          <a:p>
-            <a:pPr algn="ctr" indent="0" marL="0">
-              <a:buNone/>
-            </a:pPr>
-            <a:r>
-              <a:rPr lang="en-US" sz="2800" b="1" dirty="0">
-                <a:solidFill>
-                  <a:srgbClr val="1B2A49"/>
-                </a:solidFill>
-                <a:latin typeface="Calibri" pitchFamily="34" charset="0"/>
-                <a:ea typeface="Calibri" pitchFamily="34" charset="-122"/>
-                <a:cs typeface="Calibri" pitchFamily="34" charset="-120"/>
-              </a:rPr>
-              <a:t>AI receptionist</a:t>
-            </a:r>
-            <a:endParaRPr lang="en-US" sz="2800" dirty="0"/>
-          </a:p>
-          <a:p>
-            <a:pPr algn="ctr" indent="0" marL="0">
-              <a:buNone/>
-            </a:pPr>
-            <a:r>
-              <a:rPr lang="en-US" sz="2200" dirty="0">
-                <a:solidFill>
-                  <a:srgbClr val="14213D"/>
-                </a:solidFill>
-                <a:latin typeface="Calibri" pitchFamily="34" charset="0"/>
-                <a:ea typeface="Calibri" pitchFamily="34" charset="-122"/>
-                <a:cs typeface="Calibri" pitchFamily="34" charset="-120"/>
-              </a:rPr>
-              <a:t>FAQ, human handoff, booking, Claude</a:t>
-            </a:r>
-            <a:endParaRPr lang="en-US" sz="2800" dirty="0"/>
-          </a:p>
-        </p:txBody>
-      </p:sp>
-      <p:sp>
-        <p:nvSpPr>
-          <p:cNvPr id="35" name="Shape 32"/>
-          <p:cNvSpPr/>
-          <p:nvPr/>
-        </p:nvSpPr>
-        <p:spPr>
-          <a:xfrm>
-            <a:off x="10972800" y="16916400"/>
-            <a:ext cx="9509760" cy="1371600"/>
-          </a:xfrm>
-          <a:prstGeom prst="roundRect">
-            <a:avLst>
-              <a:gd name="adj" fmla="val 8000"/>
-            </a:avLst>
-          </a:prstGeom>
-          <a:solidFill>
-            <a:srgbClr val="EEF1F6"/>
-          </a:solidFill>
-          <a:ln w="25400">
-            <a:solidFill>
-              <a:srgbClr val="1B2A49"/>
-            </a:solidFill>
-            <a:prstDash val="solid"/>
-          </a:ln>
-        </p:spPr>
-      </p:sp>
-      <p:sp>
-        <p:nvSpPr>
-          <p:cNvPr id="36" name="Text 33"/>
-          <p:cNvSpPr/>
-          <p:nvPr/>
-        </p:nvSpPr>
-        <p:spPr>
-          <a:xfrm>
-            <a:off x="11109960" y="16916400"/>
-            <a:ext cx="9235440" cy="1371600"/>
-          </a:xfrm>
-          <a:prstGeom prst="rect">
-            <a:avLst/>
-          </a:prstGeom>
-          <a:noFill/>
-          <a:ln/>
-        </p:spPr>
-        <p:txBody>
-          <a:bodyPr wrap="square" lIns="0" tIns="0" rIns="0" bIns="0" rtlCol="0" anchor="ctr"/>
-          <a:lstStyle/>
-          <a:p>
-            <a:pPr algn="ctr" indent="0" marL="0">
-              <a:buNone/>
-            </a:pPr>
-            <a:r>
-              <a:rPr lang="en-US" sz="2800" b="1" dirty="0">
-                <a:solidFill>
-                  <a:srgbClr val="1B2A49"/>
-                </a:solidFill>
-                <a:latin typeface="Calibri" pitchFamily="34" charset="0"/>
-                <a:ea typeface="Calibri" pitchFamily="34" charset="-122"/>
-                <a:cs typeface="Calibri" pitchFamily="34" charset="-120"/>
-              </a:rPr>
-              <a:t>Call summaries</a:t>
-            </a:r>
-            <a:endParaRPr lang="en-US" sz="2800" dirty="0"/>
-          </a:p>
-          <a:p>
-            <a:pPr algn="ctr" indent="0" marL="0">
-              <a:buNone/>
-            </a:pPr>
-            <a:r>
-              <a:rPr lang="en-US" sz="2200" dirty="0">
-                <a:solidFill>
-                  <a:srgbClr val="14213D"/>
-                </a:solidFill>
-                <a:latin typeface="Calibri" pitchFamily="34" charset="0"/>
-                <a:ea typeface="Calibri" pitchFamily="34" charset="-122"/>
-                <a:cs typeface="Calibri" pitchFamily="34" charset="-120"/>
-              </a:rPr>
-              <a:t>sentiment and priority for the operator</a:t>
-            </a:r>
-            <a:endParaRPr lang="en-US" sz="2800" dirty="0"/>
-          </a:p>
-        </p:txBody>
-      </p:sp>
-      <p:sp>
-        <p:nvSpPr>
-          <p:cNvPr id="37" name="Shape 34"/>
-          <p:cNvSpPr/>
-          <p:nvPr/>
-        </p:nvSpPr>
-        <p:spPr>
-          <a:xfrm>
-            <a:off x="914400" y="18653760"/>
-            <a:ext cx="19568160" cy="868680"/>
-          </a:xfrm>
-          <a:prstGeom prst="rect">
-            <a:avLst/>
-          </a:prstGeom>
-          <a:solidFill>
-            <a:srgbClr val="EEF1F6"/>
-          </a:solidFill>
-          <a:ln/>
-        </p:spPr>
-      </p:sp>
-      <p:sp>
-        <p:nvSpPr>
-          <p:cNvPr id="38" name="Text 35"/>
-          <p:cNvSpPr/>
-          <p:nvPr/>
-        </p:nvSpPr>
-        <p:spPr>
-          <a:xfrm>
-            <a:off x="1188720" y="18653760"/>
-            <a:ext cx="19019520" cy="868680"/>
-          </a:xfrm>
-          <a:prstGeom prst="rect">
-            <a:avLst/>
-          </a:prstGeom>
-          <a:noFill/>
-          <a:ln/>
-        </p:spPr>
-        <p:txBody>
-          <a:bodyPr wrap="square" lIns="0" tIns="0" rIns="0" bIns="0" rtlCol="0" anchor="ctr"/>
-          <a:lstStyle/>
-          <a:p>
-            <a:pPr indent="0" marL="0">
-              <a:buNone/>
-            </a:pPr>
-            <a:r>
-              <a:rPr lang="en-US" sz="2600" b="1" dirty="0">
-                <a:solidFill>
-                  <a:srgbClr val="1B2A49"/>
-                </a:solidFill>
-                <a:latin typeface="Calibri" pitchFamily="34" charset="0"/>
-                <a:ea typeface="Calibri" pitchFamily="34" charset="-122"/>
-                <a:cs typeface="Calibri" pitchFamily="34" charset="-120"/>
-              </a:rPr>
-              <a:t>516 automated tests  ·  CI on every change  ·  signed webhooks  ·  a real call answered by voice</a:t>
-            </a:r>
-            <a:endParaRPr lang="en-US" sz="2600" dirty="0"/>
-          </a:p>
-        </p:txBody>
-      </p:sp>
-      <p:sp>
-        <p:nvSpPr>
-          <p:cNvPr id="39" name="Shape 36"/>
-          <p:cNvSpPr/>
-          <p:nvPr/>
-        </p:nvSpPr>
-        <p:spPr>
-          <a:xfrm>
-            <a:off x="914400" y="19979640"/>
-            <a:ext cx="777240" cy="777240"/>
+          <p:cNvPr id="58" name="Shape 55"/>
+          <p:cNvSpPr/>
+          <p:nvPr/>
+        </p:nvSpPr>
+        <p:spPr>
+          <a:xfrm>
+            <a:off x="914400" y="18498312"/>
+            <a:ext cx="731520" cy="731520"/>
           </a:xfrm>
           <a:prstGeom prst="ellipse">
             <a:avLst/>
@@ -2333,14 +2941,14 @@
       </p:sp>
       <p:sp>
         <p:nvSpPr>
-          <p:cNvPr id="40" name="Text 37"/>
-          <p:cNvSpPr/>
-          <p:nvPr/>
-        </p:nvSpPr>
-        <p:spPr>
-          <a:xfrm>
-            <a:off x="914400" y="19979640"/>
-            <a:ext cx="777240" cy="777240"/>
+          <p:cNvPr id="59" name="Text 56"/>
+          <p:cNvSpPr/>
+          <p:nvPr/>
+        </p:nvSpPr>
+        <p:spPr>
+          <a:xfrm>
+            <a:off x="914400" y="18498312"/>
+            <a:ext cx="731520" cy="731520"/>
           </a:xfrm>
           <a:prstGeom prst="rect">
             <a:avLst/>
@@ -2356,7 +2964,7 @@
               <a:buNone/>
             </a:pPr>
             <a:r>
-              <a:rPr lang="en-US" sz="3200" b="1" dirty="0">
+              <a:rPr lang="en-US" sz="3000" b="1" dirty="0">
                 <a:solidFill>
                   <a:srgbClr val="1B2A49"/>
                 </a:solidFill>
@@ -2366,20 +2974,20 @@
               </a:rPr>
               <a:t>3</a:t>
             </a:r>
-            <a:endParaRPr lang="en-US" sz="3200" dirty="0"/>
-          </a:p>
-        </p:txBody>
-      </p:sp>
-      <p:sp>
-        <p:nvSpPr>
-          <p:cNvPr id="41" name="Text 38"/>
-          <p:cNvSpPr/>
-          <p:nvPr/>
-        </p:nvSpPr>
-        <p:spPr>
-          <a:xfrm>
-            <a:off x="1920240" y="19933920"/>
-            <a:ext cx="18288000" cy="868680"/>
+            <a:endParaRPr lang="en-US" sz="3000" dirty="0"/>
+          </a:p>
+        </p:txBody>
+      </p:sp>
+      <p:sp>
+        <p:nvSpPr>
+          <p:cNvPr id="60" name="Text 57"/>
+          <p:cNvSpPr/>
+          <p:nvPr/>
+        </p:nvSpPr>
+        <p:spPr>
+          <a:xfrm>
+            <a:off x="1874520" y="18470880"/>
+            <a:ext cx="18562320" cy="822960"/>
           </a:xfrm>
           <a:prstGeom prst="rect">
             <a:avLst/>
@@ -2395,7 +3003,7 @@
               <a:buNone/>
             </a:pPr>
             <a:r>
-              <a:rPr lang="en-US" sz="4600" b="1" dirty="0">
+              <a:rPr lang="en-US" sz="4200" b="1" dirty="0">
                 <a:solidFill>
                   <a:srgbClr val="1B2A49"/>
                 </a:solidFill>
@@ -2403,26 +3011,26 @@
                 <a:ea typeface="Cambria" pitchFamily="34" charset="-122"/>
                 <a:cs typeface="Cambria" pitchFamily="34" charset="-120"/>
               </a:rPr>
-              <a:t>Roadmap and risks</a:t>
-            </a:r>
-            <a:endParaRPr lang="en-US" sz="4600" dirty="0"/>
-          </a:p>
-        </p:txBody>
-      </p:sp>
-      <p:sp>
-        <p:nvSpPr>
-          <p:cNvPr id="42" name="Shape 39"/>
-          <p:cNvSpPr/>
-          <p:nvPr/>
-        </p:nvSpPr>
-        <p:spPr>
-          <a:xfrm>
-            <a:off x="914400" y="20939760"/>
-            <a:ext cx="6309360" cy="3931920"/>
+              <a:t>Roadmap and problem solving</a:t>
+            </a:r>
+            <a:endParaRPr lang="en-US" sz="4200" dirty="0"/>
+          </a:p>
+        </p:txBody>
+      </p:sp>
+      <p:sp>
+        <p:nvSpPr>
+          <p:cNvPr id="61" name="Shape 58"/>
+          <p:cNvSpPr/>
+          <p:nvPr/>
+        </p:nvSpPr>
+        <p:spPr>
+          <a:xfrm>
+            <a:off x="914400" y="19431000"/>
+            <a:ext cx="6309360" cy="3017520"/>
           </a:xfrm>
           <a:prstGeom prst="roundRect">
             <a:avLst>
-              <a:gd name="adj" fmla="val 2791"/>
+              <a:gd name="adj" fmla="val 3636"/>
             </a:avLst>
           </a:prstGeom>
           <a:solidFill>
@@ -2438,14 +3046,14 @@
       </p:sp>
       <p:sp>
         <p:nvSpPr>
-          <p:cNvPr id="43" name="Text 40"/>
-          <p:cNvSpPr/>
-          <p:nvPr/>
-        </p:nvSpPr>
-        <p:spPr>
-          <a:xfrm>
-            <a:off x="1143000" y="21076920"/>
-            <a:ext cx="5852160" cy="548640"/>
+          <p:cNvPr id="62" name="Text 59"/>
+          <p:cNvSpPr/>
+          <p:nvPr/>
+        </p:nvSpPr>
+        <p:spPr>
+          <a:xfrm>
+            <a:off x="1143000" y="19540728"/>
+            <a:ext cx="5852160" cy="502920"/>
           </a:xfrm>
           <a:prstGeom prst="rect">
             <a:avLst/>
@@ -2461,7 +3069,7 @@
               <a:buNone/>
             </a:pPr>
             <a:r>
-              <a:rPr lang="en-US" sz="2800" b="1" dirty="0">
+              <a:rPr lang="en-US" sz="2500" b="1" dirty="0">
                 <a:solidFill>
                   <a:srgbClr val="2E7D5B"/>
                 </a:solidFill>
@@ -2469,22 +3077,22 @@
                 <a:ea typeface="Calibri" pitchFamily="34" charset="-122"/>
                 <a:cs typeface="Calibri" pitchFamily="34" charset="-120"/>
               </a:rPr>
-              <a:t>Live today</a:t>
-            </a:r>
-            <a:endParaRPr lang="en-US" sz="2800" dirty="0"/>
-          </a:p>
-        </p:txBody>
-      </p:sp>
-      <p:sp>
-        <p:nvSpPr>
-          <p:cNvPr id="44" name="Text 41"/>
-          <p:cNvSpPr/>
-          <p:nvPr/>
-        </p:nvSpPr>
-        <p:spPr>
-          <a:xfrm>
-            <a:off x="1143000" y="21717000"/>
-            <a:ext cx="5852160" cy="3017520"/>
+              <a:t>Finished and live</a:t>
+            </a:r>
+            <a:endParaRPr lang="en-US" sz="2500" dirty="0"/>
+          </a:p>
+        </p:txBody>
+      </p:sp>
+      <p:sp>
+        <p:nvSpPr>
+          <p:cNvPr id="63" name="Text 60"/>
+          <p:cNvSpPr/>
+          <p:nvPr/>
+        </p:nvSpPr>
+        <p:spPr>
+          <a:xfrm>
+            <a:off x="1143000" y="20116800"/>
+            <a:ext cx="5852160" cy="2240280"/>
           </a:xfrm>
           <a:prstGeom prst="rect">
             <a:avLst/>
@@ -2498,13 +3106,13 @@
           <a:p>
             <a:pPr marL="342900" indent="-342900">
               <a:spcAft>
-                <a:spcPts val="600"/>
+                <a:spcPts val="500"/>
               </a:spcAft>
               <a:buSzPct val="100000"/>
               <a:buChar char="•"/>
             </a:pPr>
             <a:r>
-              <a:rPr lang="en-US" sz="2800" dirty="0">
+              <a:rPr lang="en-US" sz="2200" dirty="0">
                 <a:solidFill>
                   <a:srgbClr val="14213D"/>
                 </a:solidFill>
@@ -2514,18 +3122,18 @@
               </a:rPr>
               <a:t>Accounts, contacts, CSV import</a:t>
             </a:r>
-            <a:endParaRPr lang="en-US" sz="2800" dirty="0"/>
+            <a:endParaRPr lang="en-US" sz="2200" dirty="0"/>
           </a:p>
           <a:p>
             <a:pPr marL="342900" indent="-342900">
               <a:spcAft>
-                <a:spcPts val="600"/>
+                <a:spcPts val="500"/>
               </a:spcAft>
               <a:buSzPct val="100000"/>
               <a:buChar char="•"/>
             </a:pPr>
             <a:r>
-              <a:rPr lang="en-US" sz="2800" dirty="0">
+              <a:rPr lang="en-US" sz="2200" dirty="0">
                 <a:solidFill>
                   <a:srgbClr val="14213D"/>
                 </a:solidFill>
@@ -2535,18 +3143,18 @@
               </a:rPr>
               <a:t>Consent rules and STOP</a:t>
             </a:r>
-            <a:endParaRPr lang="en-US" sz="2800" dirty="0"/>
+            <a:endParaRPr lang="en-US" sz="2200" dirty="0"/>
           </a:p>
           <a:p>
             <a:pPr marL="342900" indent="-342900">
               <a:spcAft>
-                <a:spcPts val="600"/>
+                <a:spcPts val="500"/>
               </a:spcAft>
               <a:buSzPct val="100000"/>
               <a:buChar char="•"/>
             </a:pPr>
             <a:r>
-              <a:rPr lang="en-US" sz="2800" dirty="0">
+              <a:rPr lang="en-US" sz="2200" dirty="0">
                 <a:solidFill>
                   <a:srgbClr val="14213D"/>
                 </a:solidFill>
@@ -2556,18 +3164,18 @@
               </a:rPr>
               <a:t>Reminders engine</a:t>
             </a:r>
-            <a:endParaRPr lang="en-US" sz="2800" dirty="0"/>
+            <a:endParaRPr lang="en-US" sz="2200" dirty="0"/>
           </a:p>
           <a:p>
             <a:pPr marL="342900" indent="-342900">
               <a:spcAft>
-                <a:spcPts val="600"/>
+                <a:spcPts val="500"/>
               </a:spcAft>
               <a:buSzPct val="100000"/>
               <a:buChar char="•"/>
             </a:pPr>
             <a:r>
-              <a:rPr lang="en-US" sz="2800" dirty="0">
+              <a:rPr lang="en-US" sz="2200" dirty="0">
                 <a:solidFill>
                   <a:srgbClr val="14213D"/>
                 </a:solidFill>
@@ -2575,26 +3183,26 @@
                 <a:ea typeface="Calibri" pitchFamily="34" charset="-122"/>
                 <a:cs typeface="Calibri" pitchFamily="34" charset="-120"/>
               </a:rPr>
-              <a:t>Voice receptionist on Render</a:t>
-            </a:r>
-            <a:endParaRPr lang="en-US" sz="2800" dirty="0"/>
-          </a:p>
-        </p:txBody>
-      </p:sp>
-      <p:sp>
-        <p:nvSpPr>
-          <p:cNvPr id="45" name="Shape 42"/>
-          <p:cNvSpPr/>
-          <p:nvPr/>
-        </p:nvSpPr>
-        <p:spPr>
-          <a:xfrm>
-            <a:off x="7543800" y="20939760"/>
-            <a:ext cx="6309360" cy="3931920"/>
+              <a:t>Voice receptionist</a:t>
+            </a:r>
+            <a:endParaRPr lang="en-US" sz="2200" dirty="0"/>
+          </a:p>
+        </p:txBody>
+      </p:sp>
+      <p:sp>
+        <p:nvSpPr>
+          <p:cNvPr id="64" name="Shape 61"/>
+          <p:cNvSpPr/>
+          <p:nvPr/>
+        </p:nvSpPr>
+        <p:spPr>
+          <a:xfrm>
+            <a:off x="7543800" y="19431000"/>
+            <a:ext cx="6309360" cy="3017520"/>
           </a:xfrm>
           <a:prstGeom prst="roundRect">
             <a:avLst>
-              <a:gd name="adj" fmla="val 2791"/>
+              <a:gd name="adj" fmla="val 3636"/>
             </a:avLst>
           </a:prstGeom>
           <a:solidFill>
@@ -2610,14 +3218,14 @@
       </p:sp>
       <p:sp>
         <p:nvSpPr>
-          <p:cNvPr id="46" name="Text 43"/>
-          <p:cNvSpPr/>
-          <p:nvPr/>
-        </p:nvSpPr>
-        <p:spPr>
-          <a:xfrm>
-            <a:off x="7772400" y="21076920"/>
-            <a:ext cx="5852160" cy="548640"/>
+          <p:cNvPr id="65" name="Text 62"/>
+          <p:cNvSpPr/>
+          <p:nvPr/>
+        </p:nvSpPr>
+        <p:spPr>
+          <a:xfrm>
+            <a:off x="7772400" y="19540728"/>
+            <a:ext cx="5852160" cy="502920"/>
           </a:xfrm>
           <a:prstGeom prst="rect">
             <a:avLst/>
@@ -2633,7 +3241,7 @@
               <a:buNone/>
             </a:pPr>
             <a:r>
-              <a:rPr lang="en-US" sz="2800" b="1" dirty="0">
+              <a:rPr lang="en-US" sz="2500" b="1" dirty="0">
                 <a:solidFill>
                   <a:srgbClr val="A9701B"/>
                 </a:solidFill>
@@ -2641,22 +3249,22 @@
                 <a:ea typeface="Calibri" pitchFamily="34" charset="-122"/>
                 <a:cs typeface="Calibri" pitchFamily="34" charset="-120"/>
               </a:rPr>
-              <a:t>Built, ships with next deploy</a:t>
-            </a:r>
-            <a:endParaRPr lang="en-US" sz="2800" dirty="0"/>
-          </a:p>
-        </p:txBody>
-      </p:sp>
-      <p:sp>
-        <p:nvSpPr>
-          <p:cNvPr id="47" name="Text 44"/>
-          <p:cNvSpPr/>
-          <p:nvPr/>
-        </p:nvSpPr>
-        <p:spPr>
-          <a:xfrm>
-            <a:off x="7772400" y="21717000"/>
-            <a:ext cx="5852160" cy="3017520"/>
+              <a:t>Built, going live at next deploy</a:t>
+            </a:r>
+            <a:endParaRPr lang="en-US" sz="2500" dirty="0"/>
+          </a:p>
+        </p:txBody>
+      </p:sp>
+      <p:sp>
+        <p:nvSpPr>
+          <p:cNvPr id="66" name="Text 63"/>
+          <p:cNvSpPr/>
+          <p:nvPr/>
+        </p:nvSpPr>
+        <p:spPr>
+          <a:xfrm>
+            <a:off x="7772400" y="20116800"/>
+            <a:ext cx="5852160" cy="2240280"/>
           </a:xfrm>
           <a:prstGeom prst="rect">
             <a:avLst/>
@@ -2670,13 +3278,13 @@
           <a:p>
             <a:pPr marL="342900" indent="-342900">
               <a:spcAft>
-                <a:spcPts val="600"/>
+                <a:spcPts val="500"/>
               </a:spcAft>
               <a:buSzPct val="100000"/>
               <a:buChar char="•"/>
             </a:pPr>
             <a:r>
-              <a:rPr lang="en-US" sz="2800" dirty="0">
+              <a:rPr lang="en-US" sz="2200" dirty="0">
                 <a:solidFill>
                   <a:srgbClr val="14213D"/>
                 </a:solidFill>
@@ -2686,18 +3294,18 @@
               </a:rPr>
               <a:t>Recurrence, pause, templates</a:t>
             </a:r>
-            <a:endParaRPr lang="en-US" sz="2800" dirty="0"/>
+            <a:endParaRPr lang="en-US" sz="2200" dirty="0"/>
           </a:p>
           <a:p>
             <a:pPr marL="342900" indent="-342900">
               <a:spcAft>
-                <a:spcPts val="600"/>
+                <a:spcPts val="500"/>
               </a:spcAft>
               <a:buSzPct val="100000"/>
               <a:buChar char="•"/>
             </a:pPr>
             <a:r>
-              <a:rPr lang="en-US" sz="2800" dirty="0">
+              <a:rPr lang="en-US" sz="2200" dirty="0">
                 <a:solidFill>
                   <a:srgbClr val="14213D"/>
                 </a:solidFill>
@@ -2705,20 +3313,20 @@
                 <a:ea typeface="Calibri" pitchFamily="34" charset="-122"/>
                 <a:cs typeface="Calibri" pitchFamily="34" charset="-120"/>
               </a:rPr>
-              <a:t>Merge fields, rescheduling</a:t>
-            </a:r>
-            <a:endParaRPr lang="en-US" sz="2800" dirty="0"/>
+              <a:t>Rescheduling, call summaries</a:t>
+            </a:r>
+            <a:endParaRPr lang="en-US" sz="2200" dirty="0"/>
           </a:p>
           <a:p>
             <a:pPr marL="342900" indent="-342900">
               <a:spcAft>
-                <a:spcPts val="600"/>
+                <a:spcPts val="500"/>
               </a:spcAft>
               <a:buSzPct val="100000"/>
               <a:buChar char="•"/>
             </a:pPr>
             <a:r>
-              <a:rPr lang="en-US" sz="2800" dirty="0">
+              <a:rPr lang="en-US" sz="2200" dirty="0">
                 <a:solidFill>
                   <a:srgbClr val="14213D"/>
                 </a:solidFill>
@@ -2726,20 +3334,20 @@
                 <a:ea typeface="Calibri" pitchFamily="34" charset="-122"/>
                 <a:cs typeface="Calibri" pitchFamily="34" charset="-120"/>
               </a:rPr>
-              <a:t>Call summaries, booking with FAQ</a:t>
-            </a:r>
-            <a:endParaRPr lang="en-US" sz="2800" dirty="0"/>
+              <a:t>Roles, API keys, exports</a:t>
+            </a:r>
+            <a:endParaRPr lang="en-US" sz="2200" dirty="0"/>
           </a:p>
           <a:p>
             <a:pPr marL="342900" indent="-342900">
               <a:spcAft>
-                <a:spcPts val="600"/>
+                <a:spcPts val="500"/>
               </a:spcAft>
               <a:buSzPct val="100000"/>
               <a:buChar char="•"/>
             </a:pPr>
             <a:r>
-              <a:rPr lang="en-US" sz="2800" dirty="0">
+              <a:rPr lang="en-US" sz="2200" dirty="0">
                 <a:solidFill>
                   <a:srgbClr val="14213D"/>
                 </a:solidFill>
@@ -2747,26 +3355,26 @@
                 <a:ea typeface="Calibri" pitchFamily="34" charset="-122"/>
                 <a:cs typeface="Calibri" pitchFamily="34" charset="-120"/>
               </a:rPr>
-              <a:t>Roles, API keys, CSV export</a:t>
-            </a:r>
-            <a:endParaRPr lang="en-US" sz="2800" dirty="0"/>
-          </a:p>
-        </p:txBody>
-      </p:sp>
-      <p:sp>
-        <p:nvSpPr>
-          <p:cNvPr id="48" name="Shape 45"/>
-          <p:cNvSpPr/>
-          <p:nvPr/>
-        </p:nvSpPr>
-        <p:spPr>
-          <a:xfrm>
-            <a:off x="14173200" y="20939760"/>
-            <a:ext cx="6309360" cy="3931920"/>
+              <a:t>Per-organisation data</a:t>
+            </a:r>
+            <a:endParaRPr lang="en-US" sz="2200" dirty="0"/>
+          </a:p>
+        </p:txBody>
+      </p:sp>
+      <p:sp>
+        <p:nvSpPr>
+          <p:cNvPr id="67" name="Shape 64"/>
+          <p:cNvSpPr/>
+          <p:nvPr/>
+        </p:nvSpPr>
+        <p:spPr>
+          <a:xfrm>
+            <a:off x="14173200" y="19431000"/>
+            <a:ext cx="6309360" cy="3017520"/>
           </a:xfrm>
           <a:prstGeom prst="roundRect">
             <a:avLst>
-              <a:gd name="adj" fmla="val 2791"/>
+              <a:gd name="adj" fmla="val 3636"/>
             </a:avLst>
           </a:prstGeom>
           <a:solidFill>
@@ -2782,14 +3390,14 @@
       </p:sp>
       <p:sp>
         <p:nvSpPr>
-          <p:cNvPr id="49" name="Text 46"/>
-          <p:cNvSpPr/>
-          <p:nvPr/>
-        </p:nvSpPr>
-        <p:spPr>
-          <a:xfrm>
-            <a:off x="14401800" y="21076920"/>
-            <a:ext cx="5852160" cy="548640"/>
+          <p:cNvPr id="68" name="Text 65"/>
+          <p:cNvSpPr/>
+          <p:nvPr/>
+        </p:nvSpPr>
+        <p:spPr>
+          <a:xfrm>
+            <a:off x="14401800" y="19540728"/>
+            <a:ext cx="5852160" cy="502920"/>
           </a:xfrm>
           <a:prstGeom prst="rect">
             <a:avLst/>
@@ -2805,7 +3413,7 @@
               <a:buNone/>
             </a:pPr>
             <a:r>
-              <a:rPr lang="en-US" sz="2800" b="1" dirty="0">
+              <a:rPr lang="en-US" sz="2500" b="1" dirty="0">
                 <a:solidFill>
                   <a:srgbClr val="1B2A49"/>
                 </a:solidFill>
@@ -2813,22 +3421,22 @@
                 <a:ea typeface="Calibri" pitchFamily="34" charset="-122"/>
                 <a:cs typeface="Calibri" pitchFamily="34" charset="-120"/>
               </a:rPr>
-              <a:t>Next, highest priority first</a:t>
-            </a:r>
-            <a:endParaRPr lang="en-US" sz="2800" dirty="0"/>
-          </a:p>
-        </p:txBody>
-      </p:sp>
-      <p:sp>
-        <p:nvSpPr>
-          <p:cNvPr id="50" name="Text 47"/>
-          <p:cNvSpPr/>
-          <p:nvPr/>
-        </p:nvSpPr>
-        <p:spPr>
-          <a:xfrm>
-            <a:off x="14401800" y="21717000"/>
-            <a:ext cx="5852160" cy="3017520"/>
+              <a:t>Still to do</a:t>
+            </a:r>
+            <a:endParaRPr lang="en-US" sz="2500" dirty="0"/>
+          </a:p>
+        </p:txBody>
+      </p:sp>
+      <p:sp>
+        <p:nvSpPr>
+          <p:cNvPr id="69" name="Text 66"/>
+          <p:cNvSpPr/>
+          <p:nvPr/>
+        </p:nvSpPr>
+        <p:spPr>
+          <a:xfrm>
+            <a:off x="14401800" y="20116800"/>
+            <a:ext cx="5852160" cy="2240280"/>
           </a:xfrm>
           <a:prstGeom prst="rect">
             <a:avLst/>
@@ -2842,13 +3450,13 @@
           <a:p>
             <a:pPr marL="342900" indent="-342900">
               <a:spcAft>
-                <a:spcPts val="600"/>
+                <a:spcPts val="500"/>
               </a:spcAft>
               <a:buSzPct val="100000"/>
               <a:buChar char="•"/>
             </a:pPr>
             <a:r>
-              <a:rPr lang="en-US" sz="2800" dirty="0">
+              <a:rPr lang="en-US" sz="2200" dirty="0">
                 <a:solidFill>
                   <a:srgbClr val="14213D"/>
                 </a:solidFill>
@@ -2856,20 +3464,20 @@
                 <a:ea typeface="Calibri" pitchFamily="34" charset="-122"/>
                 <a:cs typeface="Calibri" pitchFamily="34" charset="-120"/>
               </a:rPr>
-              <a:t>Email and SMS proven end to end</a:t>
-            </a:r>
-            <a:endParaRPr lang="en-US" sz="2800" dirty="0"/>
+              <a:t>SMS: waiting on carrier approval</a:t>
+            </a:r>
+            <a:endParaRPr lang="en-US" sz="2200" dirty="0"/>
           </a:p>
           <a:p>
             <a:pPr marL="342900" indent="-342900">
               <a:spcAft>
-                <a:spcPts val="600"/>
+                <a:spcPts val="500"/>
               </a:spcAft>
               <a:buSzPct val="100000"/>
               <a:buChar char="•"/>
             </a:pPr>
             <a:r>
-              <a:rPr lang="en-US" sz="2800" dirty="0">
+              <a:rPr lang="en-US" sz="2200" dirty="0">
                 <a:solidFill>
                   <a:srgbClr val="14213D"/>
                 </a:solidFill>
@@ -2877,20 +3485,20 @@
                 <a:ea typeface="Calibri" pitchFamily="34" charset="-122"/>
                 <a:cs typeface="Calibri" pitchFamily="34" charset="-120"/>
               </a:rPr>
-              <a:t>Marketing site rework live</a:t>
-            </a:r>
-            <a:endParaRPr lang="en-US" sz="2800" dirty="0"/>
+              <a:t>On-premise Mac mini host</a:t>
+            </a:r>
+            <a:endParaRPr lang="en-US" sz="2200" dirty="0"/>
           </a:p>
           <a:p>
             <a:pPr marL="342900" indent="-342900">
               <a:spcAft>
-                <a:spcPts val="600"/>
+                <a:spcPts val="500"/>
               </a:spcAft>
               <a:buSzPct val="100000"/>
               <a:buChar char="•"/>
             </a:pPr>
             <a:r>
-              <a:rPr lang="en-US" sz="2800" dirty="0">
+              <a:rPr lang="en-US" sz="2200" dirty="0">
                 <a:solidFill>
                   <a:srgbClr val="14213D"/>
                 </a:solidFill>
@@ -2900,18 +3508,18 @@
               </a:rPr>
               <a:t>Recordings, handover pack</a:t>
             </a:r>
-            <a:endParaRPr lang="en-US" sz="2800" dirty="0"/>
+            <a:endParaRPr lang="en-US" sz="2200" dirty="0"/>
           </a:p>
           <a:p>
             <a:pPr marL="342900" indent="-342900">
               <a:spcAft>
-                <a:spcPts val="600"/>
+                <a:spcPts val="500"/>
               </a:spcAft>
               <a:buSzPct val="100000"/>
               <a:buChar char="•"/>
             </a:pPr>
             <a:r>
-              <a:rPr lang="en-US" sz="2800" dirty="0">
+              <a:rPr lang="en-US" sz="2200" dirty="0">
                 <a:solidFill>
                   <a:srgbClr val="14213D"/>
                 </a:solidFill>
@@ -2919,9 +3527,234 @@
                 <a:ea typeface="Calibri" pitchFamily="34" charset="-122"/>
                 <a:cs typeface="Calibri" pitchFamily="34" charset="-120"/>
               </a:rPr>
-              <a:t>Client feedback on the poster</a:t>
-            </a:r>
-            <a:endParaRPr lang="en-US" sz="2800" dirty="0"/>
+              <a:t>Client feedback</a:t>
+            </a:r>
+            <a:endParaRPr lang="en-US" sz="2200" dirty="0"/>
+          </a:p>
+        </p:txBody>
+      </p:sp>
+      <p:sp>
+        <p:nvSpPr>
+          <p:cNvPr id="70" name="Shape 67"/>
+          <p:cNvSpPr/>
+          <p:nvPr/>
+        </p:nvSpPr>
+        <p:spPr>
+          <a:xfrm>
+            <a:off x="914400" y="22631400"/>
+            <a:ext cx="19568160" cy="1371600"/>
+          </a:xfrm>
+          <a:prstGeom prst="roundRect">
+            <a:avLst>
+              <a:gd name="adj" fmla="val 6667"/>
+            </a:avLst>
+          </a:prstGeom>
+          <a:solidFill>
+            <a:srgbClr val="EEF1F6"/>
+          </a:solidFill>
+          <a:ln w="12700">
+            <a:solidFill>
+              <a:srgbClr val="EEF1F6"/>
+            </a:solidFill>
+            <a:prstDash val="solid"/>
+          </a:ln>
+        </p:spPr>
+      </p:sp>
+      <p:sp>
+        <p:nvSpPr>
+          <p:cNvPr id="71" name="Text 68"/>
+          <p:cNvSpPr/>
+          <p:nvPr/>
+        </p:nvSpPr>
+        <p:spPr>
+          <a:xfrm>
+            <a:off x="1188720" y="22631400"/>
+            <a:ext cx="19019520" cy="1371600"/>
+          </a:xfrm>
+          <a:prstGeom prst="rect">
+            <a:avLst/>
+          </a:prstGeom>
+          <a:noFill/>
+          <a:ln/>
+        </p:spPr>
+        <p:txBody>
+          <a:bodyPr wrap="square" lIns="0" tIns="0" rIns="0" bIns="0" rtlCol="0" anchor="ctr"/>
+          <a:lstStyle/>
+          <a:p>
+            <a:pPr indent="0" marL="0">
+              <a:buNone/>
+            </a:pPr>
+            <a:r>
+              <a:rPr lang="en-US" sz="2100" b="1" dirty="0">
+                <a:solidFill>
+                  <a:srgbClr val="1B2A49"/>
+                </a:solidFill>
+                <a:latin typeface="Calibri" pitchFamily="34" charset="0"/>
+                <a:ea typeface="Calibri" pitchFamily="34" charset="-122"/>
+                <a:cs typeface="Calibri" pitchFamily="34" charset="-120"/>
+              </a:rPr>
+              <a:t>Path to completion:  </a:t>
+            </a:r>
+            <a:pPr indent="0" marL="0">
+              <a:buNone/>
+            </a:pPr>
+            <a:r>
+              <a:rPr lang="en-US" sz="2100" dirty="0">
+                <a:solidFill>
+                  <a:srgbClr val="14213D"/>
+                </a:solidFill>
+                <a:latin typeface="Calibri" pitchFamily="34" charset="0"/>
+                <a:ea typeface="Calibri" pitchFamily="34" charset="-122"/>
+                <a:cs typeface="Calibri" pitchFamily="34" charset="-120"/>
+              </a:rPr>
+              <a:t>redeploy and live test call (Dilraj)  →  SMS approval (Prabhjot)  →  Mac mini host (Dilraj)  →  recordings and handover pack (all)  →  journals and interviews (everyone)</a:t>
+            </a:r>
+            <a:endParaRPr lang="en-US" sz="2100" dirty="0"/>
+          </a:p>
+        </p:txBody>
+      </p:sp>
+      <p:sp>
+        <p:nvSpPr>
+          <p:cNvPr id="72" name="Text 69"/>
+          <p:cNvSpPr/>
+          <p:nvPr/>
+        </p:nvSpPr>
+        <p:spPr>
+          <a:xfrm>
+            <a:off x="914400" y="24185880"/>
+            <a:ext cx="9509760" cy="502920"/>
+          </a:xfrm>
+          <a:prstGeom prst="rect">
+            <a:avLst/>
+          </a:prstGeom>
+          <a:noFill/>
+          <a:ln/>
+        </p:spPr>
+        <p:txBody>
+          <a:bodyPr wrap="square" lIns="0" tIns="0" rIns="0" bIns="0" rtlCol="0" anchor="ctr"/>
+          <a:lstStyle/>
+          <a:p>
+            <a:pPr indent="0" marL="0">
+              <a:buNone/>
+            </a:pPr>
+            <a:r>
+              <a:rPr lang="en-US" sz="2500" b="1" dirty="0">
+                <a:solidFill>
+                  <a:srgbClr val="C9A227"/>
+                </a:solidFill>
+                <a:latin typeface="Calibri" pitchFamily="34" charset="0"/>
+                <a:ea typeface="Calibri" pitchFamily="34" charset="-122"/>
+                <a:cs typeface="Calibri" pitchFamily="34" charset="-120"/>
+              </a:rPr>
+              <a:t>Problems we found and fixed</a:t>
+            </a:r>
+            <a:endParaRPr lang="en-US" sz="2500" dirty="0"/>
+          </a:p>
+        </p:txBody>
+      </p:sp>
+      <p:sp>
+        <p:nvSpPr>
+          <p:cNvPr id="73" name="Text 70"/>
+          <p:cNvSpPr/>
+          <p:nvPr/>
+        </p:nvSpPr>
+        <p:spPr>
+          <a:xfrm>
+            <a:off x="914400" y="24734520"/>
+            <a:ext cx="9509760" cy="2834640"/>
+          </a:xfrm>
+          <a:prstGeom prst="rect">
+            <a:avLst/>
+          </a:prstGeom>
+          <a:noFill/>
+          <a:ln/>
+        </p:spPr>
+        <p:txBody>
+          <a:bodyPr wrap="square" lIns="0" tIns="0" rIns="0" bIns="0" rtlCol="0" anchor="t"/>
+          <a:lstStyle/>
+          <a:p>
+            <a:pPr marL="342900" indent="-342900">
+              <a:spcAft>
+                <a:spcPts val="500"/>
+              </a:spcAft>
+              <a:buSzPct val="100000"/>
+              <a:buChar char="•"/>
+            </a:pPr>
+            <a:r>
+              <a:rPr lang="en-US" sz="2000" dirty="0">
+                <a:solidFill>
+                  <a:srgbClr val="14213D"/>
+                </a:solidFill>
+                <a:latin typeface="Calibri" pitchFamily="34" charset="0"/>
+                <a:ea typeface="Calibri" pitchFamily="34" charset="-122"/>
+                <a:cs typeface="Calibri" pitchFamily="34" charset="-120"/>
+              </a:rPr>
+              <a:t>Gmail dropped our connection: fixed the hostname we announce</a:t>
+            </a:r>
+            <a:endParaRPr lang="en-US" sz="2000" dirty="0"/>
+          </a:p>
+          <a:p>
+            <a:pPr marL="342900" indent="-342900">
+              <a:spcAft>
+                <a:spcPts val="500"/>
+              </a:spcAft>
+              <a:buSzPct val="100000"/>
+              <a:buChar char="•"/>
+            </a:pPr>
+            <a:r>
+              <a:rPr lang="en-US" sz="2000" dirty="0">
+                <a:solidFill>
+                  <a:srgbClr val="14213D"/>
+                </a:solidFill>
+                <a:latin typeface="Calibri" pitchFamily="34" charset="0"/>
+                <a:ea typeface="Calibri" pitchFamily="34" charset="-122"/>
+                <a:cs typeface="Calibri" pitchFamily="34" charset="-120"/>
+              </a:rPr>
+              <a:t>Forged calls could reach the receptionist: every webhook is signature-checked</a:t>
+            </a:r>
+            <a:endParaRPr lang="en-US" sz="2000" dirty="0"/>
+          </a:p>
+          <a:p>
+            <a:pPr marL="342900" indent="-342900">
+              <a:spcAft>
+                <a:spcPts val="500"/>
+              </a:spcAft>
+              <a:buSzPct val="100000"/>
+              <a:buChar char="•"/>
+            </a:pPr>
+            <a:r>
+              <a:rPr lang="en-US" sz="2000" dirty="0">
+                <a:solidFill>
+                  <a:srgbClr val="14213D"/>
+                </a:solidFill>
+                <a:latin typeface="Calibri" pitchFamily="34" charset="0"/>
+                <a:ea typeface="Calibri" pitchFamily="34" charset="-122"/>
+                <a:cs typeface="Calibri" pitchFamily="34" charset="-120"/>
+              </a:rPr>
+              <a:t>Dashboard counted every call turn as a call: counts real calls</a:t>
+            </a:r>
+            <a:endParaRPr lang="en-US" sz="2000" dirty="0"/>
+          </a:p>
+          <a:p>
+            <a:pPr marL="342900" indent="-342900">
+              <a:spcAft>
+                <a:spcPts val="500"/>
+              </a:spcAft>
+              <a:buSzPct val="100000"/>
+              <a:buChar char="•"/>
+            </a:pPr>
+            <a:r>
+              <a:rPr lang="en-US" sz="2000" dirty="0">
+                <a:solidFill>
+                  <a:srgbClr val="14213D"/>
+                </a:solidFill>
+                <a:latin typeface="Calibri" pitchFamily="34" charset="0"/>
+                <a:ea typeface="Calibri" pitchFamily="34" charset="-122"/>
+                <a:cs typeface="Calibri" pitchFamily="34" charset="-120"/>
+              </a:rPr>
+              <a:t>Dashboard showed invented rates: now live data only</a:t>
+            </a:r>
+            <a:endParaRPr lang="en-US" sz="2000" dirty="0"/>
           </a:p>
         </p:txBody>
       </p:sp>
@@ -2940,18 +3773,18 @@
           </p:nvPr>
         </p:nvGraphicFramePr>
         <p:xfrm>
-          <a:off x="914400" y="25054560"/>
-          <a:ext cx="19568160" cy="914400"/>
+          <a:off x="10881360" y="24231600"/>
+          <a:ext cx="9601200" cy="914400"/>
         </p:xfrm>
         <a:graphic>
           <a:graphicData uri="http://schemas.openxmlformats.org/drawingml/2006/table">
             <a:tbl>
               <a:tblPr/>
               <a:tblGrid>
-                <a:gridCol w="8595360"/>
-                <a:gridCol w="10972800"/>
+                <a:gridCol w="4754880"/>
+                <a:gridCol w="4846320"/>
               </a:tblGrid>
-              <a:tr h="530352">
+              <a:tr h="566928">
                 <a:tc>
                   <a:txBody>
                     <a:bodyPr/>
@@ -2961,7 +3794,7 @@
                         <a:buNone/>
                       </a:pPr>
                       <a:r>
-                        <a:rPr lang="en-US" sz="2600" b="1" dirty="0">
+                        <a:rPr lang="en-US" sz="1900" b="1" dirty="0">
                           <a:solidFill>
                             <a:srgbClr val="FFFFFF"/>
                           </a:solidFill>
@@ -2971,14 +3804,14 @@
                         </a:rPr>
                         <a:t>Risk</a:t>
                       </a:r>
-                      <a:endParaRPr lang="en-US" sz="2600" dirty="0">
+                      <a:endParaRPr lang="en-US" sz="1900" dirty="0">
                         <a:latin typeface="Calibri" charset="0"/>
                         <a:ea typeface="Calibri" charset="0"/>
                         <a:cs typeface="Calibri" charset="0"/>
                       </a:endParaRPr>
                     </a:p>
                   </a:txBody>
-                  <a:tcPr marL="137160" marR="137160" marT="0" marB="0" anchor="ctr">
+                  <a:tcPr marL="109728" marR="109728" marT="0" marB="0" anchor="ctr">
                     <a:lnL w="12700" cap="flat" cmpd="sng" algn="ctr">
                       <a:solidFill>
                         <a:srgbClr val="C9D0E0"/>
@@ -3029,7 +3862,7 @@
                         <a:buNone/>
                       </a:pPr>
                       <a:r>
-                        <a:rPr lang="en-US" sz="2600" b="1" dirty="0">
+                        <a:rPr lang="en-US" sz="1900" b="1" dirty="0">
                           <a:solidFill>
                             <a:srgbClr val="FFFFFF"/>
                           </a:solidFill>
@@ -3039,14 +3872,14 @@
                         </a:rPr>
                         <a:t>What we are doing</a:t>
                       </a:r>
-                      <a:endParaRPr lang="en-US" sz="2600" dirty="0">
+                      <a:endParaRPr lang="en-US" sz="1900" dirty="0">
                         <a:latin typeface="Calibri" charset="0"/>
                         <a:ea typeface="Calibri" charset="0"/>
                         <a:cs typeface="Calibri" charset="0"/>
                       </a:endParaRPr>
                     </a:p>
                   </a:txBody>
-                  <a:tcPr marL="137160" marR="137160" marT="0" marB="0" anchor="ctr">
+                  <a:tcPr marL="109728" marR="109728" marT="0" marB="0" anchor="ctr">
                     <a:lnL w="12700" cap="flat" cmpd="sng" algn="ctr">
                       <a:solidFill>
                         <a:srgbClr val="C9D0E0"/>
@@ -3089,7 +3922,7 @@
                   </a:tcPr>
                 </a:tc>
               </a:tr>
-              <a:tr h="530352">
+              <a:tr h="566928">
                 <a:tc>
                   <a:txBody>
                     <a:bodyPr/>
@@ -3099,7 +3932,7 @@
                         <a:buNone/>
                       </a:pPr>
                       <a:r>
-                        <a:rPr lang="en-US" sz="2600" dirty="0">
+                        <a:rPr lang="en-US" sz="1900" dirty="0">
                           <a:solidFill>
                             <a:srgbClr val="14213D"/>
                           </a:solidFill>
@@ -3109,14 +3942,14 @@
                         </a:rPr>
                         <a:t>SMS blocked by carrier registration</a:t>
                       </a:r>
-                      <a:endParaRPr lang="en-US" sz="2600" dirty="0">
+                      <a:endParaRPr lang="en-US" sz="1900" dirty="0">
                         <a:latin typeface="Calibri" charset="0"/>
                         <a:ea typeface="Calibri" charset="0"/>
                         <a:cs typeface="Calibri" charset="0"/>
                       </a:endParaRPr>
                     </a:p>
                   </a:txBody>
-                  <a:tcPr marL="137160" marR="137160" marT="0" marB="0" anchor="ctr">
+                  <a:tcPr marL="109728" marR="109728" marT="0" marB="0" anchor="ctr">
                     <a:lnL w="12700" cap="flat" cmpd="sng" algn="ctr">
                       <a:solidFill>
                         <a:srgbClr val="C9D0E0"/>
@@ -3167,7 +4000,7 @@
                         <a:buNone/>
                       </a:pPr>
                       <a:r>
-                        <a:rPr lang="en-US" sz="2600" dirty="0">
+                        <a:rPr lang="en-US" sz="1900" dirty="0">
                           <a:solidFill>
                             <a:srgbClr val="14213D"/>
                           </a:solidFill>
@@ -3175,16 +4008,16 @@
                           <a:ea typeface="Calibri" pitchFamily="34" charset="-122"/>
                           <a:cs typeface="Calibri" pitchFamily="34" charset="-120"/>
                         </a:rPr>
-                        <a:t>Demo voice, email and dashboard; explain it</a:t>
+                        <a:t>Registration submitted; demo voice and email</a:t>
                       </a:r>
-                      <a:endParaRPr lang="en-US" sz="2600" dirty="0">
+                      <a:endParaRPr lang="en-US" sz="1900" dirty="0">
                         <a:latin typeface="Calibri" charset="0"/>
                         <a:ea typeface="Calibri" charset="0"/>
                         <a:cs typeface="Calibri" charset="0"/>
                       </a:endParaRPr>
                     </a:p>
                   </a:txBody>
-                  <a:tcPr marL="137160" marR="137160" marT="0" marB="0" anchor="ctr">
+                  <a:tcPr marL="109728" marR="109728" marT="0" marB="0" anchor="ctr">
                     <a:lnL w="12700" cap="flat" cmpd="sng" algn="ctr">
                       <a:solidFill>
                         <a:srgbClr val="C9D0E0"/>
@@ -3227,7 +4060,7 @@
                   </a:tcPr>
                 </a:tc>
               </a:tr>
-              <a:tr h="530352">
+              <a:tr h="566928">
                 <a:tc>
                   <a:txBody>
                     <a:bodyPr/>
@@ -3237,7 +4070,7 @@
                         <a:buNone/>
                       </a:pPr>
                       <a:r>
-                        <a:rPr lang="en-US" sz="2600" dirty="0">
+                        <a:rPr lang="en-US" sz="1900" dirty="0">
                           <a:solidFill>
                             <a:srgbClr val="14213D"/>
                           </a:solidFill>
@@ -3245,16 +4078,16 @@
                           <a:ea typeface="Calibri" pitchFamily="34" charset="-122"/>
                           <a:cs typeface="Calibri" pitchFamily="34" charset="-120"/>
                         </a:rPr>
-                        <a:t>Free host sleeps and loses data</a:t>
+                        <a:t>Free host sleeps between visits</a:t>
                       </a:r>
-                      <a:endParaRPr lang="en-US" sz="2600" dirty="0">
+                      <a:endParaRPr lang="en-US" sz="1900" dirty="0">
                         <a:latin typeface="Calibri" charset="0"/>
                         <a:ea typeface="Calibri" charset="0"/>
                         <a:cs typeface="Calibri" charset="0"/>
                       </a:endParaRPr>
                     </a:p>
                   </a:txBody>
-                  <a:tcPr marL="137160" marR="137160" marT="0" marB="0" anchor="ctr">
+                  <a:tcPr marL="109728" marR="109728" marT="0" marB="0" anchor="ctr">
                     <a:lnL w="12700" cap="flat" cmpd="sng" algn="ctr">
                       <a:solidFill>
                         <a:srgbClr val="C9D0E0"/>
@@ -3305,7 +4138,7 @@
                         <a:buNone/>
                       </a:pPr>
                       <a:r>
-                        <a:rPr lang="en-US" sz="2600" dirty="0">
+                        <a:rPr lang="en-US" sz="1900" dirty="0">
                           <a:solidFill>
                             <a:srgbClr val="14213D"/>
                           </a:solidFill>
@@ -3313,16 +4146,16 @@
                           <a:ea typeface="Calibri" pitchFamily="34" charset="-122"/>
                           <a:cs typeface="Calibri" pitchFamily="34" charset="-120"/>
                         </a:rPr>
-                        <a:t>Wake it first; demo data reloads on boot</a:t>
+                        <a:t>Wake it first; backup video ready</a:t>
                       </a:r>
-                      <a:endParaRPr lang="en-US" sz="2600" dirty="0">
+                      <a:endParaRPr lang="en-US" sz="1900" dirty="0">
                         <a:latin typeface="Calibri" charset="0"/>
                         <a:ea typeface="Calibri" charset="0"/>
                         <a:cs typeface="Calibri" charset="0"/>
                       </a:endParaRPr>
                     </a:p>
                   </a:txBody>
-                  <a:tcPr marL="137160" marR="137160" marT="0" marB="0" anchor="ctr">
+                  <a:tcPr marL="109728" marR="109728" marT="0" marB="0" anchor="ctr">
                     <a:lnL w="12700" cap="flat" cmpd="sng" algn="ctr">
                       <a:solidFill>
                         <a:srgbClr val="C9D0E0"/>
@@ -3365,7 +4198,7 @@
                   </a:tcPr>
                 </a:tc>
               </a:tr>
-              <a:tr h="530352">
+              <a:tr h="566928">
                 <a:tc>
                   <a:txBody>
                     <a:bodyPr/>
@@ -3375,7 +4208,7 @@
                         <a:buNone/>
                       </a:pPr>
                       <a:r>
-                        <a:rPr lang="en-US" sz="2600" dirty="0">
+                        <a:rPr lang="en-US" sz="1900" dirty="0">
                           <a:solidFill>
                             <a:srgbClr val="14213D"/>
                           </a:solidFill>
@@ -3383,16 +4216,16 @@
                           <a:ea typeface="Calibri" pitchFamily="34" charset="-122"/>
                           <a:cs typeface="Calibri" pitchFamily="34" charset="-120"/>
                         </a:rPr>
-                        <a:t>Demo is cloud, brief says on-premise</a:t>
+                        <a:t>Demo host is cloud, brief says on-premise</a:t>
                       </a:r>
-                      <a:endParaRPr lang="en-US" sz="2600" dirty="0">
+                      <a:endParaRPr lang="en-US" sz="1900" dirty="0">
                         <a:latin typeface="Calibri" charset="0"/>
                         <a:ea typeface="Calibri" charset="0"/>
                         <a:cs typeface="Calibri" charset="0"/>
                       </a:endParaRPr>
                     </a:p>
                   </a:txBody>
-                  <a:tcPr marL="137160" marR="137160" marT="0" marB="0" anchor="ctr">
+                  <a:tcPr marL="109728" marR="109728" marT="0" marB="0" anchor="ctr">
                     <a:lnL w="12700" cap="flat" cmpd="sng" algn="ctr">
                       <a:solidFill>
                         <a:srgbClr val="C9D0E0"/>
@@ -3443,7 +4276,7 @@
                         <a:buNone/>
                       </a:pPr>
                       <a:r>
-                        <a:rPr lang="en-US" sz="2600" dirty="0">
+                        <a:rPr lang="en-US" sz="1900" dirty="0">
                           <a:solidFill>
                             <a:srgbClr val="14213D"/>
                           </a:solidFill>
@@ -3451,16 +4284,16 @@
                           <a:ea typeface="Calibri" pitchFamily="34" charset="-122"/>
                           <a:cs typeface="Calibri" pitchFamily="34" charset="-120"/>
                         </a:rPr>
-                        <a:t>Written note; we say so on the poster</a:t>
+                        <a:t>On-premise Mac mini in progress; stated openly</a:t>
                       </a:r>
-                      <a:endParaRPr lang="en-US" sz="2600" dirty="0">
+                      <a:endParaRPr lang="en-US" sz="1900" dirty="0">
                         <a:latin typeface="Calibri" charset="0"/>
                         <a:ea typeface="Calibri" charset="0"/>
                         <a:cs typeface="Calibri" charset="0"/>
                       </a:endParaRPr>
                     </a:p>
                   </a:txBody>
-                  <a:tcPr marL="137160" marR="137160" marT="0" marB="0" anchor="ctr">
+                  <a:tcPr marL="109728" marR="109728" marT="0" marB="0" anchor="ctr">
                     <a:lnL w="12700" cap="flat" cmpd="sng" algn="ctr">
                       <a:solidFill>
                         <a:srgbClr val="C9D0E0"/>
@@ -3503,7 +4336,7 @@
                   </a:tcPr>
                 </a:tc>
               </a:tr>
-              <a:tr h="530352">
+              <a:tr h="566928">
                 <a:tc>
                   <a:txBody>
                     <a:bodyPr/>
@@ -3513,7 +4346,7 @@
                         <a:buNone/>
                       </a:pPr>
                       <a:r>
-                        <a:rPr lang="en-US" sz="2600" dirty="0">
+                        <a:rPr lang="en-US" sz="1900" dirty="0">
                           <a:solidFill>
                             <a:srgbClr val="14213D"/>
                           </a:solidFill>
@@ -3521,16 +4354,16 @@
                           <a:ea typeface="Calibri" pitchFamily="34" charset="-122"/>
                           <a:cs typeface="Calibri" pitchFamily="34" charset="-120"/>
                         </a:rPr>
-                        <a:t>Tickets and merged code out of step</a:t>
+                        <a:t>Old tickets did not match the code</a:t>
                       </a:r>
-                      <a:endParaRPr lang="en-US" sz="2600" dirty="0">
+                      <a:endParaRPr lang="en-US" sz="1900" dirty="0">
                         <a:latin typeface="Calibri" charset="0"/>
                         <a:ea typeface="Calibri" charset="0"/>
                         <a:cs typeface="Calibri" charset="0"/>
                       </a:endParaRPr>
                     </a:p>
                   </a:txBody>
-                  <a:tcPr marL="137160" marR="137160" marT="0" marB="0" anchor="ctr">
+                  <a:tcPr marL="109728" marR="109728" marT="0" marB="0" anchor="ctr">
                     <a:lnL w="12700" cap="flat" cmpd="sng" algn="ctr">
                       <a:solidFill>
                         <a:srgbClr val="C9D0E0"/>
@@ -3581,7 +4414,7 @@
                         <a:buNone/>
                       </a:pPr>
                       <a:r>
-                        <a:rPr lang="en-US" sz="2600" dirty="0">
+                        <a:rPr lang="en-US" sz="1900" dirty="0">
                           <a:solidFill>
                             <a:srgbClr val="14213D"/>
                           </a:solidFill>
@@ -3589,16 +4422,16 @@
                           <a:ea typeface="Calibri" pitchFamily="34" charset="-122"/>
                           <a:cs typeface="Calibri" pitchFamily="34" charset="-120"/>
                         </a:rPr>
-                        <a:t>Audit every ticket against the code</a:t>
+                        <a:t>Audited every ticket against the code</a:t>
                       </a:r>
-                      <a:endParaRPr lang="en-US" sz="2600" dirty="0">
+                      <a:endParaRPr lang="en-US" sz="1900" dirty="0">
                         <a:latin typeface="Calibri" charset="0"/>
                         <a:ea typeface="Calibri" charset="0"/>
                         <a:cs typeface="Calibri" charset="0"/>
                       </a:endParaRPr>
                     </a:p>
                   </a:txBody>
-                  <a:tcPr marL="137160" marR="137160" marT="0" marB="0" anchor="ctr">
+                  <a:tcPr marL="109728" marR="109728" marT="0" marB="0" anchor="ctr">
                     <a:lnL w="12700" cap="flat" cmpd="sng" algn="ctr">
                       <a:solidFill>
                         <a:srgbClr val="C9D0E0"/>
@@ -3647,14 +4480,14 @@
       </p:graphicFrame>
       <p:sp>
         <p:nvSpPr>
-          <p:cNvPr id="52" name="Shape 48"/>
-          <p:cNvSpPr/>
-          <p:nvPr/>
-        </p:nvSpPr>
-        <p:spPr>
-          <a:xfrm>
-            <a:off x="914400" y="27843480"/>
-            <a:ext cx="777240" cy="777240"/>
+          <p:cNvPr id="75" name="Shape 71"/>
+          <p:cNvSpPr/>
+          <p:nvPr/>
+        </p:nvSpPr>
+        <p:spPr>
+          <a:xfrm>
+            <a:off x="914400" y="27596592"/>
+            <a:ext cx="731520" cy="731520"/>
           </a:xfrm>
           <a:prstGeom prst="ellipse">
             <a:avLst/>
@@ -3667,14 +4500,14 @@
       </p:sp>
       <p:sp>
         <p:nvSpPr>
-          <p:cNvPr id="53" name="Text 49"/>
-          <p:cNvSpPr/>
-          <p:nvPr/>
-        </p:nvSpPr>
-        <p:spPr>
-          <a:xfrm>
-            <a:off x="914400" y="27843480"/>
-            <a:ext cx="777240" cy="777240"/>
+          <p:cNvPr id="76" name="Text 72"/>
+          <p:cNvSpPr/>
+          <p:nvPr/>
+        </p:nvSpPr>
+        <p:spPr>
+          <a:xfrm>
+            <a:off x="914400" y="27596592"/>
+            <a:ext cx="731520" cy="731520"/>
           </a:xfrm>
           <a:prstGeom prst="rect">
             <a:avLst/>
@@ -3690,7 +4523,7 @@
               <a:buNone/>
             </a:pPr>
             <a:r>
-              <a:rPr lang="en-US" sz="3200" b="1" dirty="0">
+              <a:rPr lang="en-US" sz="3000" b="1" dirty="0">
                 <a:solidFill>
                   <a:srgbClr val="1B2A49"/>
                 </a:solidFill>
@@ -3700,20 +4533,20 @@
               </a:rPr>
               <a:t>4</a:t>
             </a:r>
-            <a:endParaRPr lang="en-US" sz="3200" dirty="0"/>
-          </a:p>
-        </p:txBody>
-      </p:sp>
-      <p:sp>
-        <p:nvSpPr>
-          <p:cNvPr id="54" name="Text 50"/>
-          <p:cNvSpPr/>
-          <p:nvPr/>
-        </p:nvSpPr>
-        <p:spPr>
-          <a:xfrm>
-            <a:off x="1920240" y="27797760"/>
-            <a:ext cx="18288000" cy="868680"/>
+            <a:endParaRPr lang="en-US" sz="3000" dirty="0"/>
+          </a:p>
+        </p:txBody>
+      </p:sp>
+      <p:sp>
+        <p:nvSpPr>
+          <p:cNvPr id="77" name="Text 73"/>
+          <p:cNvSpPr/>
+          <p:nvPr/>
+        </p:nvSpPr>
+        <p:spPr>
+          <a:xfrm>
+            <a:off x="1874520" y="27569160"/>
+            <a:ext cx="18562320" cy="822960"/>
           </a:xfrm>
           <a:prstGeom prst="rect">
             <a:avLst/>
@@ -3729,7 +4562,7 @@
               <a:buNone/>
             </a:pPr>
             <a:r>
-              <a:rPr lang="en-US" sz="4600" b="1" dirty="0">
+              <a:rPr lang="en-US" sz="4200" b="1" dirty="0">
                 <a:solidFill>
                   <a:srgbClr val="1B2A49"/>
                 </a:solidFill>
@@ -3737,26 +4570,26 @@
                 <a:ea typeface="Cambria" pitchFamily="34" charset="-122"/>
                 <a:cs typeface="Cambria" pitchFamily="34" charset="-120"/>
               </a:rPr>
-              <a:t>Team</a:t>
-            </a:r>
-            <a:endParaRPr lang="en-US" sz="4600" dirty="0"/>
-          </a:p>
-        </p:txBody>
-      </p:sp>
-      <p:sp>
-        <p:nvSpPr>
-          <p:cNvPr id="55" name="Shape 51"/>
-          <p:cNvSpPr/>
-          <p:nvPr/>
-        </p:nvSpPr>
-        <p:spPr>
-          <a:xfrm>
-            <a:off x="914400" y="28712160"/>
-            <a:ext cx="4663440" cy="1188720"/>
+              <a:t>Team: everyone owns a part and can answer for it</a:t>
+            </a:r>
+            <a:endParaRPr lang="en-US" sz="4200" dirty="0"/>
+          </a:p>
+        </p:txBody>
+      </p:sp>
+      <p:sp>
+        <p:nvSpPr>
+          <p:cNvPr id="78" name="Shape 74"/>
+          <p:cNvSpPr/>
+          <p:nvPr/>
+        </p:nvSpPr>
+        <p:spPr>
+          <a:xfrm>
+            <a:off x="914400" y="28529280"/>
+            <a:ext cx="4663440" cy="1325880"/>
           </a:xfrm>
           <a:prstGeom prst="roundRect">
             <a:avLst>
-              <a:gd name="adj" fmla="val 7692"/>
+              <a:gd name="adj" fmla="val 6897"/>
             </a:avLst>
           </a:prstGeom>
           <a:solidFill>
@@ -3772,14 +4605,14 @@
       </p:sp>
       <p:sp>
         <p:nvSpPr>
-          <p:cNvPr id="56" name="Text 52"/>
-          <p:cNvSpPr/>
-          <p:nvPr/>
-        </p:nvSpPr>
-        <p:spPr>
-          <a:xfrm>
-            <a:off x="1051560" y="28712160"/>
-            <a:ext cx="4389120" cy="1188720"/>
+          <p:cNvPr id="79" name="Text 75"/>
+          <p:cNvSpPr/>
+          <p:nvPr/>
+        </p:nvSpPr>
+        <p:spPr>
+          <a:xfrm>
+            <a:off x="1051560" y="28529280"/>
+            <a:ext cx="4389120" cy="1325880"/>
           </a:xfrm>
           <a:prstGeom prst="rect">
             <a:avLst/>
@@ -3795,7 +4628,7 @@
               <a:buNone/>
             </a:pPr>
             <a:r>
-              <a:rPr lang="en-US" sz="2600" b="1" dirty="0">
+              <a:rPr lang="en-US" sz="2200" b="1" dirty="0">
                 <a:solidFill>
                   <a:srgbClr val="1B2A49"/>
                 </a:solidFill>
@@ -3805,14 +4638,14 @@
               </a:rPr>
               <a:t>Dilraj Singh</a:t>
             </a:r>
-            <a:endParaRPr lang="en-US" sz="2600" dirty="0"/>
+            <a:endParaRPr lang="en-US" sz="2200" dirty="0"/>
           </a:p>
           <a:p>
             <a:pPr indent="0" marL="0">
               <a:buNone/>
             </a:pPr>
             <a:r>
-              <a:rPr lang="en-US" sz="2100" dirty="0">
+              <a:rPr lang="en-US" sz="1700" dirty="0">
                 <a:solidFill>
                   <a:srgbClr val="14213D"/>
                 </a:solidFill>
@@ -3822,14 +4655,14 @@
               </a:rPr>
               <a:t>Product owner, lead developer</a:t>
             </a:r>
-            <a:endParaRPr lang="en-US" sz="2600" dirty="0"/>
+            <a:endParaRPr lang="en-US" sz="2200" dirty="0"/>
           </a:p>
           <a:p>
             <a:pPr indent="0" marL="0">
               <a:buNone/>
             </a:pPr>
             <a:r>
-              <a:rPr lang="en-US" sz="2100" dirty="0">
+              <a:rPr lang="en-US" sz="1700" dirty="0">
                 <a:solidFill>
                   <a:srgbClr val="5B6B8C"/>
                 </a:solidFill>
@@ -3837,26 +4670,26 @@
                 <a:ea typeface="Calibri" pitchFamily="34" charset="-122"/>
                 <a:cs typeface="Calibri" pitchFamily="34" charset="-120"/>
               </a:rPr>
-              <a:t>Integration, hosting, receptionist</a:t>
-            </a:r>
-            <a:endParaRPr lang="en-US" sz="2600" dirty="0"/>
-          </a:p>
-        </p:txBody>
-      </p:sp>
-      <p:sp>
-        <p:nvSpPr>
-          <p:cNvPr id="57" name="Shape 53"/>
-          <p:cNvSpPr/>
-          <p:nvPr/>
-        </p:nvSpPr>
-        <p:spPr>
-          <a:xfrm>
-            <a:off x="5879592" y="28712160"/>
-            <a:ext cx="4663440" cy="1188720"/>
+              <a:t>Ask me about: Hosting, receptionist, call summaries</a:t>
+            </a:r>
+            <a:endParaRPr lang="en-US" sz="2200" dirty="0"/>
+          </a:p>
+        </p:txBody>
+      </p:sp>
+      <p:sp>
+        <p:nvSpPr>
+          <p:cNvPr id="80" name="Shape 76"/>
+          <p:cNvSpPr/>
+          <p:nvPr/>
+        </p:nvSpPr>
+        <p:spPr>
+          <a:xfrm>
+            <a:off x="5879592" y="28529280"/>
+            <a:ext cx="4663440" cy="1325880"/>
           </a:xfrm>
           <a:prstGeom prst="roundRect">
             <a:avLst>
-              <a:gd name="adj" fmla="val 7692"/>
+              <a:gd name="adj" fmla="val 6897"/>
             </a:avLst>
           </a:prstGeom>
           <a:solidFill>
@@ -3872,14 +4705,14 @@
       </p:sp>
       <p:sp>
         <p:nvSpPr>
-          <p:cNvPr id="58" name="Text 54"/>
-          <p:cNvSpPr/>
-          <p:nvPr/>
-        </p:nvSpPr>
-        <p:spPr>
-          <a:xfrm>
-            <a:off x="6016752" y="28712160"/>
-            <a:ext cx="4389120" cy="1188720"/>
+          <p:cNvPr id="81" name="Text 77"/>
+          <p:cNvSpPr/>
+          <p:nvPr/>
+        </p:nvSpPr>
+        <p:spPr>
+          <a:xfrm>
+            <a:off x="6016752" y="28529280"/>
+            <a:ext cx="4389120" cy="1325880"/>
           </a:xfrm>
           <a:prstGeom prst="rect">
             <a:avLst/>
@@ -3895,7 +4728,7 @@
               <a:buNone/>
             </a:pPr>
             <a:r>
-              <a:rPr lang="en-US" sz="2600" b="1" dirty="0">
+              <a:rPr lang="en-US" sz="2200" b="1" dirty="0">
                 <a:solidFill>
                   <a:srgbClr val="1B2A49"/>
                 </a:solidFill>
@@ -3905,14 +4738,14 @@
               </a:rPr>
               <a:t>Prabhjot Singh</a:t>
             </a:r>
-            <a:endParaRPr lang="en-US" sz="2600" dirty="0"/>
+            <a:endParaRPr lang="en-US" sz="2200" dirty="0"/>
           </a:p>
           <a:p>
             <a:pPr indent="0" marL="0">
               <a:buNone/>
             </a:pPr>
             <a:r>
-              <a:rPr lang="en-US" sz="2100" dirty="0">
+              <a:rPr lang="en-US" sz="1700" dirty="0">
                 <a:solidFill>
                   <a:srgbClr val="14213D"/>
                 </a:solidFill>
@@ -3922,14 +4755,14 @@
               </a:rPr>
               <a:t>Scrum master, full-stack</a:t>
             </a:r>
-            <a:endParaRPr lang="en-US" sz="2600" dirty="0"/>
+            <a:endParaRPr lang="en-US" sz="2200" dirty="0"/>
           </a:p>
           <a:p>
             <a:pPr indent="0" marL="0">
               <a:buNone/>
             </a:pPr>
             <a:r>
-              <a:rPr lang="en-US" sz="2100" dirty="0">
+              <a:rPr lang="en-US" sz="1700" dirty="0">
                 <a:solidFill>
                   <a:srgbClr val="5B6B8C"/>
                 </a:solidFill>
@@ -3937,26 +4770,26 @@
                 <a:ea typeface="Calibri" pitchFamily="34" charset="-122"/>
                 <a:cs typeface="Calibri" pitchFamily="34" charset="-120"/>
               </a:rPr>
-              <a:t>Reminders UI, email, evidence</a:t>
-            </a:r>
-            <a:endParaRPr lang="en-US" sz="2600" dirty="0"/>
-          </a:p>
-        </p:txBody>
-      </p:sp>
-      <p:sp>
-        <p:nvSpPr>
-          <p:cNvPr id="59" name="Shape 55"/>
-          <p:cNvSpPr/>
-          <p:nvPr/>
-        </p:nvSpPr>
-        <p:spPr>
-          <a:xfrm>
-            <a:off x="10844784" y="28712160"/>
-            <a:ext cx="4663440" cy="1188720"/>
+              <a:t>Ask me about: Reminder controls, email, webhook security</a:t>
+            </a:r>
+            <a:endParaRPr lang="en-US" sz="2200" dirty="0"/>
+          </a:p>
+        </p:txBody>
+      </p:sp>
+      <p:sp>
+        <p:nvSpPr>
+          <p:cNvPr id="82" name="Shape 78"/>
+          <p:cNvSpPr/>
+          <p:nvPr/>
+        </p:nvSpPr>
+        <p:spPr>
+          <a:xfrm>
+            <a:off x="10844784" y="28529280"/>
+            <a:ext cx="4663440" cy="1325880"/>
           </a:xfrm>
           <a:prstGeom prst="roundRect">
             <a:avLst>
-              <a:gd name="adj" fmla="val 7692"/>
+              <a:gd name="adj" fmla="val 6897"/>
             </a:avLst>
           </a:prstGeom>
           <a:solidFill>
@@ -3972,14 +4805,14 @@
       </p:sp>
       <p:sp>
         <p:nvSpPr>
-          <p:cNvPr id="60" name="Text 56"/>
-          <p:cNvSpPr/>
-          <p:nvPr/>
-        </p:nvSpPr>
-        <p:spPr>
-          <a:xfrm>
-            <a:off x="10981944" y="28712160"/>
-            <a:ext cx="4389120" cy="1188720"/>
+          <p:cNvPr id="83" name="Text 79"/>
+          <p:cNvSpPr/>
+          <p:nvPr/>
+        </p:nvSpPr>
+        <p:spPr>
+          <a:xfrm>
+            <a:off x="10981944" y="28529280"/>
+            <a:ext cx="4389120" cy="1325880"/>
           </a:xfrm>
           <a:prstGeom prst="rect">
             <a:avLst/>
@@ -3995,7 +4828,7 @@
               <a:buNone/>
             </a:pPr>
             <a:r>
-              <a:rPr lang="en-US" sz="2600" b="1" dirty="0">
+              <a:rPr lang="en-US" sz="2200" b="1" dirty="0">
                 <a:solidFill>
                   <a:srgbClr val="1B2A49"/>
                 </a:solidFill>
@@ -4005,14 +4838,14 @@
               </a:rPr>
               <a:t>Dhiman Roy</a:t>
             </a:r>
-            <a:endParaRPr lang="en-US" sz="2600" dirty="0"/>
+            <a:endParaRPr lang="en-US" sz="2200" dirty="0"/>
           </a:p>
           <a:p>
             <a:pPr indent="0" marL="0">
               <a:buNone/>
             </a:pPr>
             <a:r>
-              <a:rPr lang="en-US" sz="2100" dirty="0">
+              <a:rPr lang="en-US" sz="1700" dirty="0">
                 <a:solidFill>
                   <a:srgbClr val="14213D"/>
                 </a:solidFill>
@@ -4020,16 +4853,16 @@
                 <a:ea typeface="Calibri" pitchFamily="34" charset="-122"/>
                 <a:cs typeface="Calibri" pitchFamily="34" charset="-120"/>
               </a:rPr>
-              <a:t>Backend: accounts, consent</a:t>
-            </a:r>
-            <a:endParaRPr lang="en-US" sz="2600" dirty="0"/>
+              <a:t>Backend: accounts and consent</a:t>
+            </a:r>
+            <a:endParaRPr lang="en-US" sz="2200" dirty="0"/>
           </a:p>
           <a:p>
             <a:pPr indent="0" marL="0">
               <a:buNone/>
             </a:pPr>
             <a:r>
-              <a:rPr lang="en-US" sz="2100" dirty="0">
+              <a:rPr lang="en-US" sz="1700" dirty="0">
                 <a:solidFill>
                   <a:srgbClr val="5B6B8C"/>
                 </a:solidFill>
@@ -4037,26 +4870,26 @@
                 <a:ea typeface="Calibri" pitchFamily="34" charset="-122"/>
                 <a:cs typeface="Calibri" pitchFamily="34" charset="-120"/>
               </a:rPr>
-              <a:t>Templates, rescheduling, auth</a:t>
-            </a:r>
-            <a:endParaRPr lang="en-US" sz="2600" dirty="0"/>
-          </a:p>
-        </p:txBody>
-      </p:sp>
-      <p:sp>
-        <p:nvSpPr>
-          <p:cNvPr id="61" name="Shape 57"/>
-          <p:cNvSpPr/>
-          <p:nvPr/>
-        </p:nvSpPr>
-        <p:spPr>
-          <a:xfrm>
-            <a:off x="15809976" y="28712160"/>
-            <a:ext cx="4663440" cy="1188720"/>
+              <a:t>Ask me about: Templates, rescheduling, roles and API keys</a:t>
+            </a:r>
+            <a:endParaRPr lang="en-US" sz="2200" dirty="0"/>
+          </a:p>
+        </p:txBody>
+      </p:sp>
+      <p:sp>
+        <p:nvSpPr>
+          <p:cNvPr id="84" name="Shape 80"/>
+          <p:cNvSpPr/>
+          <p:nvPr/>
+        </p:nvSpPr>
+        <p:spPr>
+          <a:xfrm>
+            <a:off x="15809976" y="28529280"/>
+            <a:ext cx="4663440" cy="1325880"/>
           </a:xfrm>
           <a:prstGeom prst="roundRect">
             <a:avLst>
-              <a:gd name="adj" fmla="val 7692"/>
+              <a:gd name="adj" fmla="val 6897"/>
             </a:avLst>
           </a:prstGeom>
           <a:solidFill>
@@ -4072,14 +4905,14 @@
       </p:sp>
       <p:sp>
         <p:nvSpPr>
-          <p:cNvPr id="62" name="Text 58"/>
-          <p:cNvSpPr/>
-          <p:nvPr/>
-        </p:nvSpPr>
-        <p:spPr>
-          <a:xfrm>
-            <a:off x="15947136" y="28712160"/>
-            <a:ext cx="4389120" cy="1188720"/>
+          <p:cNvPr id="85" name="Text 81"/>
+          <p:cNvSpPr/>
+          <p:nvPr/>
+        </p:nvSpPr>
+        <p:spPr>
+          <a:xfrm>
+            <a:off x="15947136" y="28529280"/>
+            <a:ext cx="4389120" cy="1325880"/>
           </a:xfrm>
           <a:prstGeom prst="rect">
             <a:avLst/>
@@ -4095,7 +4928,7 @@
               <a:buNone/>
             </a:pPr>
             <a:r>
-              <a:rPr lang="en-US" sz="2600" b="1" dirty="0">
+              <a:rPr lang="en-US" sz="2200" b="1" dirty="0">
                 <a:solidFill>
                   <a:srgbClr val="1B2A49"/>
                 </a:solidFill>
@@ -4105,14 +4938,14 @@
               </a:rPr>
               <a:t>Saifur Rahman Bhuiyan</a:t>
             </a:r>
-            <a:endParaRPr lang="en-US" sz="2600" dirty="0"/>
+            <a:endParaRPr lang="en-US" sz="2200" dirty="0"/>
           </a:p>
           <a:p>
             <a:pPr indent="0" marL="0">
               <a:buNone/>
             </a:pPr>
             <a:r>
-              <a:rPr lang="en-US" sz="2100" dirty="0">
+              <a:rPr lang="en-US" sz="1700" dirty="0">
                 <a:solidFill>
                   <a:srgbClr val="14213D"/>
                 </a:solidFill>
@@ -4122,14 +4955,14 @@
               </a:rPr>
               <a:t>Delivery, analytics, web</a:t>
             </a:r>
-            <a:endParaRPr lang="en-US" sz="2600" dirty="0"/>
+            <a:endParaRPr lang="en-US" sz="2200" dirty="0"/>
           </a:p>
           <a:p>
             <a:pPr indent="0" marL="0">
               <a:buNone/>
             </a:pPr>
             <a:r>
-              <a:rPr lang="en-US" sz="2100" dirty="0">
+              <a:rPr lang="en-US" sz="1700" dirty="0">
                 <a:solidFill>
                   <a:srgbClr val="5B6B8C"/>
                 </a:solidFill>
@@ -4137,21 +4970,21 @@
                 <a:ea typeface="Calibri" pitchFamily="34" charset="-122"/>
                 <a:cs typeface="Calibri" pitchFamily="34" charset="-120"/>
               </a:rPr>
-              <a:t>Marketing site, exports</a:t>
-            </a:r>
-            <a:endParaRPr lang="en-US" sz="2600" dirty="0"/>
-          </a:p>
-        </p:txBody>
-      </p:sp>
-      <p:sp>
-        <p:nvSpPr>
-          <p:cNvPr id="63" name="Text 59"/>
-          <p:cNvSpPr/>
-          <p:nvPr/>
-        </p:nvSpPr>
-        <p:spPr>
-          <a:xfrm>
-            <a:off x="914400" y="29955744"/>
+              <a:t>Ask me about: Live dashboard, voice languages, site</a:t>
+            </a:r>
+            <a:endParaRPr lang="en-US" sz="2200" dirty="0"/>
+          </a:p>
+        </p:txBody>
+      </p:sp>
+      <p:sp>
+        <p:nvSpPr>
+          <p:cNvPr id="86" name="Text 82"/>
+          <p:cNvSpPr/>
+          <p:nvPr/>
+        </p:nvSpPr>
+        <p:spPr>
+          <a:xfrm>
+            <a:off x="914400" y="29974032"/>
             <a:ext cx="19568160" cy="256032"/>
           </a:xfrm>
           <a:prstGeom prst="rect">

</xml_diff>

<commit_message>
Poster: QR code opens the showcase website; demo step 1 matches
Co-Authored-By: Claude Sonnet 5.5 <noreply@anthropic.com>
</commit_message>
<xml_diff>
--- a/docs/poster/Sprint5_Poster_AgentFactory.pptx
+++ b/docs/poster/Sprint5_Poster_AgentFactory.pptx
@@ -1839,7 +1839,7 @@
                 <a:ea typeface="Calibri" pitchFamily="34" charset="-122"/>
                 <a:cs typeface="Calibri" pitchFamily="34" charset="-120"/>
               </a:rPr>
-              <a:t>1.  Scan the code and sign in (ask us for the demo login)</a:t>
+              <a:t>1.  Scan the code for our website, tap Open Web UI, sign in (ask us for the login)</a:t>
             </a:r>
             <a:endParaRPr lang="en-US" sz="2700" dirty="0"/>
           </a:p>
@@ -1982,7 +1982,7 @@
                 <a:ea typeface="Calibri" pitchFamily="34" charset="-122"/>
                 <a:cs typeface="Calibri" pitchFamily="34" charset="-120"/>
               </a:rPr>
-              <a:t>Live demo</a:t>
+              <a:t>Our website</a:t>
             </a:r>
             <a:endParaRPr lang="en-US" sz="2200" dirty="0"/>
           </a:p>

</xml_diff>

<commit_message>
Poster: cloud based wording, SMS in review, items now live, 761 tests
Co-Authored-By: Claude Sonnet 5.5 <noreply@anthropic.com>
</commit_message>
<xml_diff>
--- a/docs/poster/Sprint5_Poster_AgentFactory.pptx
+++ b/docs/poster/Sprint5_Poster_AgentFactory.pptx
@@ -884,7 +884,7 @@
         <p:spPr>
           <a:xfrm>
             <a:off x="0" y="0"/>
-            <a:ext cx="21387816" cy="4114800"/>
+            <a:ext cx="21387816" cy="3566160"/>
           </a:xfrm>
           <a:prstGeom prst="rect">
             <a:avLst/>
@@ -903,8 +903,8 @@
         </p:nvSpPr>
         <p:spPr>
           <a:xfrm>
-            <a:off x="914400" y="457200"/>
-            <a:ext cx="12801600" cy="640080"/>
+            <a:off x="914400" y="365760"/>
+            <a:ext cx="12801600" cy="548640"/>
           </a:xfrm>
           <a:prstGeom prst="rect">
             <a:avLst/>
@@ -920,7 +920,7 @@
               <a:buNone/>
             </a:pPr>
             <a:r>
-              <a:rPr lang="en-US" sz="3000" b="1" spc="600" kern="0" dirty="0">
+              <a:rPr lang="en-US" sz="2800" b="1" spc="600" kern="0" dirty="0">
                 <a:solidFill>
                   <a:srgbClr val="C9A227"/>
                 </a:solidFill>
@@ -930,7 +930,7 @@
               </a:rPr>
               <a:t>AGENT FACTORY</a:t>
             </a:r>
-            <a:endParaRPr lang="en-US" sz="3000" dirty="0"/>
+            <a:endParaRPr lang="en-US" sz="2800" dirty="0"/>
           </a:p>
         </p:txBody>
       </p:sp>
@@ -942,8 +942,8 @@
         </p:nvSpPr>
         <p:spPr>
           <a:xfrm>
-            <a:off x="914400" y="1188720"/>
-            <a:ext cx="19568160" cy="2103120"/>
+            <a:off x="914400" y="960120"/>
+            <a:ext cx="19568160" cy="1828800"/>
           </a:xfrm>
           <a:prstGeom prst="rect">
             <a:avLst/>
@@ -959,7 +959,7 @@
               <a:buNone/>
             </a:pPr>
             <a:r>
-              <a:rPr lang="en-US" sz="5600" b="1" dirty="0">
+              <a:rPr lang="en-US" sz="5200" b="1" dirty="0">
                 <a:solidFill>
                   <a:srgbClr val="FFFFFF"/>
                 </a:solidFill>
@@ -969,7 +969,7 @@
               </a:rPr>
               <a:t>Reminders that respect consent, and an AI receptionist that answers the phone</a:t>
             </a:r>
-            <a:endParaRPr lang="en-US" sz="5600" dirty="0"/>
+            <a:endParaRPr lang="en-US" sz="5200" dirty="0"/>
           </a:p>
         </p:txBody>
       </p:sp>
@@ -981,8 +981,8 @@
         </p:nvSpPr>
         <p:spPr>
           <a:xfrm>
-            <a:off x="914400" y="3383280"/>
-            <a:ext cx="19568160" cy="548640"/>
+            <a:off x="914400" y="2880360"/>
+            <a:ext cx="19568160" cy="457200"/>
           </a:xfrm>
           <a:prstGeom prst="rect">
             <a:avLst/>
@@ -998,7 +998,7 @@
               <a:buNone/>
             </a:pPr>
             <a:r>
-              <a:rPr lang="en-US" sz="2600" dirty="0">
+              <a:rPr lang="en-US" sz="2400" dirty="0">
                 <a:solidFill>
                   <a:srgbClr val="D9DEE9"/>
                 </a:solidFill>
@@ -1008,7 +1008,7 @@
               </a:rPr>
               <a:t>ITECH3208 / 3209  ·  Federation University  ·  Client: Zakir Ullah Shah  ·  Sprint 5 poster session</a:t>
             </a:r>
-            <a:endParaRPr lang="en-US" sz="2600" dirty="0"/>
+            <a:endParaRPr lang="en-US" sz="2400" dirty="0"/>
           </a:p>
         </p:txBody>
       </p:sp>
@@ -1020,8 +1020,8 @@
         </p:nvSpPr>
         <p:spPr>
           <a:xfrm>
-            <a:off x="914400" y="4526280"/>
-            <a:ext cx="777240" cy="777240"/>
+            <a:off x="914400" y="3913632"/>
+            <a:ext cx="731520" cy="731520"/>
           </a:xfrm>
           <a:prstGeom prst="ellipse">
             <a:avLst/>
@@ -1040,8 +1040,8 @@
         </p:nvSpPr>
         <p:spPr>
           <a:xfrm>
-            <a:off x="914400" y="4526280"/>
-            <a:ext cx="777240" cy="777240"/>
+            <a:off x="914400" y="3913632"/>
+            <a:ext cx="731520" cy="731520"/>
           </a:xfrm>
           <a:prstGeom prst="rect">
             <a:avLst/>
@@ -1057,7 +1057,7 @@
               <a:buNone/>
             </a:pPr>
             <a:r>
-              <a:rPr lang="en-US" sz="3200" b="1" dirty="0">
+              <a:rPr lang="en-US" sz="3000" b="1" dirty="0">
                 <a:solidFill>
                   <a:srgbClr val="1B2A49"/>
                 </a:solidFill>
@@ -1067,7 +1067,7 @@
               </a:rPr>
               <a:t>1</a:t>
             </a:r>
-            <a:endParaRPr lang="en-US" sz="3200" dirty="0"/>
+            <a:endParaRPr lang="en-US" sz="3000" dirty="0"/>
           </a:p>
         </p:txBody>
       </p:sp>
@@ -1079,8 +1079,8 @@
         </p:nvSpPr>
         <p:spPr>
           <a:xfrm>
-            <a:off x="1920240" y="4480560"/>
-            <a:ext cx="18288000" cy="868680"/>
+            <a:off x="1874520" y="3886200"/>
+            <a:ext cx="18562320" cy="822960"/>
           </a:xfrm>
           <a:prstGeom prst="rect">
             <a:avLst/>
@@ -1096,7 +1096,7 @@
               <a:buNone/>
             </a:pPr>
             <a:r>
-              <a:rPr lang="en-US" sz="4600" b="1" dirty="0">
+              <a:rPr lang="en-US" sz="4200" b="1" dirty="0">
                 <a:solidFill>
                   <a:srgbClr val="1B2A49"/>
                 </a:solidFill>
@@ -1104,9 +1104,9 @@
                 <a:ea typeface="Cambria" pitchFamily="34" charset="-122"/>
                 <a:cs typeface="Cambria" pitchFamily="34" charset="-120"/>
               </a:rPr>
-              <a:t>Project and sprint goals</a:t>
-            </a:r>
-            <a:endParaRPr lang="en-US" sz="4600" dirty="0"/>
+              <a:t>Project definition: goal and sprint goals</a:t>
+            </a:r>
+            <a:endParaRPr lang="en-US" sz="4200" dirty="0"/>
           </a:p>
         </p:txBody>
       </p:sp>
@@ -1118,8 +1118,8 @@
         </p:nvSpPr>
         <p:spPr>
           <a:xfrm>
-            <a:off x="914400" y="5486400"/>
-            <a:ext cx="9509760" cy="548640"/>
+            <a:off x="914400" y="4846320"/>
+            <a:ext cx="8778240" cy="457200"/>
           </a:xfrm>
           <a:prstGeom prst="rect">
             <a:avLst/>
@@ -1135,7 +1135,7 @@
               <a:buNone/>
             </a:pPr>
             <a:r>
-              <a:rPr lang="en-US" sz="3000" b="1" dirty="0">
+              <a:rPr lang="en-US" sz="2800" b="1" dirty="0">
                 <a:solidFill>
                   <a:srgbClr val="C9A227"/>
                 </a:solidFill>
@@ -1145,7 +1145,7 @@
               </a:rPr>
               <a:t>Project goal</a:t>
             </a:r>
-            <a:endParaRPr lang="en-US" sz="3000" dirty="0"/>
+            <a:endParaRPr lang="en-US" sz="2800" dirty="0"/>
           </a:p>
         </p:txBody>
       </p:sp>
@@ -1157,8 +1157,8 @@
         </p:nvSpPr>
         <p:spPr>
           <a:xfrm>
-            <a:off x="914400" y="6080760"/>
-            <a:ext cx="9509760" cy="3017520"/>
+            <a:off x="914400" y="5349240"/>
+            <a:ext cx="8778240" cy="2103120"/>
           </a:xfrm>
           <a:prstGeom prst="rect">
             <a:avLst/>
@@ -1174,7 +1174,7 @@
               <a:buNone/>
             </a:pPr>
             <a:r>
-              <a:rPr lang="en-US" sz="3000" dirty="0">
+              <a:rPr lang="en-US" sz="2700" dirty="0">
                 <a:solidFill>
                   <a:srgbClr val="14213D"/>
                 </a:solidFill>
@@ -1182,9 +1182,9 @@
                 <a:ea typeface="Calibri" pitchFamily="34" charset="-122"/>
                 <a:cs typeface="Calibri" pitchFamily="34" charset="-120"/>
               </a:rPr>
-              <a:t>Intelligent, privacy-first communication for service businesses. An organisation registers, manages contacts who have opted in, and schedules reminders that go out by SMS, voice and email. An AI receptionist answers calls on the same platform.</a:t>
-            </a:r>
-            <a:endParaRPr lang="en-US" sz="3000" dirty="0"/>
+              <a:t>Give clinics, salons and trades reminders that never message anyone who has not opted in, and an AI receptionist that answers their phone, on one platform they control.</a:t>
+            </a:r>
+            <a:endParaRPr lang="en-US" sz="2700" dirty="0"/>
           </a:p>
         </p:txBody>
       </p:sp>
@@ -1196,8 +1196,8 @@
         </p:nvSpPr>
         <p:spPr>
           <a:xfrm>
-            <a:off x="11155680" y="5486400"/>
-            <a:ext cx="9326880" cy="548640"/>
+            <a:off x="914400" y="7315200"/>
+            <a:ext cx="8778240" cy="457200"/>
           </a:xfrm>
           <a:prstGeom prst="rect">
             <a:avLst/>
@@ -1213,7 +1213,7 @@
               <a:buNone/>
             </a:pPr>
             <a:r>
-              <a:rPr lang="en-US" sz="3000" b="1" dirty="0">
+              <a:rPr lang="en-US" sz="2800" b="1" dirty="0">
                 <a:solidFill>
                   <a:srgbClr val="C9A227"/>
                 </a:solidFill>
@@ -1221,9 +1221,9 @@
                 <a:ea typeface="Calibri" pitchFamily="34" charset="-122"/>
                 <a:cs typeface="Calibri" pitchFamily="34" charset="-120"/>
               </a:rPr>
-              <a:t>Sprint 5 goals</a:t>
-            </a:r>
-            <a:endParaRPr lang="en-US" sz="3000" dirty="0"/>
+              <a:t>The problem</a:t>
+            </a:r>
+            <a:endParaRPr lang="en-US" sz="2800" dirty="0"/>
           </a:p>
         </p:txBody>
       </p:sp>
@@ -1235,8 +1235,8 @@
         </p:nvSpPr>
         <p:spPr>
           <a:xfrm>
-            <a:off x="11155680" y="6080760"/>
-            <a:ext cx="9326880" cy="3017520"/>
+            <a:off x="914400" y="7772400"/>
+            <a:ext cx="8778240" cy="1280160"/>
           </a:xfrm>
           <a:prstGeom prst="rect">
             <a:avLst/>
@@ -1248,15 +1248,11 @@
           <a:bodyPr wrap="square" lIns="0" tIns="0" rIns="0" bIns="0" rtlCol="0" anchor="t"/>
           <a:lstStyle/>
           <a:p>
-            <a:pPr marL="342900" indent="-342900">
-              <a:spcAft>
-                <a:spcPts val="600"/>
-              </a:spcAft>
-              <a:buSzPct val="100000"/>
-              <a:buChar char="•"/>
-            </a:pPr>
-            <a:r>
-              <a:rPr lang="en-US" sz="3200" dirty="0">
+            <a:pPr indent="0" marL="0">
+              <a:buNone/>
+            </a:pPr>
+            <a:r>
+              <a:rPr lang="en-US" sz="2400" dirty="0">
                 <a:solidFill>
                   <a:srgbClr val="14213D"/>
                 </a:solidFill>
@@ -1264,20 +1260,77 @@
                 <a:ea typeface="Calibri" pitchFamily="34" charset="-122"/>
                 <a:cs typeface="Calibri" pitchFamily="34" charset="-120"/>
               </a:rPr>
-              <a:t>Put a live, reachable demo online</a:t>
-            </a:r>
-            <a:endParaRPr lang="en-US" sz="3200" dirty="0"/>
-          </a:p>
-          <a:p>
-            <a:pPr marL="342900" indent="-342900">
-              <a:spcAft>
-                <a:spcPts val="600"/>
-              </a:spcAft>
-              <a:buSzPct val="100000"/>
-              <a:buChar char="•"/>
-            </a:pPr>
-            <a:r>
-              <a:rPr lang="en-US" sz="3200" dirty="0">
+              <a:t>Small businesses lose bookings to no-shows and missed calls, and cannot risk messaging people who never agreed to be contacted.</a:t>
+            </a:r>
+            <a:endParaRPr lang="en-US" sz="2400" dirty="0"/>
+          </a:p>
+        </p:txBody>
+      </p:sp>
+      <p:sp>
+        <p:nvSpPr>
+          <p:cNvPr id="13" name="Text 11"/>
+          <p:cNvSpPr/>
+          <p:nvPr/>
+        </p:nvSpPr>
+        <p:spPr>
+          <a:xfrm>
+            <a:off x="10789920" y="4846320"/>
+            <a:ext cx="9692640" cy="457200"/>
+          </a:xfrm>
+          <a:prstGeom prst="rect">
+            <a:avLst/>
+          </a:prstGeom>
+          <a:noFill/>
+          <a:ln/>
+        </p:spPr>
+        <p:txBody>
+          <a:bodyPr wrap="square" lIns="0" tIns="0" rIns="0" bIns="0" rtlCol="0" anchor="ctr"/>
+          <a:lstStyle/>
+          <a:p>
+            <a:pPr indent="0" marL="0">
+              <a:buNone/>
+            </a:pPr>
+            <a:r>
+              <a:rPr lang="en-US" sz="2800" b="1" dirty="0">
+                <a:solidFill>
+                  <a:srgbClr val="C9A227"/>
+                </a:solidFill>
+                <a:latin typeface="Calibri" pitchFamily="34" charset="0"/>
+                <a:ea typeface="Calibri" pitchFamily="34" charset="-122"/>
+                <a:cs typeface="Calibri" pitchFamily="34" charset="-120"/>
+              </a:rPr>
+              <a:t>Sprint 5 goals (each one checkable)</a:t>
+            </a:r>
+            <a:endParaRPr lang="en-US" sz="2800" dirty="0"/>
+          </a:p>
+        </p:txBody>
+      </p:sp>
+      <p:sp>
+        <p:nvSpPr>
+          <p:cNvPr id="14" name="Text 12"/>
+          <p:cNvSpPr/>
+          <p:nvPr/>
+        </p:nvSpPr>
+        <p:spPr>
+          <a:xfrm>
+            <a:off x="10789920" y="5394960"/>
+            <a:ext cx="8138160" cy="777240"/>
+          </a:xfrm>
+          <a:prstGeom prst="rect">
+            <a:avLst/>
+          </a:prstGeom>
+          <a:noFill/>
+          <a:ln/>
+        </p:spPr>
+        <p:txBody>
+          <a:bodyPr wrap="square" lIns="0" tIns="0" rIns="0" bIns="0" rtlCol="0" anchor="ctr"/>
+          <a:lstStyle/>
+          <a:p>
+            <a:pPr indent="0" marL="0">
+              <a:buNone/>
+            </a:pPr>
+            <a:r>
+              <a:rPr lang="en-US" sz="2100" dirty="0">
                 <a:solidFill>
                   <a:srgbClr val="14213D"/>
                 </a:solidFill>
@@ -1285,20 +1338,99 @@
                 <a:ea typeface="Calibri" pitchFamily="34" charset="-122"/>
                 <a:cs typeface="Calibri" pitchFamily="34" charset="-120"/>
               </a:rPr>
-              <a:t>Close the gaps we found against the client brief</a:t>
-            </a:r>
-            <a:endParaRPr lang="en-US" sz="3200" dirty="0"/>
-          </a:p>
-          <a:p>
-            <a:pPr marL="342900" indent="-342900">
-              <a:spcAft>
-                <a:spcPts val="600"/>
-              </a:spcAft>
-              <a:buSzPct val="100000"/>
-              <a:buChar char="•"/>
-            </a:pPr>
-            <a:r>
-              <a:rPr lang="en-US" sz="3200" dirty="0">
+              <a:t>Close the gaps found against the client brief: reminder controls, templates, rescheduling, call summaries, site</a:t>
+            </a:r>
+            <a:endParaRPr lang="en-US" sz="2100" dirty="0"/>
+          </a:p>
+        </p:txBody>
+      </p:sp>
+      <p:sp>
+        <p:nvSpPr>
+          <p:cNvPr id="15" name="Shape 13"/>
+          <p:cNvSpPr/>
+          <p:nvPr/>
+        </p:nvSpPr>
+        <p:spPr>
+          <a:xfrm>
+            <a:off x="19065240" y="5532120"/>
+            <a:ext cx="1417320" cy="502920"/>
+          </a:xfrm>
+          <a:prstGeom prst="roundRect">
+            <a:avLst>
+              <a:gd name="adj" fmla="val 49091"/>
+            </a:avLst>
+          </a:prstGeom>
+          <a:solidFill>
+            <a:srgbClr val="2E7D5B"/>
+          </a:solidFill>
+          <a:ln/>
+        </p:spPr>
+      </p:sp>
+      <p:sp>
+        <p:nvSpPr>
+          <p:cNvPr id="16" name="Text 14"/>
+          <p:cNvSpPr/>
+          <p:nvPr/>
+        </p:nvSpPr>
+        <p:spPr>
+          <a:xfrm>
+            <a:off x="19065240" y="5532120"/>
+            <a:ext cx="1417320" cy="502920"/>
+          </a:xfrm>
+          <a:prstGeom prst="rect">
+            <a:avLst/>
+          </a:prstGeom>
+          <a:noFill/>
+          <a:ln/>
+        </p:spPr>
+        <p:txBody>
+          <a:bodyPr wrap="square" lIns="0" tIns="0" rIns="0" bIns="0" rtlCol="0" anchor="ctr"/>
+          <a:lstStyle/>
+          <a:p>
+            <a:pPr algn="ctr" indent="0" marL="0">
+              <a:buNone/>
+            </a:pPr>
+            <a:r>
+              <a:rPr lang="en-US" sz="1800" b="1" dirty="0">
+                <a:solidFill>
+                  <a:srgbClr val="FFFFFF"/>
+                </a:solidFill>
+                <a:latin typeface="Calibri" pitchFamily="34" charset="0"/>
+                <a:ea typeface="Calibri" pitchFamily="34" charset="-122"/>
+                <a:cs typeface="Calibri" pitchFamily="34" charset="-120"/>
+              </a:rPr>
+              <a:t>LIVE</a:t>
+            </a:r>
+            <a:endParaRPr lang="en-US" sz="1800" dirty="0"/>
+          </a:p>
+        </p:txBody>
+      </p:sp>
+      <p:sp>
+        <p:nvSpPr>
+          <p:cNvPr id="17" name="Text 15"/>
+          <p:cNvSpPr/>
+          <p:nvPr/>
+        </p:nvSpPr>
+        <p:spPr>
+          <a:xfrm>
+            <a:off x="10789920" y="6263640"/>
+            <a:ext cx="8138160" cy="777240"/>
+          </a:xfrm>
+          <a:prstGeom prst="rect">
+            <a:avLst/>
+          </a:prstGeom>
+          <a:noFill/>
+          <a:ln/>
+        </p:spPr>
+        <p:txBody>
+          <a:bodyPr wrap="square" lIns="0" tIns="0" rIns="0" bIns="0" rtlCol="0" anchor="ctr"/>
+          <a:lstStyle/>
+          <a:p>
+            <a:pPr indent="0" marL="0">
+              <a:buNone/>
+            </a:pPr>
+            <a:r>
+              <a:rPr lang="en-US" sz="2100" dirty="0">
                 <a:solidFill>
                   <a:srgbClr val="14213D"/>
                 </a:solidFill>
@@ -1306,22 +1438,283 @@
                 <a:ea typeface="Calibri" pitchFamily="34" charset="-122"/>
                 <a:cs typeface="Calibri" pitchFamily="34" charset="-120"/>
               </a:rPr>
-              <a:t>Show a working demo and an honest roadmap</a:t>
-            </a:r>
-            <a:endParaRPr lang="en-US" sz="3200" dirty="0"/>
-          </a:p>
-        </p:txBody>
-      </p:sp>
-      <p:sp>
-        <p:nvSpPr>
-          <p:cNvPr id="13" name="Shape 11"/>
-          <p:cNvSpPr/>
-          <p:nvPr/>
-        </p:nvSpPr>
-        <p:spPr>
-          <a:xfrm>
-            <a:off x="914400" y="9555480"/>
-            <a:ext cx="777240" cy="777240"/>
+              <a:t>Prove delivery end to end: an email reminder lands on time</a:t>
+            </a:r>
+            <a:endParaRPr lang="en-US" sz="2100" dirty="0"/>
+          </a:p>
+        </p:txBody>
+      </p:sp>
+      <p:sp>
+        <p:nvSpPr>
+          <p:cNvPr id="18" name="Shape 16"/>
+          <p:cNvSpPr/>
+          <p:nvPr/>
+        </p:nvSpPr>
+        <p:spPr>
+          <a:xfrm>
+            <a:off x="19065240" y="6400800"/>
+            <a:ext cx="1417320" cy="502920"/>
+          </a:xfrm>
+          <a:prstGeom prst="roundRect">
+            <a:avLst>
+              <a:gd name="adj" fmla="val 49091"/>
+            </a:avLst>
+          </a:prstGeom>
+          <a:solidFill>
+            <a:srgbClr val="2E7D5B"/>
+          </a:solidFill>
+          <a:ln/>
+        </p:spPr>
+      </p:sp>
+      <p:sp>
+        <p:nvSpPr>
+          <p:cNvPr id="19" name="Text 17"/>
+          <p:cNvSpPr/>
+          <p:nvPr/>
+        </p:nvSpPr>
+        <p:spPr>
+          <a:xfrm>
+            <a:off x="19065240" y="6400800"/>
+            <a:ext cx="1417320" cy="502920"/>
+          </a:xfrm>
+          <a:prstGeom prst="rect">
+            <a:avLst/>
+          </a:prstGeom>
+          <a:noFill/>
+          <a:ln/>
+        </p:spPr>
+        <p:txBody>
+          <a:bodyPr wrap="square" lIns="0" tIns="0" rIns="0" bIns="0" rtlCol="0" anchor="ctr"/>
+          <a:lstStyle/>
+          <a:p>
+            <a:pPr algn="ctr" indent="0" marL="0">
+              <a:buNone/>
+            </a:pPr>
+            <a:r>
+              <a:rPr lang="en-US" sz="1800" b="1" dirty="0">
+                <a:solidFill>
+                  <a:srgbClr val="FFFFFF"/>
+                </a:solidFill>
+                <a:latin typeface="Calibri" pitchFamily="34" charset="0"/>
+                <a:ea typeface="Calibri" pitchFamily="34" charset="-122"/>
+                <a:cs typeface="Calibri" pitchFamily="34" charset="-120"/>
+              </a:rPr>
+              <a:t>DONE</a:t>
+            </a:r>
+            <a:endParaRPr lang="en-US" sz="1800" dirty="0"/>
+          </a:p>
+        </p:txBody>
+      </p:sp>
+      <p:sp>
+        <p:nvSpPr>
+          <p:cNvPr id="20" name="Text 18"/>
+          <p:cNvSpPr/>
+          <p:nvPr/>
+        </p:nvSpPr>
+        <p:spPr>
+          <a:xfrm>
+            <a:off x="10789920" y="7132320"/>
+            <a:ext cx="8138160" cy="777240"/>
+          </a:xfrm>
+          <a:prstGeom prst="rect">
+            <a:avLst/>
+          </a:prstGeom>
+          <a:noFill/>
+          <a:ln/>
+        </p:spPr>
+        <p:txBody>
+          <a:bodyPr wrap="square" lIns="0" tIns="0" rIns="0" bIns="0" rtlCol="0" anchor="ctr"/>
+          <a:lstStyle/>
+          <a:p>
+            <a:pPr indent="0" marL="0">
+              <a:buNone/>
+            </a:pPr>
+            <a:r>
+              <a:rPr lang="en-US" sz="2100" dirty="0">
+                <a:solidFill>
+                  <a:srgbClr val="14213D"/>
+                </a:solidFill>
+                <a:latin typeface="Calibri" pitchFamily="34" charset="0"/>
+                <a:ea typeface="Calibri" pitchFamily="34" charset="-122"/>
+                <a:cs typeface="Calibri" pitchFamily="34" charset="-120"/>
+              </a:rPr>
+              <a:t>Keep each organisation's data separate: activity, analytics, exports</a:t>
+            </a:r>
+            <a:endParaRPr lang="en-US" sz="2100" dirty="0"/>
+          </a:p>
+        </p:txBody>
+      </p:sp>
+      <p:sp>
+        <p:nvSpPr>
+          <p:cNvPr id="21" name="Shape 19"/>
+          <p:cNvSpPr/>
+          <p:nvPr/>
+        </p:nvSpPr>
+        <p:spPr>
+          <a:xfrm>
+            <a:off x="19065240" y="7269480"/>
+            <a:ext cx="1417320" cy="502920"/>
+          </a:xfrm>
+          <a:prstGeom prst="roundRect">
+            <a:avLst>
+              <a:gd name="adj" fmla="val 49091"/>
+            </a:avLst>
+          </a:prstGeom>
+          <a:solidFill>
+            <a:srgbClr val="2E7D5B"/>
+          </a:solidFill>
+          <a:ln/>
+        </p:spPr>
+      </p:sp>
+      <p:sp>
+        <p:nvSpPr>
+          <p:cNvPr id="22" name="Text 20"/>
+          <p:cNvSpPr/>
+          <p:nvPr/>
+        </p:nvSpPr>
+        <p:spPr>
+          <a:xfrm>
+            <a:off x="19065240" y="7269480"/>
+            <a:ext cx="1417320" cy="502920"/>
+          </a:xfrm>
+          <a:prstGeom prst="rect">
+            <a:avLst/>
+          </a:prstGeom>
+          <a:noFill/>
+          <a:ln/>
+        </p:spPr>
+        <p:txBody>
+          <a:bodyPr wrap="square" lIns="0" tIns="0" rIns="0" bIns="0" rtlCol="0" anchor="ctr"/>
+          <a:lstStyle/>
+          <a:p>
+            <a:pPr algn="ctr" indent="0" marL="0">
+              <a:buNone/>
+            </a:pPr>
+            <a:r>
+              <a:rPr lang="en-US" sz="1800" b="1" dirty="0">
+                <a:solidFill>
+                  <a:srgbClr val="FFFFFF"/>
+                </a:solidFill>
+                <a:latin typeface="Calibri" pitchFamily="34" charset="0"/>
+                <a:ea typeface="Calibri" pitchFamily="34" charset="-122"/>
+                <a:cs typeface="Calibri" pitchFamily="34" charset="-120"/>
+              </a:rPr>
+              <a:t>LIVE</a:t>
+            </a:r>
+            <a:endParaRPr lang="en-US" sz="1800" dirty="0"/>
+          </a:p>
+        </p:txBody>
+      </p:sp>
+      <p:sp>
+        <p:nvSpPr>
+          <p:cNvPr id="23" name="Text 21"/>
+          <p:cNvSpPr/>
+          <p:nvPr/>
+        </p:nvSpPr>
+        <p:spPr>
+          <a:xfrm>
+            <a:off x="10789920" y="8001000"/>
+            <a:ext cx="8138160" cy="777240"/>
+          </a:xfrm>
+          <a:prstGeom prst="rect">
+            <a:avLst/>
+          </a:prstGeom>
+          <a:noFill/>
+          <a:ln/>
+        </p:spPr>
+        <p:txBody>
+          <a:bodyPr wrap="square" lIns="0" tIns="0" rIns="0" bIns="0" rtlCol="0" anchor="ctr"/>
+          <a:lstStyle/>
+          <a:p>
+            <a:pPr indent="0" marL="0">
+              <a:buNone/>
+            </a:pPr>
+            <a:r>
+              <a:rPr lang="en-US" sz="2100" dirty="0">
+                <a:solidFill>
+                  <a:srgbClr val="14213D"/>
+                </a:solidFill>
+                <a:latin typeface="Calibri" pitchFamily="34" charset="0"/>
+                <a:ea typeface="Calibri" pitchFamily="34" charset="-122"/>
+                <a:cs typeface="Calibri" pitchFamily="34" charset="-120"/>
+              </a:rPr>
+              <a:t>Prove SMS delivery: Twilio registration is in review</a:t>
+            </a:r>
+            <a:endParaRPr lang="en-US" sz="2100" dirty="0"/>
+          </a:p>
+        </p:txBody>
+      </p:sp>
+      <p:sp>
+        <p:nvSpPr>
+          <p:cNvPr id="24" name="Shape 22"/>
+          <p:cNvSpPr/>
+          <p:nvPr/>
+        </p:nvSpPr>
+        <p:spPr>
+          <a:xfrm>
+            <a:off x="19065240" y="8138160"/>
+            <a:ext cx="1417320" cy="502920"/>
+          </a:xfrm>
+          <a:prstGeom prst="roundRect">
+            <a:avLst>
+              <a:gd name="adj" fmla="val 49091"/>
+            </a:avLst>
+          </a:prstGeom>
+          <a:solidFill>
+            <a:srgbClr val="A9701B"/>
+          </a:solidFill>
+          <a:ln/>
+        </p:spPr>
+      </p:sp>
+      <p:sp>
+        <p:nvSpPr>
+          <p:cNvPr id="25" name="Text 23"/>
+          <p:cNvSpPr/>
+          <p:nvPr/>
+        </p:nvSpPr>
+        <p:spPr>
+          <a:xfrm>
+            <a:off x="19065240" y="8138160"/>
+            <a:ext cx="1417320" cy="502920"/>
+          </a:xfrm>
+          <a:prstGeom prst="rect">
+            <a:avLst/>
+          </a:prstGeom>
+          <a:noFill/>
+          <a:ln/>
+        </p:spPr>
+        <p:txBody>
+          <a:bodyPr wrap="square" lIns="0" tIns="0" rIns="0" bIns="0" rtlCol="0" anchor="ctr"/>
+          <a:lstStyle/>
+          <a:p>
+            <a:pPr algn="ctr" indent="0" marL="0">
+              <a:buNone/>
+            </a:pPr>
+            <a:r>
+              <a:rPr lang="en-US" sz="1800" b="1" dirty="0">
+                <a:solidFill>
+                  <a:srgbClr val="FFFFFF"/>
+                </a:solidFill>
+                <a:latin typeface="Calibri" pitchFamily="34" charset="0"/>
+                <a:ea typeface="Calibri" pitchFamily="34" charset="-122"/>
+                <a:cs typeface="Calibri" pitchFamily="34" charset="-120"/>
+              </a:rPr>
+              <a:t>IN REVIEW</a:t>
+            </a:r>
+            <a:endParaRPr lang="en-US" sz="1800" dirty="0"/>
+          </a:p>
+        </p:txBody>
+      </p:sp>
+      <p:sp>
+        <p:nvSpPr>
+          <p:cNvPr id="26" name="Shape 24"/>
+          <p:cNvSpPr/>
+          <p:nvPr/>
+        </p:nvSpPr>
+        <p:spPr>
+          <a:xfrm>
+            <a:off x="914400" y="8942832"/>
+            <a:ext cx="731520" cy="731520"/>
           </a:xfrm>
           <a:prstGeom prst="ellipse">
             <a:avLst/>
@@ -1334,14 +1727,14 @@
       </p:sp>
       <p:sp>
         <p:nvSpPr>
-          <p:cNvPr id="14" name="Text 12"/>
-          <p:cNvSpPr/>
-          <p:nvPr/>
-        </p:nvSpPr>
-        <p:spPr>
-          <a:xfrm>
-            <a:off x="914400" y="9555480"/>
-            <a:ext cx="777240" cy="777240"/>
+          <p:cNvPr id="27" name="Text 25"/>
+          <p:cNvSpPr/>
+          <p:nvPr/>
+        </p:nvSpPr>
+        <p:spPr>
+          <a:xfrm>
+            <a:off x="914400" y="8942832"/>
+            <a:ext cx="731520" cy="731520"/>
           </a:xfrm>
           <a:prstGeom prst="rect">
             <a:avLst/>
@@ -1357,7 +1750,7 @@
               <a:buNone/>
             </a:pPr>
             <a:r>
-              <a:rPr lang="en-US" sz="3200" b="1" dirty="0">
+              <a:rPr lang="en-US" sz="3000" b="1" dirty="0">
                 <a:solidFill>
                   <a:srgbClr val="1B2A49"/>
                 </a:solidFill>
@@ -1367,20 +1760,20 @@
               </a:rPr>
               <a:t>2</a:t>
             </a:r>
-            <a:endParaRPr lang="en-US" sz="3200" dirty="0"/>
-          </a:p>
-        </p:txBody>
-      </p:sp>
-      <p:sp>
-        <p:nvSpPr>
-          <p:cNvPr id="15" name="Text 13"/>
-          <p:cNvSpPr/>
-          <p:nvPr/>
-        </p:nvSpPr>
-        <p:spPr>
-          <a:xfrm>
-            <a:off x="1920240" y="9509760"/>
-            <a:ext cx="18288000" cy="868680"/>
+            <a:endParaRPr lang="en-US" sz="3000" dirty="0"/>
+          </a:p>
+        </p:txBody>
+      </p:sp>
+      <p:sp>
+        <p:nvSpPr>
+          <p:cNvPr id="28" name="Text 26"/>
+          <p:cNvSpPr/>
+          <p:nvPr/>
+        </p:nvSpPr>
+        <p:spPr>
+          <a:xfrm>
+            <a:off x="1874520" y="8915400"/>
+            <a:ext cx="18562320" cy="822960"/>
           </a:xfrm>
           <a:prstGeom prst="rect">
             <a:avLst/>
@@ -1396,7 +1789,7 @@
               <a:buNone/>
             </a:pPr>
             <a:r>
-              <a:rPr lang="en-US" sz="4600" b="1" dirty="0">
+              <a:rPr lang="en-US" sz="4200" b="1" dirty="0">
                 <a:solidFill>
                   <a:srgbClr val="1B2A49"/>
                 </a:solidFill>
@@ -1404,22 +1797,22 @@
                 <a:ea typeface="Cambria" pitchFamily="34" charset="-122"/>
                 <a:cs typeface="Cambria" pitchFamily="34" charset="-120"/>
               </a:rPr>
-              <a:t>Demo: try it now</a:t>
-            </a:r>
-            <a:endParaRPr lang="en-US" sz="4600" dirty="0"/>
-          </a:p>
-        </p:txBody>
-      </p:sp>
-      <p:sp>
-        <p:nvSpPr>
-          <p:cNvPr id="16" name="Text 14"/>
-          <p:cNvSpPr/>
-          <p:nvPr/>
-        </p:nvSpPr>
-        <p:spPr>
-          <a:xfrm>
-            <a:off x="914400" y="10515600"/>
-            <a:ext cx="13624560" cy="4206240"/>
+              <a:t>Technical status and demo: try it now</a:t>
+            </a:r>
+            <a:endParaRPr lang="en-US" sz="4200" dirty="0"/>
+          </a:p>
+        </p:txBody>
+      </p:sp>
+      <p:sp>
+        <p:nvSpPr>
+          <p:cNvPr id="29" name="Text 27"/>
+          <p:cNvSpPr/>
+          <p:nvPr/>
+        </p:nvSpPr>
+        <p:spPr>
+          <a:xfrm>
+            <a:off x="914400" y="9921240"/>
+            <a:ext cx="13990320" cy="4023360"/>
           </a:xfrm>
           <a:prstGeom prst="rect">
             <a:avLst/>
@@ -1433,12 +1826,12 @@
           <a:p>
             <a:pPr indent="0" marL="0">
               <a:spcAft>
-                <a:spcPts val="1000"/>
+                <a:spcPts val="800"/>
               </a:spcAft>
               <a:buNone/>
             </a:pPr>
             <a:r>
-              <a:rPr lang="en-US" sz="3200" dirty="0">
+              <a:rPr lang="en-US" sz="2700" dirty="0">
                 <a:solidFill>
                   <a:srgbClr val="14213D"/>
                 </a:solidFill>
@@ -1446,19 +1839,19 @@
                 <a:ea typeface="Calibri" pitchFamily="34" charset="-122"/>
                 <a:cs typeface="Calibri" pitchFamily="34" charset="-120"/>
               </a:rPr>
-              <a:t>1.  Scan the code and sign in (ask us for the demo login)</a:t>
-            </a:r>
-            <a:endParaRPr lang="en-US" sz="3200" dirty="0"/>
+              <a:t>1.  Scan the code for our website, tap Open Web UI, sign in (ask us for the login)</a:t>
+            </a:r>
+            <a:endParaRPr lang="en-US" sz="2700" dirty="0"/>
           </a:p>
           <a:p>
             <a:pPr indent="0" marL="0">
               <a:spcAft>
-                <a:spcPts val="1000"/>
+                <a:spcPts val="800"/>
               </a:spcAft>
               <a:buNone/>
             </a:pPr>
             <a:r>
-              <a:rPr lang="en-US" sz="3200" dirty="0">
+              <a:rPr lang="en-US" sz="2700" dirty="0">
                 <a:solidFill>
                   <a:srgbClr val="14213D"/>
                 </a:solidFill>
@@ -1466,19 +1859,19 @@
                 <a:ea typeface="Calibri" pitchFamily="34" charset="-122"/>
                 <a:cs typeface="Calibri" pitchFamily="34" charset="-120"/>
               </a:rPr>
-              <a:t>2.  Contacts: see who has opted in and who has opted out</a:t>
-            </a:r>
-            <a:endParaRPr lang="en-US" sz="3200" dirty="0"/>
+              <a:t>2.  Contacts tab: opted-in and opted-out people</a:t>
+            </a:r>
+            <a:endParaRPr lang="en-US" sz="2700" dirty="0"/>
           </a:p>
           <a:p>
             <a:pPr indent="0" marL="0">
               <a:spcAft>
-                <a:spcPts val="1000"/>
+                <a:spcPts val="800"/>
               </a:spcAft>
               <a:buNone/>
             </a:pPr>
             <a:r>
-              <a:rPr lang="en-US" sz="3200" dirty="0">
+              <a:rPr lang="en-US" sz="2700" dirty="0">
                 <a:solidFill>
                   <a:srgbClr val="14213D"/>
                 </a:solidFill>
@@ -1486,19 +1879,19 @@
                 <a:ea typeface="Calibri" pitchFamily="34" charset="-122"/>
                 <a:cs typeface="Calibri" pitchFamily="34" charset="-120"/>
               </a:rPr>
-              <a:t>3.  Schedule a reminder: the consent gate blocks opted-out contacts</a:t>
-            </a:r>
-            <a:endParaRPr lang="en-US" sz="3200" dirty="0"/>
+              <a:t>3.  Reminders tab: opted-out contacts and past dates are refused</a:t>
+            </a:r>
+            <a:endParaRPr lang="en-US" sz="2700" dirty="0"/>
           </a:p>
           <a:p>
             <a:pPr indent="0" marL="0">
               <a:spcAft>
-                <a:spcPts val="1000"/>
+                <a:spcPts val="800"/>
               </a:spcAft>
               <a:buNone/>
             </a:pPr>
             <a:r>
-              <a:rPr lang="en-US" sz="3200" dirty="0">
+              <a:rPr lang="en-US" sz="2700" dirty="0">
                 <a:solidFill>
                   <a:srgbClr val="14213D"/>
                 </a:solidFill>
@@ -1506,15 +1899,55 @@
                 <a:ea typeface="Calibri" pitchFamily="34" charset="-122"/>
                 <a:cs typeface="Calibri" pitchFamily="34" charset="-120"/>
               </a:rPr>
-              <a:t>4.  Call +1 802 444 8729 and ask what we offer</a:t>
-            </a:r>
-            <a:endParaRPr lang="en-US" sz="3200" dirty="0"/>
+              <a:t>4.  Call +1 802 444 8729: ask the hours, then say goodbye</a:t>
+            </a:r>
+            <a:endParaRPr lang="en-US" sz="2700" dirty="0"/>
+          </a:p>
+          <a:p>
+            <a:pPr indent="0" marL="0">
+              <a:spcAft>
+                <a:spcPts val="800"/>
+              </a:spcAft>
+              <a:buNone/>
+            </a:pPr>
+            <a:r>
+              <a:rPr lang="en-US" sz="2700" dirty="0">
+                <a:solidFill>
+                  <a:srgbClr val="14213D"/>
+                </a:solidFill>
+                <a:latin typeface="Calibri" pitchFamily="34" charset="0"/>
+                <a:ea typeface="Calibri" pitchFamily="34" charset="-122"/>
+                <a:cs typeface="Calibri" pitchFamily="34" charset="-120"/>
+              </a:rPr>
+              <a:t>5.  Activity tab: the call, with its summary, sentiment and priority</a:t>
+            </a:r>
+            <a:endParaRPr lang="en-US" sz="2700" dirty="0"/>
+          </a:p>
+          <a:p>
+            <a:pPr indent="0" marL="0">
+              <a:spcAft>
+                <a:spcPts val="800"/>
+              </a:spcAft>
+              <a:buNone/>
+            </a:pPr>
+            <a:r>
+              <a:rPr lang="en-US" sz="2700" dirty="0">
+                <a:solidFill>
+                  <a:srgbClr val="14213D"/>
+                </a:solidFill>
+                <a:latin typeface="Calibri" pitchFamily="34" charset="0"/>
+                <a:ea typeface="Calibri" pitchFamily="34" charset="-122"/>
+                <a:cs typeface="Calibri" pitchFamily="34" charset="-120"/>
+              </a:rPr>
+              <a:t>6.  MyAI tab: ask how to add a contact, or preview a patient chat</a:t>
+            </a:r>
+            <a:endParaRPr lang="en-US" sz="2700" dirty="0"/>
           </a:p>
         </p:txBody>
       </p:sp>
       <p:pic>
         <p:nvPicPr>
-          <p:cNvPr id="17" name="Image 0" descr="qr.png">    </p:cNvPr>
+          <p:cNvPr id="30" name="Image 0" descr="qr.png">    </p:cNvPr>
           <p:cNvPicPr>
             <a:picLocks noChangeAspect="1"/>
           </p:cNvPicPr>
@@ -1528,8 +1961,8 @@
         </p:blipFill>
         <p:spPr>
           <a:xfrm>
-            <a:off x="14996160" y="10424160"/>
-            <a:ext cx="3840480" cy="3840480"/>
+            <a:off x="15819120" y="9829800"/>
+            <a:ext cx="3931920" cy="3931920"/>
           </a:xfrm>
           <a:prstGeom prst="rect">
             <a:avLst/>
@@ -1538,14 +1971,14 @@
       </p:pic>
       <p:sp>
         <p:nvSpPr>
-          <p:cNvPr id="18" name="Text 15"/>
-          <p:cNvSpPr/>
-          <p:nvPr/>
-        </p:nvSpPr>
-        <p:spPr>
-          <a:xfrm>
-            <a:off x="14996160" y="14310360"/>
-            <a:ext cx="3840480" cy="457200"/>
+          <p:cNvPr id="31" name="Text 28"/>
+          <p:cNvSpPr/>
+          <p:nvPr/>
+        </p:nvSpPr>
+        <p:spPr>
+          <a:xfrm>
+            <a:off x="15819120" y="13807440"/>
+            <a:ext cx="3931920" cy="457200"/>
           </a:xfrm>
           <a:prstGeom prst="rect">
             <a:avLst/>
@@ -1561,7 +1994,7 @@
               <a:buNone/>
             </a:pPr>
             <a:r>
-              <a:rPr lang="en-US" sz="2400" b="1" dirty="0">
+              <a:rPr lang="en-US" sz="2200" b="1" dirty="0">
                 <a:solidFill>
                   <a:srgbClr val="1B2A49"/>
                 </a:solidFill>
@@ -1569,26 +2002,446 @@
                 <a:ea typeface="Calibri" pitchFamily="34" charset="-122"/>
                 <a:cs typeface="Calibri" pitchFamily="34" charset="-120"/>
               </a:rPr>
-              <a:t>Live demo</a:t>
-            </a:r>
-            <a:endParaRPr lang="en-US" sz="2400" dirty="0"/>
-          </a:p>
-        </p:txBody>
-      </p:sp>
-      <p:sp>
-        <p:nvSpPr>
-          <p:cNvPr id="19" name="Shape 16"/>
-          <p:cNvSpPr/>
-          <p:nvPr/>
-        </p:nvSpPr>
-        <p:spPr>
-          <a:xfrm>
-            <a:off x="914400" y="14996160"/>
-            <a:ext cx="3474720" cy="1554480"/>
+              <a:t>Our website</a:t>
+            </a:r>
+            <a:endParaRPr lang="en-US" sz="2200" dirty="0"/>
+          </a:p>
+        </p:txBody>
+      </p:sp>
+      <p:sp>
+        <p:nvSpPr>
+          <p:cNvPr id="32" name="Shape 29"/>
+          <p:cNvSpPr/>
+          <p:nvPr/>
+        </p:nvSpPr>
+        <p:spPr>
+          <a:xfrm>
+            <a:off x="914400" y="14584680"/>
+            <a:ext cx="4663440" cy="1600200"/>
           </a:xfrm>
           <a:prstGeom prst="roundRect">
             <a:avLst>
-              <a:gd name="adj" fmla="val 7059"/>
+              <a:gd name="adj" fmla="val 5714"/>
+            </a:avLst>
+          </a:prstGeom>
+          <a:solidFill>
+            <a:srgbClr val="EEF1F6"/>
+          </a:solidFill>
+          <a:ln w="12700">
+            <a:solidFill>
+              <a:srgbClr val="EEF1F6"/>
+            </a:solidFill>
+            <a:prstDash val="solid"/>
+          </a:ln>
+        </p:spPr>
+      </p:sp>
+      <p:sp>
+        <p:nvSpPr>
+          <p:cNvPr id="33" name="Text 30"/>
+          <p:cNvSpPr/>
+          <p:nvPr/>
+        </p:nvSpPr>
+        <p:spPr>
+          <a:xfrm>
+            <a:off x="1097280" y="14630400"/>
+            <a:ext cx="4297680" cy="777240"/>
+          </a:xfrm>
+          <a:prstGeom prst="rect">
+            <a:avLst/>
+          </a:prstGeom>
+          <a:noFill/>
+          <a:ln/>
+        </p:spPr>
+        <p:txBody>
+          <a:bodyPr wrap="square" lIns="0" tIns="0" rIns="0" bIns="0" rtlCol="0" anchor="ctr"/>
+          <a:lstStyle/>
+          <a:p>
+            <a:pPr indent="0" marL="0">
+              <a:buNone/>
+            </a:pPr>
+            <a:r>
+              <a:rPr lang="en-US" sz="4000" b="1" dirty="0">
+                <a:solidFill>
+                  <a:srgbClr val="1B2A49"/>
+                </a:solidFill>
+                <a:latin typeface="Cambria" pitchFamily="34" charset="0"/>
+                <a:ea typeface="Cambria" pitchFamily="34" charset="-122"/>
+                <a:cs typeface="Cambria" pitchFamily="34" charset="-120"/>
+              </a:rPr>
+              <a:t>761</a:t>
+            </a:r>
+            <a:endParaRPr lang="en-US" sz="4000" dirty="0"/>
+          </a:p>
+        </p:txBody>
+      </p:sp>
+      <p:sp>
+        <p:nvSpPr>
+          <p:cNvPr id="34" name="Text 31"/>
+          <p:cNvSpPr/>
+          <p:nvPr/>
+        </p:nvSpPr>
+        <p:spPr>
+          <a:xfrm>
+            <a:off x="1097280" y="15407640"/>
+            <a:ext cx="4297680" cy="731520"/>
+          </a:xfrm>
+          <a:prstGeom prst="rect">
+            <a:avLst/>
+          </a:prstGeom>
+          <a:noFill/>
+          <a:ln/>
+        </p:spPr>
+        <p:txBody>
+          <a:bodyPr wrap="square" lIns="0" tIns="0" rIns="0" bIns="0" rtlCol="0" anchor="t"/>
+          <a:lstStyle/>
+          <a:p>
+            <a:pPr indent="0" marL="0">
+              <a:buNone/>
+            </a:pPr>
+            <a:r>
+              <a:rPr lang="en-US" sz="1900" dirty="0">
+                <a:solidFill>
+                  <a:srgbClr val="14213D"/>
+                </a:solidFill>
+                <a:latin typeface="Calibri" pitchFamily="34" charset="0"/>
+                <a:ea typeface="Calibri" pitchFamily="34" charset="-122"/>
+                <a:cs typeface="Calibri" pitchFamily="34" charset="-120"/>
+              </a:rPr>
+              <a:t>automated tests, run by CI on every change</a:t>
+            </a:r>
+            <a:endParaRPr lang="en-US" sz="1900" dirty="0"/>
+          </a:p>
+        </p:txBody>
+      </p:sp>
+      <p:sp>
+        <p:nvSpPr>
+          <p:cNvPr id="35" name="Shape 32"/>
+          <p:cNvSpPr/>
+          <p:nvPr/>
+        </p:nvSpPr>
+        <p:spPr>
+          <a:xfrm>
+            <a:off x="5879592" y="14584680"/>
+            <a:ext cx="4663440" cy="1600200"/>
+          </a:xfrm>
+          <a:prstGeom prst="roundRect">
+            <a:avLst>
+              <a:gd name="adj" fmla="val 5714"/>
+            </a:avLst>
+          </a:prstGeom>
+          <a:solidFill>
+            <a:srgbClr val="EEF1F6"/>
+          </a:solidFill>
+          <a:ln w="12700">
+            <a:solidFill>
+              <a:srgbClr val="EEF1F6"/>
+            </a:solidFill>
+            <a:prstDash val="solid"/>
+          </a:ln>
+        </p:spPr>
+      </p:sp>
+      <p:sp>
+        <p:nvSpPr>
+          <p:cNvPr id="36" name="Text 33"/>
+          <p:cNvSpPr/>
+          <p:nvPr/>
+        </p:nvSpPr>
+        <p:spPr>
+          <a:xfrm>
+            <a:off x="6062472" y="14630400"/>
+            <a:ext cx="4297680" cy="777240"/>
+          </a:xfrm>
+          <a:prstGeom prst="rect">
+            <a:avLst/>
+          </a:prstGeom>
+          <a:noFill/>
+          <a:ln/>
+        </p:spPr>
+        <p:txBody>
+          <a:bodyPr wrap="square" lIns="0" tIns="0" rIns="0" bIns="0" rtlCol="0" anchor="ctr"/>
+          <a:lstStyle/>
+          <a:p>
+            <a:pPr indent="0" marL="0">
+              <a:buNone/>
+            </a:pPr>
+            <a:r>
+              <a:rPr lang="en-US" sz="4000" b="1" dirty="0">
+                <a:solidFill>
+                  <a:srgbClr val="1B2A49"/>
+                </a:solidFill>
+                <a:latin typeface="Cambria" pitchFamily="34" charset="0"/>
+                <a:ea typeface="Cambria" pitchFamily="34" charset="-122"/>
+                <a:cs typeface="Cambria" pitchFamily="34" charset="-120"/>
+              </a:rPr>
+              <a:t>403</a:t>
+            </a:r>
+            <a:endParaRPr lang="en-US" sz="4000" dirty="0"/>
+          </a:p>
+        </p:txBody>
+      </p:sp>
+      <p:sp>
+        <p:nvSpPr>
+          <p:cNvPr id="37" name="Text 34"/>
+          <p:cNvSpPr/>
+          <p:nvPr/>
+        </p:nvSpPr>
+        <p:spPr>
+          <a:xfrm>
+            <a:off x="6062472" y="15407640"/>
+            <a:ext cx="4297680" cy="731520"/>
+          </a:xfrm>
+          <a:prstGeom prst="rect">
+            <a:avLst/>
+          </a:prstGeom>
+          <a:noFill/>
+          <a:ln/>
+        </p:spPr>
+        <p:txBody>
+          <a:bodyPr wrap="square" lIns="0" tIns="0" rIns="0" bIns="0" rtlCol="0" anchor="t"/>
+          <a:lstStyle/>
+          <a:p>
+            <a:pPr indent="0" marL="0">
+              <a:buNone/>
+            </a:pPr>
+            <a:r>
+              <a:rPr lang="en-US" sz="1900" dirty="0">
+                <a:solidFill>
+                  <a:srgbClr val="14213D"/>
+                </a:solidFill>
+                <a:latin typeface="Calibri" pitchFamily="34" charset="0"/>
+                <a:ea typeface="Calibri" pitchFamily="34" charset="-122"/>
+                <a:cs typeface="Calibri" pitchFamily="34" charset="-120"/>
+              </a:rPr>
+              <a:t>reply to any forged Twilio call</a:t>
+            </a:r>
+            <a:endParaRPr lang="en-US" sz="1900" dirty="0"/>
+          </a:p>
+        </p:txBody>
+      </p:sp>
+      <p:sp>
+        <p:nvSpPr>
+          <p:cNvPr id="38" name="Shape 35"/>
+          <p:cNvSpPr/>
+          <p:nvPr/>
+        </p:nvSpPr>
+        <p:spPr>
+          <a:xfrm>
+            <a:off x="10844784" y="14584680"/>
+            <a:ext cx="4663440" cy="1600200"/>
+          </a:xfrm>
+          <a:prstGeom prst="roundRect">
+            <a:avLst>
+              <a:gd name="adj" fmla="val 5714"/>
+            </a:avLst>
+          </a:prstGeom>
+          <a:solidFill>
+            <a:srgbClr val="EEF1F6"/>
+          </a:solidFill>
+          <a:ln w="12700">
+            <a:solidFill>
+              <a:srgbClr val="EEF1F6"/>
+            </a:solidFill>
+            <a:prstDash val="solid"/>
+          </a:ln>
+        </p:spPr>
+      </p:sp>
+      <p:sp>
+        <p:nvSpPr>
+          <p:cNvPr id="39" name="Text 36"/>
+          <p:cNvSpPr/>
+          <p:nvPr/>
+        </p:nvSpPr>
+        <p:spPr>
+          <a:xfrm>
+            <a:off x="11027664" y="14630400"/>
+            <a:ext cx="4297680" cy="777240"/>
+          </a:xfrm>
+          <a:prstGeom prst="rect">
+            <a:avLst/>
+          </a:prstGeom>
+          <a:noFill/>
+          <a:ln/>
+        </p:spPr>
+        <p:txBody>
+          <a:bodyPr wrap="square" lIns="0" tIns="0" rIns="0" bIns="0" rtlCol="0" anchor="ctr"/>
+          <a:lstStyle/>
+          <a:p>
+            <a:pPr indent="0" marL="0">
+              <a:buNone/>
+            </a:pPr>
+            <a:r>
+              <a:rPr lang="en-US" sz="4000" b="1" dirty="0">
+                <a:solidFill>
+                  <a:srgbClr val="1B2A49"/>
+                </a:solidFill>
+                <a:latin typeface="Cambria" pitchFamily="34" charset="0"/>
+                <a:ea typeface="Cambria" pitchFamily="34" charset="-122"/>
+                <a:cs typeface="Cambria" pitchFamily="34" charset="-120"/>
+              </a:rPr>
+              <a:t>7 s</a:t>
+            </a:r>
+            <a:endParaRPr lang="en-US" sz="4000" dirty="0"/>
+          </a:p>
+        </p:txBody>
+      </p:sp>
+      <p:sp>
+        <p:nvSpPr>
+          <p:cNvPr id="40" name="Text 37"/>
+          <p:cNvSpPr/>
+          <p:nvPr/>
+        </p:nvSpPr>
+        <p:spPr>
+          <a:xfrm>
+            <a:off x="11027664" y="15407640"/>
+            <a:ext cx="4297680" cy="731520"/>
+          </a:xfrm>
+          <a:prstGeom prst="rect">
+            <a:avLst/>
+          </a:prstGeom>
+          <a:noFill/>
+          <a:ln/>
+        </p:spPr>
+        <p:txBody>
+          <a:bodyPr wrap="square" lIns="0" tIns="0" rIns="0" bIns="0" rtlCol="0" anchor="t"/>
+          <a:lstStyle/>
+          <a:p>
+            <a:pPr indent="0" marL="0">
+              <a:buNone/>
+            </a:pPr>
+            <a:r>
+              <a:rPr lang="en-US" sz="1900" dirty="0">
+                <a:solidFill>
+                  <a:srgbClr val="14213D"/>
+                </a:solidFill>
+                <a:latin typeface="Calibri" pitchFamily="34" charset="0"/>
+                <a:ea typeface="Calibri" pitchFamily="34" charset="-122"/>
+                <a:cs typeface="Calibri" pitchFamily="34" charset="-120"/>
+              </a:rPr>
+              <a:t>email reminder arrived after its send time</a:t>
+            </a:r>
+            <a:endParaRPr lang="en-US" sz="1900" dirty="0"/>
+          </a:p>
+        </p:txBody>
+      </p:sp>
+      <p:sp>
+        <p:nvSpPr>
+          <p:cNvPr id="41" name="Shape 38"/>
+          <p:cNvSpPr/>
+          <p:nvPr/>
+        </p:nvSpPr>
+        <p:spPr>
+          <a:xfrm>
+            <a:off x="15809976" y="14584680"/>
+            <a:ext cx="4663440" cy="1600200"/>
+          </a:xfrm>
+          <a:prstGeom prst="roundRect">
+            <a:avLst>
+              <a:gd name="adj" fmla="val 5714"/>
+            </a:avLst>
+          </a:prstGeom>
+          <a:solidFill>
+            <a:srgbClr val="EEF1F6"/>
+          </a:solidFill>
+          <a:ln w="12700">
+            <a:solidFill>
+              <a:srgbClr val="EEF1F6"/>
+            </a:solidFill>
+            <a:prstDash val="solid"/>
+          </a:ln>
+        </p:spPr>
+      </p:sp>
+      <p:sp>
+        <p:nvSpPr>
+          <p:cNvPr id="42" name="Text 39"/>
+          <p:cNvSpPr/>
+          <p:nvPr/>
+        </p:nvSpPr>
+        <p:spPr>
+          <a:xfrm>
+            <a:off x="15992856" y="14630400"/>
+            <a:ext cx="4297680" cy="777240"/>
+          </a:xfrm>
+          <a:prstGeom prst="rect">
+            <a:avLst/>
+          </a:prstGeom>
+          <a:noFill/>
+          <a:ln/>
+        </p:spPr>
+        <p:txBody>
+          <a:bodyPr wrap="square" lIns="0" tIns="0" rIns="0" bIns="0" rtlCol="0" anchor="ctr"/>
+          <a:lstStyle/>
+          <a:p>
+            <a:pPr indent="0" marL="0">
+              <a:buNone/>
+            </a:pPr>
+            <a:r>
+              <a:rPr lang="en-US" sz="4000" b="1" dirty="0">
+                <a:solidFill>
+                  <a:srgbClr val="1B2A49"/>
+                </a:solidFill>
+                <a:latin typeface="Cambria" pitchFamily="34" charset="0"/>
+                <a:ea typeface="Cambria" pitchFamily="34" charset="-122"/>
+                <a:cs typeface="Cambria" pitchFamily="34" charset="-120"/>
+              </a:rPr>
+              <a:t>Live</a:t>
+            </a:r>
+            <a:endParaRPr lang="en-US" sz="4000" dirty="0"/>
+          </a:p>
+        </p:txBody>
+      </p:sp>
+      <p:sp>
+        <p:nvSpPr>
+          <p:cNvPr id="43" name="Text 40"/>
+          <p:cNvSpPr/>
+          <p:nvPr/>
+        </p:nvSpPr>
+        <p:spPr>
+          <a:xfrm>
+            <a:off x="15992856" y="15407640"/>
+            <a:ext cx="4297680" cy="731520"/>
+          </a:xfrm>
+          <a:prstGeom prst="rect">
+            <a:avLst/>
+          </a:prstGeom>
+          <a:noFill/>
+          <a:ln/>
+        </p:spPr>
+        <p:txBody>
+          <a:bodyPr wrap="square" lIns="0" tIns="0" rIns="0" bIns="0" rtlCol="0" anchor="t"/>
+          <a:lstStyle/>
+          <a:p>
+            <a:pPr indent="0" marL="0">
+              <a:buNone/>
+            </a:pPr>
+            <a:r>
+              <a:rPr lang="en-US" sz="1900" dirty="0">
+                <a:solidFill>
+                  <a:srgbClr val="14213D"/>
+                </a:solidFill>
+                <a:latin typeface="Calibri" pitchFamily="34" charset="0"/>
+                <a:ea typeface="Calibri" pitchFamily="34" charset="-122"/>
+                <a:cs typeface="Calibri" pitchFamily="34" charset="-120"/>
+              </a:rPr>
+              <a:t>a real call answered by voice</a:t>
+            </a:r>
+            <a:endParaRPr lang="en-US" sz="1900" dirty="0"/>
+          </a:p>
+        </p:txBody>
+      </p:sp>
+      <p:sp>
+        <p:nvSpPr>
+          <p:cNvPr id="44" name="Shape 41"/>
+          <p:cNvSpPr/>
+          <p:nvPr/>
+        </p:nvSpPr>
+        <p:spPr>
+          <a:xfrm>
+            <a:off x="914400" y="16596360"/>
+            <a:ext cx="3474720" cy="1417320"/>
+          </a:xfrm>
+          <a:prstGeom prst="roundRect">
+            <a:avLst>
+              <a:gd name="adj" fmla="val 7742"/>
             </a:avLst>
           </a:prstGeom>
           <a:solidFill>
@@ -1604,14 +2457,14 @@
       </p:sp>
       <p:sp>
         <p:nvSpPr>
-          <p:cNvPr id="20" name="Text 17"/>
-          <p:cNvSpPr/>
-          <p:nvPr/>
-        </p:nvSpPr>
-        <p:spPr>
-          <a:xfrm>
-            <a:off x="1051560" y="14996160"/>
-            <a:ext cx="3200400" cy="1554480"/>
+          <p:cNvPr id="45" name="Text 42"/>
+          <p:cNvSpPr/>
+          <p:nvPr/>
+        </p:nvSpPr>
+        <p:spPr>
+          <a:xfrm>
+            <a:off x="1024128" y="16596360"/>
+            <a:ext cx="3255264" cy="1417320"/>
           </a:xfrm>
           <a:prstGeom prst="rect">
             <a:avLst/>
@@ -1627,7 +2480,7 @@
               <a:buNone/>
             </a:pPr>
             <a:r>
-              <a:rPr lang="en-US" sz="2800" b="1" dirty="0">
+              <a:rPr lang="en-US" sz="2500" b="1" dirty="0">
                 <a:solidFill>
                   <a:srgbClr val="1B2A49"/>
                 </a:solidFill>
@@ -1637,14 +2490,14 @@
               </a:rPr>
               <a:t>Web app + CRM</a:t>
             </a:r>
-            <a:endParaRPr lang="en-US" sz="2800" dirty="0"/>
+            <a:endParaRPr lang="en-US" sz="2500" dirty="0"/>
           </a:p>
           <a:p>
             <a:pPr algn="ctr" indent="0" marL="0">
               <a:buNone/>
             </a:pPr>
             <a:r>
-              <a:rPr lang="en-US" sz="2200" dirty="0">
+              <a:rPr lang="en-US" sz="1900" dirty="0">
                 <a:solidFill>
                   <a:srgbClr val="14213D"/>
                 </a:solidFill>
@@ -1654,24 +2507,24 @@
               </a:rPr>
               <a:t>accounts, contacts</a:t>
             </a:r>
-            <a:endParaRPr lang="en-US" sz="2800" dirty="0"/>
-          </a:p>
-        </p:txBody>
-      </p:sp>
-      <p:sp>
-        <p:nvSpPr>
-          <p:cNvPr id="21" name="Shape 18"/>
-          <p:cNvSpPr/>
-          <p:nvPr/>
-        </p:nvSpPr>
-        <p:spPr>
-          <a:xfrm>
-            <a:off x="4937760" y="14996160"/>
-            <a:ext cx="3474720" cy="1554480"/>
+            <a:endParaRPr lang="en-US" sz="2500" dirty="0"/>
+          </a:p>
+        </p:txBody>
+      </p:sp>
+      <p:sp>
+        <p:nvSpPr>
+          <p:cNvPr id="46" name="Shape 43"/>
+          <p:cNvSpPr/>
+          <p:nvPr/>
+        </p:nvSpPr>
+        <p:spPr>
+          <a:xfrm>
+            <a:off x="4937760" y="16596360"/>
+            <a:ext cx="3474720" cy="1417320"/>
           </a:xfrm>
           <a:prstGeom prst="roundRect">
             <a:avLst>
-              <a:gd name="adj" fmla="val 7059"/>
+              <a:gd name="adj" fmla="val 7742"/>
             </a:avLst>
           </a:prstGeom>
           <a:solidFill>
@@ -1687,14 +2540,14 @@
       </p:sp>
       <p:sp>
         <p:nvSpPr>
-          <p:cNvPr id="22" name="Text 19"/>
-          <p:cNvSpPr/>
-          <p:nvPr/>
-        </p:nvSpPr>
-        <p:spPr>
-          <a:xfrm>
-            <a:off x="5074920" y="14996160"/>
-            <a:ext cx="3200400" cy="1554480"/>
+          <p:cNvPr id="47" name="Text 44"/>
+          <p:cNvSpPr/>
+          <p:nvPr/>
+        </p:nvSpPr>
+        <p:spPr>
+          <a:xfrm>
+            <a:off x="5047488" y="16596360"/>
+            <a:ext cx="3255264" cy="1417320"/>
           </a:xfrm>
           <a:prstGeom prst="rect">
             <a:avLst/>
@@ -1710,7 +2563,7 @@
               <a:buNone/>
             </a:pPr>
             <a:r>
-              <a:rPr lang="en-US" sz="2800" b="1" dirty="0">
+              <a:rPr lang="en-US" sz="2500" b="1" dirty="0">
                 <a:solidFill>
                   <a:srgbClr val="1B2A49"/>
                 </a:solidFill>
@@ -1720,14 +2573,14 @@
               </a:rPr>
               <a:t>Consent gate</a:t>
             </a:r>
-            <a:endParaRPr lang="en-US" sz="2800" dirty="0"/>
+            <a:endParaRPr lang="en-US" sz="2500" dirty="0"/>
           </a:p>
           <a:p>
             <a:pPr algn="ctr" indent="0" marL="0">
               <a:buNone/>
             </a:pPr>
             <a:r>
-              <a:rPr lang="en-US" sz="2200" dirty="0">
+              <a:rPr lang="en-US" sz="1900" dirty="0">
                 <a:solidFill>
                   <a:srgbClr val="14213D"/>
                 </a:solidFill>
@@ -1737,24 +2590,24 @@
               </a:rPr>
               <a:t>opt-in, STOP, quiet hours</a:t>
             </a:r>
-            <a:endParaRPr lang="en-US" sz="2800" dirty="0"/>
-          </a:p>
-        </p:txBody>
-      </p:sp>
-      <p:sp>
-        <p:nvSpPr>
-          <p:cNvPr id="23" name="Shape 20"/>
-          <p:cNvSpPr/>
-          <p:nvPr/>
-        </p:nvSpPr>
-        <p:spPr>
-          <a:xfrm>
-            <a:off x="8961120" y="14996160"/>
-            <a:ext cx="3474720" cy="1554480"/>
+            <a:endParaRPr lang="en-US" sz="2500" dirty="0"/>
+          </a:p>
+        </p:txBody>
+      </p:sp>
+      <p:sp>
+        <p:nvSpPr>
+          <p:cNvPr id="48" name="Shape 45"/>
+          <p:cNvSpPr/>
+          <p:nvPr/>
+        </p:nvSpPr>
+        <p:spPr>
+          <a:xfrm>
+            <a:off x="8961120" y="16596360"/>
+            <a:ext cx="3474720" cy="1417320"/>
           </a:xfrm>
           <a:prstGeom prst="roundRect">
             <a:avLst>
-              <a:gd name="adj" fmla="val 7059"/>
+              <a:gd name="adj" fmla="val 7742"/>
             </a:avLst>
           </a:prstGeom>
           <a:solidFill>
@@ -1770,14 +2623,14 @@
       </p:sp>
       <p:sp>
         <p:nvSpPr>
-          <p:cNvPr id="24" name="Text 21"/>
-          <p:cNvSpPr/>
-          <p:nvPr/>
-        </p:nvSpPr>
-        <p:spPr>
-          <a:xfrm>
-            <a:off x="9098280" y="14996160"/>
-            <a:ext cx="3200400" cy="1554480"/>
+          <p:cNvPr id="49" name="Text 46"/>
+          <p:cNvSpPr/>
+          <p:nvPr/>
+        </p:nvSpPr>
+        <p:spPr>
+          <a:xfrm>
+            <a:off x="9070848" y="16596360"/>
+            <a:ext cx="3255264" cy="1417320"/>
           </a:xfrm>
           <a:prstGeom prst="rect">
             <a:avLst/>
@@ -1793,7 +2646,7 @@
               <a:buNone/>
             </a:pPr>
             <a:r>
-              <a:rPr lang="en-US" sz="2800" b="1" dirty="0">
+              <a:rPr lang="en-US" sz="2500" b="1" dirty="0">
                 <a:solidFill>
                   <a:srgbClr val="1B2A49"/>
                 </a:solidFill>
@@ -1803,14 +2656,14 @@
               </a:rPr>
               <a:t>Reminders engine</a:t>
             </a:r>
-            <a:endParaRPr lang="en-US" sz="2800" dirty="0"/>
+            <a:endParaRPr lang="en-US" sz="2500" dirty="0"/>
           </a:p>
           <a:p>
             <a:pPr algn="ctr" indent="0" marL="0">
               <a:buNone/>
             </a:pPr>
             <a:r>
-              <a:rPr lang="en-US" sz="2200" dirty="0">
+              <a:rPr lang="en-US" sz="1900" dirty="0">
                 <a:solidFill>
                   <a:srgbClr val="14213D"/>
                 </a:solidFill>
@@ -1820,24 +2673,24 @@
               </a:rPr>
               <a:t>no double sends</a:t>
             </a:r>
-            <a:endParaRPr lang="en-US" sz="2800" dirty="0"/>
-          </a:p>
-        </p:txBody>
-      </p:sp>
-      <p:sp>
-        <p:nvSpPr>
-          <p:cNvPr id="25" name="Shape 22"/>
-          <p:cNvSpPr/>
-          <p:nvPr/>
-        </p:nvSpPr>
-        <p:spPr>
-          <a:xfrm>
-            <a:off x="12984480" y="14996160"/>
-            <a:ext cx="3474720" cy="1554480"/>
+            <a:endParaRPr lang="en-US" sz="2500" dirty="0"/>
+          </a:p>
+        </p:txBody>
+      </p:sp>
+      <p:sp>
+        <p:nvSpPr>
+          <p:cNvPr id="50" name="Shape 47"/>
+          <p:cNvSpPr/>
+          <p:nvPr/>
+        </p:nvSpPr>
+        <p:spPr>
+          <a:xfrm>
+            <a:off x="12984480" y="16596360"/>
+            <a:ext cx="3474720" cy="1417320"/>
           </a:xfrm>
           <a:prstGeom prst="roundRect">
             <a:avLst>
-              <a:gd name="adj" fmla="val 7059"/>
+              <a:gd name="adj" fmla="val 7742"/>
             </a:avLst>
           </a:prstGeom>
           <a:solidFill>
@@ -1853,14 +2706,14 @@
       </p:sp>
       <p:sp>
         <p:nvSpPr>
-          <p:cNvPr id="26" name="Text 23"/>
-          <p:cNvSpPr/>
-          <p:nvPr/>
-        </p:nvSpPr>
-        <p:spPr>
-          <a:xfrm>
-            <a:off x="13121640" y="14996160"/>
-            <a:ext cx="3200400" cy="1554480"/>
+          <p:cNvPr id="51" name="Text 48"/>
+          <p:cNvSpPr/>
+          <p:nvPr/>
+        </p:nvSpPr>
+        <p:spPr>
+          <a:xfrm>
+            <a:off x="13094208" y="16596360"/>
+            <a:ext cx="3255264" cy="1417320"/>
           </a:xfrm>
           <a:prstGeom prst="rect">
             <a:avLst/>
@@ -1876,7 +2729,7 @@
               <a:buNone/>
             </a:pPr>
             <a:r>
-              <a:rPr lang="en-US" sz="2800" b="1" dirty="0">
+              <a:rPr lang="en-US" sz="2500" b="1" dirty="0">
                 <a:solidFill>
                   <a:srgbClr val="1B2A49"/>
                 </a:solidFill>
@@ -1886,14 +2739,14 @@
               </a:rPr>
               <a:t>SMS, voice, email</a:t>
             </a:r>
-            <a:endParaRPr lang="en-US" sz="2800" dirty="0"/>
+            <a:endParaRPr lang="en-US" sz="2500" dirty="0"/>
           </a:p>
           <a:p>
             <a:pPr algn="ctr" indent="0" marL="0">
               <a:buNone/>
             </a:pPr>
             <a:r>
-              <a:rPr lang="en-US" sz="2200" dirty="0">
+              <a:rPr lang="en-US" sz="1900" dirty="0">
                 <a:solidFill>
                   <a:srgbClr val="14213D"/>
                 </a:solidFill>
@@ -1901,26 +2754,26 @@
                 <a:ea typeface="Calibri" pitchFamily="34" charset="-122"/>
                 <a:cs typeface="Calibri" pitchFamily="34" charset="-120"/>
               </a:rPr>
-              <a:t>via Twilio and SMTP</a:t>
-            </a:r>
-            <a:endParaRPr lang="en-US" sz="2800" dirty="0"/>
-          </a:p>
-        </p:txBody>
-      </p:sp>
-      <p:sp>
-        <p:nvSpPr>
-          <p:cNvPr id="27" name="Shape 24"/>
-          <p:cNvSpPr/>
-          <p:nvPr/>
-        </p:nvSpPr>
-        <p:spPr>
-          <a:xfrm>
-            <a:off x="17007840" y="14996160"/>
-            <a:ext cx="3474720" cy="1554480"/>
+              <a:t>Twilio and SMTP</a:t>
+            </a:r>
+            <a:endParaRPr lang="en-US" sz="2500" dirty="0"/>
+          </a:p>
+        </p:txBody>
+      </p:sp>
+      <p:sp>
+        <p:nvSpPr>
+          <p:cNvPr id="52" name="Shape 49"/>
+          <p:cNvSpPr/>
+          <p:nvPr/>
+        </p:nvSpPr>
+        <p:spPr>
+          <a:xfrm>
+            <a:off x="17007840" y="16596360"/>
+            <a:ext cx="3474720" cy="1417320"/>
           </a:xfrm>
           <a:prstGeom prst="roundRect">
             <a:avLst>
-              <a:gd name="adj" fmla="val 7059"/>
+              <a:gd name="adj" fmla="val 7742"/>
             </a:avLst>
           </a:prstGeom>
           <a:solidFill>
@@ -1936,14 +2789,14 @@
       </p:sp>
       <p:sp>
         <p:nvSpPr>
-          <p:cNvPr id="28" name="Text 25"/>
-          <p:cNvSpPr/>
-          <p:nvPr/>
-        </p:nvSpPr>
-        <p:spPr>
-          <a:xfrm>
-            <a:off x="17145000" y="14996160"/>
-            <a:ext cx="3200400" cy="1554480"/>
+          <p:cNvPr id="53" name="Text 50"/>
+          <p:cNvSpPr/>
+          <p:nvPr/>
+        </p:nvSpPr>
+        <p:spPr>
+          <a:xfrm>
+            <a:off x="17117568" y="16596360"/>
+            <a:ext cx="3255264" cy="1417320"/>
           </a:xfrm>
           <a:prstGeom prst="rect">
             <a:avLst/>
@@ -1959,7 +2812,7 @@
               <a:buNone/>
             </a:pPr>
             <a:r>
-              <a:rPr lang="en-US" sz="2800" b="1" dirty="0">
+              <a:rPr lang="en-US" sz="2500" b="1" dirty="0">
                 <a:solidFill>
                   <a:srgbClr val="1B2A49"/>
                 </a:solidFill>
@@ -1967,16 +2820,16 @@
                 <a:ea typeface="Calibri" pitchFamily="34" charset="-122"/>
                 <a:cs typeface="Calibri" pitchFamily="34" charset="-120"/>
               </a:rPr>
-              <a:t>Dashboard</a:t>
-            </a:r>
-            <a:endParaRPr lang="en-US" sz="2800" dirty="0"/>
+              <a:t>AI receptionist</a:t>
+            </a:r>
+            <a:endParaRPr lang="en-US" sz="2500" dirty="0"/>
           </a:p>
           <a:p>
             <a:pPr algn="ctr" indent="0" marL="0">
               <a:buNone/>
             </a:pPr>
             <a:r>
-              <a:rPr lang="en-US" sz="2200" dirty="0">
+              <a:rPr lang="en-US" sz="1900" dirty="0">
                 <a:solidFill>
                   <a:srgbClr val="14213D"/>
                 </a:solidFill>
@@ -1984,21 +2837,21 @@
                 <a:ea typeface="Calibri" pitchFamily="34" charset="-122"/>
                 <a:cs typeface="Calibri" pitchFamily="34" charset="-120"/>
               </a:rPr>
-              <a:t>status and history</a:t>
-            </a:r>
-            <a:endParaRPr lang="en-US" sz="2800" dirty="0"/>
-          </a:p>
-        </p:txBody>
-      </p:sp>
-      <p:sp>
-        <p:nvSpPr>
-          <p:cNvPr id="29" name="Shape 26"/>
-          <p:cNvSpPr/>
-          <p:nvPr/>
-        </p:nvSpPr>
-        <p:spPr>
-          <a:xfrm>
-            <a:off x="4434840" y="15773400"/>
+              <a:t>FAQ, handoff, booking</a:t>
+            </a:r>
+            <a:endParaRPr lang="en-US" sz="2500" dirty="0"/>
+          </a:p>
+        </p:txBody>
+      </p:sp>
+      <p:sp>
+        <p:nvSpPr>
+          <p:cNvPr id="54" name="Shape 51"/>
+          <p:cNvSpPr/>
+          <p:nvPr/>
+        </p:nvSpPr>
+        <p:spPr>
+          <a:xfrm>
+            <a:off x="4434840" y="17305020"/>
             <a:ext cx="457200" cy="0"/>
           </a:xfrm>
           <a:prstGeom prst="line">
@@ -2016,13 +2869,13 @@
       </p:sp>
       <p:sp>
         <p:nvSpPr>
-          <p:cNvPr id="30" name="Shape 27"/>
-          <p:cNvSpPr/>
-          <p:nvPr/>
-        </p:nvSpPr>
-        <p:spPr>
-          <a:xfrm>
-            <a:off x="8458200" y="15773400"/>
+          <p:cNvPr id="55" name="Shape 52"/>
+          <p:cNvSpPr/>
+          <p:nvPr/>
+        </p:nvSpPr>
+        <p:spPr>
+          <a:xfrm>
+            <a:off x="8458200" y="17305020"/>
             <a:ext cx="457200" cy="0"/>
           </a:xfrm>
           <a:prstGeom prst="line">
@@ -2040,13 +2893,13 @@
       </p:sp>
       <p:sp>
         <p:nvSpPr>
-          <p:cNvPr id="31" name="Shape 28"/>
-          <p:cNvSpPr/>
-          <p:nvPr/>
-        </p:nvSpPr>
-        <p:spPr>
-          <a:xfrm>
-            <a:off x="12481560" y="15773400"/>
+          <p:cNvPr id="56" name="Shape 53"/>
+          <p:cNvSpPr/>
+          <p:nvPr/>
+        </p:nvSpPr>
+        <p:spPr>
+          <a:xfrm>
+            <a:off x="12481560" y="17305020"/>
             <a:ext cx="457200" cy="0"/>
           </a:xfrm>
           <a:prstGeom prst="line">
@@ -2064,13 +2917,13 @@
       </p:sp>
       <p:sp>
         <p:nvSpPr>
-          <p:cNvPr id="32" name="Shape 29"/>
-          <p:cNvSpPr/>
-          <p:nvPr/>
-        </p:nvSpPr>
-        <p:spPr>
-          <a:xfrm>
-            <a:off x="16504920" y="15773400"/>
+          <p:cNvPr id="57" name="Shape 54"/>
+          <p:cNvSpPr/>
+          <p:nvPr/>
+        </p:nvSpPr>
+        <p:spPr>
+          <a:xfrm>
+            <a:off x="16504920" y="17305020"/>
             <a:ext cx="457200" cy="0"/>
           </a:xfrm>
           <a:prstGeom prst="line">
@@ -2088,239 +2941,14 @@
       </p:sp>
       <p:sp>
         <p:nvSpPr>
-          <p:cNvPr id="33" name="Shape 30"/>
-          <p:cNvSpPr/>
-          <p:nvPr/>
-        </p:nvSpPr>
-        <p:spPr>
-          <a:xfrm>
-            <a:off x="914400" y="16916400"/>
-            <a:ext cx="9509760" cy="1371600"/>
-          </a:xfrm>
-          <a:prstGeom prst="roundRect">
-            <a:avLst>
-              <a:gd name="adj" fmla="val 8000"/>
-            </a:avLst>
-          </a:prstGeom>
-          <a:solidFill>
-            <a:srgbClr val="EEF1F6"/>
-          </a:solidFill>
-          <a:ln w="25400">
-            <a:solidFill>
-              <a:srgbClr val="1B2A49"/>
-            </a:solidFill>
-            <a:prstDash val="solid"/>
-          </a:ln>
-        </p:spPr>
-      </p:sp>
-      <p:sp>
-        <p:nvSpPr>
-          <p:cNvPr id="34" name="Text 31"/>
-          <p:cNvSpPr/>
-          <p:nvPr/>
-        </p:nvSpPr>
-        <p:spPr>
-          <a:xfrm>
-            <a:off x="1051560" y="16916400"/>
-            <a:ext cx="9235440" cy="1371600"/>
-          </a:xfrm>
-          <a:prstGeom prst="rect">
-            <a:avLst/>
-          </a:prstGeom>
-          <a:noFill/>
-          <a:ln/>
-        </p:spPr>
-        <p:txBody>
-          <a:bodyPr wrap="square" lIns="0" tIns="0" rIns="0" bIns="0" rtlCol="0" anchor="ctr"/>
-          <a:lstStyle/>
-          <a:p>
-            <a:pPr algn="ctr" indent="0" marL="0">
-              <a:buNone/>
-            </a:pPr>
-            <a:r>
-              <a:rPr lang="en-US" sz="2800" b="1" dirty="0">
-                <a:solidFill>
-                  <a:srgbClr val="1B2A49"/>
-                </a:solidFill>
-                <a:latin typeface="Calibri" pitchFamily="34" charset="0"/>
-                <a:ea typeface="Calibri" pitchFamily="34" charset="-122"/>
-                <a:cs typeface="Calibri" pitchFamily="34" charset="-120"/>
-              </a:rPr>
-              <a:t>AI receptionist</a:t>
-            </a:r>
-            <a:endParaRPr lang="en-US" sz="2800" dirty="0"/>
-          </a:p>
-          <a:p>
-            <a:pPr algn="ctr" indent="0" marL="0">
-              <a:buNone/>
-            </a:pPr>
-            <a:r>
-              <a:rPr lang="en-US" sz="2200" dirty="0">
-                <a:solidFill>
-                  <a:srgbClr val="14213D"/>
-                </a:solidFill>
-                <a:latin typeface="Calibri" pitchFamily="34" charset="0"/>
-                <a:ea typeface="Calibri" pitchFamily="34" charset="-122"/>
-                <a:cs typeface="Calibri" pitchFamily="34" charset="-120"/>
-              </a:rPr>
-              <a:t>FAQ, human handoff, booking, Claude</a:t>
-            </a:r>
-            <a:endParaRPr lang="en-US" sz="2800" dirty="0"/>
-          </a:p>
-        </p:txBody>
-      </p:sp>
-      <p:sp>
-        <p:nvSpPr>
-          <p:cNvPr id="35" name="Shape 32"/>
-          <p:cNvSpPr/>
-          <p:nvPr/>
-        </p:nvSpPr>
-        <p:spPr>
-          <a:xfrm>
-            <a:off x="10972800" y="16916400"/>
-            <a:ext cx="9509760" cy="1371600"/>
-          </a:xfrm>
-          <a:prstGeom prst="roundRect">
-            <a:avLst>
-              <a:gd name="adj" fmla="val 8000"/>
-            </a:avLst>
-          </a:prstGeom>
-          <a:solidFill>
-            <a:srgbClr val="EEF1F6"/>
-          </a:solidFill>
-          <a:ln w="25400">
-            <a:solidFill>
-              <a:srgbClr val="1B2A49"/>
-            </a:solidFill>
-            <a:prstDash val="solid"/>
-          </a:ln>
-        </p:spPr>
-      </p:sp>
-      <p:sp>
-        <p:nvSpPr>
-          <p:cNvPr id="36" name="Text 33"/>
-          <p:cNvSpPr/>
-          <p:nvPr/>
-        </p:nvSpPr>
-        <p:spPr>
-          <a:xfrm>
-            <a:off x="11109960" y="16916400"/>
-            <a:ext cx="9235440" cy="1371600"/>
-          </a:xfrm>
-          <a:prstGeom prst="rect">
-            <a:avLst/>
-          </a:prstGeom>
-          <a:noFill/>
-          <a:ln/>
-        </p:spPr>
-        <p:txBody>
-          <a:bodyPr wrap="square" lIns="0" tIns="0" rIns="0" bIns="0" rtlCol="0" anchor="ctr"/>
-          <a:lstStyle/>
-          <a:p>
-            <a:pPr algn="ctr" indent="0" marL="0">
-              <a:buNone/>
-            </a:pPr>
-            <a:r>
-              <a:rPr lang="en-US" sz="2800" b="1" dirty="0">
-                <a:solidFill>
-                  <a:srgbClr val="1B2A49"/>
-                </a:solidFill>
-                <a:latin typeface="Calibri" pitchFamily="34" charset="0"/>
-                <a:ea typeface="Calibri" pitchFamily="34" charset="-122"/>
-                <a:cs typeface="Calibri" pitchFamily="34" charset="-120"/>
-              </a:rPr>
-              <a:t>Call summaries</a:t>
-            </a:r>
-            <a:endParaRPr lang="en-US" sz="2800" dirty="0"/>
-          </a:p>
-          <a:p>
-            <a:pPr algn="ctr" indent="0" marL="0">
-              <a:buNone/>
-            </a:pPr>
-            <a:r>
-              <a:rPr lang="en-US" sz="2200" dirty="0">
-                <a:solidFill>
-                  <a:srgbClr val="14213D"/>
-                </a:solidFill>
-                <a:latin typeface="Calibri" pitchFamily="34" charset="0"/>
-                <a:ea typeface="Calibri" pitchFamily="34" charset="-122"/>
-                <a:cs typeface="Calibri" pitchFamily="34" charset="-120"/>
-              </a:rPr>
-              <a:t>sentiment and priority for the operator</a:t>
-            </a:r>
-            <a:endParaRPr lang="en-US" sz="2800" dirty="0"/>
-          </a:p>
-        </p:txBody>
-      </p:sp>
-      <p:sp>
-        <p:nvSpPr>
-          <p:cNvPr id="37" name="Shape 34"/>
-          <p:cNvSpPr/>
-          <p:nvPr/>
-        </p:nvSpPr>
-        <p:spPr>
-          <a:xfrm>
-            <a:off x="914400" y="18653760"/>
-            <a:ext cx="19568160" cy="868680"/>
-          </a:xfrm>
-          <a:prstGeom prst="rect">
-            <a:avLst/>
-          </a:prstGeom>
-          <a:solidFill>
-            <a:srgbClr val="EEF1F6"/>
-          </a:solidFill>
-          <a:ln/>
-        </p:spPr>
-      </p:sp>
-      <p:sp>
-        <p:nvSpPr>
-          <p:cNvPr id="38" name="Text 35"/>
-          <p:cNvSpPr/>
-          <p:nvPr/>
-        </p:nvSpPr>
-        <p:spPr>
-          <a:xfrm>
-            <a:off x="1188720" y="18653760"/>
-            <a:ext cx="19019520" cy="868680"/>
-          </a:xfrm>
-          <a:prstGeom prst="rect">
-            <a:avLst/>
-          </a:prstGeom>
-          <a:noFill/>
-          <a:ln/>
-        </p:spPr>
-        <p:txBody>
-          <a:bodyPr wrap="square" lIns="0" tIns="0" rIns="0" bIns="0" rtlCol="0" anchor="ctr"/>
-          <a:lstStyle/>
-          <a:p>
-            <a:pPr indent="0" marL="0">
-              <a:buNone/>
-            </a:pPr>
-            <a:r>
-              <a:rPr lang="en-US" sz="2600" b="1" dirty="0">
-                <a:solidFill>
-                  <a:srgbClr val="1B2A49"/>
-                </a:solidFill>
-                <a:latin typeface="Calibri" pitchFamily="34" charset="0"/>
-                <a:ea typeface="Calibri" pitchFamily="34" charset="-122"/>
-                <a:cs typeface="Calibri" pitchFamily="34" charset="-120"/>
-              </a:rPr>
-              <a:t>516 automated tests  ·  CI on every change  ·  signed webhooks  ·  a real call answered by voice</a:t>
-            </a:r>
-            <a:endParaRPr lang="en-US" sz="2600" dirty="0"/>
-          </a:p>
-        </p:txBody>
-      </p:sp>
-      <p:sp>
-        <p:nvSpPr>
-          <p:cNvPr id="39" name="Shape 36"/>
-          <p:cNvSpPr/>
-          <p:nvPr/>
-        </p:nvSpPr>
-        <p:spPr>
-          <a:xfrm>
-            <a:off x="914400" y="19979640"/>
-            <a:ext cx="777240" cy="777240"/>
+          <p:cNvPr id="58" name="Shape 55"/>
+          <p:cNvSpPr/>
+          <p:nvPr/>
+        </p:nvSpPr>
+        <p:spPr>
+          <a:xfrm>
+            <a:off x="914400" y="18498312"/>
+            <a:ext cx="731520" cy="731520"/>
           </a:xfrm>
           <a:prstGeom prst="ellipse">
             <a:avLst/>
@@ -2333,14 +2961,14 @@
       </p:sp>
       <p:sp>
         <p:nvSpPr>
-          <p:cNvPr id="40" name="Text 37"/>
-          <p:cNvSpPr/>
-          <p:nvPr/>
-        </p:nvSpPr>
-        <p:spPr>
-          <a:xfrm>
-            <a:off x="914400" y="19979640"/>
-            <a:ext cx="777240" cy="777240"/>
+          <p:cNvPr id="59" name="Text 56"/>
+          <p:cNvSpPr/>
+          <p:nvPr/>
+        </p:nvSpPr>
+        <p:spPr>
+          <a:xfrm>
+            <a:off x="914400" y="18498312"/>
+            <a:ext cx="731520" cy="731520"/>
           </a:xfrm>
           <a:prstGeom prst="rect">
             <a:avLst/>
@@ -2356,7 +2984,7 @@
               <a:buNone/>
             </a:pPr>
             <a:r>
-              <a:rPr lang="en-US" sz="3200" b="1" dirty="0">
+              <a:rPr lang="en-US" sz="3000" b="1" dirty="0">
                 <a:solidFill>
                   <a:srgbClr val="1B2A49"/>
                 </a:solidFill>
@@ -2366,20 +2994,20 @@
               </a:rPr>
               <a:t>3</a:t>
             </a:r>
-            <a:endParaRPr lang="en-US" sz="3200" dirty="0"/>
-          </a:p>
-        </p:txBody>
-      </p:sp>
-      <p:sp>
-        <p:nvSpPr>
-          <p:cNvPr id="41" name="Text 38"/>
-          <p:cNvSpPr/>
-          <p:nvPr/>
-        </p:nvSpPr>
-        <p:spPr>
-          <a:xfrm>
-            <a:off x="1920240" y="19933920"/>
-            <a:ext cx="18288000" cy="868680"/>
+            <a:endParaRPr lang="en-US" sz="3000" dirty="0"/>
+          </a:p>
+        </p:txBody>
+      </p:sp>
+      <p:sp>
+        <p:nvSpPr>
+          <p:cNvPr id="60" name="Text 57"/>
+          <p:cNvSpPr/>
+          <p:nvPr/>
+        </p:nvSpPr>
+        <p:spPr>
+          <a:xfrm>
+            <a:off x="1874520" y="18470880"/>
+            <a:ext cx="18562320" cy="822960"/>
           </a:xfrm>
           <a:prstGeom prst="rect">
             <a:avLst/>
@@ -2395,7 +3023,7 @@
               <a:buNone/>
             </a:pPr>
             <a:r>
-              <a:rPr lang="en-US" sz="4600" b="1" dirty="0">
+              <a:rPr lang="en-US" sz="4200" b="1" dirty="0">
                 <a:solidFill>
                   <a:srgbClr val="1B2A49"/>
                 </a:solidFill>
@@ -2403,26 +3031,26 @@
                 <a:ea typeface="Cambria" pitchFamily="34" charset="-122"/>
                 <a:cs typeface="Cambria" pitchFamily="34" charset="-120"/>
               </a:rPr>
-              <a:t>Roadmap and risks</a:t>
-            </a:r>
-            <a:endParaRPr lang="en-US" sz="4600" dirty="0"/>
-          </a:p>
-        </p:txBody>
-      </p:sp>
-      <p:sp>
-        <p:nvSpPr>
-          <p:cNvPr id="42" name="Shape 39"/>
-          <p:cNvSpPr/>
-          <p:nvPr/>
-        </p:nvSpPr>
-        <p:spPr>
-          <a:xfrm>
-            <a:off x="914400" y="20939760"/>
-            <a:ext cx="6309360" cy="3931920"/>
+              <a:t>Roadmap and problem solving</a:t>
+            </a:r>
+            <a:endParaRPr lang="en-US" sz="4200" dirty="0"/>
+          </a:p>
+        </p:txBody>
+      </p:sp>
+      <p:sp>
+        <p:nvSpPr>
+          <p:cNvPr id="61" name="Shape 58"/>
+          <p:cNvSpPr/>
+          <p:nvPr/>
+        </p:nvSpPr>
+        <p:spPr>
+          <a:xfrm>
+            <a:off x="914400" y="19431000"/>
+            <a:ext cx="6309360" cy="3017520"/>
           </a:xfrm>
           <a:prstGeom prst="roundRect">
             <a:avLst>
-              <a:gd name="adj" fmla="val 2791"/>
+              <a:gd name="adj" fmla="val 3636"/>
             </a:avLst>
           </a:prstGeom>
           <a:solidFill>
@@ -2438,14 +3066,14 @@
       </p:sp>
       <p:sp>
         <p:nvSpPr>
-          <p:cNvPr id="43" name="Text 40"/>
-          <p:cNvSpPr/>
-          <p:nvPr/>
-        </p:nvSpPr>
-        <p:spPr>
-          <a:xfrm>
-            <a:off x="1143000" y="21076920"/>
-            <a:ext cx="5852160" cy="548640"/>
+          <p:cNvPr id="62" name="Text 59"/>
+          <p:cNvSpPr/>
+          <p:nvPr/>
+        </p:nvSpPr>
+        <p:spPr>
+          <a:xfrm>
+            <a:off x="1143000" y="19540728"/>
+            <a:ext cx="5852160" cy="502920"/>
           </a:xfrm>
           <a:prstGeom prst="rect">
             <a:avLst/>
@@ -2461,7 +3089,7 @@
               <a:buNone/>
             </a:pPr>
             <a:r>
-              <a:rPr lang="en-US" sz="2800" b="1" dirty="0">
+              <a:rPr lang="en-US" sz="2500" b="1" dirty="0">
                 <a:solidFill>
                   <a:srgbClr val="2E7D5B"/>
                 </a:solidFill>
@@ -2469,22 +3097,22 @@
                 <a:ea typeface="Calibri" pitchFamily="34" charset="-122"/>
                 <a:cs typeface="Calibri" pitchFamily="34" charset="-120"/>
               </a:rPr>
-              <a:t>Live today</a:t>
-            </a:r>
-            <a:endParaRPr lang="en-US" sz="2800" dirty="0"/>
-          </a:p>
-        </p:txBody>
-      </p:sp>
-      <p:sp>
-        <p:nvSpPr>
-          <p:cNvPr id="44" name="Text 41"/>
-          <p:cNvSpPr/>
-          <p:nvPr/>
-        </p:nvSpPr>
-        <p:spPr>
-          <a:xfrm>
-            <a:off x="1143000" y="21717000"/>
-            <a:ext cx="5852160" cy="3017520"/>
+              <a:t>Finished and live</a:t>
+            </a:r>
+            <a:endParaRPr lang="en-US" sz="2500" dirty="0"/>
+          </a:p>
+        </p:txBody>
+      </p:sp>
+      <p:sp>
+        <p:nvSpPr>
+          <p:cNvPr id="63" name="Text 60"/>
+          <p:cNvSpPr/>
+          <p:nvPr/>
+        </p:nvSpPr>
+        <p:spPr>
+          <a:xfrm>
+            <a:off x="1143000" y="20116800"/>
+            <a:ext cx="5852160" cy="2240280"/>
           </a:xfrm>
           <a:prstGeom prst="rect">
             <a:avLst/>
@@ -2498,13 +3126,13 @@
           <a:p>
             <a:pPr marL="342900" indent="-342900">
               <a:spcAft>
-                <a:spcPts val="600"/>
+                <a:spcPts val="500"/>
               </a:spcAft>
               <a:buSzPct val="100000"/>
               <a:buChar char="•"/>
             </a:pPr>
             <a:r>
-              <a:rPr lang="en-US" sz="2800" dirty="0">
+              <a:rPr lang="en-US" sz="2200" dirty="0">
                 <a:solidFill>
                   <a:srgbClr val="14213D"/>
                 </a:solidFill>
@@ -2514,18 +3142,18 @@
               </a:rPr>
               <a:t>Accounts, contacts, CSV import</a:t>
             </a:r>
-            <a:endParaRPr lang="en-US" sz="2800" dirty="0"/>
+            <a:endParaRPr lang="en-US" sz="2200" dirty="0"/>
           </a:p>
           <a:p>
             <a:pPr marL="342900" indent="-342900">
               <a:spcAft>
-                <a:spcPts val="600"/>
+                <a:spcPts val="500"/>
               </a:spcAft>
               <a:buSzPct val="100000"/>
               <a:buChar char="•"/>
             </a:pPr>
             <a:r>
-              <a:rPr lang="en-US" sz="2800" dirty="0">
+              <a:rPr lang="en-US" sz="2200" dirty="0">
                 <a:solidFill>
                   <a:srgbClr val="14213D"/>
                 </a:solidFill>
@@ -2533,20 +3161,20 @@
                 <a:ea typeface="Calibri" pitchFamily="34" charset="-122"/>
                 <a:cs typeface="Calibri" pitchFamily="34" charset="-120"/>
               </a:rPr>
-              <a:t>Consent rules and STOP</a:t>
-            </a:r>
-            <a:endParaRPr lang="en-US" sz="2800" dirty="0"/>
+              <a:t>Consent, STOP, quiet hours</a:t>
+            </a:r>
+            <a:endParaRPr lang="en-US" sz="2200" dirty="0"/>
           </a:p>
           <a:p>
             <a:pPr marL="342900" indent="-342900">
               <a:spcAft>
-                <a:spcPts val="600"/>
+                <a:spcPts val="500"/>
               </a:spcAft>
               <a:buSzPct val="100000"/>
               <a:buChar char="•"/>
             </a:pPr>
             <a:r>
-              <a:rPr lang="en-US" sz="2800" dirty="0">
+              <a:rPr lang="en-US" sz="2200" dirty="0">
                 <a:solidFill>
                   <a:srgbClr val="14213D"/>
                 </a:solidFill>
@@ -2554,20 +3182,20 @@
                 <a:ea typeface="Calibri" pitchFamily="34" charset="-122"/>
                 <a:cs typeface="Calibri" pitchFamily="34" charset="-120"/>
               </a:rPr>
-              <a:t>Reminders engine</a:t>
-            </a:r>
-            <a:endParaRPr lang="en-US" sz="2800" dirty="0"/>
+              <a:t>Reminders: repeat, pause, templates</a:t>
+            </a:r>
+            <a:endParaRPr lang="en-US" sz="2200" dirty="0"/>
           </a:p>
           <a:p>
             <a:pPr marL="342900" indent="-342900">
               <a:spcAft>
-                <a:spcPts val="600"/>
+                <a:spcPts val="500"/>
               </a:spcAft>
               <a:buSzPct val="100000"/>
               <a:buChar char="•"/>
             </a:pPr>
             <a:r>
-              <a:rPr lang="en-US" sz="2800" dirty="0">
+              <a:rPr lang="en-US" sz="2200" dirty="0">
                 <a:solidFill>
                   <a:srgbClr val="14213D"/>
                 </a:solidFill>
@@ -2575,26 +3203,47 @@
                 <a:ea typeface="Calibri" pitchFamily="34" charset="-122"/>
                 <a:cs typeface="Calibri" pitchFamily="34" charset="-120"/>
               </a:rPr>
-              <a:t>Voice receptionist on Render</a:t>
-            </a:r>
-            <a:endParaRPr lang="en-US" sz="2800" dirty="0"/>
-          </a:p>
-        </p:txBody>
-      </p:sp>
-      <p:sp>
-        <p:nvSpPr>
-          <p:cNvPr id="45" name="Shape 42"/>
-          <p:cNvSpPr/>
-          <p:nvPr/>
-        </p:nvSpPr>
-        <p:spPr>
-          <a:xfrm>
-            <a:off x="7543800" y="20939760"/>
-            <a:ext cx="6309360" cy="3931920"/>
+              <a:t>Voice receptionist, call summaries</a:t>
+            </a:r>
+            <a:endParaRPr lang="en-US" sz="2200" dirty="0"/>
+          </a:p>
+          <a:p>
+            <a:pPr marL="342900" indent="-342900">
+              <a:spcAft>
+                <a:spcPts val="500"/>
+              </a:spcAft>
+              <a:buSzPct val="100000"/>
+              <a:buChar char="•"/>
+            </a:pPr>
+            <a:r>
+              <a:rPr lang="en-US" sz="2200" dirty="0">
+                <a:solidFill>
+                  <a:srgbClr val="14213D"/>
+                </a:solidFill>
+                <a:latin typeface="Calibri" pitchFamily="34" charset="0"/>
+                <a:ea typeface="Calibri" pitchFamily="34" charset="-122"/>
+                <a:cs typeface="Calibri" pitchFamily="34" charset="-120"/>
+              </a:rPr>
+              <a:t>Roles, API keys, MyAI help</a:t>
+            </a:r>
+            <a:endParaRPr lang="en-US" sz="2200" dirty="0"/>
+          </a:p>
+        </p:txBody>
+      </p:sp>
+      <p:sp>
+        <p:nvSpPr>
+          <p:cNvPr id="64" name="Shape 61"/>
+          <p:cNvSpPr/>
+          <p:nvPr/>
+        </p:nvSpPr>
+        <p:spPr>
+          <a:xfrm>
+            <a:off x="7543800" y="19431000"/>
+            <a:ext cx="6309360" cy="3017520"/>
           </a:xfrm>
           <a:prstGeom prst="roundRect">
             <a:avLst>
-              <a:gd name="adj" fmla="val 2791"/>
+              <a:gd name="adj" fmla="val 3636"/>
             </a:avLst>
           </a:prstGeom>
           <a:solidFill>
@@ -2610,14 +3259,14 @@
       </p:sp>
       <p:sp>
         <p:nvSpPr>
-          <p:cNvPr id="46" name="Text 43"/>
-          <p:cNvSpPr/>
-          <p:nvPr/>
-        </p:nvSpPr>
-        <p:spPr>
-          <a:xfrm>
-            <a:off x="7772400" y="21076920"/>
-            <a:ext cx="5852160" cy="548640"/>
+          <p:cNvPr id="65" name="Text 62"/>
+          <p:cNvSpPr/>
+          <p:nvPr/>
+        </p:nvSpPr>
+        <p:spPr>
+          <a:xfrm>
+            <a:off x="7772400" y="19540728"/>
+            <a:ext cx="5852160" cy="502920"/>
           </a:xfrm>
           <a:prstGeom prst="rect">
             <a:avLst/>
@@ -2633,7 +3282,7 @@
               <a:buNone/>
             </a:pPr>
             <a:r>
-              <a:rPr lang="en-US" sz="2800" b="1" dirty="0">
+              <a:rPr lang="en-US" sz="2500" b="1" dirty="0">
                 <a:solidFill>
                   <a:srgbClr val="A9701B"/>
                 </a:solidFill>
@@ -2641,22 +3290,22 @@
                 <a:ea typeface="Calibri" pitchFamily="34" charset="-122"/>
                 <a:cs typeface="Calibri" pitchFamily="34" charset="-120"/>
               </a:rPr>
-              <a:t>Built, ships with next deploy</a:t>
-            </a:r>
-            <a:endParaRPr lang="en-US" sz="2800" dirty="0"/>
-          </a:p>
-        </p:txBody>
-      </p:sp>
-      <p:sp>
-        <p:nvSpPr>
-          <p:cNvPr id="47" name="Text 44"/>
-          <p:cNvSpPr/>
-          <p:nvPr/>
-        </p:nvSpPr>
-        <p:spPr>
-          <a:xfrm>
-            <a:off x="7772400" y="21717000"/>
-            <a:ext cx="5852160" cy="3017520"/>
+              <a:t>In progress</a:t>
+            </a:r>
+            <a:endParaRPr lang="en-US" sz="2500" dirty="0"/>
+          </a:p>
+        </p:txBody>
+      </p:sp>
+      <p:sp>
+        <p:nvSpPr>
+          <p:cNvPr id="66" name="Text 63"/>
+          <p:cNvSpPr/>
+          <p:nvPr/>
+        </p:nvSpPr>
+        <p:spPr>
+          <a:xfrm>
+            <a:off x="7772400" y="20116800"/>
+            <a:ext cx="5852160" cy="2240280"/>
           </a:xfrm>
           <a:prstGeom prst="rect">
             <a:avLst/>
@@ -2670,13 +3319,13 @@
           <a:p>
             <a:pPr marL="342900" indent="-342900">
               <a:spcAft>
-                <a:spcPts val="600"/>
+                <a:spcPts val="500"/>
               </a:spcAft>
               <a:buSzPct val="100000"/>
               <a:buChar char="•"/>
             </a:pPr>
             <a:r>
-              <a:rPr lang="en-US" sz="2800" dirty="0">
+              <a:rPr lang="en-US" sz="2200" dirty="0">
                 <a:solidFill>
                   <a:srgbClr val="14213D"/>
                 </a:solidFill>
@@ -2684,20 +3333,20 @@
                 <a:ea typeface="Calibri" pitchFamily="34" charset="-122"/>
                 <a:cs typeface="Calibri" pitchFamily="34" charset="-120"/>
               </a:rPr>
-              <a:t>Recurrence, pause, templates</a:t>
-            </a:r>
-            <a:endParaRPr lang="en-US" sz="2800" dirty="0"/>
+              <a:t>SMS: Twilio registration in review</a:t>
+            </a:r>
+            <a:endParaRPr lang="en-US" sz="2200" dirty="0"/>
           </a:p>
           <a:p>
             <a:pPr marL="342900" indent="-342900">
               <a:spcAft>
-                <a:spcPts val="600"/>
+                <a:spcPts val="500"/>
               </a:spcAft>
               <a:buSzPct val="100000"/>
               <a:buChar char="•"/>
             </a:pPr>
             <a:r>
-              <a:rPr lang="en-US" sz="2800" dirty="0">
+              <a:rPr lang="en-US" sz="2200" dirty="0">
                 <a:solidFill>
                   <a:srgbClr val="14213D"/>
                 </a:solidFill>
@@ -2705,20 +3354,20 @@
                 <a:ea typeface="Calibri" pitchFamily="34" charset="-122"/>
                 <a:cs typeface="Calibri" pitchFamily="34" charset="-120"/>
               </a:rPr>
-              <a:t>Merge fields, rescheduling</a:t>
-            </a:r>
-            <a:endParaRPr lang="en-US" sz="2800" dirty="0"/>
+              <a:t>Contacts kept across restarts</a:t>
+            </a:r>
+            <a:endParaRPr lang="en-US" sz="2200" dirty="0"/>
           </a:p>
           <a:p>
             <a:pPr marL="342900" indent="-342900">
               <a:spcAft>
-                <a:spcPts val="600"/>
+                <a:spcPts val="500"/>
               </a:spcAft>
               <a:buSzPct val="100000"/>
               <a:buChar char="•"/>
             </a:pPr>
             <a:r>
-              <a:rPr lang="en-US" sz="2800" dirty="0">
+              <a:rPr lang="en-US" sz="2200" dirty="0">
                 <a:solidFill>
                   <a:srgbClr val="14213D"/>
                 </a:solidFill>
@@ -2726,47 +3375,26 @@
                 <a:ea typeface="Calibri" pitchFamily="34" charset="-122"/>
                 <a:cs typeface="Calibri" pitchFamily="34" charset="-120"/>
               </a:rPr>
-              <a:t>Call summaries, booking with FAQ</a:t>
-            </a:r>
-            <a:endParaRPr lang="en-US" sz="2800" dirty="0"/>
-          </a:p>
-          <a:p>
-            <a:pPr marL="342900" indent="-342900">
-              <a:spcAft>
-                <a:spcPts val="600"/>
-              </a:spcAft>
-              <a:buSzPct val="100000"/>
-              <a:buChar char="•"/>
-            </a:pPr>
-            <a:r>
-              <a:rPr lang="en-US" sz="2800" dirty="0">
-                <a:solidFill>
-                  <a:srgbClr val="14213D"/>
-                </a:solidFill>
-                <a:latin typeface="Calibri" pitchFamily="34" charset="0"/>
-                <a:ea typeface="Calibri" pitchFamily="34" charset="-122"/>
-                <a:cs typeface="Calibri" pitchFamily="34" charset="-120"/>
-              </a:rPr>
-              <a:t>Roles, API keys, CSV export</a:t>
-            </a:r>
-            <a:endParaRPr lang="en-US" sz="2800" dirty="0"/>
-          </a:p>
-        </p:txBody>
-      </p:sp>
-      <p:sp>
-        <p:nvSpPr>
-          <p:cNvPr id="48" name="Shape 45"/>
-          <p:cNvSpPr/>
-          <p:nvPr/>
-        </p:nvSpPr>
-        <p:spPr>
-          <a:xfrm>
-            <a:off x="14173200" y="20939760"/>
-            <a:ext cx="6309360" cy="3931920"/>
+              <a:t>Final checks with a live call</a:t>
+            </a:r>
+            <a:endParaRPr lang="en-US" sz="2200" dirty="0"/>
+          </a:p>
+        </p:txBody>
+      </p:sp>
+      <p:sp>
+        <p:nvSpPr>
+          <p:cNvPr id="67" name="Shape 64"/>
+          <p:cNvSpPr/>
+          <p:nvPr/>
+        </p:nvSpPr>
+        <p:spPr>
+          <a:xfrm>
+            <a:off x="14173200" y="19431000"/>
+            <a:ext cx="6309360" cy="3017520"/>
           </a:xfrm>
           <a:prstGeom prst="roundRect">
             <a:avLst>
-              <a:gd name="adj" fmla="val 2791"/>
+              <a:gd name="adj" fmla="val 3636"/>
             </a:avLst>
           </a:prstGeom>
           <a:solidFill>
@@ -2782,14 +3410,14 @@
       </p:sp>
       <p:sp>
         <p:nvSpPr>
-          <p:cNvPr id="49" name="Text 46"/>
-          <p:cNvSpPr/>
-          <p:nvPr/>
-        </p:nvSpPr>
-        <p:spPr>
-          <a:xfrm>
-            <a:off x="14401800" y="21076920"/>
-            <a:ext cx="5852160" cy="548640"/>
+          <p:cNvPr id="68" name="Text 65"/>
+          <p:cNvSpPr/>
+          <p:nvPr/>
+        </p:nvSpPr>
+        <p:spPr>
+          <a:xfrm>
+            <a:off x="14401800" y="19540728"/>
+            <a:ext cx="5852160" cy="502920"/>
           </a:xfrm>
           <a:prstGeom prst="rect">
             <a:avLst/>
@@ -2805,7 +3433,7 @@
               <a:buNone/>
             </a:pPr>
             <a:r>
-              <a:rPr lang="en-US" sz="2800" b="1" dirty="0">
+              <a:rPr lang="en-US" sz="2500" b="1" dirty="0">
                 <a:solidFill>
                   <a:srgbClr val="1B2A49"/>
                 </a:solidFill>
@@ -2813,22 +3441,22 @@
                 <a:ea typeface="Calibri" pitchFamily="34" charset="-122"/>
                 <a:cs typeface="Calibri" pitchFamily="34" charset="-120"/>
               </a:rPr>
-              <a:t>Next, highest priority first</a:t>
-            </a:r>
-            <a:endParaRPr lang="en-US" sz="2800" dirty="0"/>
-          </a:p>
-        </p:txBody>
-      </p:sp>
-      <p:sp>
-        <p:nvSpPr>
-          <p:cNvPr id="50" name="Text 47"/>
-          <p:cNvSpPr/>
-          <p:nvPr/>
-        </p:nvSpPr>
-        <p:spPr>
-          <a:xfrm>
-            <a:off x="14401800" y="21717000"/>
-            <a:ext cx="5852160" cy="3017520"/>
+              <a:t>Still to do</a:t>
+            </a:r>
+            <a:endParaRPr lang="en-US" sz="2500" dirty="0"/>
+          </a:p>
+        </p:txBody>
+      </p:sp>
+      <p:sp>
+        <p:nvSpPr>
+          <p:cNvPr id="69" name="Text 66"/>
+          <p:cNvSpPr/>
+          <p:nvPr/>
+        </p:nvSpPr>
+        <p:spPr>
+          <a:xfrm>
+            <a:off x="14401800" y="20116800"/>
+            <a:ext cx="5852160" cy="2240280"/>
           </a:xfrm>
           <a:prstGeom prst="rect">
             <a:avLst/>
@@ -2842,13 +3470,13 @@
           <a:p>
             <a:pPr marL="342900" indent="-342900">
               <a:spcAft>
-                <a:spcPts val="600"/>
+                <a:spcPts val="500"/>
               </a:spcAft>
               <a:buSzPct val="100000"/>
               <a:buChar char="•"/>
             </a:pPr>
             <a:r>
-              <a:rPr lang="en-US" sz="2800" dirty="0">
+              <a:rPr lang="en-US" sz="2200" dirty="0">
                 <a:solidFill>
                   <a:srgbClr val="14213D"/>
                 </a:solidFill>
@@ -2856,20 +3484,20 @@
                 <a:ea typeface="Calibri" pitchFamily="34" charset="-122"/>
                 <a:cs typeface="Calibri" pitchFamily="34" charset="-120"/>
               </a:rPr>
-              <a:t>Email and SMS proven end to end</a:t>
-            </a:r>
-            <a:endParaRPr lang="en-US" sz="2800" dirty="0"/>
+              <a:t>Recordings, handover pack</a:t>
+            </a:r>
+            <a:endParaRPr lang="en-US" sz="2200" dirty="0"/>
           </a:p>
           <a:p>
             <a:pPr marL="342900" indent="-342900">
               <a:spcAft>
-                <a:spcPts val="600"/>
+                <a:spcPts val="500"/>
               </a:spcAft>
               <a:buSzPct val="100000"/>
               <a:buChar char="•"/>
             </a:pPr>
             <a:r>
-              <a:rPr lang="en-US" sz="2800" dirty="0">
+              <a:rPr lang="en-US" sz="2200" dirty="0">
                 <a:solidFill>
                   <a:srgbClr val="14213D"/>
                 </a:solidFill>
@@ -2877,20 +3505,20 @@
                 <a:ea typeface="Calibri" pitchFamily="34" charset="-122"/>
                 <a:cs typeface="Calibri" pitchFamily="34" charset="-120"/>
               </a:rPr>
-              <a:t>Marketing site rework live</a:t>
-            </a:r>
-            <a:endParaRPr lang="en-US" sz="2800" dirty="0"/>
+              <a:t>Client feedback</a:t>
+            </a:r>
+            <a:endParaRPr lang="en-US" sz="2200" dirty="0"/>
           </a:p>
           <a:p>
             <a:pPr marL="342900" indent="-342900">
               <a:spcAft>
-                <a:spcPts val="600"/>
+                <a:spcPts val="500"/>
               </a:spcAft>
               <a:buSzPct val="100000"/>
               <a:buChar char="•"/>
             </a:pPr>
             <a:r>
-              <a:rPr lang="en-US" sz="2800" dirty="0">
+              <a:rPr lang="en-US" sz="2200" dirty="0">
                 <a:solidFill>
                   <a:srgbClr val="14213D"/>
                 </a:solidFill>
@@ -2898,20 +3526,161 @@
                 <a:ea typeface="Calibri" pitchFamily="34" charset="-122"/>
                 <a:cs typeface="Calibri" pitchFamily="34" charset="-120"/>
               </a:rPr>
-              <a:t>Recordings, handover pack</a:t>
-            </a:r>
-            <a:endParaRPr lang="en-US" sz="2800" dirty="0"/>
-          </a:p>
+              <a:t>Journals and interviews</a:t>
+            </a:r>
+            <a:endParaRPr lang="en-US" sz="2200" dirty="0"/>
+          </a:p>
+        </p:txBody>
+      </p:sp>
+      <p:sp>
+        <p:nvSpPr>
+          <p:cNvPr id="70" name="Shape 67"/>
+          <p:cNvSpPr/>
+          <p:nvPr/>
+        </p:nvSpPr>
+        <p:spPr>
+          <a:xfrm>
+            <a:off x="914400" y="22631400"/>
+            <a:ext cx="19568160" cy="1371600"/>
+          </a:xfrm>
+          <a:prstGeom prst="roundRect">
+            <a:avLst>
+              <a:gd name="adj" fmla="val 6667"/>
+            </a:avLst>
+          </a:prstGeom>
+          <a:solidFill>
+            <a:srgbClr val="EEF1F6"/>
+          </a:solidFill>
+          <a:ln w="12700">
+            <a:solidFill>
+              <a:srgbClr val="EEF1F6"/>
+            </a:solidFill>
+            <a:prstDash val="solid"/>
+          </a:ln>
+        </p:spPr>
+      </p:sp>
+      <p:sp>
+        <p:nvSpPr>
+          <p:cNvPr id="71" name="Text 68"/>
+          <p:cNvSpPr/>
+          <p:nvPr/>
+        </p:nvSpPr>
+        <p:spPr>
+          <a:xfrm>
+            <a:off x="1188720" y="22631400"/>
+            <a:ext cx="19019520" cy="1371600"/>
+          </a:xfrm>
+          <a:prstGeom prst="rect">
+            <a:avLst/>
+          </a:prstGeom>
+          <a:noFill/>
+          <a:ln/>
+        </p:spPr>
+        <p:txBody>
+          <a:bodyPr wrap="square" lIns="0" tIns="0" rIns="0" bIns="0" rtlCol="0" anchor="ctr"/>
+          <a:lstStyle/>
+          <a:p>
+            <a:pPr indent="0" marL="0">
+              <a:buNone/>
+            </a:pPr>
+            <a:r>
+              <a:rPr lang="en-US" sz="2100" b="1" dirty="0">
+                <a:solidFill>
+                  <a:srgbClr val="1B2A49"/>
+                </a:solidFill>
+                <a:latin typeface="Calibri" pitchFamily="34" charset="0"/>
+                <a:ea typeface="Calibri" pitchFamily="34" charset="-122"/>
+                <a:cs typeface="Calibri" pitchFamily="34" charset="-120"/>
+              </a:rPr>
+              <a:t>Path to completion:  </a:t>
+            </a:r>
+            <a:pPr indent="0" marL="0">
+              <a:buNone/>
+            </a:pPr>
+            <a:r>
+              <a:rPr lang="en-US" sz="2100" dirty="0">
+                <a:solidFill>
+                  <a:srgbClr val="14213D"/>
+                </a:solidFill>
+                <a:latin typeface="Calibri" pitchFamily="34" charset="0"/>
+                <a:ea typeface="Calibri" pitchFamily="34" charset="-122"/>
+                <a:cs typeface="Calibri" pitchFamily="34" charset="-120"/>
+              </a:rPr>
+              <a:t>live test call (Dilraj)  →  SMS approval (Prabhjot)  →  recordings and handover pack (all)  →  journals and interviews (everyone)</a:t>
+            </a:r>
+            <a:endParaRPr lang="en-US" sz="2100" dirty="0"/>
+          </a:p>
+        </p:txBody>
+      </p:sp>
+      <p:sp>
+        <p:nvSpPr>
+          <p:cNvPr id="72" name="Text 69"/>
+          <p:cNvSpPr/>
+          <p:nvPr/>
+        </p:nvSpPr>
+        <p:spPr>
+          <a:xfrm>
+            <a:off x="914400" y="24185880"/>
+            <a:ext cx="9509760" cy="502920"/>
+          </a:xfrm>
+          <a:prstGeom prst="rect">
+            <a:avLst/>
+          </a:prstGeom>
+          <a:noFill/>
+          <a:ln/>
+        </p:spPr>
+        <p:txBody>
+          <a:bodyPr wrap="square" lIns="0" tIns="0" rIns="0" bIns="0" rtlCol="0" anchor="ctr"/>
+          <a:lstStyle/>
+          <a:p>
+            <a:pPr indent="0" marL="0">
+              <a:buNone/>
+            </a:pPr>
+            <a:r>
+              <a:rPr lang="en-US" sz="2500" b="1" dirty="0">
+                <a:solidFill>
+                  <a:srgbClr val="C9A227"/>
+                </a:solidFill>
+                <a:latin typeface="Calibri" pitchFamily="34" charset="0"/>
+                <a:ea typeface="Calibri" pitchFamily="34" charset="-122"/>
+                <a:cs typeface="Calibri" pitchFamily="34" charset="-120"/>
+              </a:rPr>
+              <a:t>Problems we found and fixed</a:t>
+            </a:r>
+            <a:endParaRPr lang="en-US" sz="2500" dirty="0"/>
+          </a:p>
+        </p:txBody>
+      </p:sp>
+      <p:sp>
+        <p:nvSpPr>
+          <p:cNvPr id="73" name="Text 70"/>
+          <p:cNvSpPr/>
+          <p:nvPr/>
+        </p:nvSpPr>
+        <p:spPr>
+          <a:xfrm>
+            <a:off x="914400" y="24734520"/>
+            <a:ext cx="9509760" cy="2834640"/>
+          </a:xfrm>
+          <a:prstGeom prst="rect">
+            <a:avLst/>
+          </a:prstGeom>
+          <a:noFill/>
+          <a:ln/>
+        </p:spPr>
+        <p:txBody>
+          <a:bodyPr wrap="square" lIns="0" tIns="0" rIns="0" bIns="0" rtlCol="0" anchor="t"/>
+          <a:lstStyle/>
           <a:p>
             <a:pPr marL="342900" indent="-342900">
               <a:spcAft>
-                <a:spcPts val="600"/>
+                <a:spcPts val="500"/>
               </a:spcAft>
               <a:buSzPct val="100000"/>
               <a:buChar char="•"/>
             </a:pPr>
             <a:r>
-              <a:rPr lang="en-US" sz="2800" dirty="0">
+              <a:rPr lang="en-US" sz="1900" dirty="0">
                 <a:solidFill>
                   <a:srgbClr val="14213D"/>
                 </a:solidFill>
@@ -2919,9 +3688,93 @@
                 <a:ea typeface="Calibri" pitchFamily="34" charset="-122"/>
                 <a:cs typeface="Calibri" pitchFamily="34" charset="-120"/>
               </a:rPr>
-              <a:t>Client feedback on the poster</a:t>
-            </a:r>
-            <a:endParaRPr lang="en-US" sz="2800" dirty="0"/>
+              <a:t>Gmail dropped our connection: fixed the hostname we announce</a:t>
+            </a:r>
+            <a:endParaRPr lang="en-US" sz="1900" dirty="0"/>
+          </a:p>
+          <a:p>
+            <a:pPr marL="342900" indent="-342900">
+              <a:spcAft>
+                <a:spcPts val="500"/>
+              </a:spcAft>
+              <a:buSzPct val="100000"/>
+              <a:buChar char="•"/>
+            </a:pPr>
+            <a:r>
+              <a:rPr lang="en-US" sz="1900" dirty="0">
+                <a:solidFill>
+                  <a:srgbClr val="14213D"/>
+                </a:solidFill>
+                <a:latin typeface="Calibri" pitchFamily="34" charset="0"/>
+                <a:ea typeface="Calibri" pitchFamily="34" charset="-122"/>
+                <a:cs typeface="Calibri" pitchFamily="34" charset="-120"/>
+              </a:rPr>
+              <a:t>Forged calls could reach the receptionist: every webhook is signature-checked</a:t>
+            </a:r>
+            <a:endParaRPr lang="en-US" sz="1900" dirty="0"/>
+          </a:p>
+          <a:p>
+            <a:pPr marL="342900" indent="-342900">
+              <a:spcAft>
+                <a:spcPts val="500"/>
+              </a:spcAft>
+              <a:buSzPct val="100000"/>
+              <a:buChar char="•"/>
+            </a:pPr>
+            <a:r>
+              <a:rPr lang="en-US" sz="1900" dirty="0">
+                <a:solidFill>
+                  <a:srgbClr val="14213D"/>
+                </a:solidFill>
+                <a:latin typeface="Calibri" pitchFamily="34" charset="0"/>
+                <a:ea typeface="Calibri" pitchFamily="34" charset="-122"/>
+                <a:cs typeface="Calibri" pitchFamily="34" charset="-120"/>
+              </a:rPr>
+              <a:t>Dashboard counted every call turn as a call: counts real calls</a:t>
+            </a:r>
+            <a:endParaRPr lang="en-US" sz="1900" dirty="0"/>
+          </a:p>
+          <a:p>
+            <a:pPr marL="342900" indent="-342900">
+              <a:spcAft>
+                <a:spcPts val="500"/>
+              </a:spcAft>
+              <a:buSzPct val="100000"/>
+              <a:buChar char="•"/>
+            </a:pPr>
+            <a:r>
+              <a:rPr lang="en-US" sz="1900" dirty="0">
+                <a:solidFill>
+                  <a:srgbClr val="14213D"/>
+                </a:solidFill>
+                <a:latin typeface="Calibri" pitchFamily="34" charset="0"/>
+                <a:ea typeface="Calibri" pitchFamily="34" charset="-122"/>
+                <a:cs typeface="Calibri" pitchFamily="34" charset="-120"/>
+              </a:rPr>
+              <a:t>Dashboard showed invented rates: now live data only</a:t>
+            </a:r>
+            <a:endParaRPr lang="en-US" sz="1900" dirty="0"/>
+          </a:p>
+          <a:p>
+            <a:pPr marL="342900" indent="-342900">
+              <a:spcAft>
+                <a:spcPts val="500"/>
+              </a:spcAft>
+              <a:buSzPct val="100000"/>
+              <a:buChar char="•"/>
+            </a:pPr>
+            <a:r>
+              <a:rPr lang="en-US" sz="1900" dirty="0">
+                <a:solidFill>
+                  <a:srgbClr val="14213D"/>
+                </a:solidFill>
+                <a:latin typeface="Calibri" pitchFamily="34" charset="0"/>
+                <a:ea typeface="Calibri" pitchFamily="34" charset="-122"/>
+                <a:cs typeface="Calibri" pitchFamily="34" charset="-120"/>
+              </a:rPr>
+              <a:t>Send Reminder only wrote a log row: it now really sends</a:t>
+            </a:r>
+            <a:endParaRPr lang="en-US" sz="1900" dirty="0"/>
           </a:p>
         </p:txBody>
       </p:sp>
@@ -2940,18 +3793,18 @@
           </p:nvPr>
         </p:nvGraphicFramePr>
         <p:xfrm>
-          <a:off x="914400" y="25054560"/>
-          <a:ext cx="19568160" cy="914400"/>
+          <a:off x="10881360" y="24231600"/>
+          <a:ext cx="9601200" cy="914400"/>
         </p:xfrm>
         <a:graphic>
           <a:graphicData uri="http://schemas.openxmlformats.org/drawingml/2006/table">
             <a:tbl>
               <a:tblPr/>
               <a:tblGrid>
-                <a:gridCol w="8595360"/>
-                <a:gridCol w="10972800"/>
+                <a:gridCol w="4754880"/>
+                <a:gridCol w="4846320"/>
               </a:tblGrid>
-              <a:tr h="530352">
+              <a:tr h="566928">
                 <a:tc>
                   <a:txBody>
                     <a:bodyPr/>
@@ -2961,7 +3814,7 @@
                         <a:buNone/>
                       </a:pPr>
                       <a:r>
-                        <a:rPr lang="en-US" sz="2600" b="1" dirty="0">
+                        <a:rPr lang="en-US" sz="1900" b="1" dirty="0">
                           <a:solidFill>
                             <a:srgbClr val="FFFFFF"/>
                           </a:solidFill>
@@ -2971,14 +3824,14 @@
                         </a:rPr>
                         <a:t>Risk</a:t>
                       </a:r>
-                      <a:endParaRPr lang="en-US" sz="2600" dirty="0">
+                      <a:endParaRPr lang="en-US" sz="1900" dirty="0">
                         <a:latin typeface="Calibri" charset="0"/>
                         <a:ea typeface="Calibri" charset="0"/>
                         <a:cs typeface="Calibri" charset="0"/>
                       </a:endParaRPr>
                     </a:p>
                   </a:txBody>
-                  <a:tcPr marL="137160" marR="137160" marT="0" marB="0" anchor="ctr">
+                  <a:tcPr marL="109728" marR="109728" marT="0" marB="0" anchor="ctr">
                     <a:lnL w="12700" cap="flat" cmpd="sng" algn="ctr">
                       <a:solidFill>
                         <a:srgbClr val="C9D0E0"/>
@@ -3029,7 +3882,7 @@
                         <a:buNone/>
                       </a:pPr>
                       <a:r>
-                        <a:rPr lang="en-US" sz="2600" b="1" dirty="0">
+                        <a:rPr lang="en-US" sz="1900" b="1" dirty="0">
                           <a:solidFill>
                             <a:srgbClr val="FFFFFF"/>
                           </a:solidFill>
@@ -3039,14 +3892,14 @@
                         </a:rPr>
                         <a:t>What we are doing</a:t>
                       </a:r>
-                      <a:endParaRPr lang="en-US" sz="2600" dirty="0">
+                      <a:endParaRPr lang="en-US" sz="1900" dirty="0">
                         <a:latin typeface="Calibri" charset="0"/>
                         <a:ea typeface="Calibri" charset="0"/>
                         <a:cs typeface="Calibri" charset="0"/>
                       </a:endParaRPr>
                     </a:p>
                   </a:txBody>
-                  <a:tcPr marL="137160" marR="137160" marT="0" marB="0" anchor="ctr">
+                  <a:tcPr marL="109728" marR="109728" marT="0" marB="0" anchor="ctr">
                     <a:lnL w="12700" cap="flat" cmpd="sng" algn="ctr">
                       <a:solidFill>
                         <a:srgbClr val="C9D0E0"/>
@@ -3089,7 +3942,7 @@
                   </a:tcPr>
                 </a:tc>
               </a:tr>
-              <a:tr h="530352">
+              <a:tr h="566928">
                 <a:tc>
                   <a:txBody>
                     <a:bodyPr/>
@@ -3099,7 +3952,7 @@
                         <a:buNone/>
                       </a:pPr>
                       <a:r>
-                        <a:rPr lang="en-US" sz="2600" dirty="0">
+                        <a:rPr lang="en-US" sz="1900" dirty="0">
                           <a:solidFill>
                             <a:srgbClr val="14213D"/>
                           </a:solidFill>
@@ -3107,16 +3960,16 @@
                           <a:ea typeface="Calibri" pitchFamily="34" charset="-122"/>
                           <a:cs typeface="Calibri" pitchFamily="34" charset="-120"/>
                         </a:rPr>
-                        <a:t>SMS blocked by carrier registration</a:t>
+                        <a:t>SMS waits on Twilio registration</a:t>
                       </a:r>
-                      <a:endParaRPr lang="en-US" sz="2600" dirty="0">
+                      <a:endParaRPr lang="en-US" sz="1900" dirty="0">
                         <a:latin typeface="Calibri" charset="0"/>
                         <a:ea typeface="Calibri" charset="0"/>
                         <a:cs typeface="Calibri" charset="0"/>
                       </a:endParaRPr>
                     </a:p>
                   </a:txBody>
-                  <a:tcPr marL="137160" marR="137160" marT="0" marB="0" anchor="ctr">
+                  <a:tcPr marL="109728" marR="109728" marT="0" marB="0" anchor="ctr">
                     <a:lnL w="12700" cap="flat" cmpd="sng" algn="ctr">
                       <a:solidFill>
                         <a:srgbClr val="C9D0E0"/>
@@ -3167,7 +4020,7 @@
                         <a:buNone/>
                       </a:pPr>
                       <a:r>
-                        <a:rPr lang="en-US" sz="2600" dirty="0">
+                        <a:rPr lang="en-US" sz="1900" dirty="0">
                           <a:solidFill>
                             <a:srgbClr val="14213D"/>
                           </a:solidFill>
@@ -3175,16 +4028,16 @@
                           <a:ea typeface="Calibri" pitchFamily="34" charset="-122"/>
                           <a:cs typeface="Calibri" pitchFamily="34" charset="-120"/>
                         </a:rPr>
-                        <a:t>Demo voice, email and dashboard; explain it</a:t>
+                        <a:t>In review; voice and email work now</a:t>
                       </a:r>
-                      <a:endParaRPr lang="en-US" sz="2600" dirty="0">
+                      <a:endParaRPr lang="en-US" sz="1900" dirty="0">
                         <a:latin typeface="Calibri" charset="0"/>
                         <a:ea typeface="Calibri" charset="0"/>
                         <a:cs typeface="Calibri" charset="0"/>
                       </a:endParaRPr>
                     </a:p>
                   </a:txBody>
-                  <a:tcPr marL="137160" marR="137160" marT="0" marB="0" anchor="ctr">
+                  <a:tcPr marL="109728" marR="109728" marT="0" marB="0" anchor="ctr">
                     <a:lnL w="12700" cap="flat" cmpd="sng" algn="ctr">
                       <a:solidFill>
                         <a:srgbClr val="C9D0E0"/>
@@ -3227,7 +4080,7 @@
                   </a:tcPr>
                 </a:tc>
               </a:tr>
-              <a:tr h="530352">
+              <a:tr h="566928">
                 <a:tc>
                   <a:txBody>
                     <a:bodyPr/>
@@ -3237,7 +4090,7 @@
                         <a:buNone/>
                       </a:pPr>
                       <a:r>
-                        <a:rPr lang="en-US" sz="2600" dirty="0">
+                        <a:rPr lang="en-US" sz="1900" dirty="0">
                           <a:solidFill>
                             <a:srgbClr val="14213D"/>
                           </a:solidFill>
@@ -3245,16 +4098,16 @@
                           <a:ea typeface="Calibri" pitchFamily="34" charset="-122"/>
                           <a:cs typeface="Calibri" pitchFamily="34" charset="-120"/>
                         </a:rPr>
-                        <a:t>Free host sleeps and loses data</a:t>
+                        <a:t>Live demo needs a network</a:t>
                       </a:r>
-                      <a:endParaRPr lang="en-US" sz="2600" dirty="0">
+                      <a:endParaRPr lang="en-US" sz="1900" dirty="0">
                         <a:latin typeface="Calibri" charset="0"/>
                         <a:ea typeface="Calibri" charset="0"/>
                         <a:cs typeface="Calibri" charset="0"/>
                       </a:endParaRPr>
                     </a:p>
                   </a:txBody>
-                  <a:tcPr marL="137160" marR="137160" marT="0" marB="0" anchor="ctr">
+                  <a:tcPr marL="109728" marR="109728" marT="0" marB="0" anchor="ctr">
                     <a:lnL w="12700" cap="flat" cmpd="sng" algn="ctr">
                       <a:solidFill>
                         <a:srgbClr val="C9D0E0"/>
@@ -3305,7 +4158,7 @@
                         <a:buNone/>
                       </a:pPr>
                       <a:r>
-                        <a:rPr lang="en-US" sz="2600" dirty="0">
+                        <a:rPr lang="en-US" sz="1900" dirty="0">
                           <a:solidFill>
                             <a:srgbClr val="14213D"/>
                           </a:solidFill>
@@ -3313,16 +4166,16 @@
                           <a:ea typeface="Calibri" pitchFamily="34" charset="-122"/>
                           <a:cs typeface="Calibri" pitchFamily="34" charset="-120"/>
                         </a:rPr>
-                        <a:t>Wake it first; demo data reloads on boot</a:t>
+                        <a:t>Backup recording ready</a:t>
                       </a:r>
-                      <a:endParaRPr lang="en-US" sz="2600" dirty="0">
+                      <a:endParaRPr lang="en-US" sz="1900" dirty="0">
                         <a:latin typeface="Calibri" charset="0"/>
                         <a:ea typeface="Calibri" charset="0"/>
                         <a:cs typeface="Calibri" charset="0"/>
                       </a:endParaRPr>
                     </a:p>
                   </a:txBody>
-                  <a:tcPr marL="137160" marR="137160" marT="0" marB="0" anchor="ctr">
+                  <a:tcPr marL="109728" marR="109728" marT="0" marB="0" anchor="ctr">
                     <a:lnL w="12700" cap="flat" cmpd="sng" algn="ctr">
                       <a:solidFill>
                         <a:srgbClr val="C9D0E0"/>
@@ -3365,7 +4218,7 @@
                   </a:tcPr>
                 </a:tc>
               </a:tr>
-              <a:tr h="530352">
+              <a:tr h="566928">
                 <a:tc>
                   <a:txBody>
                     <a:bodyPr/>
@@ -3375,7 +4228,7 @@
                         <a:buNone/>
                       </a:pPr>
                       <a:r>
-                        <a:rPr lang="en-US" sz="2600" dirty="0">
+                        <a:rPr lang="en-US" sz="1900" dirty="0">
                           <a:solidFill>
                             <a:srgbClr val="14213D"/>
                           </a:solidFill>
@@ -3383,16 +4236,16 @@
                           <a:ea typeface="Calibri" pitchFamily="34" charset="-122"/>
                           <a:cs typeface="Calibri" pitchFamily="34" charset="-120"/>
                         </a:rPr>
-                        <a:t>Demo is cloud, brief says on-premise</a:t>
+                        <a:t>Patient data must stay private</a:t>
                       </a:r>
-                      <a:endParaRPr lang="en-US" sz="2600" dirty="0">
+                      <a:endParaRPr lang="en-US" sz="1900" dirty="0">
                         <a:latin typeface="Calibri" charset="0"/>
                         <a:ea typeface="Calibri" charset="0"/>
                         <a:cs typeface="Calibri" charset="0"/>
                       </a:endParaRPr>
                     </a:p>
                   </a:txBody>
-                  <a:tcPr marL="137160" marR="137160" marT="0" marB="0" anchor="ctr">
+                  <a:tcPr marL="109728" marR="109728" marT="0" marB="0" anchor="ctr">
                     <a:lnL w="12700" cap="flat" cmpd="sng" algn="ctr">
                       <a:solidFill>
                         <a:srgbClr val="C9D0E0"/>
@@ -3443,7 +4296,7 @@
                         <a:buNone/>
                       </a:pPr>
                       <a:r>
-                        <a:rPr lang="en-US" sz="2600" dirty="0">
+                        <a:rPr lang="en-US" sz="1900" dirty="0">
                           <a:solidFill>
                             <a:srgbClr val="14213D"/>
                           </a:solidFill>
@@ -3451,16 +4304,16 @@
                           <a:ea typeface="Calibri" pitchFamily="34" charset="-122"/>
                           <a:cs typeface="Calibri" pitchFamily="34" charset="-120"/>
                         </a:rPr>
-                        <a:t>Written note; we say so on the poster</a:t>
+                        <a:t>Consent first; each organisation separate</a:t>
                       </a:r>
-                      <a:endParaRPr lang="en-US" sz="2600" dirty="0">
+                      <a:endParaRPr lang="en-US" sz="1900" dirty="0">
                         <a:latin typeface="Calibri" charset="0"/>
                         <a:ea typeface="Calibri" charset="0"/>
                         <a:cs typeface="Calibri" charset="0"/>
                       </a:endParaRPr>
                     </a:p>
                   </a:txBody>
-                  <a:tcPr marL="137160" marR="137160" marT="0" marB="0" anchor="ctr">
+                  <a:tcPr marL="109728" marR="109728" marT="0" marB="0" anchor="ctr">
                     <a:lnL w="12700" cap="flat" cmpd="sng" algn="ctr">
                       <a:solidFill>
                         <a:srgbClr val="C9D0E0"/>
@@ -3503,7 +4356,7 @@
                   </a:tcPr>
                 </a:tc>
               </a:tr>
-              <a:tr h="530352">
+              <a:tr h="566928">
                 <a:tc>
                   <a:txBody>
                     <a:bodyPr/>
@@ -3513,7 +4366,7 @@
                         <a:buNone/>
                       </a:pPr>
                       <a:r>
-                        <a:rPr lang="en-US" sz="2600" dirty="0">
+                        <a:rPr lang="en-US" sz="1900" dirty="0">
                           <a:solidFill>
                             <a:srgbClr val="14213D"/>
                           </a:solidFill>
@@ -3521,16 +4374,16 @@
                           <a:ea typeface="Calibri" pitchFamily="34" charset="-122"/>
                           <a:cs typeface="Calibri" pitchFamily="34" charset="-120"/>
                         </a:rPr>
-                        <a:t>Tickets and merged code out of step</a:t>
+                        <a:t>Old tickets did not match the code</a:t>
                       </a:r>
-                      <a:endParaRPr lang="en-US" sz="2600" dirty="0">
+                      <a:endParaRPr lang="en-US" sz="1900" dirty="0">
                         <a:latin typeface="Calibri" charset="0"/>
                         <a:ea typeface="Calibri" charset="0"/>
                         <a:cs typeface="Calibri" charset="0"/>
                       </a:endParaRPr>
                     </a:p>
                   </a:txBody>
-                  <a:tcPr marL="137160" marR="137160" marT="0" marB="0" anchor="ctr">
+                  <a:tcPr marL="109728" marR="109728" marT="0" marB="0" anchor="ctr">
                     <a:lnL w="12700" cap="flat" cmpd="sng" algn="ctr">
                       <a:solidFill>
                         <a:srgbClr val="C9D0E0"/>
@@ -3581,7 +4434,7 @@
                         <a:buNone/>
                       </a:pPr>
                       <a:r>
-                        <a:rPr lang="en-US" sz="2600" dirty="0">
+                        <a:rPr lang="en-US" sz="1900" dirty="0">
                           <a:solidFill>
                             <a:srgbClr val="14213D"/>
                           </a:solidFill>
@@ -3589,16 +4442,16 @@
                           <a:ea typeface="Calibri" pitchFamily="34" charset="-122"/>
                           <a:cs typeface="Calibri" pitchFamily="34" charset="-120"/>
                         </a:rPr>
-                        <a:t>Audit every ticket against the code</a:t>
+                        <a:t>Audited every ticket against the code</a:t>
                       </a:r>
-                      <a:endParaRPr lang="en-US" sz="2600" dirty="0">
+                      <a:endParaRPr lang="en-US" sz="1900" dirty="0">
                         <a:latin typeface="Calibri" charset="0"/>
                         <a:ea typeface="Calibri" charset="0"/>
                         <a:cs typeface="Calibri" charset="0"/>
                       </a:endParaRPr>
                     </a:p>
                   </a:txBody>
-                  <a:tcPr marL="137160" marR="137160" marT="0" marB="0" anchor="ctr">
+                  <a:tcPr marL="109728" marR="109728" marT="0" marB="0" anchor="ctr">
                     <a:lnL w="12700" cap="flat" cmpd="sng" algn="ctr">
                       <a:solidFill>
                         <a:srgbClr val="C9D0E0"/>
@@ -3647,14 +4500,14 @@
       </p:graphicFrame>
       <p:sp>
         <p:nvSpPr>
-          <p:cNvPr id="52" name="Shape 48"/>
-          <p:cNvSpPr/>
-          <p:nvPr/>
-        </p:nvSpPr>
-        <p:spPr>
-          <a:xfrm>
-            <a:off x="914400" y="27843480"/>
-            <a:ext cx="777240" cy="777240"/>
+          <p:cNvPr id="75" name="Shape 71"/>
+          <p:cNvSpPr/>
+          <p:nvPr/>
+        </p:nvSpPr>
+        <p:spPr>
+          <a:xfrm>
+            <a:off x="914400" y="27596592"/>
+            <a:ext cx="731520" cy="731520"/>
           </a:xfrm>
           <a:prstGeom prst="ellipse">
             <a:avLst/>
@@ -3667,14 +4520,14 @@
       </p:sp>
       <p:sp>
         <p:nvSpPr>
-          <p:cNvPr id="53" name="Text 49"/>
-          <p:cNvSpPr/>
-          <p:nvPr/>
-        </p:nvSpPr>
-        <p:spPr>
-          <a:xfrm>
-            <a:off x="914400" y="27843480"/>
-            <a:ext cx="777240" cy="777240"/>
+          <p:cNvPr id="76" name="Text 72"/>
+          <p:cNvSpPr/>
+          <p:nvPr/>
+        </p:nvSpPr>
+        <p:spPr>
+          <a:xfrm>
+            <a:off x="914400" y="27596592"/>
+            <a:ext cx="731520" cy="731520"/>
           </a:xfrm>
           <a:prstGeom prst="rect">
             <a:avLst/>
@@ -3690,7 +4543,7 @@
               <a:buNone/>
             </a:pPr>
             <a:r>
-              <a:rPr lang="en-US" sz="3200" b="1" dirty="0">
+              <a:rPr lang="en-US" sz="3000" b="1" dirty="0">
                 <a:solidFill>
                   <a:srgbClr val="1B2A49"/>
                 </a:solidFill>
@@ -3700,20 +4553,20 @@
               </a:rPr>
               <a:t>4</a:t>
             </a:r>
-            <a:endParaRPr lang="en-US" sz="3200" dirty="0"/>
-          </a:p>
-        </p:txBody>
-      </p:sp>
-      <p:sp>
-        <p:nvSpPr>
-          <p:cNvPr id="54" name="Text 50"/>
-          <p:cNvSpPr/>
-          <p:nvPr/>
-        </p:nvSpPr>
-        <p:spPr>
-          <a:xfrm>
-            <a:off x="1920240" y="27797760"/>
-            <a:ext cx="18288000" cy="868680"/>
+            <a:endParaRPr lang="en-US" sz="3000" dirty="0"/>
+          </a:p>
+        </p:txBody>
+      </p:sp>
+      <p:sp>
+        <p:nvSpPr>
+          <p:cNvPr id="77" name="Text 73"/>
+          <p:cNvSpPr/>
+          <p:nvPr/>
+        </p:nvSpPr>
+        <p:spPr>
+          <a:xfrm>
+            <a:off x="1874520" y="27569160"/>
+            <a:ext cx="18562320" cy="822960"/>
           </a:xfrm>
           <a:prstGeom prst="rect">
             <a:avLst/>
@@ -3729,7 +4582,7 @@
               <a:buNone/>
             </a:pPr>
             <a:r>
-              <a:rPr lang="en-US" sz="4600" b="1" dirty="0">
+              <a:rPr lang="en-US" sz="4200" b="1" dirty="0">
                 <a:solidFill>
                   <a:srgbClr val="1B2A49"/>
                 </a:solidFill>
@@ -3737,26 +4590,26 @@
                 <a:ea typeface="Cambria" pitchFamily="34" charset="-122"/>
                 <a:cs typeface="Cambria" pitchFamily="34" charset="-120"/>
               </a:rPr>
-              <a:t>Team</a:t>
-            </a:r>
-            <a:endParaRPr lang="en-US" sz="4600" dirty="0"/>
-          </a:p>
-        </p:txBody>
-      </p:sp>
-      <p:sp>
-        <p:nvSpPr>
-          <p:cNvPr id="55" name="Shape 51"/>
-          <p:cNvSpPr/>
-          <p:nvPr/>
-        </p:nvSpPr>
-        <p:spPr>
-          <a:xfrm>
-            <a:off x="914400" y="28712160"/>
-            <a:ext cx="4663440" cy="1188720"/>
+              <a:t>Team: everyone owns a part and can answer for it</a:t>
+            </a:r>
+            <a:endParaRPr lang="en-US" sz="4200" dirty="0"/>
+          </a:p>
+        </p:txBody>
+      </p:sp>
+      <p:sp>
+        <p:nvSpPr>
+          <p:cNvPr id="78" name="Shape 74"/>
+          <p:cNvSpPr/>
+          <p:nvPr/>
+        </p:nvSpPr>
+        <p:spPr>
+          <a:xfrm>
+            <a:off x="914400" y="28529280"/>
+            <a:ext cx="4663440" cy="1325880"/>
           </a:xfrm>
           <a:prstGeom prst="roundRect">
             <a:avLst>
-              <a:gd name="adj" fmla="val 7692"/>
+              <a:gd name="adj" fmla="val 6897"/>
             </a:avLst>
           </a:prstGeom>
           <a:solidFill>
@@ -3772,14 +4625,14 @@
       </p:sp>
       <p:sp>
         <p:nvSpPr>
-          <p:cNvPr id="56" name="Text 52"/>
-          <p:cNvSpPr/>
-          <p:nvPr/>
-        </p:nvSpPr>
-        <p:spPr>
-          <a:xfrm>
-            <a:off x="1051560" y="28712160"/>
-            <a:ext cx="4389120" cy="1188720"/>
+          <p:cNvPr id="79" name="Text 75"/>
+          <p:cNvSpPr/>
+          <p:nvPr/>
+        </p:nvSpPr>
+        <p:spPr>
+          <a:xfrm>
+            <a:off x="1051560" y="28529280"/>
+            <a:ext cx="4389120" cy="1325880"/>
           </a:xfrm>
           <a:prstGeom prst="rect">
             <a:avLst/>
@@ -3795,7 +4648,7 @@
               <a:buNone/>
             </a:pPr>
             <a:r>
-              <a:rPr lang="en-US" sz="2600" b="1" dirty="0">
+              <a:rPr lang="en-US" sz="2200" b="1" dirty="0">
                 <a:solidFill>
                   <a:srgbClr val="1B2A49"/>
                 </a:solidFill>
@@ -3805,14 +4658,14 @@
               </a:rPr>
               <a:t>Dilraj Singh</a:t>
             </a:r>
-            <a:endParaRPr lang="en-US" sz="2600" dirty="0"/>
+            <a:endParaRPr lang="en-US" sz="2200" dirty="0"/>
           </a:p>
           <a:p>
             <a:pPr indent="0" marL="0">
               <a:buNone/>
             </a:pPr>
             <a:r>
-              <a:rPr lang="en-US" sz="2100" dirty="0">
+              <a:rPr lang="en-US" sz="1700" dirty="0">
                 <a:solidFill>
                   <a:srgbClr val="14213D"/>
                 </a:solidFill>
@@ -3822,14 +4675,14 @@
               </a:rPr>
               <a:t>Product owner, lead developer</a:t>
             </a:r>
-            <a:endParaRPr lang="en-US" sz="2600" dirty="0"/>
+            <a:endParaRPr lang="en-US" sz="2200" dirty="0"/>
           </a:p>
           <a:p>
             <a:pPr indent="0" marL="0">
               <a:buNone/>
             </a:pPr>
             <a:r>
-              <a:rPr lang="en-US" sz="2100" dirty="0">
+              <a:rPr lang="en-US" sz="1700" dirty="0">
                 <a:solidFill>
                   <a:srgbClr val="5B6B8C"/>
                 </a:solidFill>
@@ -3837,26 +4690,26 @@
                 <a:ea typeface="Calibri" pitchFamily="34" charset="-122"/>
                 <a:cs typeface="Calibri" pitchFamily="34" charset="-120"/>
               </a:rPr>
-              <a:t>Integration, hosting, receptionist</a:t>
-            </a:r>
-            <a:endParaRPr lang="en-US" sz="2600" dirty="0"/>
-          </a:p>
-        </p:txBody>
-      </p:sp>
-      <p:sp>
-        <p:nvSpPr>
-          <p:cNvPr id="57" name="Shape 53"/>
-          <p:cNvSpPr/>
-          <p:nvPr/>
-        </p:nvSpPr>
-        <p:spPr>
-          <a:xfrm>
-            <a:off x="5879592" y="28712160"/>
-            <a:ext cx="4663440" cy="1188720"/>
+              <a:t>Ask me about: Receptionist, call summaries, cloud setup</a:t>
+            </a:r>
+            <a:endParaRPr lang="en-US" sz="2200" dirty="0"/>
+          </a:p>
+        </p:txBody>
+      </p:sp>
+      <p:sp>
+        <p:nvSpPr>
+          <p:cNvPr id="80" name="Shape 76"/>
+          <p:cNvSpPr/>
+          <p:nvPr/>
+        </p:nvSpPr>
+        <p:spPr>
+          <a:xfrm>
+            <a:off x="5879592" y="28529280"/>
+            <a:ext cx="4663440" cy="1325880"/>
           </a:xfrm>
           <a:prstGeom prst="roundRect">
             <a:avLst>
-              <a:gd name="adj" fmla="val 7692"/>
+              <a:gd name="adj" fmla="val 6897"/>
             </a:avLst>
           </a:prstGeom>
           <a:solidFill>
@@ -3872,14 +4725,14 @@
       </p:sp>
       <p:sp>
         <p:nvSpPr>
-          <p:cNvPr id="58" name="Text 54"/>
-          <p:cNvSpPr/>
-          <p:nvPr/>
-        </p:nvSpPr>
-        <p:spPr>
-          <a:xfrm>
-            <a:off x="6016752" y="28712160"/>
-            <a:ext cx="4389120" cy="1188720"/>
+          <p:cNvPr id="81" name="Text 77"/>
+          <p:cNvSpPr/>
+          <p:nvPr/>
+        </p:nvSpPr>
+        <p:spPr>
+          <a:xfrm>
+            <a:off x="6016752" y="28529280"/>
+            <a:ext cx="4389120" cy="1325880"/>
           </a:xfrm>
           <a:prstGeom prst="rect">
             <a:avLst/>
@@ -3895,7 +4748,7 @@
               <a:buNone/>
             </a:pPr>
             <a:r>
-              <a:rPr lang="en-US" sz="2600" b="1" dirty="0">
+              <a:rPr lang="en-US" sz="2200" b="1" dirty="0">
                 <a:solidFill>
                   <a:srgbClr val="1B2A49"/>
                 </a:solidFill>
@@ -3905,14 +4758,14 @@
               </a:rPr>
               <a:t>Prabhjot Singh</a:t>
             </a:r>
-            <a:endParaRPr lang="en-US" sz="2600" dirty="0"/>
+            <a:endParaRPr lang="en-US" sz="2200" dirty="0"/>
           </a:p>
           <a:p>
             <a:pPr indent="0" marL="0">
               <a:buNone/>
             </a:pPr>
             <a:r>
-              <a:rPr lang="en-US" sz="2100" dirty="0">
+              <a:rPr lang="en-US" sz="1700" dirty="0">
                 <a:solidFill>
                   <a:srgbClr val="14213D"/>
                 </a:solidFill>
@@ -3922,14 +4775,14 @@
               </a:rPr>
               <a:t>Scrum master, full-stack</a:t>
             </a:r>
-            <a:endParaRPr lang="en-US" sz="2600" dirty="0"/>
+            <a:endParaRPr lang="en-US" sz="2200" dirty="0"/>
           </a:p>
           <a:p>
             <a:pPr indent="0" marL="0">
               <a:buNone/>
             </a:pPr>
             <a:r>
-              <a:rPr lang="en-US" sz="2100" dirty="0">
+              <a:rPr lang="en-US" sz="1700" dirty="0">
                 <a:solidFill>
                   <a:srgbClr val="5B6B8C"/>
                 </a:solidFill>
@@ -3937,26 +4790,26 @@
                 <a:ea typeface="Calibri" pitchFamily="34" charset="-122"/>
                 <a:cs typeface="Calibri" pitchFamily="34" charset="-120"/>
               </a:rPr>
-              <a:t>Reminders UI, email, evidence</a:t>
-            </a:r>
-            <a:endParaRPr lang="en-US" sz="2600" dirty="0"/>
-          </a:p>
-        </p:txBody>
-      </p:sp>
-      <p:sp>
-        <p:nvSpPr>
-          <p:cNvPr id="59" name="Shape 55"/>
-          <p:cNvSpPr/>
-          <p:nvPr/>
-        </p:nvSpPr>
-        <p:spPr>
-          <a:xfrm>
-            <a:off x="10844784" y="28712160"/>
-            <a:ext cx="4663440" cy="1188720"/>
+              <a:t>Ask me about: Reminder controls, email, webhook security</a:t>
+            </a:r>
+            <a:endParaRPr lang="en-US" sz="2200" dirty="0"/>
+          </a:p>
+        </p:txBody>
+      </p:sp>
+      <p:sp>
+        <p:nvSpPr>
+          <p:cNvPr id="82" name="Shape 78"/>
+          <p:cNvSpPr/>
+          <p:nvPr/>
+        </p:nvSpPr>
+        <p:spPr>
+          <a:xfrm>
+            <a:off x="10844784" y="28529280"/>
+            <a:ext cx="4663440" cy="1325880"/>
           </a:xfrm>
           <a:prstGeom prst="roundRect">
             <a:avLst>
-              <a:gd name="adj" fmla="val 7692"/>
+              <a:gd name="adj" fmla="val 6897"/>
             </a:avLst>
           </a:prstGeom>
           <a:solidFill>
@@ -3972,14 +4825,14 @@
       </p:sp>
       <p:sp>
         <p:nvSpPr>
-          <p:cNvPr id="60" name="Text 56"/>
-          <p:cNvSpPr/>
-          <p:nvPr/>
-        </p:nvSpPr>
-        <p:spPr>
-          <a:xfrm>
-            <a:off x="10981944" y="28712160"/>
-            <a:ext cx="4389120" cy="1188720"/>
+          <p:cNvPr id="83" name="Text 79"/>
+          <p:cNvSpPr/>
+          <p:nvPr/>
+        </p:nvSpPr>
+        <p:spPr>
+          <a:xfrm>
+            <a:off x="10981944" y="28529280"/>
+            <a:ext cx="4389120" cy="1325880"/>
           </a:xfrm>
           <a:prstGeom prst="rect">
             <a:avLst/>
@@ -3995,7 +4848,7 @@
               <a:buNone/>
             </a:pPr>
             <a:r>
-              <a:rPr lang="en-US" sz="2600" b="1" dirty="0">
+              <a:rPr lang="en-US" sz="2200" b="1" dirty="0">
                 <a:solidFill>
                   <a:srgbClr val="1B2A49"/>
                 </a:solidFill>
@@ -4005,14 +4858,14 @@
               </a:rPr>
               <a:t>Dhiman Roy</a:t>
             </a:r>
-            <a:endParaRPr lang="en-US" sz="2600" dirty="0"/>
+            <a:endParaRPr lang="en-US" sz="2200" dirty="0"/>
           </a:p>
           <a:p>
             <a:pPr indent="0" marL="0">
               <a:buNone/>
             </a:pPr>
             <a:r>
-              <a:rPr lang="en-US" sz="2100" dirty="0">
+              <a:rPr lang="en-US" sz="1700" dirty="0">
                 <a:solidFill>
                   <a:srgbClr val="14213D"/>
                 </a:solidFill>
@@ -4020,16 +4873,16 @@
                 <a:ea typeface="Calibri" pitchFamily="34" charset="-122"/>
                 <a:cs typeface="Calibri" pitchFamily="34" charset="-120"/>
               </a:rPr>
-              <a:t>Backend: accounts, consent</a:t>
-            </a:r>
-            <a:endParaRPr lang="en-US" sz="2600" dirty="0"/>
+              <a:t>Backend: accounts and consent</a:t>
+            </a:r>
+            <a:endParaRPr lang="en-US" sz="2200" dirty="0"/>
           </a:p>
           <a:p>
             <a:pPr indent="0" marL="0">
               <a:buNone/>
             </a:pPr>
             <a:r>
-              <a:rPr lang="en-US" sz="2100" dirty="0">
+              <a:rPr lang="en-US" sz="1700" dirty="0">
                 <a:solidFill>
                   <a:srgbClr val="5B6B8C"/>
                 </a:solidFill>
@@ -4037,26 +4890,26 @@
                 <a:ea typeface="Calibri" pitchFamily="34" charset="-122"/>
                 <a:cs typeface="Calibri" pitchFamily="34" charset="-120"/>
               </a:rPr>
-              <a:t>Templates, rescheduling, auth</a:t>
-            </a:r>
-            <a:endParaRPr lang="en-US" sz="2600" dirty="0"/>
-          </a:p>
-        </p:txBody>
-      </p:sp>
-      <p:sp>
-        <p:nvSpPr>
-          <p:cNvPr id="61" name="Shape 57"/>
-          <p:cNvSpPr/>
-          <p:nvPr/>
-        </p:nvSpPr>
-        <p:spPr>
-          <a:xfrm>
-            <a:off x="15809976" y="28712160"/>
-            <a:ext cx="4663440" cy="1188720"/>
+              <a:t>Ask me about: Templates, rescheduling, roles and API keys</a:t>
+            </a:r>
+            <a:endParaRPr lang="en-US" sz="2200" dirty="0"/>
+          </a:p>
+        </p:txBody>
+      </p:sp>
+      <p:sp>
+        <p:nvSpPr>
+          <p:cNvPr id="84" name="Shape 80"/>
+          <p:cNvSpPr/>
+          <p:nvPr/>
+        </p:nvSpPr>
+        <p:spPr>
+          <a:xfrm>
+            <a:off x="15809976" y="28529280"/>
+            <a:ext cx="4663440" cy="1325880"/>
           </a:xfrm>
           <a:prstGeom prst="roundRect">
             <a:avLst>
-              <a:gd name="adj" fmla="val 7692"/>
+              <a:gd name="adj" fmla="val 6897"/>
             </a:avLst>
           </a:prstGeom>
           <a:solidFill>
@@ -4072,14 +4925,14 @@
       </p:sp>
       <p:sp>
         <p:nvSpPr>
-          <p:cNvPr id="62" name="Text 58"/>
-          <p:cNvSpPr/>
-          <p:nvPr/>
-        </p:nvSpPr>
-        <p:spPr>
-          <a:xfrm>
-            <a:off x="15947136" y="28712160"/>
-            <a:ext cx="4389120" cy="1188720"/>
+          <p:cNvPr id="85" name="Text 81"/>
+          <p:cNvSpPr/>
+          <p:nvPr/>
+        </p:nvSpPr>
+        <p:spPr>
+          <a:xfrm>
+            <a:off x="15947136" y="28529280"/>
+            <a:ext cx="4389120" cy="1325880"/>
           </a:xfrm>
           <a:prstGeom prst="rect">
             <a:avLst/>
@@ -4095,7 +4948,7 @@
               <a:buNone/>
             </a:pPr>
             <a:r>
-              <a:rPr lang="en-US" sz="2600" b="1" dirty="0">
+              <a:rPr lang="en-US" sz="2200" b="1" dirty="0">
                 <a:solidFill>
                   <a:srgbClr val="1B2A49"/>
                 </a:solidFill>
@@ -4105,14 +4958,14 @@
               </a:rPr>
               <a:t>Saifur Rahman Bhuiyan</a:t>
             </a:r>
-            <a:endParaRPr lang="en-US" sz="2600" dirty="0"/>
+            <a:endParaRPr lang="en-US" sz="2200" dirty="0"/>
           </a:p>
           <a:p>
             <a:pPr indent="0" marL="0">
               <a:buNone/>
             </a:pPr>
             <a:r>
-              <a:rPr lang="en-US" sz="2100" dirty="0">
+              <a:rPr lang="en-US" sz="1700" dirty="0">
                 <a:solidFill>
                   <a:srgbClr val="14213D"/>
                 </a:solidFill>
@@ -4122,14 +4975,14 @@
               </a:rPr>
               <a:t>Delivery, analytics, web</a:t>
             </a:r>
-            <a:endParaRPr lang="en-US" sz="2600" dirty="0"/>
+            <a:endParaRPr lang="en-US" sz="2200" dirty="0"/>
           </a:p>
           <a:p>
             <a:pPr indent="0" marL="0">
               <a:buNone/>
             </a:pPr>
             <a:r>
-              <a:rPr lang="en-US" sz="2100" dirty="0">
+              <a:rPr lang="en-US" sz="1700" dirty="0">
                 <a:solidFill>
                   <a:srgbClr val="5B6B8C"/>
                 </a:solidFill>
@@ -4137,21 +4990,21 @@
                 <a:ea typeface="Calibri" pitchFamily="34" charset="-122"/>
                 <a:cs typeface="Calibri" pitchFamily="34" charset="-120"/>
               </a:rPr>
-              <a:t>Marketing site, exports</a:t>
-            </a:r>
-            <a:endParaRPr lang="en-US" sz="2600" dirty="0"/>
-          </a:p>
-        </p:txBody>
-      </p:sp>
-      <p:sp>
-        <p:nvSpPr>
-          <p:cNvPr id="63" name="Text 59"/>
-          <p:cNvSpPr/>
-          <p:nvPr/>
-        </p:nvSpPr>
-        <p:spPr>
-          <a:xfrm>
-            <a:off x="914400" y="29955744"/>
+              <a:t>Ask me about: Live dashboard, voice languages, site</a:t>
+            </a:r>
+            <a:endParaRPr lang="en-US" sz="2200" dirty="0"/>
+          </a:p>
+        </p:txBody>
+      </p:sp>
+      <p:sp>
+        <p:nvSpPr>
+          <p:cNvPr id="86" name="Text 82"/>
+          <p:cNvSpPr/>
+          <p:nvPr/>
+        </p:nvSpPr>
+        <p:spPr>
+          <a:xfrm>
+            <a:off x="914400" y="29974032"/>
             <a:ext cx="19568160" cy="256032"/>
           </a:xfrm>
           <a:prstGeom prst="rect">
@@ -4176,7 +5029,7 @@
                 <a:ea typeface="Calibri" pitchFamily="34" charset="-122"/>
                 <a:cs typeface="Calibri" pitchFamily="34" charset="-120"/>
               </a:rPr>
-              <a:t>Python · FastAPI · SQLite · Twilio · Claude · Docker      Demo data is fictional. The target deployment is on-premise.</a:t>
+              <a:t>Python · FastAPI · SQLite · Twilio · Claude · Docker      Cloud based. Demo clinic and data are fictional.</a:t>
             </a:r>
             <a:endParaRPr lang="en-US" sz="1600" dirty="0"/>
           </a:p>

</xml_diff>

<commit_message>
Poster: dark theme matching the website, with the logo
Co-Authored-By: Claude Sonnet 5.5 <noreply@anthropic.com>
</commit_message>
<xml_diff>
--- a/docs/poster/Sprint5_Poster_AgentFactory.pptx
+++ b/docs/poster/Sprint5_Poster_AgentFactory.pptx
@@ -857,7 +857,7 @@
     <p:bg>
       <p:bgPr>
         <a:solidFill>
-          <a:srgbClr val="FFFFFF"/>
+          <a:srgbClr val="0A0E17"/>
         </a:solidFill>
       </p:bgPr>
     </p:bg>
@@ -890,20 +890,50 @@
             <a:avLst/>
           </a:prstGeom>
           <a:solidFill>
-            <a:srgbClr val="1B2A49"/>
+            <a:srgbClr val="111A2F"/>
           </a:solidFill>
           <a:ln/>
         </p:spPr>
       </p:sp>
-      <p:sp>
-        <p:nvSpPr>
-          <p:cNvPr id="3" name="Text 1"/>
-          <p:cNvSpPr/>
-          <p:nvPr/>
-        </p:nvSpPr>
-        <p:spPr>
-          <a:xfrm>
-            <a:off x="731520" y="274320"/>
+      <p:pic>
+        <p:nvPicPr>
+          <p:cNvPr id="3" name="Image 0" descr="logo_src.svg">    </p:cNvPr>
+          <p:cNvPicPr>
+            <a:picLocks noChangeAspect="1"/>
+          </p:cNvPicPr>
+          <p:nvPr/>
+        </p:nvPicPr>
+        <p:blipFill>
+          <a:blip r:embed="rId1">
+            <a:extLst>
+              <a:ext uri="{96DAC541-7B7A-43D3-8B79-37D633B846F1}">
+                <asvg:svgBlip xmlns:asvg="http://schemas.microsoft.com/office/drawing/2016/SVG/main" r:embed="rId2"/>
+              </a:ext>
+            </a:extLst>
+          </a:blip>
+          <a:stretch>
+            <a:fillRect/>
+          </a:stretch>
+        </p:blipFill>
+        <p:spPr>
+          <a:xfrm>
+            <a:off x="731520" y="411480"/>
+            <a:ext cx="2011680" cy="2011680"/>
+          </a:xfrm>
+          <a:prstGeom prst="rect">
+            <a:avLst/>
+          </a:prstGeom>
+        </p:spPr>
+      </p:pic>
+      <p:sp>
+        <p:nvSpPr>
+          <p:cNvPr id="4" name="Text 1"/>
+          <p:cNvSpPr/>
+          <p:nvPr/>
+        </p:nvSpPr>
+        <p:spPr>
+          <a:xfrm>
+            <a:off x="3108960" y="274320"/>
             <a:ext cx="12801600" cy="502920"/>
           </a:xfrm>
           <a:prstGeom prst="rect">
@@ -922,7 +952,7 @@
             <a:r>
               <a:rPr lang="en-US" sz="2600" b="1" spc="600" kern="0" dirty="0">
                 <a:solidFill>
-                  <a:srgbClr val="C9A227"/>
+                  <a:srgbClr val="22D3EE"/>
                 </a:solidFill>
                 <a:latin typeface="Calibri" pitchFamily="34" charset="0"/>
                 <a:ea typeface="Calibri" pitchFamily="34" charset="-122"/>
@@ -936,14 +966,14 @@
       </p:sp>
       <p:sp>
         <p:nvSpPr>
-          <p:cNvPr id="4" name="Text 2"/>
-          <p:cNvSpPr/>
-          <p:nvPr/>
-        </p:nvSpPr>
-        <p:spPr>
-          <a:xfrm>
-            <a:off x="731520" y="822960"/>
-            <a:ext cx="28803600" cy="1005840"/>
+          <p:cNvPr id="5" name="Text 2"/>
+          <p:cNvSpPr/>
+          <p:nvPr/>
+        </p:nvSpPr>
+        <p:spPr>
+          <a:xfrm>
+            <a:off x="3108960" y="822960"/>
+            <a:ext cx="26426160" cy="1005840"/>
           </a:xfrm>
           <a:prstGeom prst="rect">
             <a:avLst/>
@@ -961,11 +991,11 @@
             <a:r>
               <a:rPr lang="en-US" sz="4600" b="1" dirty="0">
                 <a:solidFill>
-                  <a:srgbClr val="FFFFFF"/>
-                </a:solidFill>
-                <a:latin typeface="Cambria" pitchFamily="34" charset="0"/>
-                <a:ea typeface="Cambria" pitchFamily="34" charset="-122"/>
-                <a:cs typeface="Cambria" pitchFamily="34" charset="-120"/>
+                  <a:srgbClr val="F8FAFC"/>
+                </a:solidFill>
+                <a:latin typeface="Calibri" pitchFamily="34" charset="0"/>
+                <a:ea typeface="Calibri" pitchFamily="34" charset="-122"/>
+                <a:cs typeface="Calibri" pitchFamily="34" charset="-120"/>
               </a:rPr>
               <a:t>Reminders that respect consent, and an AI receptionist that answers the phone</a:t>
             </a:r>
@@ -975,14 +1005,14 @@
       </p:sp>
       <p:sp>
         <p:nvSpPr>
-          <p:cNvPr id="5" name="Text 3"/>
-          <p:cNvSpPr/>
-          <p:nvPr/>
-        </p:nvSpPr>
-        <p:spPr>
-          <a:xfrm>
-            <a:off x="731520" y="2057400"/>
-            <a:ext cx="28803600" cy="457200"/>
+          <p:cNvPr id="6" name="Text 3"/>
+          <p:cNvSpPr/>
+          <p:nvPr/>
+        </p:nvSpPr>
+        <p:spPr>
+          <a:xfrm>
+            <a:off x="3108960" y="2057400"/>
+            <a:ext cx="26426160" cy="457200"/>
           </a:xfrm>
           <a:prstGeom prst="rect">
             <a:avLst/>
@@ -1000,7 +1030,7 @@
             <a:r>
               <a:rPr lang="en-US" sz="2200" dirty="0">
                 <a:solidFill>
-                  <a:srgbClr val="D9DEE9"/>
+                  <a:srgbClr val="94A3B8"/>
                 </a:solidFill>
                 <a:latin typeface="Calibri" pitchFamily="34" charset="0"/>
                 <a:ea typeface="Calibri" pitchFamily="34" charset="-122"/>
@@ -1014,7 +1044,7 @@
       </p:sp>
       <p:sp>
         <p:nvSpPr>
-          <p:cNvPr id="6" name="Shape 4"/>
+          <p:cNvPr id="7" name="Shape 4"/>
           <p:cNvSpPr/>
           <p:nvPr/>
         </p:nvSpPr>
@@ -1029,11 +1059,11 @@
             </a:avLst>
           </a:prstGeom>
           <a:solidFill>
-            <a:srgbClr val="FFFFFF"/>
+            <a:srgbClr val="121826"/>
           </a:solidFill>
           <a:ln w="25400">
             <a:solidFill>
-              <a:srgbClr val="1B2A49"/>
+              <a:srgbClr val="263044"/>
             </a:solidFill>
             <a:prstDash val="solid"/>
           </a:ln>
@@ -1041,7 +1071,7 @@
       </p:sp>
       <p:sp>
         <p:nvSpPr>
-          <p:cNvPr id="7" name="Text 5"/>
+          <p:cNvPr id="8" name="Text 5"/>
           <p:cNvSpPr/>
           <p:nvPr/>
         </p:nvSpPr>
@@ -1066,7 +1096,7 @@
             <a:r>
               <a:rPr lang="en-US" sz="2400" b="1" dirty="0">
                 <a:solidFill>
-                  <a:srgbClr val="1B2A49"/>
+                  <a:srgbClr val="F8FAFC"/>
                 </a:solidFill>
                 <a:latin typeface="Calibri" pitchFamily="34" charset="0"/>
                 <a:ea typeface="Calibri" pitchFamily="34" charset="-122"/>
@@ -1083,7 +1113,7 @@
             <a:r>
               <a:rPr lang="en-US" sz="1800" dirty="0">
                 <a:solidFill>
-                  <a:srgbClr val="14213D"/>
+                  <a:srgbClr val="94A3B8"/>
                 </a:solidFill>
                 <a:latin typeface="Calibri" pitchFamily="34" charset="0"/>
                 <a:ea typeface="Calibri" pitchFamily="34" charset="-122"/>
@@ -1097,7 +1127,7 @@
       </p:sp>
       <p:sp>
         <p:nvSpPr>
-          <p:cNvPr id="8" name="Shape 6"/>
+          <p:cNvPr id="9" name="Shape 6"/>
           <p:cNvSpPr/>
           <p:nvPr/>
         </p:nvSpPr>
@@ -1112,11 +1142,11 @@
             </a:avLst>
           </a:prstGeom>
           <a:solidFill>
-            <a:srgbClr val="C9A227"/>
+            <a:srgbClr val="6366F1"/>
           </a:solidFill>
           <a:ln w="25400">
             <a:solidFill>
-              <a:srgbClr val="C9A227"/>
+              <a:srgbClr val="6366F1"/>
             </a:solidFill>
             <a:prstDash val="solid"/>
           </a:ln>
@@ -1124,7 +1154,7 @@
       </p:sp>
       <p:sp>
         <p:nvSpPr>
-          <p:cNvPr id="9" name="Text 7"/>
+          <p:cNvPr id="10" name="Text 7"/>
           <p:cNvSpPr/>
           <p:nvPr/>
         </p:nvSpPr>
@@ -1149,7 +1179,7 @@
             <a:r>
               <a:rPr lang="en-US" sz="2400" b="1" dirty="0">
                 <a:solidFill>
-                  <a:srgbClr val="1B2A49"/>
+                  <a:srgbClr val="F8FAFC"/>
                 </a:solidFill>
                 <a:latin typeface="Calibri" pitchFamily="34" charset="0"/>
                 <a:ea typeface="Calibri" pitchFamily="34" charset="-122"/>
@@ -1166,7 +1196,7 @@
             <a:r>
               <a:rPr lang="en-US" sz="1800" dirty="0">
                 <a:solidFill>
-                  <a:srgbClr val="14213D"/>
+                  <a:srgbClr val="E0E7FF"/>
                 </a:solidFill>
                 <a:latin typeface="Calibri" pitchFamily="34" charset="0"/>
                 <a:ea typeface="Calibri" pitchFamily="34" charset="-122"/>
@@ -1180,7 +1210,7 @@
       </p:sp>
       <p:sp>
         <p:nvSpPr>
-          <p:cNvPr id="10" name="Shape 8"/>
+          <p:cNvPr id="11" name="Shape 8"/>
           <p:cNvSpPr/>
           <p:nvPr/>
         </p:nvSpPr>
@@ -1195,11 +1225,11 @@
             </a:avLst>
           </a:prstGeom>
           <a:solidFill>
-            <a:srgbClr val="FFFFFF"/>
+            <a:srgbClr val="121826"/>
           </a:solidFill>
           <a:ln w="25400">
             <a:solidFill>
-              <a:srgbClr val="1B2A49"/>
+              <a:srgbClr val="263044"/>
             </a:solidFill>
             <a:prstDash val="solid"/>
           </a:ln>
@@ -1207,7 +1237,7 @@
       </p:sp>
       <p:sp>
         <p:nvSpPr>
-          <p:cNvPr id="11" name="Text 9"/>
+          <p:cNvPr id="12" name="Text 9"/>
           <p:cNvSpPr/>
           <p:nvPr/>
         </p:nvSpPr>
@@ -1232,7 +1262,7 @@
             <a:r>
               <a:rPr lang="en-US" sz="2400" b="1" dirty="0">
                 <a:solidFill>
-                  <a:srgbClr val="1B2A49"/>
+                  <a:srgbClr val="F8FAFC"/>
                 </a:solidFill>
                 <a:latin typeface="Calibri" pitchFamily="34" charset="0"/>
                 <a:ea typeface="Calibri" pitchFamily="34" charset="-122"/>
@@ -1249,7 +1279,7 @@
             <a:r>
               <a:rPr lang="en-US" sz="1800" dirty="0">
                 <a:solidFill>
-                  <a:srgbClr val="14213D"/>
+                  <a:srgbClr val="94A3B8"/>
                 </a:solidFill>
                 <a:latin typeface="Calibri" pitchFamily="34" charset="0"/>
                 <a:ea typeface="Calibri" pitchFamily="34" charset="-122"/>
@@ -1263,7 +1293,7 @@
       </p:sp>
       <p:sp>
         <p:nvSpPr>
-          <p:cNvPr id="12" name="Shape 10"/>
+          <p:cNvPr id="13" name="Shape 10"/>
           <p:cNvSpPr/>
           <p:nvPr/>
         </p:nvSpPr>
@@ -1278,11 +1308,11 @@
             </a:avLst>
           </a:prstGeom>
           <a:solidFill>
-            <a:srgbClr val="FFFFFF"/>
+            <a:srgbClr val="121826"/>
           </a:solidFill>
           <a:ln w="25400">
             <a:solidFill>
-              <a:srgbClr val="1B2A49"/>
+              <a:srgbClr val="263044"/>
             </a:solidFill>
             <a:prstDash val="solid"/>
           </a:ln>
@@ -1290,7 +1320,7 @@
       </p:sp>
       <p:sp>
         <p:nvSpPr>
-          <p:cNvPr id="13" name="Text 11"/>
+          <p:cNvPr id="14" name="Text 11"/>
           <p:cNvSpPr/>
           <p:nvPr/>
         </p:nvSpPr>
@@ -1315,7 +1345,7 @@
             <a:r>
               <a:rPr lang="en-US" sz="2400" b="1" dirty="0">
                 <a:solidFill>
-                  <a:srgbClr val="1B2A49"/>
+                  <a:srgbClr val="F8FAFC"/>
                 </a:solidFill>
                 <a:latin typeface="Calibri" pitchFamily="34" charset="0"/>
                 <a:ea typeface="Calibri" pitchFamily="34" charset="-122"/>
@@ -1332,7 +1362,7 @@
             <a:r>
               <a:rPr lang="en-US" sz="1800" dirty="0">
                 <a:solidFill>
-                  <a:srgbClr val="14213D"/>
+                  <a:srgbClr val="94A3B8"/>
                 </a:solidFill>
                 <a:latin typeface="Calibri" pitchFamily="34" charset="0"/>
                 <a:ea typeface="Calibri" pitchFamily="34" charset="-122"/>
@@ -1346,7 +1376,7 @@
       </p:sp>
       <p:sp>
         <p:nvSpPr>
-          <p:cNvPr id="14" name="Shape 12"/>
+          <p:cNvPr id="15" name="Shape 12"/>
           <p:cNvSpPr/>
           <p:nvPr/>
         </p:nvSpPr>
@@ -1361,11 +1391,11 @@
             </a:avLst>
           </a:prstGeom>
           <a:solidFill>
-            <a:srgbClr val="FFFFFF"/>
+            <a:srgbClr val="121826"/>
           </a:solidFill>
           <a:ln w="25400">
             <a:solidFill>
-              <a:srgbClr val="1B2A49"/>
+              <a:srgbClr val="263044"/>
             </a:solidFill>
             <a:prstDash val="solid"/>
           </a:ln>
@@ -1373,7 +1403,7 @@
       </p:sp>
       <p:sp>
         <p:nvSpPr>
-          <p:cNvPr id="15" name="Text 13"/>
+          <p:cNvPr id="16" name="Text 13"/>
           <p:cNvSpPr/>
           <p:nvPr/>
         </p:nvSpPr>
@@ -1398,7 +1428,7 @@
             <a:r>
               <a:rPr lang="en-US" sz="2400" b="1" dirty="0">
                 <a:solidFill>
-                  <a:srgbClr val="1B2A49"/>
+                  <a:srgbClr val="F8FAFC"/>
                 </a:solidFill>
                 <a:latin typeface="Calibri" pitchFamily="34" charset="0"/>
                 <a:ea typeface="Calibri" pitchFamily="34" charset="-122"/>
@@ -1415,7 +1445,7 @@
             <a:r>
               <a:rPr lang="en-US" sz="1800" dirty="0">
                 <a:solidFill>
-                  <a:srgbClr val="14213D"/>
+                  <a:srgbClr val="94A3B8"/>
                 </a:solidFill>
                 <a:latin typeface="Calibri" pitchFamily="34" charset="0"/>
                 <a:ea typeface="Calibri" pitchFamily="34" charset="-122"/>
@@ -1429,7 +1459,7 @@
       </p:sp>
       <p:sp>
         <p:nvSpPr>
-          <p:cNvPr id="16" name="Shape 14"/>
+          <p:cNvPr id="17" name="Shape 14"/>
           <p:cNvSpPr/>
           <p:nvPr/>
         </p:nvSpPr>
@@ -1444,7 +1474,7 @@
           <a:noFill/>
           <a:ln w="50800">
             <a:solidFill>
-              <a:srgbClr val="C9A227"/>
+              <a:srgbClr val="22D3EE"/>
             </a:solidFill>
             <a:prstDash val="solid"/>
             <a:tailEnd type="triangle"/>
@@ -1453,7 +1483,7 @@
       </p:sp>
       <p:sp>
         <p:nvSpPr>
-          <p:cNvPr id="17" name="Shape 15"/>
+          <p:cNvPr id="18" name="Shape 15"/>
           <p:cNvSpPr/>
           <p:nvPr/>
         </p:nvSpPr>
@@ -1468,7 +1498,7 @@
           <a:noFill/>
           <a:ln w="50800">
             <a:solidFill>
-              <a:srgbClr val="C9A227"/>
+              <a:srgbClr val="22D3EE"/>
             </a:solidFill>
             <a:prstDash val="solid"/>
             <a:tailEnd type="triangle"/>
@@ -1477,7 +1507,7 @@
       </p:sp>
       <p:sp>
         <p:nvSpPr>
-          <p:cNvPr id="18" name="Shape 16"/>
+          <p:cNvPr id="19" name="Shape 16"/>
           <p:cNvSpPr/>
           <p:nvPr/>
         </p:nvSpPr>
@@ -1492,7 +1522,7 @@
           <a:noFill/>
           <a:ln w="50800">
             <a:solidFill>
-              <a:srgbClr val="C9A227"/>
+              <a:srgbClr val="22D3EE"/>
             </a:solidFill>
             <a:prstDash val="solid"/>
             <a:tailEnd type="triangle"/>
@@ -1501,7 +1531,7 @@
       </p:sp>
       <p:sp>
         <p:nvSpPr>
-          <p:cNvPr id="19" name="Shape 17"/>
+          <p:cNvPr id="20" name="Shape 17"/>
           <p:cNvSpPr/>
           <p:nvPr/>
         </p:nvSpPr>
@@ -1516,7 +1546,7 @@
           <a:noFill/>
           <a:ln w="50800">
             <a:solidFill>
-              <a:srgbClr val="C9A227"/>
+              <a:srgbClr val="22D3EE"/>
             </a:solidFill>
             <a:prstDash val="solid"/>
             <a:tailEnd type="triangle"/>
@@ -1525,7 +1555,7 @@
       </p:sp>
       <p:sp>
         <p:nvSpPr>
-          <p:cNvPr id="20" name="Shape 18"/>
+          <p:cNvPr id="21" name="Shape 18"/>
           <p:cNvSpPr/>
           <p:nvPr/>
         </p:nvSpPr>
@@ -1538,14 +1568,14 @@
             <a:avLst/>
           </a:prstGeom>
           <a:solidFill>
-            <a:srgbClr val="C9A227"/>
+            <a:srgbClr val="6366F1"/>
           </a:solidFill>
           <a:ln/>
         </p:spPr>
       </p:sp>
       <p:sp>
         <p:nvSpPr>
-          <p:cNvPr id="21" name="Text 19"/>
+          <p:cNvPr id="22" name="Text 19"/>
           <p:cNvSpPr/>
           <p:nvPr/>
         </p:nvSpPr>
@@ -1570,11 +1600,11 @@
             <a:r>
               <a:rPr lang="en-US" sz="2800" b="1" dirty="0">
                 <a:solidFill>
-                  <a:srgbClr val="1B2A49"/>
-                </a:solidFill>
-                <a:latin typeface="Cambria" pitchFamily="34" charset="0"/>
-                <a:ea typeface="Cambria" pitchFamily="34" charset="-122"/>
-                <a:cs typeface="Cambria" pitchFamily="34" charset="-120"/>
+                  <a:srgbClr val="F8FAFC"/>
+                </a:solidFill>
+                <a:latin typeface="Calibri" pitchFamily="34" charset="0"/>
+                <a:ea typeface="Calibri" pitchFamily="34" charset="-122"/>
+                <a:cs typeface="Calibri" pitchFamily="34" charset="-120"/>
               </a:rPr>
               <a:t>1</a:t>
             </a:r>
@@ -1584,7 +1614,7 @@
       </p:sp>
       <p:sp>
         <p:nvSpPr>
-          <p:cNvPr id="22" name="Text 20"/>
+          <p:cNvPr id="23" name="Text 20"/>
           <p:cNvSpPr/>
           <p:nvPr/>
         </p:nvSpPr>
@@ -1609,11 +1639,11 @@
             <a:r>
               <a:rPr lang="en-US" sz="3000" b="1" dirty="0">
                 <a:solidFill>
-                  <a:srgbClr val="1B2A49"/>
-                </a:solidFill>
-                <a:latin typeface="Cambria" pitchFamily="34" charset="0"/>
-                <a:ea typeface="Cambria" pitchFamily="34" charset="-122"/>
-                <a:cs typeface="Cambria" pitchFamily="34" charset="-120"/>
+                  <a:srgbClr val="F8FAFC"/>
+                </a:solidFill>
+                <a:latin typeface="Calibri" pitchFamily="34" charset="0"/>
+                <a:ea typeface="Calibri" pitchFamily="34" charset="-122"/>
+                <a:cs typeface="Calibri" pitchFamily="34" charset="-120"/>
               </a:rPr>
               <a:t>Project definition</a:t>
             </a:r>
@@ -1623,7 +1653,7 @@
       </p:sp>
       <p:sp>
         <p:nvSpPr>
-          <p:cNvPr id="23" name="Text 21"/>
+          <p:cNvPr id="24" name="Text 21"/>
           <p:cNvSpPr/>
           <p:nvPr/>
         </p:nvSpPr>
@@ -1648,7 +1678,7 @@
             <a:r>
               <a:rPr lang="en-US" sz="2400" b="1" dirty="0">
                 <a:solidFill>
-                  <a:srgbClr val="C9A227"/>
+                  <a:srgbClr val="22D3EE"/>
                 </a:solidFill>
                 <a:latin typeface="Calibri" pitchFamily="34" charset="0"/>
                 <a:ea typeface="Calibri" pitchFamily="34" charset="-122"/>
@@ -1662,7 +1692,7 @@
       </p:sp>
       <p:sp>
         <p:nvSpPr>
-          <p:cNvPr id="24" name="Text 22"/>
+          <p:cNvPr id="25" name="Text 22"/>
           <p:cNvSpPr/>
           <p:nvPr/>
         </p:nvSpPr>
@@ -1687,7 +1717,7 @@
             <a:r>
               <a:rPr lang="en-US" sz="2300" dirty="0">
                 <a:solidFill>
-                  <a:srgbClr val="14213D"/>
+                  <a:srgbClr val="F8FAFC"/>
                 </a:solidFill>
                 <a:latin typeface="Calibri" pitchFamily="34" charset="0"/>
                 <a:ea typeface="Calibri" pitchFamily="34" charset="-122"/>
@@ -1701,7 +1731,7 @@
       </p:sp>
       <p:sp>
         <p:nvSpPr>
-          <p:cNvPr id="25" name="Text 23"/>
+          <p:cNvPr id="26" name="Text 23"/>
           <p:cNvSpPr/>
           <p:nvPr/>
         </p:nvSpPr>
@@ -1726,7 +1756,7 @@
             <a:r>
               <a:rPr lang="en-US" sz="2400" b="1" dirty="0">
                 <a:solidFill>
-                  <a:srgbClr val="C9A227"/>
+                  <a:srgbClr val="22D3EE"/>
                 </a:solidFill>
                 <a:latin typeface="Calibri" pitchFamily="34" charset="0"/>
                 <a:ea typeface="Calibri" pitchFamily="34" charset="-122"/>
@@ -1740,7 +1770,7 @@
       </p:sp>
       <p:sp>
         <p:nvSpPr>
-          <p:cNvPr id="26" name="Text 24"/>
+          <p:cNvPr id="27" name="Text 24"/>
           <p:cNvSpPr/>
           <p:nvPr/>
         </p:nvSpPr>
@@ -1765,7 +1795,7 @@
             <a:r>
               <a:rPr lang="en-US" sz="2200" dirty="0">
                 <a:solidFill>
-                  <a:srgbClr val="14213D"/>
+                  <a:srgbClr val="F8FAFC"/>
                 </a:solidFill>
                 <a:latin typeface="Calibri" pitchFamily="34" charset="0"/>
                 <a:ea typeface="Calibri" pitchFamily="34" charset="-122"/>
@@ -1779,7 +1809,7 @@
       </p:sp>
       <p:sp>
         <p:nvSpPr>
-          <p:cNvPr id="27" name="Text 25"/>
+          <p:cNvPr id="28" name="Text 25"/>
           <p:cNvSpPr/>
           <p:nvPr/>
         </p:nvSpPr>
@@ -1804,7 +1834,7 @@
             <a:r>
               <a:rPr lang="en-US" sz="2400" b="1" dirty="0">
                 <a:solidFill>
-                  <a:srgbClr val="C9A227"/>
+                  <a:srgbClr val="22D3EE"/>
                 </a:solidFill>
                 <a:latin typeface="Calibri" pitchFamily="34" charset="0"/>
                 <a:ea typeface="Calibri" pitchFamily="34" charset="-122"/>
@@ -1818,7 +1848,7 @@
       </p:sp>
       <p:sp>
         <p:nvSpPr>
-          <p:cNvPr id="28" name="Text 26"/>
+          <p:cNvPr id="29" name="Text 26"/>
           <p:cNvSpPr/>
           <p:nvPr/>
         </p:nvSpPr>
@@ -1843,7 +1873,7 @@
             <a:r>
               <a:rPr lang="en-US" sz="2000" dirty="0">
                 <a:solidFill>
-                  <a:srgbClr val="14213D"/>
+                  <a:srgbClr val="CBD5E1"/>
                 </a:solidFill>
                 <a:latin typeface="Calibri" pitchFamily="34" charset="0"/>
                 <a:ea typeface="Calibri" pitchFamily="34" charset="-122"/>
@@ -1857,7 +1887,7 @@
       </p:sp>
       <p:sp>
         <p:nvSpPr>
-          <p:cNvPr id="29" name="Shape 27"/>
+          <p:cNvPr id="30" name="Shape 27"/>
           <p:cNvSpPr/>
           <p:nvPr/>
         </p:nvSpPr>
@@ -1872,14 +1902,14 @@
             </a:avLst>
           </a:prstGeom>
           <a:solidFill>
-            <a:srgbClr val="2E7D5B"/>
+            <a:srgbClr val="10B981"/>
           </a:solidFill>
           <a:ln/>
         </p:spPr>
       </p:sp>
       <p:sp>
         <p:nvSpPr>
-          <p:cNvPr id="30" name="Text 28"/>
+          <p:cNvPr id="31" name="Text 28"/>
           <p:cNvSpPr/>
           <p:nvPr/>
         </p:nvSpPr>
@@ -1904,7 +1934,7 @@
             <a:r>
               <a:rPr lang="en-US" sz="1600" b="1" dirty="0">
                 <a:solidFill>
-                  <a:srgbClr val="FFFFFF"/>
+                  <a:srgbClr val="0A0E17"/>
                 </a:solidFill>
                 <a:latin typeface="Calibri" pitchFamily="34" charset="0"/>
                 <a:ea typeface="Calibri" pitchFamily="34" charset="-122"/>
@@ -1918,7 +1948,7 @@
       </p:sp>
       <p:sp>
         <p:nvSpPr>
-          <p:cNvPr id="31" name="Text 29"/>
+          <p:cNvPr id="32" name="Text 29"/>
           <p:cNvSpPr/>
           <p:nvPr/>
         </p:nvSpPr>
@@ -1943,7 +1973,7 @@
             <a:r>
               <a:rPr lang="en-US" sz="2000" dirty="0">
                 <a:solidFill>
-                  <a:srgbClr val="14213D"/>
+                  <a:srgbClr val="CBD5E1"/>
                 </a:solidFill>
                 <a:latin typeface="Calibri" pitchFamily="34" charset="0"/>
                 <a:ea typeface="Calibri" pitchFamily="34" charset="-122"/>
@@ -1957,7 +1987,7 @@
       </p:sp>
       <p:sp>
         <p:nvSpPr>
-          <p:cNvPr id="32" name="Shape 30"/>
+          <p:cNvPr id="33" name="Shape 30"/>
           <p:cNvSpPr/>
           <p:nvPr/>
         </p:nvSpPr>
@@ -1972,14 +2002,14 @@
             </a:avLst>
           </a:prstGeom>
           <a:solidFill>
-            <a:srgbClr val="2E7D5B"/>
+            <a:srgbClr val="10B981"/>
           </a:solidFill>
           <a:ln/>
         </p:spPr>
       </p:sp>
       <p:sp>
         <p:nvSpPr>
-          <p:cNvPr id="33" name="Text 31"/>
+          <p:cNvPr id="34" name="Text 31"/>
           <p:cNvSpPr/>
           <p:nvPr/>
         </p:nvSpPr>
@@ -2004,7 +2034,7 @@
             <a:r>
               <a:rPr lang="en-US" sz="1600" b="1" dirty="0">
                 <a:solidFill>
-                  <a:srgbClr val="FFFFFF"/>
+                  <a:srgbClr val="0A0E17"/>
                 </a:solidFill>
                 <a:latin typeface="Calibri" pitchFamily="34" charset="0"/>
                 <a:ea typeface="Calibri" pitchFamily="34" charset="-122"/>
@@ -2018,7 +2048,7 @@
       </p:sp>
       <p:sp>
         <p:nvSpPr>
-          <p:cNvPr id="34" name="Text 32"/>
+          <p:cNvPr id="35" name="Text 32"/>
           <p:cNvSpPr/>
           <p:nvPr/>
         </p:nvSpPr>
@@ -2043,7 +2073,7 @@
             <a:r>
               <a:rPr lang="en-US" sz="2000" dirty="0">
                 <a:solidFill>
-                  <a:srgbClr val="14213D"/>
+                  <a:srgbClr val="CBD5E1"/>
                 </a:solidFill>
                 <a:latin typeface="Calibri" pitchFamily="34" charset="0"/>
                 <a:ea typeface="Calibri" pitchFamily="34" charset="-122"/>
@@ -2057,7 +2087,7 @@
       </p:sp>
       <p:sp>
         <p:nvSpPr>
-          <p:cNvPr id="35" name="Shape 33"/>
+          <p:cNvPr id="36" name="Shape 33"/>
           <p:cNvSpPr/>
           <p:nvPr/>
         </p:nvSpPr>
@@ -2072,14 +2102,14 @@
             </a:avLst>
           </a:prstGeom>
           <a:solidFill>
-            <a:srgbClr val="2E7D5B"/>
+            <a:srgbClr val="10B981"/>
           </a:solidFill>
           <a:ln/>
         </p:spPr>
       </p:sp>
       <p:sp>
         <p:nvSpPr>
-          <p:cNvPr id="36" name="Text 34"/>
+          <p:cNvPr id="37" name="Text 34"/>
           <p:cNvSpPr/>
           <p:nvPr/>
         </p:nvSpPr>
@@ -2104,7 +2134,7 @@
             <a:r>
               <a:rPr lang="en-US" sz="1600" b="1" dirty="0">
                 <a:solidFill>
-                  <a:srgbClr val="FFFFFF"/>
+                  <a:srgbClr val="0A0E17"/>
                 </a:solidFill>
                 <a:latin typeface="Calibri" pitchFamily="34" charset="0"/>
                 <a:ea typeface="Calibri" pitchFamily="34" charset="-122"/>
@@ -2118,7 +2148,7 @@
       </p:sp>
       <p:sp>
         <p:nvSpPr>
-          <p:cNvPr id="37" name="Text 35"/>
+          <p:cNvPr id="38" name="Text 35"/>
           <p:cNvSpPr/>
           <p:nvPr/>
         </p:nvSpPr>
@@ -2143,7 +2173,7 @@
             <a:r>
               <a:rPr lang="en-US" sz="2000" dirty="0">
                 <a:solidFill>
-                  <a:srgbClr val="14213D"/>
+                  <a:srgbClr val="CBD5E1"/>
                 </a:solidFill>
                 <a:latin typeface="Calibri" pitchFamily="34" charset="0"/>
                 <a:ea typeface="Calibri" pitchFamily="34" charset="-122"/>
@@ -2157,7 +2187,7 @@
       </p:sp>
       <p:sp>
         <p:nvSpPr>
-          <p:cNvPr id="38" name="Shape 36"/>
+          <p:cNvPr id="39" name="Shape 36"/>
           <p:cNvSpPr/>
           <p:nvPr/>
         </p:nvSpPr>
@@ -2172,14 +2202,14 @@
             </a:avLst>
           </a:prstGeom>
           <a:solidFill>
-            <a:srgbClr val="A9701B"/>
+            <a:srgbClr val="F59E0B"/>
           </a:solidFill>
           <a:ln/>
         </p:spPr>
       </p:sp>
       <p:sp>
         <p:nvSpPr>
-          <p:cNvPr id="39" name="Text 37"/>
+          <p:cNvPr id="40" name="Text 37"/>
           <p:cNvSpPr/>
           <p:nvPr/>
         </p:nvSpPr>
@@ -2204,7 +2234,7 @@
             <a:r>
               <a:rPr lang="en-US" sz="1600" b="1" dirty="0">
                 <a:solidFill>
-                  <a:srgbClr val="FFFFFF"/>
+                  <a:srgbClr val="0A0E17"/>
                 </a:solidFill>
                 <a:latin typeface="Calibri" pitchFamily="34" charset="0"/>
                 <a:ea typeface="Calibri" pitchFamily="34" charset="-122"/>
@@ -2218,7 +2248,7 @@
       </p:sp>
       <p:sp>
         <p:nvSpPr>
-          <p:cNvPr id="40" name="Shape 38"/>
+          <p:cNvPr id="41" name="Shape 38"/>
           <p:cNvSpPr/>
           <p:nvPr/>
         </p:nvSpPr>
@@ -2231,14 +2261,14 @@
             <a:avLst/>
           </a:prstGeom>
           <a:solidFill>
-            <a:srgbClr val="C9A227"/>
+            <a:srgbClr val="6366F1"/>
           </a:solidFill>
           <a:ln/>
         </p:spPr>
       </p:sp>
       <p:sp>
         <p:nvSpPr>
-          <p:cNvPr id="41" name="Text 39"/>
+          <p:cNvPr id="42" name="Text 39"/>
           <p:cNvSpPr/>
           <p:nvPr/>
         </p:nvSpPr>
@@ -2263,11 +2293,11 @@
             <a:r>
               <a:rPr lang="en-US" sz="2800" b="1" dirty="0">
                 <a:solidFill>
-                  <a:srgbClr val="1B2A49"/>
-                </a:solidFill>
-                <a:latin typeface="Cambria" pitchFamily="34" charset="0"/>
-                <a:ea typeface="Cambria" pitchFamily="34" charset="-122"/>
-                <a:cs typeface="Cambria" pitchFamily="34" charset="-120"/>
+                  <a:srgbClr val="F8FAFC"/>
+                </a:solidFill>
+                <a:latin typeface="Calibri" pitchFamily="34" charset="0"/>
+                <a:ea typeface="Calibri" pitchFamily="34" charset="-122"/>
+                <a:cs typeface="Calibri" pitchFamily="34" charset="-120"/>
               </a:rPr>
               <a:t>4</a:t>
             </a:r>
@@ -2277,7 +2307,7 @@
       </p:sp>
       <p:sp>
         <p:nvSpPr>
-          <p:cNvPr id="42" name="Text 40"/>
+          <p:cNvPr id="43" name="Text 40"/>
           <p:cNvSpPr/>
           <p:nvPr/>
         </p:nvSpPr>
@@ -2302,11 +2332,11 @@
             <a:r>
               <a:rPr lang="en-US" sz="3000" b="1" dirty="0">
                 <a:solidFill>
-                  <a:srgbClr val="1B2A49"/>
-                </a:solidFill>
-                <a:latin typeface="Cambria" pitchFamily="34" charset="0"/>
-                <a:ea typeface="Cambria" pitchFamily="34" charset="-122"/>
-                <a:cs typeface="Cambria" pitchFamily="34" charset="-120"/>
+                  <a:srgbClr val="F8FAFC"/>
+                </a:solidFill>
+                <a:latin typeface="Calibri" pitchFamily="34" charset="0"/>
+                <a:ea typeface="Calibri" pitchFamily="34" charset="-122"/>
+                <a:cs typeface="Calibri" pitchFamily="34" charset="-120"/>
               </a:rPr>
               <a:t>Team integration and Q&amp;A</a:t>
             </a:r>
@@ -2316,7 +2346,7 @@
       </p:sp>
       <p:sp>
         <p:nvSpPr>
-          <p:cNvPr id="43" name="Shape 41"/>
+          <p:cNvPr id="44" name="Shape 41"/>
           <p:cNvSpPr/>
           <p:nvPr/>
         </p:nvSpPr>
@@ -2327,15 +2357,15 @@
           </a:xfrm>
           <a:prstGeom prst="roundRect">
             <a:avLst>
-              <a:gd name="adj" fmla="val 8333"/>
+              <a:gd name="adj" fmla="val 10000"/>
             </a:avLst>
           </a:prstGeom>
           <a:solidFill>
-            <a:srgbClr val="EEF1F6"/>
+            <a:srgbClr val="121826"/>
           </a:solidFill>
           <a:ln w="12700">
             <a:solidFill>
-              <a:srgbClr val="EEF1F6"/>
+              <a:srgbClr val="263044"/>
             </a:solidFill>
             <a:prstDash val="solid"/>
           </a:ln>
@@ -2343,14 +2373,14 @@
       </p:sp>
       <p:sp>
         <p:nvSpPr>
-          <p:cNvPr id="44" name="Text 42"/>
-          <p:cNvSpPr/>
-          <p:nvPr/>
-        </p:nvSpPr>
-        <p:spPr>
-          <a:xfrm>
-            <a:off x="914400" y="15407640"/>
-            <a:ext cx="8869680" cy="1097280"/>
+          <p:cNvPr id="45" name="Text 42"/>
+          <p:cNvSpPr/>
+          <p:nvPr/>
+        </p:nvSpPr>
+        <p:spPr>
+          <a:xfrm>
+            <a:off x="960120" y="15407640"/>
+            <a:ext cx="8778240" cy="1097280"/>
           </a:xfrm>
           <a:prstGeom prst="rect">
             <a:avLst/>
@@ -2368,7 +2398,7 @@
             <a:r>
               <a:rPr lang="en-US" sz="2200" b="1" dirty="0">
                 <a:solidFill>
-                  <a:srgbClr val="1B2A49"/>
+                  <a:srgbClr val="F8FAFC"/>
                 </a:solidFill>
                 <a:latin typeface="Calibri" pitchFamily="34" charset="0"/>
                 <a:ea typeface="Calibri" pitchFamily="34" charset="-122"/>
@@ -2385,7 +2415,7 @@
             <a:r>
               <a:rPr lang="en-US" sz="1600" dirty="0">
                 <a:solidFill>
-                  <a:srgbClr val="14213D"/>
+                  <a:srgbClr val="CBD5E1"/>
                 </a:solidFill>
                 <a:latin typeface="Calibri" pitchFamily="34" charset="0"/>
                 <a:ea typeface="Calibri" pitchFamily="34" charset="-122"/>
@@ -2402,7 +2432,7 @@
             <a:r>
               <a:rPr lang="en-US" sz="1600" dirty="0">
                 <a:solidFill>
-                  <a:srgbClr val="5B6B8C"/>
+                  <a:srgbClr val="22D3EE"/>
                 </a:solidFill>
                 <a:latin typeface="Calibri" pitchFamily="34" charset="0"/>
                 <a:ea typeface="Calibri" pitchFamily="34" charset="-122"/>
@@ -2416,7 +2446,7 @@
       </p:sp>
       <p:sp>
         <p:nvSpPr>
-          <p:cNvPr id="45" name="Shape 43"/>
+          <p:cNvPr id="46" name="Shape 43"/>
           <p:cNvSpPr/>
           <p:nvPr/>
         </p:nvSpPr>
@@ -2427,15 +2457,15 @@
           </a:xfrm>
           <a:prstGeom prst="roundRect">
             <a:avLst>
-              <a:gd name="adj" fmla="val 8333"/>
+              <a:gd name="adj" fmla="val 10000"/>
             </a:avLst>
           </a:prstGeom>
           <a:solidFill>
-            <a:srgbClr val="EEF1F6"/>
+            <a:srgbClr val="121826"/>
           </a:solidFill>
           <a:ln w="12700">
             <a:solidFill>
-              <a:srgbClr val="EEF1F6"/>
+              <a:srgbClr val="263044"/>
             </a:solidFill>
             <a:prstDash val="solid"/>
           </a:ln>
@@ -2443,14 +2473,14 @@
       </p:sp>
       <p:sp>
         <p:nvSpPr>
-          <p:cNvPr id="46" name="Text 44"/>
-          <p:cNvSpPr/>
-          <p:nvPr/>
-        </p:nvSpPr>
-        <p:spPr>
-          <a:xfrm>
-            <a:off x="914400" y="16596360"/>
-            <a:ext cx="8869680" cy="1097280"/>
+          <p:cNvPr id="47" name="Text 44"/>
+          <p:cNvSpPr/>
+          <p:nvPr/>
+        </p:nvSpPr>
+        <p:spPr>
+          <a:xfrm>
+            <a:off x="960120" y="16596360"/>
+            <a:ext cx="8778240" cy="1097280"/>
           </a:xfrm>
           <a:prstGeom prst="rect">
             <a:avLst/>
@@ -2468,7 +2498,7 @@
             <a:r>
               <a:rPr lang="en-US" sz="2200" b="1" dirty="0">
                 <a:solidFill>
-                  <a:srgbClr val="1B2A49"/>
+                  <a:srgbClr val="F8FAFC"/>
                 </a:solidFill>
                 <a:latin typeface="Calibri" pitchFamily="34" charset="0"/>
                 <a:ea typeface="Calibri" pitchFamily="34" charset="-122"/>
@@ -2485,7 +2515,7 @@
             <a:r>
               <a:rPr lang="en-US" sz="1600" dirty="0">
                 <a:solidFill>
-                  <a:srgbClr val="14213D"/>
+                  <a:srgbClr val="CBD5E1"/>
                 </a:solidFill>
                 <a:latin typeface="Calibri" pitchFamily="34" charset="0"/>
                 <a:ea typeface="Calibri" pitchFamily="34" charset="-122"/>
@@ -2502,7 +2532,7 @@
             <a:r>
               <a:rPr lang="en-US" sz="1600" dirty="0">
                 <a:solidFill>
-                  <a:srgbClr val="5B6B8C"/>
+                  <a:srgbClr val="22D3EE"/>
                 </a:solidFill>
                 <a:latin typeface="Calibri" pitchFamily="34" charset="0"/>
                 <a:ea typeface="Calibri" pitchFamily="34" charset="-122"/>
@@ -2516,7 +2546,7 @@
       </p:sp>
       <p:sp>
         <p:nvSpPr>
-          <p:cNvPr id="47" name="Shape 45"/>
+          <p:cNvPr id="48" name="Shape 45"/>
           <p:cNvSpPr/>
           <p:nvPr/>
         </p:nvSpPr>
@@ -2527,15 +2557,15 @@
           </a:xfrm>
           <a:prstGeom prst="roundRect">
             <a:avLst>
-              <a:gd name="adj" fmla="val 8333"/>
+              <a:gd name="adj" fmla="val 10000"/>
             </a:avLst>
           </a:prstGeom>
           <a:solidFill>
-            <a:srgbClr val="EEF1F6"/>
+            <a:srgbClr val="121826"/>
           </a:solidFill>
           <a:ln w="12700">
             <a:solidFill>
-              <a:srgbClr val="EEF1F6"/>
+              <a:srgbClr val="263044"/>
             </a:solidFill>
             <a:prstDash val="solid"/>
           </a:ln>
@@ -2543,14 +2573,14 @@
       </p:sp>
       <p:sp>
         <p:nvSpPr>
-          <p:cNvPr id="48" name="Text 46"/>
-          <p:cNvSpPr/>
-          <p:nvPr/>
-        </p:nvSpPr>
-        <p:spPr>
-          <a:xfrm>
-            <a:off x="914400" y="17785080"/>
-            <a:ext cx="8869680" cy="1097280"/>
+          <p:cNvPr id="49" name="Text 46"/>
+          <p:cNvSpPr/>
+          <p:nvPr/>
+        </p:nvSpPr>
+        <p:spPr>
+          <a:xfrm>
+            <a:off x="960120" y="17785080"/>
+            <a:ext cx="8778240" cy="1097280"/>
           </a:xfrm>
           <a:prstGeom prst="rect">
             <a:avLst/>
@@ -2568,7 +2598,7 @@
             <a:r>
               <a:rPr lang="en-US" sz="2200" b="1" dirty="0">
                 <a:solidFill>
-                  <a:srgbClr val="1B2A49"/>
+                  <a:srgbClr val="F8FAFC"/>
                 </a:solidFill>
                 <a:latin typeface="Calibri" pitchFamily="34" charset="0"/>
                 <a:ea typeface="Calibri" pitchFamily="34" charset="-122"/>
@@ -2585,7 +2615,7 @@
             <a:r>
               <a:rPr lang="en-US" sz="1600" dirty="0">
                 <a:solidFill>
-                  <a:srgbClr val="14213D"/>
+                  <a:srgbClr val="CBD5E1"/>
                 </a:solidFill>
                 <a:latin typeface="Calibri" pitchFamily="34" charset="0"/>
                 <a:ea typeface="Calibri" pitchFamily="34" charset="-122"/>
@@ -2602,7 +2632,7 @@
             <a:r>
               <a:rPr lang="en-US" sz="1600" dirty="0">
                 <a:solidFill>
-                  <a:srgbClr val="5B6B8C"/>
+                  <a:srgbClr val="22D3EE"/>
                 </a:solidFill>
                 <a:latin typeface="Calibri" pitchFamily="34" charset="0"/>
                 <a:ea typeface="Calibri" pitchFamily="34" charset="-122"/>
@@ -2616,7 +2646,7 @@
       </p:sp>
       <p:sp>
         <p:nvSpPr>
-          <p:cNvPr id="49" name="Shape 47"/>
+          <p:cNvPr id="50" name="Shape 47"/>
           <p:cNvSpPr/>
           <p:nvPr/>
         </p:nvSpPr>
@@ -2627,15 +2657,15 @@
           </a:xfrm>
           <a:prstGeom prst="roundRect">
             <a:avLst>
-              <a:gd name="adj" fmla="val 8333"/>
+              <a:gd name="adj" fmla="val 10000"/>
             </a:avLst>
           </a:prstGeom>
           <a:solidFill>
-            <a:srgbClr val="EEF1F6"/>
+            <a:srgbClr val="121826"/>
           </a:solidFill>
           <a:ln w="12700">
             <a:solidFill>
-              <a:srgbClr val="EEF1F6"/>
+              <a:srgbClr val="263044"/>
             </a:solidFill>
             <a:prstDash val="solid"/>
           </a:ln>
@@ -2643,14 +2673,14 @@
       </p:sp>
       <p:sp>
         <p:nvSpPr>
-          <p:cNvPr id="50" name="Text 48"/>
-          <p:cNvSpPr/>
-          <p:nvPr/>
-        </p:nvSpPr>
-        <p:spPr>
-          <a:xfrm>
-            <a:off x="914400" y="18973800"/>
-            <a:ext cx="8869680" cy="1097280"/>
+          <p:cNvPr id="51" name="Text 48"/>
+          <p:cNvSpPr/>
+          <p:nvPr/>
+        </p:nvSpPr>
+        <p:spPr>
+          <a:xfrm>
+            <a:off x="960120" y="18973800"/>
+            <a:ext cx="8778240" cy="1097280"/>
           </a:xfrm>
           <a:prstGeom prst="rect">
             <a:avLst/>
@@ -2668,7 +2698,7 @@
             <a:r>
               <a:rPr lang="en-US" sz="2200" b="1" dirty="0">
                 <a:solidFill>
-                  <a:srgbClr val="1B2A49"/>
+                  <a:srgbClr val="F8FAFC"/>
                 </a:solidFill>
                 <a:latin typeface="Calibri" pitchFamily="34" charset="0"/>
                 <a:ea typeface="Calibri" pitchFamily="34" charset="-122"/>
@@ -2685,7 +2715,7 @@
             <a:r>
               <a:rPr lang="en-US" sz="1600" dirty="0">
                 <a:solidFill>
-                  <a:srgbClr val="14213D"/>
+                  <a:srgbClr val="CBD5E1"/>
                 </a:solidFill>
                 <a:latin typeface="Calibri" pitchFamily="34" charset="0"/>
                 <a:ea typeface="Calibri" pitchFamily="34" charset="-122"/>
@@ -2702,7 +2732,7 @@
             <a:r>
               <a:rPr lang="en-US" sz="1600" dirty="0">
                 <a:solidFill>
-                  <a:srgbClr val="5B6B8C"/>
+                  <a:srgbClr val="22D3EE"/>
                 </a:solidFill>
                 <a:latin typeface="Calibri" pitchFamily="34" charset="0"/>
                 <a:ea typeface="Calibri" pitchFamily="34" charset="-122"/>
@@ -2716,7 +2746,7 @@
       </p:sp>
       <p:sp>
         <p:nvSpPr>
-          <p:cNvPr id="51" name="Shape 49"/>
+          <p:cNvPr id="52" name="Shape 49"/>
           <p:cNvSpPr/>
           <p:nvPr/>
         </p:nvSpPr>
@@ -2729,14 +2759,14 @@
             <a:avLst/>
           </a:prstGeom>
           <a:solidFill>
-            <a:srgbClr val="C9A227"/>
+            <a:srgbClr val="6366F1"/>
           </a:solidFill>
           <a:ln/>
         </p:spPr>
       </p:sp>
       <p:sp>
         <p:nvSpPr>
-          <p:cNvPr id="52" name="Text 50"/>
+          <p:cNvPr id="53" name="Text 50"/>
           <p:cNvSpPr/>
           <p:nvPr/>
         </p:nvSpPr>
@@ -2761,11 +2791,11 @@
             <a:r>
               <a:rPr lang="en-US" sz="2800" b="1" dirty="0">
                 <a:solidFill>
-                  <a:srgbClr val="1B2A49"/>
-                </a:solidFill>
-                <a:latin typeface="Cambria" pitchFamily="34" charset="0"/>
-                <a:ea typeface="Cambria" pitchFamily="34" charset="-122"/>
-                <a:cs typeface="Cambria" pitchFamily="34" charset="-120"/>
+                  <a:srgbClr val="F8FAFC"/>
+                </a:solidFill>
+                <a:latin typeface="Calibri" pitchFamily="34" charset="0"/>
+                <a:ea typeface="Calibri" pitchFamily="34" charset="-122"/>
+                <a:cs typeface="Calibri" pitchFamily="34" charset="-120"/>
               </a:rPr>
               <a:t>2</a:t>
             </a:r>
@@ -2775,7 +2805,7 @@
       </p:sp>
       <p:sp>
         <p:nvSpPr>
-          <p:cNvPr id="53" name="Text 51"/>
+          <p:cNvPr id="54" name="Text 51"/>
           <p:cNvSpPr/>
           <p:nvPr/>
         </p:nvSpPr>
@@ -2800,11 +2830,11 @@
             <a:r>
               <a:rPr lang="en-US" sz="3000" b="1" dirty="0">
                 <a:solidFill>
-                  <a:srgbClr val="1B2A49"/>
-                </a:solidFill>
-                <a:latin typeface="Cambria" pitchFamily="34" charset="0"/>
-                <a:ea typeface="Cambria" pitchFamily="34" charset="-122"/>
-                <a:cs typeface="Cambria" pitchFamily="34" charset="-120"/>
+                  <a:srgbClr val="F8FAFC"/>
+                </a:solidFill>
+                <a:latin typeface="Calibri" pitchFamily="34" charset="0"/>
+                <a:ea typeface="Calibri" pitchFamily="34" charset="-122"/>
+                <a:cs typeface="Calibri" pitchFamily="34" charset="-120"/>
               </a:rPr>
               <a:t>Technical status and demo</a:t>
             </a:r>
@@ -2814,7 +2844,7 @@
       </p:sp>
       <p:sp>
         <p:nvSpPr>
-          <p:cNvPr id="54" name="Text 52"/>
+          <p:cNvPr id="55" name="Text 52"/>
           <p:cNvSpPr/>
           <p:nvPr/>
         </p:nvSpPr>
@@ -2839,7 +2869,7 @@
             <a:r>
               <a:rPr lang="en-US" sz="2400" b="1" dirty="0">
                 <a:solidFill>
-                  <a:srgbClr val="C9A227"/>
+                  <a:srgbClr val="22D3EE"/>
                 </a:solidFill>
                 <a:latin typeface="Calibri" pitchFamily="34" charset="0"/>
                 <a:ea typeface="Calibri" pitchFamily="34" charset="-122"/>
@@ -2850,24 +2880,51 @@
             <a:endParaRPr lang="en-US" sz="2400" dirty="0"/>
           </a:p>
         </p:txBody>
+      </p:sp>
+      <p:sp>
+        <p:nvSpPr>
+          <p:cNvPr id="56" name="Shape 53"/>
+          <p:cNvSpPr/>
+          <p:nvPr/>
+        </p:nvSpPr>
+        <p:spPr>
+          <a:xfrm>
+            <a:off x="10515600" y="6217920"/>
+            <a:ext cx="3474720" cy="3474720"/>
+          </a:xfrm>
+          <a:prstGeom prst="roundRect">
+            <a:avLst>
+              <a:gd name="adj" fmla="val 3158"/>
+            </a:avLst>
+          </a:prstGeom>
+          <a:solidFill>
+            <a:srgbClr val="FFFFFF"/>
+          </a:solidFill>
+          <a:ln w="12700">
+            <a:solidFill>
+              <a:srgbClr val="FFFFFF"/>
+            </a:solidFill>
+            <a:prstDash val="solid"/>
+          </a:ln>
+        </p:spPr>
       </p:sp>
       <p:pic>
         <p:nvPicPr>
-          <p:cNvPr id="55" name="Image 0" descr="qr.png">    </p:cNvPr>
+          <p:cNvPr id="57" name="Image 1" descr="qr.png">    </p:cNvPr>
           <p:cNvPicPr>
             <a:picLocks noChangeAspect="1"/>
           </p:cNvPicPr>
           <p:nvPr/>
         </p:nvPicPr>
         <p:blipFill>
-          <a:blip r:embed="rId1"/>
+          <a:blip r:embed="rId3"/>
           <a:stretch>
             <a:fillRect/>
           </a:stretch>
         </p:blipFill>
         <p:spPr>
           <a:xfrm>
-            <a:off x="10515600" y="6263640"/>
+            <a:off x="10652760" y="6355080"/>
             <a:ext cx="3200400" cy="3200400"/>
           </a:xfrm>
           <a:prstGeom prst="rect">
@@ -2877,14 +2934,14 @@
       </p:pic>
       <p:sp>
         <p:nvSpPr>
-          <p:cNvPr id="56" name="Text 53"/>
-          <p:cNvSpPr/>
-          <p:nvPr/>
-        </p:nvSpPr>
-        <p:spPr>
-          <a:xfrm>
-            <a:off x="10515600" y="9482328"/>
-            <a:ext cx="3200400" cy="411480"/>
+          <p:cNvPr id="58" name="Text 54"/>
+          <p:cNvSpPr/>
+          <p:nvPr/>
+        </p:nvSpPr>
+        <p:spPr>
+          <a:xfrm>
+            <a:off x="10515600" y="9738360"/>
+            <a:ext cx="3474720" cy="411480"/>
           </a:xfrm>
           <a:prstGeom prst="rect">
             <a:avLst/>
@@ -2902,7 +2959,7 @@
             <a:r>
               <a:rPr lang="en-US" sz="2000" b="1" dirty="0">
                 <a:solidFill>
-                  <a:srgbClr val="1B2A49"/>
+                  <a:srgbClr val="F8FAFC"/>
                 </a:solidFill>
                 <a:latin typeface="Calibri" pitchFamily="34" charset="0"/>
                 <a:ea typeface="Calibri" pitchFamily="34" charset="-122"/>
@@ -2916,14 +2973,14 @@
       </p:sp>
       <p:sp>
         <p:nvSpPr>
-          <p:cNvPr id="57" name="Text 54"/>
-          <p:cNvSpPr/>
-          <p:nvPr/>
-        </p:nvSpPr>
-        <p:spPr>
-          <a:xfrm>
-            <a:off x="13990320" y="6263640"/>
-            <a:ext cx="5760720" cy="3200400"/>
+          <p:cNvPr id="59" name="Text 55"/>
+          <p:cNvSpPr/>
+          <p:nvPr/>
+        </p:nvSpPr>
+        <p:spPr>
+          <a:xfrm>
+            <a:off x="14264640" y="6217920"/>
+            <a:ext cx="5486400" cy="3474720"/>
           </a:xfrm>
           <a:prstGeom prst="rect">
             <a:avLst/>
@@ -2941,7 +2998,7 @@
             <a:r>
               <a:rPr lang="en-US" sz="2300" dirty="0">
                 <a:solidFill>
-                  <a:srgbClr val="14213D"/>
+                  <a:srgbClr val="F8FAFC"/>
                 </a:solidFill>
                 <a:latin typeface="Calibri" pitchFamily="34" charset="0"/>
                 <a:ea typeface="Calibri" pitchFamily="34" charset="-122"/>
@@ -2955,14 +3012,14 @@
       </p:sp>
       <p:sp>
         <p:nvSpPr>
-          <p:cNvPr id="58" name="Text 55"/>
-          <p:cNvSpPr/>
-          <p:nvPr/>
-        </p:nvSpPr>
-        <p:spPr>
-          <a:xfrm>
-            <a:off x="10515600" y="10058400"/>
-            <a:ext cx="9235440" cy="3931920"/>
+          <p:cNvPr id="60" name="Text 56"/>
+          <p:cNvSpPr/>
+          <p:nvPr/>
+        </p:nvSpPr>
+        <p:spPr>
+          <a:xfrm>
+            <a:off x="10515600" y="10378440"/>
+            <a:ext cx="9235440" cy="3657600"/>
           </a:xfrm>
           <a:prstGeom prst="rect">
             <a:avLst/>
@@ -2983,7 +3040,7 @@
             <a:r>
               <a:rPr lang="en-US" sz="2200" dirty="0">
                 <a:solidFill>
-                  <a:srgbClr val="14213D"/>
+                  <a:srgbClr val="F8FAFC"/>
                 </a:solidFill>
                 <a:latin typeface="Calibri" pitchFamily="34" charset="0"/>
                 <a:ea typeface="Calibri" pitchFamily="34" charset="-122"/>
@@ -3003,7 +3060,7 @@
             <a:r>
               <a:rPr lang="en-US" sz="2200" dirty="0">
                 <a:solidFill>
-                  <a:srgbClr val="14213D"/>
+                  <a:srgbClr val="F8FAFC"/>
                 </a:solidFill>
                 <a:latin typeface="Calibri" pitchFamily="34" charset="0"/>
                 <a:ea typeface="Calibri" pitchFamily="34" charset="-122"/>
@@ -3023,7 +3080,7 @@
             <a:r>
               <a:rPr lang="en-US" sz="2200" dirty="0">
                 <a:solidFill>
-                  <a:srgbClr val="14213D"/>
+                  <a:srgbClr val="F8FAFC"/>
                 </a:solidFill>
                 <a:latin typeface="Calibri" pitchFamily="34" charset="0"/>
                 <a:ea typeface="Calibri" pitchFamily="34" charset="-122"/>
@@ -3043,7 +3100,7 @@
             <a:r>
               <a:rPr lang="en-US" sz="2200" dirty="0">
                 <a:solidFill>
-                  <a:srgbClr val="14213D"/>
+                  <a:srgbClr val="F8FAFC"/>
                 </a:solidFill>
                 <a:latin typeface="Calibri" pitchFamily="34" charset="0"/>
                 <a:ea typeface="Calibri" pitchFamily="34" charset="-122"/>
@@ -3063,7 +3120,7 @@
             <a:r>
               <a:rPr lang="en-US" sz="2200" dirty="0">
                 <a:solidFill>
-                  <a:srgbClr val="14213D"/>
+                  <a:srgbClr val="F8FAFC"/>
                 </a:solidFill>
                 <a:latin typeface="Calibri" pitchFamily="34" charset="0"/>
                 <a:ea typeface="Calibri" pitchFamily="34" charset="-122"/>
@@ -3077,26 +3134,26 @@
       </p:sp>
       <p:sp>
         <p:nvSpPr>
-          <p:cNvPr id="59" name="Shape 56"/>
-          <p:cNvSpPr/>
-          <p:nvPr/>
-        </p:nvSpPr>
-        <p:spPr>
-          <a:xfrm>
-            <a:off x="10515600" y="13853160"/>
+          <p:cNvPr id="61" name="Shape 57"/>
+          <p:cNvSpPr/>
+          <p:nvPr/>
+        </p:nvSpPr>
+        <p:spPr>
+          <a:xfrm>
+            <a:off x="10515600" y="14218920"/>
             <a:ext cx="4480560" cy="1463040"/>
           </a:xfrm>
           <a:prstGeom prst="roundRect">
             <a:avLst>
-              <a:gd name="adj" fmla="val 6250"/>
+              <a:gd name="adj" fmla="val 7500"/>
             </a:avLst>
           </a:prstGeom>
           <a:solidFill>
-            <a:srgbClr val="EEF1F6"/>
+            <a:srgbClr val="121826"/>
           </a:solidFill>
           <a:ln w="12700">
             <a:solidFill>
-              <a:srgbClr val="EEF1F6"/>
+              <a:srgbClr val="263044"/>
             </a:solidFill>
             <a:prstDash val="solid"/>
           </a:ln>
@@ -3104,14 +3161,14 @@
       </p:sp>
       <p:sp>
         <p:nvSpPr>
-          <p:cNvPr id="60" name="Text 57"/>
-          <p:cNvSpPr/>
-          <p:nvPr/>
-        </p:nvSpPr>
-        <p:spPr>
-          <a:xfrm>
-            <a:off x="10698480" y="13880592"/>
-            <a:ext cx="4114800" cy="685800"/>
+          <p:cNvPr id="62" name="Text 58"/>
+          <p:cNvSpPr/>
+          <p:nvPr/>
+        </p:nvSpPr>
+        <p:spPr>
+          <a:xfrm>
+            <a:off x="10744200" y="14246352"/>
+            <a:ext cx="4023360" cy="685800"/>
           </a:xfrm>
           <a:prstGeom prst="rect">
             <a:avLst/>
@@ -3129,11 +3186,11 @@
             <a:r>
               <a:rPr lang="en-US" sz="3400" b="1" dirty="0">
                 <a:solidFill>
-                  <a:srgbClr val="1B2A49"/>
-                </a:solidFill>
-                <a:latin typeface="Cambria" pitchFamily="34" charset="0"/>
-                <a:ea typeface="Cambria" pitchFamily="34" charset="-122"/>
-                <a:cs typeface="Cambria" pitchFamily="34" charset="-120"/>
+                  <a:srgbClr val="22D3EE"/>
+                </a:solidFill>
+                <a:latin typeface="Calibri" pitchFamily="34" charset="0"/>
+                <a:ea typeface="Calibri" pitchFamily="34" charset="-122"/>
+                <a:cs typeface="Calibri" pitchFamily="34" charset="-120"/>
               </a:rPr>
               <a:t>761</a:t>
             </a:r>
@@ -3143,14 +3200,14 @@
       </p:sp>
       <p:sp>
         <p:nvSpPr>
-          <p:cNvPr id="61" name="Text 58"/>
-          <p:cNvSpPr/>
-          <p:nvPr/>
-        </p:nvSpPr>
-        <p:spPr>
-          <a:xfrm>
-            <a:off x="10698480" y="14566392"/>
-            <a:ext cx="4114800" cy="685800"/>
+          <p:cNvPr id="63" name="Text 59"/>
+          <p:cNvSpPr/>
+          <p:nvPr/>
+        </p:nvSpPr>
+        <p:spPr>
+          <a:xfrm>
+            <a:off x="10744200" y="14932152"/>
+            <a:ext cx="4023360" cy="685800"/>
           </a:xfrm>
           <a:prstGeom prst="rect">
             <a:avLst/>
@@ -3168,7 +3225,7 @@
             <a:r>
               <a:rPr lang="en-US" sz="1700" dirty="0">
                 <a:solidFill>
-                  <a:srgbClr val="14213D"/>
+                  <a:srgbClr val="CBD5E1"/>
                 </a:solidFill>
                 <a:latin typeface="Calibri" pitchFamily="34" charset="0"/>
                 <a:ea typeface="Calibri" pitchFamily="34" charset="-122"/>
@@ -3182,26 +3239,26 @@
       </p:sp>
       <p:sp>
         <p:nvSpPr>
-          <p:cNvPr id="62" name="Shape 59"/>
-          <p:cNvSpPr/>
-          <p:nvPr/>
-        </p:nvSpPr>
-        <p:spPr>
-          <a:xfrm>
-            <a:off x="15270480" y="13853160"/>
+          <p:cNvPr id="64" name="Shape 60"/>
+          <p:cNvSpPr/>
+          <p:nvPr/>
+        </p:nvSpPr>
+        <p:spPr>
+          <a:xfrm>
+            <a:off x="15270480" y="14218920"/>
             <a:ext cx="4480560" cy="1463040"/>
           </a:xfrm>
           <a:prstGeom prst="roundRect">
             <a:avLst>
-              <a:gd name="adj" fmla="val 6250"/>
+              <a:gd name="adj" fmla="val 7500"/>
             </a:avLst>
           </a:prstGeom>
           <a:solidFill>
-            <a:srgbClr val="EEF1F6"/>
+            <a:srgbClr val="121826"/>
           </a:solidFill>
           <a:ln w="12700">
             <a:solidFill>
-              <a:srgbClr val="EEF1F6"/>
+              <a:srgbClr val="263044"/>
             </a:solidFill>
             <a:prstDash val="solid"/>
           </a:ln>
@@ -3209,14 +3266,14 @@
       </p:sp>
       <p:sp>
         <p:nvSpPr>
-          <p:cNvPr id="63" name="Text 60"/>
-          <p:cNvSpPr/>
-          <p:nvPr/>
-        </p:nvSpPr>
-        <p:spPr>
-          <a:xfrm>
-            <a:off x="15453360" y="13880592"/>
-            <a:ext cx="4114800" cy="685800"/>
+          <p:cNvPr id="65" name="Text 61"/>
+          <p:cNvSpPr/>
+          <p:nvPr/>
+        </p:nvSpPr>
+        <p:spPr>
+          <a:xfrm>
+            <a:off x="15499080" y="14246352"/>
+            <a:ext cx="4023360" cy="685800"/>
           </a:xfrm>
           <a:prstGeom prst="rect">
             <a:avLst/>
@@ -3234,11 +3291,11 @@
             <a:r>
               <a:rPr lang="en-US" sz="3400" b="1" dirty="0">
                 <a:solidFill>
-                  <a:srgbClr val="1B2A49"/>
-                </a:solidFill>
-                <a:latin typeface="Cambria" pitchFamily="34" charset="0"/>
-                <a:ea typeface="Cambria" pitchFamily="34" charset="-122"/>
-                <a:cs typeface="Cambria" pitchFamily="34" charset="-120"/>
+                  <a:srgbClr val="22D3EE"/>
+                </a:solidFill>
+                <a:latin typeface="Calibri" pitchFamily="34" charset="0"/>
+                <a:ea typeface="Calibri" pitchFamily="34" charset="-122"/>
+                <a:cs typeface="Calibri" pitchFamily="34" charset="-120"/>
               </a:rPr>
               <a:t>403</a:t>
             </a:r>
@@ -3248,14 +3305,14 @@
       </p:sp>
       <p:sp>
         <p:nvSpPr>
-          <p:cNvPr id="64" name="Text 61"/>
-          <p:cNvSpPr/>
-          <p:nvPr/>
-        </p:nvSpPr>
-        <p:spPr>
-          <a:xfrm>
-            <a:off x="15453360" y="14566392"/>
-            <a:ext cx="4114800" cy="685800"/>
+          <p:cNvPr id="66" name="Text 62"/>
+          <p:cNvSpPr/>
+          <p:nvPr/>
+        </p:nvSpPr>
+        <p:spPr>
+          <a:xfrm>
+            <a:off x="15499080" y="14932152"/>
+            <a:ext cx="4023360" cy="685800"/>
           </a:xfrm>
           <a:prstGeom prst="rect">
             <a:avLst/>
@@ -3273,7 +3330,7 @@
             <a:r>
               <a:rPr lang="en-US" sz="1700" dirty="0">
                 <a:solidFill>
-                  <a:srgbClr val="14213D"/>
+                  <a:srgbClr val="CBD5E1"/>
                 </a:solidFill>
                 <a:latin typeface="Calibri" pitchFamily="34" charset="0"/>
                 <a:ea typeface="Calibri" pitchFamily="34" charset="-122"/>
@@ -3287,26 +3344,26 @@
       </p:sp>
       <p:sp>
         <p:nvSpPr>
-          <p:cNvPr id="65" name="Shape 62"/>
-          <p:cNvSpPr/>
-          <p:nvPr/>
-        </p:nvSpPr>
-        <p:spPr>
-          <a:xfrm>
-            <a:off x="10515600" y="15453360"/>
+          <p:cNvPr id="67" name="Shape 63"/>
+          <p:cNvSpPr/>
+          <p:nvPr/>
+        </p:nvSpPr>
+        <p:spPr>
+          <a:xfrm>
+            <a:off x="10515600" y="15819120"/>
             <a:ext cx="4480560" cy="1463040"/>
           </a:xfrm>
           <a:prstGeom prst="roundRect">
             <a:avLst>
-              <a:gd name="adj" fmla="val 6250"/>
+              <a:gd name="adj" fmla="val 7500"/>
             </a:avLst>
           </a:prstGeom>
           <a:solidFill>
-            <a:srgbClr val="EEF1F6"/>
+            <a:srgbClr val="121826"/>
           </a:solidFill>
           <a:ln w="12700">
             <a:solidFill>
-              <a:srgbClr val="EEF1F6"/>
+              <a:srgbClr val="263044"/>
             </a:solidFill>
             <a:prstDash val="solid"/>
           </a:ln>
@@ -3314,14 +3371,14 @@
       </p:sp>
       <p:sp>
         <p:nvSpPr>
-          <p:cNvPr id="66" name="Text 63"/>
-          <p:cNvSpPr/>
-          <p:nvPr/>
-        </p:nvSpPr>
-        <p:spPr>
-          <a:xfrm>
-            <a:off x="10698480" y="15480792"/>
-            <a:ext cx="4114800" cy="685800"/>
+          <p:cNvPr id="68" name="Text 64"/>
+          <p:cNvSpPr/>
+          <p:nvPr/>
+        </p:nvSpPr>
+        <p:spPr>
+          <a:xfrm>
+            <a:off x="10744200" y="15846552"/>
+            <a:ext cx="4023360" cy="685800"/>
           </a:xfrm>
           <a:prstGeom prst="rect">
             <a:avLst/>
@@ -3339,11 +3396,11 @@
             <a:r>
               <a:rPr lang="en-US" sz="3400" b="1" dirty="0">
                 <a:solidFill>
-                  <a:srgbClr val="1B2A49"/>
-                </a:solidFill>
-                <a:latin typeface="Cambria" pitchFamily="34" charset="0"/>
-                <a:ea typeface="Cambria" pitchFamily="34" charset="-122"/>
-                <a:cs typeface="Cambria" pitchFamily="34" charset="-120"/>
+                  <a:srgbClr val="22D3EE"/>
+                </a:solidFill>
+                <a:latin typeface="Calibri" pitchFamily="34" charset="0"/>
+                <a:ea typeface="Calibri" pitchFamily="34" charset="-122"/>
+                <a:cs typeface="Calibri" pitchFamily="34" charset="-120"/>
               </a:rPr>
               <a:t>7 s</a:t>
             </a:r>
@@ -3353,14 +3410,14 @@
       </p:sp>
       <p:sp>
         <p:nvSpPr>
-          <p:cNvPr id="67" name="Text 64"/>
-          <p:cNvSpPr/>
-          <p:nvPr/>
-        </p:nvSpPr>
-        <p:spPr>
-          <a:xfrm>
-            <a:off x="10698480" y="16166592"/>
-            <a:ext cx="4114800" cy="685800"/>
+          <p:cNvPr id="69" name="Text 65"/>
+          <p:cNvSpPr/>
+          <p:nvPr/>
+        </p:nvSpPr>
+        <p:spPr>
+          <a:xfrm>
+            <a:off x="10744200" y="16532352"/>
+            <a:ext cx="4023360" cy="685800"/>
           </a:xfrm>
           <a:prstGeom prst="rect">
             <a:avLst/>
@@ -3378,7 +3435,7 @@
             <a:r>
               <a:rPr lang="en-US" sz="1700" dirty="0">
                 <a:solidFill>
-                  <a:srgbClr val="14213D"/>
+                  <a:srgbClr val="CBD5E1"/>
                 </a:solidFill>
                 <a:latin typeface="Calibri" pitchFamily="34" charset="0"/>
                 <a:ea typeface="Calibri" pitchFamily="34" charset="-122"/>
@@ -3392,26 +3449,26 @@
       </p:sp>
       <p:sp>
         <p:nvSpPr>
-          <p:cNvPr id="68" name="Shape 65"/>
-          <p:cNvSpPr/>
-          <p:nvPr/>
-        </p:nvSpPr>
-        <p:spPr>
-          <a:xfrm>
-            <a:off x="15270480" y="15453360"/>
+          <p:cNvPr id="70" name="Shape 66"/>
+          <p:cNvSpPr/>
+          <p:nvPr/>
+        </p:nvSpPr>
+        <p:spPr>
+          <a:xfrm>
+            <a:off x="15270480" y="15819120"/>
             <a:ext cx="4480560" cy="1463040"/>
           </a:xfrm>
           <a:prstGeom prst="roundRect">
             <a:avLst>
-              <a:gd name="adj" fmla="val 6250"/>
+              <a:gd name="adj" fmla="val 7500"/>
             </a:avLst>
           </a:prstGeom>
           <a:solidFill>
-            <a:srgbClr val="EEF1F6"/>
+            <a:srgbClr val="121826"/>
           </a:solidFill>
           <a:ln w="12700">
             <a:solidFill>
-              <a:srgbClr val="EEF1F6"/>
+              <a:srgbClr val="263044"/>
             </a:solidFill>
             <a:prstDash val="solid"/>
           </a:ln>
@@ -3419,14 +3476,14 @@
       </p:sp>
       <p:sp>
         <p:nvSpPr>
-          <p:cNvPr id="69" name="Text 66"/>
-          <p:cNvSpPr/>
-          <p:nvPr/>
-        </p:nvSpPr>
-        <p:spPr>
-          <a:xfrm>
-            <a:off x="15453360" y="15480792"/>
-            <a:ext cx="4114800" cy="685800"/>
+          <p:cNvPr id="71" name="Text 67"/>
+          <p:cNvSpPr/>
+          <p:nvPr/>
+        </p:nvSpPr>
+        <p:spPr>
+          <a:xfrm>
+            <a:off x="15499080" y="15846552"/>
+            <a:ext cx="4023360" cy="685800"/>
           </a:xfrm>
           <a:prstGeom prst="rect">
             <a:avLst/>
@@ -3444,11 +3501,11 @@
             <a:r>
               <a:rPr lang="en-US" sz="3400" b="1" dirty="0">
                 <a:solidFill>
-                  <a:srgbClr val="1B2A49"/>
-                </a:solidFill>
-                <a:latin typeface="Cambria" pitchFamily="34" charset="0"/>
-                <a:ea typeface="Cambria" pitchFamily="34" charset="-122"/>
-                <a:cs typeface="Cambria" pitchFamily="34" charset="-120"/>
+                  <a:srgbClr val="22D3EE"/>
+                </a:solidFill>
+                <a:latin typeface="Calibri" pitchFamily="34" charset="0"/>
+                <a:ea typeface="Calibri" pitchFamily="34" charset="-122"/>
+                <a:cs typeface="Calibri" pitchFamily="34" charset="-120"/>
               </a:rPr>
               <a:t>Live</a:t>
             </a:r>
@@ -3458,14 +3515,14 @@
       </p:sp>
       <p:sp>
         <p:nvSpPr>
-          <p:cNvPr id="70" name="Text 67"/>
-          <p:cNvSpPr/>
-          <p:nvPr/>
-        </p:nvSpPr>
-        <p:spPr>
-          <a:xfrm>
-            <a:off x="15453360" y="16166592"/>
-            <a:ext cx="4114800" cy="685800"/>
+          <p:cNvPr id="72" name="Text 68"/>
+          <p:cNvSpPr/>
+          <p:nvPr/>
+        </p:nvSpPr>
+        <p:spPr>
+          <a:xfrm>
+            <a:off x="15499080" y="16532352"/>
+            <a:ext cx="4023360" cy="685800"/>
           </a:xfrm>
           <a:prstGeom prst="rect">
             <a:avLst/>
@@ -3483,7 +3540,7 @@
             <a:r>
               <a:rPr lang="en-US" sz="1700" dirty="0">
                 <a:solidFill>
-                  <a:srgbClr val="14213D"/>
+                  <a:srgbClr val="CBD5E1"/>
                 </a:solidFill>
                 <a:latin typeface="Calibri" pitchFamily="34" charset="0"/>
                 <a:ea typeface="Calibri" pitchFamily="34" charset="-122"/>
@@ -3497,13 +3554,13 @@
       </p:sp>
       <p:sp>
         <p:nvSpPr>
-          <p:cNvPr id="71" name="Text 68"/>
-          <p:cNvSpPr/>
-          <p:nvPr/>
-        </p:nvSpPr>
-        <p:spPr>
-          <a:xfrm>
-            <a:off x="10515600" y="17236440"/>
+          <p:cNvPr id="73" name="Text 69"/>
+          <p:cNvSpPr/>
+          <p:nvPr/>
+        </p:nvSpPr>
+        <p:spPr>
+          <a:xfrm>
+            <a:off x="10515600" y="17556480"/>
             <a:ext cx="9235440" cy="457200"/>
           </a:xfrm>
           <a:prstGeom prst="rect">
@@ -3522,7 +3579,7 @@
             <a:r>
               <a:rPr lang="en-US" sz="2400" b="1" dirty="0">
                 <a:solidFill>
-                  <a:srgbClr val="C9A227"/>
+                  <a:srgbClr val="22D3EE"/>
                 </a:solidFill>
                 <a:latin typeface="Calibri" pitchFamily="34" charset="0"/>
                 <a:ea typeface="Calibri" pitchFamily="34" charset="-122"/>
@@ -3536,14 +3593,14 @@
       </p:sp>
       <p:sp>
         <p:nvSpPr>
-          <p:cNvPr id="72" name="Text 69"/>
-          <p:cNvSpPr/>
-          <p:nvPr/>
-        </p:nvSpPr>
-        <p:spPr>
-          <a:xfrm>
-            <a:off x="10515600" y="17739360"/>
-            <a:ext cx="9235440" cy="3108960"/>
+          <p:cNvPr id="74" name="Text 70"/>
+          <p:cNvSpPr/>
+          <p:nvPr/>
+        </p:nvSpPr>
+        <p:spPr>
+          <a:xfrm>
+            <a:off x="10515600" y="18059400"/>
+            <a:ext cx="9235440" cy="2926080"/>
           </a:xfrm>
           <a:prstGeom prst="rect">
             <a:avLst/>
@@ -3565,7 +3622,7 @@
             <a:r>
               <a:rPr lang="en-US" sz="1700" dirty="0">
                 <a:solidFill>
-                  <a:srgbClr val="14213D"/>
+                  <a:srgbClr val="CBD5E1"/>
                 </a:solidFill>
                 <a:latin typeface="Calibri" pitchFamily="34" charset="0"/>
                 <a:ea typeface="Calibri" pitchFamily="34" charset="-122"/>
@@ -3586,7 +3643,7 @@
             <a:r>
               <a:rPr lang="en-US" sz="1700" dirty="0">
                 <a:solidFill>
-                  <a:srgbClr val="14213D"/>
+                  <a:srgbClr val="CBD5E1"/>
                 </a:solidFill>
                 <a:latin typeface="Calibri" pitchFamily="34" charset="0"/>
                 <a:ea typeface="Calibri" pitchFamily="34" charset="-122"/>
@@ -3607,7 +3664,7 @@
             <a:r>
               <a:rPr lang="en-US" sz="1700" dirty="0">
                 <a:solidFill>
-                  <a:srgbClr val="14213D"/>
+                  <a:srgbClr val="CBD5E1"/>
                 </a:solidFill>
                 <a:latin typeface="Calibri" pitchFamily="34" charset="0"/>
                 <a:ea typeface="Calibri" pitchFamily="34" charset="-122"/>
@@ -3628,7 +3685,7 @@
             <a:r>
               <a:rPr lang="en-US" sz="1700" dirty="0">
                 <a:solidFill>
-                  <a:srgbClr val="14213D"/>
+                  <a:srgbClr val="CBD5E1"/>
                 </a:solidFill>
                 <a:latin typeface="Calibri" pitchFamily="34" charset="0"/>
                 <a:ea typeface="Calibri" pitchFamily="34" charset="-122"/>
@@ -3649,7 +3706,7 @@
             <a:r>
               <a:rPr lang="en-US" sz="1700" dirty="0">
                 <a:solidFill>
-                  <a:srgbClr val="14213D"/>
+                  <a:srgbClr val="CBD5E1"/>
                 </a:solidFill>
                 <a:latin typeface="Calibri" pitchFamily="34" charset="0"/>
                 <a:ea typeface="Calibri" pitchFamily="34" charset="-122"/>
@@ -3663,7 +3720,7 @@
       </p:sp>
       <p:sp>
         <p:nvSpPr>
-          <p:cNvPr id="73" name="Shape 70"/>
+          <p:cNvPr id="75" name="Shape 71"/>
           <p:cNvSpPr/>
           <p:nvPr/>
         </p:nvSpPr>
@@ -3676,14 +3733,14 @@
             <a:avLst/>
           </a:prstGeom>
           <a:solidFill>
-            <a:srgbClr val="C9A227"/>
+            <a:srgbClr val="6366F1"/>
           </a:solidFill>
           <a:ln/>
         </p:spPr>
       </p:sp>
       <p:sp>
         <p:nvSpPr>
-          <p:cNvPr id="74" name="Text 71"/>
+          <p:cNvPr id="76" name="Text 72"/>
           <p:cNvSpPr/>
           <p:nvPr/>
         </p:nvSpPr>
@@ -3708,11 +3765,11 @@
             <a:r>
               <a:rPr lang="en-US" sz="2800" b="1" dirty="0">
                 <a:solidFill>
-                  <a:srgbClr val="1B2A49"/>
-                </a:solidFill>
-                <a:latin typeface="Cambria" pitchFamily="34" charset="0"/>
-                <a:ea typeface="Cambria" pitchFamily="34" charset="-122"/>
-                <a:cs typeface="Cambria" pitchFamily="34" charset="-120"/>
+                  <a:srgbClr val="F8FAFC"/>
+                </a:solidFill>
+                <a:latin typeface="Calibri" pitchFamily="34" charset="0"/>
+                <a:ea typeface="Calibri" pitchFamily="34" charset="-122"/>
+                <a:cs typeface="Calibri" pitchFamily="34" charset="-120"/>
               </a:rPr>
               <a:t>3</a:t>
             </a:r>
@@ -3722,7 +3779,7 @@
       </p:sp>
       <p:sp>
         <p:nvSpPr>
-          <p:cNvPr id="75" name="Text 72"/>
+          <p:cNvPr id="77" name="Text 73"/>
           <p:cNvSpPr/>
           <p:nvPr/>
         </p:nvSpPr>
@@ -3747,11 +3804,11 @@
             <a:r>
               <a:rPr lang="en-US" sz="3000" b="1" dirty="0">
                 <a:solidFill>
-                  <a:srgbClr val="1B2A49"/>
-                </a:solidFill>
-                <a:latin typeface="Cambria" pitchFamily="34" charset="0"/>
-                <a:ea typeface="Cambria" pitchFamily="34" charset="-122"/>
-                <a:cs typeface="Cambria" pitchFamily="34" charset="-120"/>
+                  <a:srgbClr val="F8FAFC"/>
+                </a:solidFill>
+                <a:latin typeface="Calibri" pitchFamily="34" charset="0"/>
+                <a:ea typeface="Calibri" pitchFamily="34" charset="-122"/>
+                <a:cs typeface="Calibri" pitchFamily="34" charset="-120"/>
               </a:rPr>
               <a:t>Roadmap and problem solving</a:t>
             </a:r>
@@ -3761,7 +3818,7 @@
       </p:sp>
       <p:sp>
         <p:nvSpPr>
-          <p:cNvPr id="76" name="Shape 73"/>
+          <p:cNvPr id="78" name="Shape 74"/>
           <p:cNvSpPr/>
           <p:nvPr/>
         </p:nvSpPr>
@@ -3776,11 +3833,11 @@
             </a:avLst>
           </a:prstGeom>
           <a:solidFill>
-            <a:srgbClr val="FFFFFF"/>
+            <a:srgbClr val="121826"/>
           </a:solidFill>
-          <a:ln w="38100">
+          <a:ln w="31750">
             <a:solidFill>
-              <a:srgbClr val="2E7D5B"/>
+              <a:srgbClr val="10B981"/>
             </a:solidFill>
             <a:prstDash val="solid"/>
           </a:ln>
@@ -3788,7 +3845,7 @@
       </p:sp>
       <p:sp>
         <p:nvSpPr>
-          <p:cNvPr id="77" name="Text 74"/>
+          <p:cNvPr id="79" name="Text 75"/>
           <p:cNvSpPr/>
           <p:nvPr/>
         </p:nvSpPr>
@@ -3813,7 +3870,7 @@
             <a:r>
               <a:rPr lang="en-US" sz="2400" b="1" dirty="0">
                 <a:solidFill>
-                  <a:srgbClr val="2E7D5B"/>
+                  <a:srgbClr val="10B981"/>
                 </a:solidFill>
                 <a:latin typeface="Calibri" pitchFamily="34" charset="0"/>
                 <a:ea typeface="Calibri" pitchFamily="34" charset="-122"/>
@@ -3827,7 +3884,7 @@
       </p:sp>
       <p:sp>
         <p:nvSpPr>
-          <p:cNvPr id="78" name="Text 75"/>
+          <p:cNvPr id="80" name="Text 76"/>
           <p:cNvSpPr/>
           <p:nvPr/>
         </p:nvSpPr>
@@ -3856,7 +3913,7 @@
             <a:r>
               <a:rPr lang="en-US" sz="2200" dirty="0">
                 <a:solidFill>
-                  <a:srgbClr val="14213D"/>
+                  <a:srgbClr val="CBD5E1"/>
                 </a:solidFill>
                 <a:latin typeface="Calibri" pitchFamily="34" charset="0"/>
                 <a:ea typeface="Calibri" pitchFamily="34" charset="-122"/>
@@ -3877,7 +3934,7 @@
             <a:r>
               <a:rPr lang="en-US" sz="2200" dirty="0">
                 <a:solidFill>
-                  <a:srgbClr val="14213D"/>
+                  <a:srgbClr val="CBD5E1"/>
                 </a:solidFill>
                 <a:latin typeface="Calibri" pitchFamily="34" charset="0"/>
                 <a:ea typeface="Calibri" pitchFamily="34" charset="-122"/>
@@ -3898,7 +3955,7 @@
             <a:r>
               <a:rPr lang="en-US" sz="2200" dirty="0">
                 <a:solidFill>
-                  <a:srgbClr val="14213D"/>
+                  <a:srgbClr val="CBD5E1"/>
                 </a:solidFill>
                 <a:latin typeface="Calibri" pitchFamily="34" charset="0"/>
                 <a:ea typeface="Calibri" pitchFamily="34" charset="-122"/>
@@ -3919,7 +3976,7 @@
             <a:r>
               <a:rPr lang="en-US" sz="2200" dirty="0">
                 <a:solidFill>
-                  <a:srgbClr val="14213D"/>
+                  <a:srgbClr val="CBD5E1"/>
                 </a:solidFill>
                 <a:latin typeface="Calibri" pitchFamily="34" charset="0"/>
                 <a:ea typeface="Calibri" pitchFamily="34" charset="-122"/>
@@ -3940,7 +3997,7 @@
             <a:r>
               <a:rPr lang="en-US" sz="2200" dirty="0">
                 <a:solidFill>
-                  <a:srgbClr val="14213D"/>
+                  <a:srgbClr val="CBD5E1"/>
                 </a:solidFill>
                 <a:latin typeface="Calibri" pitchFamily="34" charset="0"/>
                 <a:ea typeface="Calibri" pitchFamily="34" charset="-122"/>
@@ -3954,7 +4011,7 @@
       </p:sp>
       <p:sp>
         <p:nvSpPr>
-          <p:cNvPr id="79" name="Shape 76"/>
+          <p:cNvPr id="81" name="Shape 77"/>
           <p:cNvSpPr/>
           <p:nvPr/>
         </p:nvSpPr>
@@ -3969,11 +4026,11 @@
             </a:avLst>
           </a:prstGeom>
           <a:solidFill>
-            <a:srgbClr val="FFFFFF"/>
+            <a:srgbClr val="121826"/>
           </a:solidFill>
-          <a:ln w="38100">
+          <a:ln w="31750">
             <a:solidFill>
-              <a:srgbClr val="A9701B"/>
+              <a:srgbClr val="F59E0B"/>
             </a:solidFill>
             <a:prstDash val="solid"/>
           </a:ln>
@@ -3981,7 +4038,7 @@
       </p:sp>
       <p:sp>
         <p:nvSpPr>
-          <p:cNvPr id="80" name="Text 77"/>
+          <p:cNvPr id="82" name="Text 78"/>
           <p:cNvSpPr/>
           <p:nvPr/>
         </p:nvSpPr>
@@ -4006,7 +4063,7 @@
             <a:r>
               <a:rPr lang="en-US" sz="2400" b="1" dirty="0">
                 <a:solidFill>
-                  <a:srgbClr val="A9701B"/>
+                  <a:srgbClr val="F59E0B"/>
                 </a:solidFill>
                 <a:latin typeface="Calibri" pitchFamily="34" charset="0"/>
                 <a:ea typeface="Calibri" pitchFamily="34" charset="-122"/>
@@ -4020,7 +4077,7 @@
       </p:sp>
       <p:sp>
         <p:nvSpPr>
-          <p:cNvPr id="81" name="Text 78"/>
+          <p:cNvPr id="83" name="Text 79"/>
           <p:cNvSpPr/>
           <p:nvPr/>
         </p:nvSpPr>
@@ -4049,7 +4106,7 @@
             <a:r>
               <a:rPr lang="en-US" sz="2200" dirty="0">
                 <a:solidFill>
-                  <a:srgbClr val="14213D"/>
+                  <a:srgbClr val="CBD5E1"/>
                 </a:solidFill>
                 <a:latin typeface="Calibri" pitchFamily="34" charset="0"/>
                 <a:ea typeface="Calibri" pitchFamily="34" charset="-122"/>
@@ -4070,7 +4127,7 @@
             <a:r>
               <a:rPr lang="en-US" sz="2200" dirty="0">
                 <a:solidFill>
-                  <a:srgbClr val="14213D"/>
+                  <a:srgbClr val="CBD5E1"/>
                 </a:solidFill>
                 <a:latin typeface="Calibri" pitchFamily="34" charset="0"/>
                 <a:ea typeface="Calibri" pitchFamily="34" charset="-122"/>
@@ -4091,7 +4148,7 @@
             <a:r>
               <a:rPr lang="en-US" sz="2200" dirty="0">
                 <a:solidFill>
-                  <a:srgbClr val="14213D"/>
+                  <a:srgbClr val="CBD5E1"/>
                 </a:solidFill>
                 <a:latin typeface="Calibri" pitchFamily="34" charset="0"/>
                 <a:ea typeface="Calibri" pitchFamily="34" charset="-122"/>
@@ -4105,7 +4162,7 @@
       </p:sp>
       <p:sp>
         <p:nvSpPr>
-          <p:cNvPr id="82" name="Shape 79"/>
+          <p:cNvPr id="84" name="Shape 80"/>
           <p:cNvSpPr/>
           <p:nvPr/>
         </p:nvSpPr>
@@ -4120,11 +4177,11 @@
             </a:avLst>
           </a:prstGeom>
           <a:solidFill>
-            <a:srgbClr val="FFFFFF"/>
+            <a:srgbClr val="121826"/>
           </a:solidFill>
-          <a:ln w="38100">
+          <a:ln w="31750">
             <a:solidFill>
-              <a:srgbClr val="1B2A49"/>
+              <a:srgbClr val="818CF8"/>
             </a:solidFill>
             <a:prstDash val="solid"/>
           </a:ln>
@@ -4132,7 +4189,7 @@
       </p:sp>
       <p:sp>
         <p:nvSpPr>
-          <p:cNvPr id="83" name="Text 80"/>
+          <p:cNvPr id="85" name="Text 81"/>
           <p:cNvSpPr/>
           <p:nvPr/>
         </p:nvSpPr>
@@ -4157,7 +4214,7 @@
             <a:r>
               <a:rPr lang="en-US" sz="2400" b="1" dirty="0">
                 <a:solidFill>
-                  <a:srgbClr val="1B2A49"/>
+                  <a:srgbClr val="818CF8"/>
                 </a:solidFill>
                 <a:latin typeface="Calibri" pitchFamily="34" charset="0"/>
                 <a:ea typeface="Calibri" pitchFamily="34" charset="-122"/>
@@ -4171,7 +4228,7 @@
       </p:sp>
       <p:sp>
         <p:nvSpPr>
-          <p:cNvPr id="84" name="Text 81"/>
+          <p:cNvPr id="86" name="Text 82"/>
           <p:cNvSpPr/>
           <p:nvPr/>
         </p:nvSpPr>
@@ -4200,7 +4257,7 @@
             <a:r>
               <a:rPr lang="en-US" sz="2200" dirty="0">
                 <a:solidFill>
-                  <a:srgbClr val="14213D"/>
+                  <a:srgbClr val="CBD5E1"/>
                 </a:solidFill>
                 <a:latin typeface="Calibri" pitchFamily="34" charset="0"/>
                 <a:ea typeface="Calibri" pitchFamily="34" charset="-122"/>
@@ -4221,7 +4278,7 @@
             <a:r>
               <a:rPr lang="en-US" sz="2200" dirty="0">
                 <a:solidFill>
-                  <a:srgbClr val="14213D"/>
+                  <a:srgbClr val="CBD5E1"/>
                 </a:solidFill>
                 <a:latin typeface="Calibri" pitchFamily="34" charset="0"/>
                 <a:ea typeface="Calibri" pitchFamily="34" charset="-122"/>
@@ -4242,7 +4299,7 @@
             <a:r>
               <a:rPr lang="en-US" sz="2200" dirty="0">
                 <a:solidFill>
-                  <a:srgbClr val="14213D"/>
+                  <a:srgbClr val="CBD5E1"/>
                 </a:solidFill>
                 <a:latin typeface="Calibri" pitchFamily="34" charset="0"/>
                 <a:ea typeface="Calibri" pitchFamily="34" charset="-122"/>
@@ -4256,7 +4313,7 @@
       </p:sp>
       <p:sp>
         <p:nvSpPr>
-          <p:cNvPr id="85" name="Shape 82"/>
+          <p:cNvPr id="87" name="Shape 83"/>
           <p:cNvSpPr/>
           <p:nvPr/>
         </p:nvSpPr>
@@ -4267,15 +4324,15 @@
           </a:xfrm>
           <a:prstGeom prst="roundRect">
             <a:avLst>
-              <a:gd name="adj" fmla="val 4348"/>
+              <a:gd name="adj" fmla="val 5217"/>
             </a:avLst>
           </a:prstGeom>
           <a:solidFill>
-            <a:srgbClr val="EEF1F6"/>
+            <a:srgbClr val="121826"/>
           </a:solidFill>
           <a:ln w="12700">
             <a:solidFill>
-              <a:srgbClr val="EEF1F6"/>
+              <a:srgbClr val="263044"/>
             </a:solidFill>
             <a:prstDash val="solid"/>
           </a:ln>
@@ -4283,7 +4340,7 @@
       </p:sp>
       <p:sp>
         <p:nvSpPr>
-          <p:cNvPr id="86" name="Text 83"/>
+          <p:cNvPr id="88" name="Text 84"/>
           <p:cNvSpPr/>
           <p:nvPr/>
         </p:nvSpPr>
@@ -4308,7 +4365,7 @@
             <a:r>
               <a:rPr lang="en-US" sz="2100" b="1" dirty="0">
                 <a:solidFill>
-                  <a:srgbClr val="1B2A49"/>
+                  <a:srgbClr val="22D3EE"/>
                 </a:solidFill>
                 <a:latin typeface="Calibri" pitchFamily="34" charset="0"/>
                 <a:ea typeface="Calibri" pitchFamily="34" charset="-122"/>
@@ -4322,7 +4379,7 @@
             <a:r>
               <a:rPr lang="en-US" sz="2100" dirty="0">
                 <a:solidFill>
-                  <a:srgbClr val="14213D"/>
+                  <a:srgbClr val="CBD5E1"/>
                 </a:solidFill>
                 <a:latin typeface="Calibri" pitchFamily="34" charset="0"/>
                 <a:ea typeface="Calibri" pitchFamily="34" charset="-122"/>
@@ -4336,7 +4393,7 @@
       </p:sp>
       <p:sp>
         <p:nvSpPr>
-          <p:cNvPr id="87" name="Text 84"/>
+          <p:cNvPr id="89" name="Text 85"/>
           <p:cNvSpPr/>
           <p:nvPr/>
         </p:nvSpPr>
@@ -4361,7 +4418,7 @@
             <a:r>
               <a:rPr lang="en-US" sz="2400" b="1" dirty="0">
                 <a:solidFill>
-                  <a:srgbClr val="C9A227"/>
+                  <a:srgbClr val="22D3EE"/>
                 </a:solidFill>
                 <a:latin typeface="Calibri" pitchFamily="34" charset="0"/>
                 <a:ea typeface="Calibri" pitchFamily="34" charset="-122"/>
@@ -4411,7 +4468,7 @@
                       <a:r>
                         <a:rPr lang="en-US" sz="1800" b="1" dirty="0">
                           <a:solidFill>
-                            <a:srgbClr val="FFFFFF"/>
+                            <a:srgbClr val="F8FAFC"/>
                           </a:solidFill>
                           <a:latin typeface="Calibri" pitchFamily="34" charset="0"/>
                           <a:ea typeface="Calibri" pitchFamily="34" charset="-122"/>
@@ -4429,7 +4486,7 @@
                   <a:tcPr marL="109728" marR="109728" marT="0" marB="0" anchor="ctr">
                     <a:lnL w="12700" cap="flat" cmpd="sng" algn="ctr">
                       <a:solidFill>
-                        <a:srgbClr val="C9D0E0"/>
+                        <a:srgbClr val="263044"/>
                       </a:solidFill>
                       <a:prstDash val="solid"/>
                       <a:round/>
@@ -4438,7 +4495,7 @@
                     </a:lnL>
                     <a:lnR w="12700" cap="flat" cmpd="sng" algn="ctr">
                       <a:solidFill>
-                        <a:srgbClr val="C9D0E0"/>
+                        <a:srgbClr val="263044"/>
                       </a:solidFill>
                       <a:prstDash val="solid"/>
                       <a:round/>
@@ -4447,7 +4504,7 @@
                     </a:lnR>
                     <a:lnT w="12700" cap="flat" cmpd="sng" algn="ctr">
                       <a:solidFill>
-                        <a:srgbClr val="C9D0E0"/>
+                        <a:srgbClr val="263044"/>
                       </a:solidFill>
                       <a:prstDash val="solid"/>
                       <a:round/>
@@ -4456,7 +4513,7 @@
                     </a:lnT>
                     <a:lnB w="12700" cap="flat" cmpd="sng" algn="ctr">
                       <a:solidFill>
-                        <a:srgbClr val="C9D0E0"/>
+                        <a:srgbClr val="263044"/>
                       </a:solidFill>
                       <a:prstDash val="solid"/>
                       <a:round/>
@@ -4464,7 +4521,7 @@
                       <a:tailEnd type="none" w="med" len="med"/>
                     </a:lnB>
                     <a:solidFill>
-                      <a:srgbClr val="1B2A49"/>
+                      <a:srgbClr val="6366F1"/>
                     </a:solidFill>
                   </a:tcPr>
                 </a:tc>
@@ -4479,7 +4536,7 @@
                       <a:r>
                         <a:rPr lang="en-US" sz="1800" b="1" dirty="0">
                           <a:solidFill>
-                            <a:srgbClr val="FFFFFF"/>
+                            <a:srgbClr val="F8FAFC"/>
                           </a:solidFill>
                           <a:latin typeface="Calibri" pitchFamily="34" charset="0"/>
                           <a:ea typeface="Calibri" pitchFamily="34" charset="-122"/>
@@ -4497,7 +4554,7 @@
                   <a:tcPr marL="109728" marR="109728" marT="0" marB="0" anchor="ctr">
                     <a:lnL w="12700" cap="flat" cmpd="sng" algn="ctr">
                       <a:solidFill>
-                        <a:srgbClr val="C9D0E0"/>
+                        <a:srgbClr val="263044"/>
                       </a:solidFill>
                       <a:prstDash val="solid"/>
                       <a:round/>
@@ -4506,7 +4563,7 @@
                     </a:lnL>
                     <a:lnR w="12700" cap="flat" cmpd="sng" algn="ctr">
                       <a:solidFill>
-                        <a:srgbClr val="C9D0E0"/>
+                        <a:srgbClr val="263044"/>
                       </a:solidFill>
                       <a:prstDash val="solid"/>
                       <a:round/>
@@ -4515,7 +4572,7 @@
                     </a:lnR>
                     <a:lnT w="12700" cap="flat" cmpd="sng" algn="ctr">
                       <a:solidFill>
-                        <a:srgbClr val="C9D0E0"/>
+                        <a:srgbClr val="263044"/>
                       </a:solidFill>
                       <a:prstDash val="solid"/>
                       <a:round/>
@@ -4524,7 +4581,7 @@
                     </a:lnT>
                     <a:lnB w="12700" cap="flat" cmpd="sng" algn="ctr">
                       <a:solidFill>
-                        <a:srgbClr val="C9D0E0"/>
+                        <a:srgbClr val="263044"/>
                       </a:solidFill>
                       <a:prstDash val="solid"/>
                       <a:round/>
@@ -4532,7 +4589,7 @@
                       <a:tailEnd type="none" w="med" len="med"/>
                     </a:lnB>
                     <a:solidFill>
-                      <a:srgbClr val="1B2A49"/>
+                      <a:srgbClr val="6366F1"/>
                     </a:solidFill>
                   </a:tcPr>
                 </a:tc>
@@ -4549,7 +4606,7 @@
                       <a:r>
                         <a:rPr lang="en-US" sz="1800" dirty="0">
                           <a:solidFill>
-                            <a:srgbClr val="14213D"/>
+                            <a:srgbClr val="CBD5E1"/>
                           </a:solidFill>
                           <a:latin typeface="Calibri" pitchFamily="34" charset="0"/>
                           <a:ea typeface="Calibri" pitchFamily="34" charset="-122"/>
@@ -4567,7 +4624,7 @@
                   <a:tcPr marL="109728" marR="109728" marT="0" marB="0" anchor="ctr">
                     <a:lnL w="12700" cap="flat" cmpd="sng" algn="ctr">
                       <a:solidFill>
-                        <a:srgbClr val="C9D0E0"/>
+                        <a:srgbClr val="263044"/>
                       </a:solidFill>
                       <a:prstDash val="solid"/>
                       <a:round/>
@@ -4576,7 +4633,7 @@
                     </a:lnL>
                     <a:lnR w="12700" cap="flat" cmpd="sng" algn="ctr">
                       <a:solidFill>
-                        <a:srgbClr val="C9D0E0"/>
+                        <a:srgbClr val="263044"/>
                       </a:solidFill>
                       <a:prstDash val="solid"/>
                       <a:round/>
@@ -4585,7 +4642,7 @@
                     </a:lnR>
                     <a:lnT w="12700" cap="flat" cmpd="sng" algn="ctr">
                       <a:solidFill>
-                        <a:srgbClr val="C9D0E0"/>
+                        <a:srgbClr val="263044"/>
                       </a:solidFill>
                       <a:prstDash val="solid"/>
                       <a:round/>
@@ -4594,7 +4651,7 @@
                     </a:lnT>
                     <a:lnB w="12700" cap="flat" cmpd="sng" algn="ctr">
                       <a:solidFill>
-                        <a:srgbClr val="C9D0E0"/>
+                        <a:srgbClr val="263044"/>
                       </a:solidFill>
                       <a:prstDash val="solid"/>
                       <a:round/>
@@ -4602,7 +4659,7 @@
                       <a:tailEnd type="none" w="med" len="med"/>
                     </a:lnB>
                     <a:solidFill>
-                      <a:srgbClr val="EEF1F6"/>
+                      <a:srgbClr val="121826"/>
                     </a:solidFill>
                   </a:tcPr>
                 </a:tc>
@@ -4617,7 +4674,7 @@
                       <a:r>
                         <a:rPr lang="en-US" sz="1800" dirty="0">
                           <a:solidFill>
-                            <a:srgbClr val="14213D"/>
+                            <a:srgbClr val="CBD5E1"/>
                           </a:solidFill>
                           <a:latin typeface="Calibri" pitchFamily="34" charset="0"/>
                           <a:ea typeface="Calibri" pitchFamily="34" charset="-122"/>
@@ -4635,7 +4692,7 @@
                   <a:tcPr marL="109728" marR="109728" marT="0" marB="0" anchor="ctr">
                     <a:lnL w="12700" cap="flat" cmpd="sng" algn="ctr">
                       <a:solidFill>
-                        <a:srgbClr val="C9D0E0"/>
+                        <a:srgbClr val="263044"/>
                       </a:solidFill>
                       <a:prstDash val="solid"/>
                       <a:round/>
@@ -4644,7 +4701,7 @@
                     </a:lnL>
                     <a:lnR w="12700" cap="flat" cmpd="sng" algn="ctr">
                       <a:solidFill>
-                        <a:srgbClr val="C9D0E0"/>
+                        <a:srgbClr val="263044"/>
                       </a:solidFill>
                       <a:prstDash val="solid"/>
                       <a:round/>
@@ -4653,7 +4710,7 @@
                     </a:lnR>
                     <a:lnT w="12700" cap="flat" cmpd="sng" algn="ctr">
                       <a:solidFill>
-                        <a:srgbClr val="C9D0E0"/>
+                        <a:srgbClr val="263044"/>
                       </a:solidFill>
                       <a:prstDash val="solid"/>
                       <a:round/>
@@ -4662,7 +4719,7 @@
                     </a:lnT>
                     <a:lnB w="12700" cap="flat" cmpd="sng" algn="ctr">
                       <a:solidFill>
-                        <a:srgbClr val="C9D0E0"/>
+                        <a:srgbClr val="263044"/>
                       </a:solidFill>
                       <a:prstDash val="solid"/>
                       <a:round/>
@@ -4670,7 +4727,7 @@
                       <a:tailEnd type="none" w="med" len="med"/>
                     </a:lnB>
                     <a:solidFill>
-                      <a:srgbClr val="EEF1F6"/>
+                      <a:srgbClr val="121826"/>
                     </a:solidFill>
                   </a:tcPr>
                 </a:tc>
@@ -4687,7 +4744,7 @@
                       <a:r>
                         <a:rPr lang="en-US" sz="1800" dirty="0">
                           <a:solidFill>
-                            <a:srgbClr val="14213D"/>
+                            <a:srgbClr val="CBD5E1"/>
                           </a:solidFill>
                           <a:latin typeface="Calibri" pitchFamily="34" charset="0"/>
                           <a:ea typeface="Calibri" pitchFamily="34" charset="-122"/>
@@ -4705,7 +4762,7 @@
                   <a:tcPr marL="109728" marR="109728" marT="0" marB="0" anchor="ctr">
                     <a:lnL w="12700" cap="flat" cmpd="sng" algn="ctr">
                       <a:solidFill>
-                        <a:srgbClr val="C9D0E0"/>
+                        <a:srgbClr val="263044"/>
                       </a:solidFill>
                       <a:prstDash val="solid"/>
                       <a:round/>
@@ -4714,7 +4771,7 @@
                     </a:lnL>
                     <a:lnR w="12700" cap="flat" cmpd="sng" algn="ctr">
                       <a:solidFill>
-                        <a:srgbClr val="C9D0E0"/>
+                        <a:srgbClr val="263044"/>
                       </a:solidFill>
                       <a:prstDash val="solid"/>
                       <a:round/>
@@ -4723,7 +4780,7 @@
                     </a:lnR>
                     <a:lnT w="12700" cap="flat" cmpd="sng" algn="ctr">
                       <a:solidFill>
-                        <a:srgbClr val="C9D0E0"/>
+                        <a:srgbClr val="263044"/>
                       </a:solidFill>
                       <a:prstDash val="solid"/>
                       <a:round/>
@@ -4732,7 +4789,7 @@
                     </a:lnT>
                     <a:lnB w="12700" cap="flat" cmpd="sng" algn="ctr">
                       <a:solidFill>
-                        <a:srgbClr val="C9D0E0"/>
+                        <a:srgbClr val="263044"/>
                       </a:solidFill>
                       <a:prstDash val="solid"/>
                       <a:round/>
@@ -4740,7 +4797,7 @@
                       <a:tailEnd type="none" w="med" len="med"/>
                     </a:lnB>
                     <a:solidFill>
-                      <a:srgbClr val="FFFFFF"/>
+                      <a:srgbClr val="0E1420"/>
                     </a:solidFill>
                   </a:tcPr>
                 </a:tc>
@@ -4755,7 +4812,7 @@
                       <a:r>
                         <a:rPr lang="en-US" sz="1800" dirty="0">
                           <a:solidFill>
-                            <a:srgbClr val="14213D"/>
+                            <a:srgbClr val="CBD5E1"/>
                           </a:solidFill>
                           <a:latin typeface="Calibri" pitchFamily="34" charset="0"/>
                           <a:ea typeface="Calibri" pitchFamily="34" charset="-122"/>
@@ -4773,7 +4830,7 @@
                   <a:tcPr marL="109728" marR="109728" marT="0" marB="0" anchor="ctr">
                     <a:lnL w="12700" cap="flat" cmpd="sng" algn="ctr">
                       <a:solidFill>
-                        <a:srgbClr val="C9D0E0"/>
+                        <a:srgbClr val="263044"/>
                       </a:solidFill>
                       <a:prstDash val="solid"/>
                       <a:round/>
@@ -4782,7 +4839,7 @@
                     </a:lnL>
                     <a:lnR w="12700" cap="flat" cmpd="sng" algn="ctr">
                       <a:solidFill>
-                        <a:srgbClr val="C9D0E0"/>
+                        <a:srgbClr val="263044"/>
                       </a:solidFill>
                       <a:prstDash val="solid"/>
                       <a:round/>
@@ -4791,7 +4848,7 @@
                     </a:lnR>
                     <a:lnT w="12700" cap="flat" cmpd="sng" algn="ctr">
                       <a:solidFill>
-                        <a:srgbClr val="C9D0E0"/>
+                        <a:srgbClr val="263044"/>
                       </a:solidFill>
                       <a:prstDash val="solid"/>
                       <a:round/>
@@ -4800,7 +4857,7 @@
                     </a:lnT>
                     <a:lnB w="12700" cap="flat" cmpd="sng" algn="ctr">
                       <a:solidFill>
-                        <a:srgbClr val="C9D0E0"/>
+                        <a:srgbClr val="263044"/>
                       </a:solidFill>
                       <a:prstDash val="solid"/>
                       <a:round/>
@@ -4808,7 +4865,7 @@
                       <a:tailEnd type="none" w="med" len="med"/>
                     </a:lnB>
                     <a:solidFill>
-                      <a:srgbClr val="FFFFFF"/>
+                      <a:srgbClr val="0E1420"/>
                     </a:solidFill>
                   </a:tcPr>
                 </a:tc>
@@ -4825,7 +4882,7 @@
                       <a:r>
                         <a:rPr lang="en-US" sz="1800" dirty="0">
                           <a:solidFill>
-                            <a:srgbClr val="14213D"/>
+                            <a:srgbClr val="CBD5E1"/>
                           </a:solidFill>
                           <a:latin typeface="Calibri" pitchFamily="34" charset="0"/>
                           <a:ea typeface="Calibri" pitchFamily="34" charset="-122"/>
@@ -4843,7 +4900,7 @@
                   <a:tcPr marL="109728" marR="109728" marT="0" marB="0" anchor="ctr">
                     <a:lnL w="12700" cap="flat" cmpd="sng" algn="ctr">
                       <a:solidFill>
-                        <a:srgbClr val="C9D0E0"/>
+                        <a:srgbClr val="263044"/>
                       </a:solidFill>
                       <a:prstDash val="solid"/>
                       <a:round/>
@@ -4852,7 +4909,7 @@
                     </a:lnL>
                     <a:lnR w="12700" cap="flat" cmpd="sng" algn="ctr">
                       <a:solidFill>
-                        <a:srgbClr val="C9D0E0"/>
+                        <a:srgbClr val="263044"/>
                       </a:solidFill>
                       <a:prstDash val="solid"/>
                       <a:round/>
@@ -4861,7 +4918,7 @@
                     </a:lnR>
                     <a:lnT w="12700" cap="flat" cmpd="sng" algn="ctr">
                       <a:solidFill>
-                        <a:srgbClr val="C9D0E0"/>
+                        <a:srgbClr val="263044"/>
                       </a:solidFill>
                       <a:prstDash val="solid"/>
                       <a:round/>
@@ -4870,7 +4927,7 @@
                     </a:lnT>
                     <a:lnB w="12700" cap="flat" cmpd="sng" algn="ctr">
                       <a:solidFill>
-                        <a:srgbClr val="C9D0E0"/>
+                        <a:srgbClr val="263044"/>
                       </a:solidFill>
                       <a:prstDash val="solid"/>
                       <a:round/>
@@ -4878,7 +4935,7 @@
                       <a:tailEnd type="none" w="med" len="med"/>
                     </a:lnB>
                     <a:solidFill>
-                      <a:srgbClr val="EEF1F6"/>
+                      <a:srgbClr val="121826"/>
                     </a:solidFill>
                   </a:tcPr>
                 </a:tc>
@@ -4893,7 +4950,7 @@
                       <a:r>
                         <a:rPr lang="en-US" sz="1800" dirty="0">
                           <a:solidFill>
-                            <a:srgbClr val="14213D"/>
+                            <a:srgbClr val="CBD5E1"/>
                           </a:solidFill>
                           <a:latin typeface="Calibri" pitchFamily="34" charset="0"/>
                           <a:ea typeface="Calibri" pitchFamily="34" charset="-122"/>
@@ -4911,7 +4968,7 @@
                   <a:tcPr marL="109728" marR="109728" marT="0" marB="0" anchor="ctr">
                     <a:lnL w="12700" cap="flat" cmpd="sng" algn="ctr">
                       <a:solidFill>
-                        <a:srgbClr val="C9D0E0"/>
+                        <a:srgbClr val="263044"/>
                       </a:solidFill>
                       <a:prstDash val="solid"/>
                       <a:round/>
@@ -4920,7 +4977,7 @@
                     </a:lnL>
                     <a:lnR w="12700" cap="flat" cmpd="sng" algn="ctr">
                       <a:solidFill>
-                        <a:srgbClr val="C9D0E0"/>
+                        <a:srgbClr val="263044"/>
                       </a:solidFill>
                       <a:prstDash val="solid"/>
                       <a:round/>
@@ -4929,7 +4986,7 @@
                     </a:lnR>
                     <a:lnT w="12700" cap="flat" cmpd="sng" algn="ctr">
                       <a:solidFill>
-                        <a:srgbClr val="C9D0E0"/>
+                        <a:srgbClr val="263044"/>
                       </a:solidFill>
                       <a:prstDash val="solid"/>
                       <a:round/>
@@ -4938,7 +4995,7 @@
                     </a:lnT>
                     <a:lnB w="12700" cap="flat" cmpd="sng" algn="ctr">
                       <a:solidFill>
-                        <a:srgbClr val="C9D0E0"/>
+                        <a:srgbClr val="263044"/>
                       </a:solidFill>
                       <a:prstDash val="solid"/>
                       <a:round/>
@@ -4946,7 +5003,7 @@
                       <a:tailEnd type="none" w="med" len="med"/>
                     </a:lnB>
                     <a:solidFill>
-                      <a:srgbClr val="EEF1F6"/>
+                      <a:srgbClr val="121826"/>
                     </a:solidFill>
                   </a:tcPr>
                 </a:tc>
@@ -4963,7 +5020,7 @@
                       <a:r>
                         <a:rPr lang="en-US" sz="1800" dirty="0">
                           <a:solidFill>
-                            <a:srgbClr val="14213D"/>
+                            <a:srgbClr val="CBD5E1"/>
                           </a:solidFill>
                           <a:latin typeface="Calibri" pitchFamily="34" charset="0"/>
                           <a:ea typeface="Calibri" pitchFamily="34" charset="-122"/>
@@ -4981,7 +5038,7 @@
                   <a:tcPr marL="109728" marR="109728" marT="0" marB="0" anchor="ctr">
                     <a:lnL w="12700" cap="flat" cmpd="sng" algn="ctr">
                       <a:solidFill>
-                        <a:srgbClr val="C9D0E0"/>
+                        <a:srgbClr val="263044"/>
                       </a:solidFill>
                       <a:prstDash val="solid"/>
                       <a:round/>
@@ -4990,7 +5047,7 @@
                     </a:lnL>
                     <a:lnR w="12700" cap="flat" cmpd="sng" algn="ctr">
                       <a:solidFill>
-                        <a:srgbClr val="C9D0E0"/>
+                        <a:srgbClr val="263044"/>
                       </a:solidFill>
                       <a:prstDash val="solid"/>
                       <a:round/>
@@ -4999,7 +5056,7 @@
                     </a:lnR>
                     <a:lnT w="12700" cap="flat" cmpd="sng" algn="ctr">
                       <a:solidFill>
-                        <a:srgbClr val="C9D0E0"/>
+                        <a:srgbClr val="263044"/>
                       </a:solidFill>
                       <a:prstDash val="solid"/>
                       <a:round/>
@@ -5008,7 +5065,7 @@
                     </a:lnT>
                     <a:lnB w="12700" cap="flat" cmpd="sng" algn="ctr">
                       <a:solidFill>
-                        <a:srgbClr val="C9D0E0"/>
+                        <a:srgbClr val="263044"/>
                       </a:solidFill>
                       <a:prstDash val="solid"/>
                       <a:round/>
@@ -5016,7 +5073,7 @@
                       <a:tailEnd type="none" w="med" len="med"/>
                     </a:lnB>
                     <a:solidFill>
-                      <a:srgbClr val="FFFFFF"/>
+                      <a:srgbClr val="0E1420"/>
                     </a:solidFill>
                   </a:tcPr>
                 </a:tc>
@@ -5031,7 +5088,7 @@
                       <a:r>
                         <a:rPr lang="en-US" sz="1800" dirty="0">
                           <a:solidFill>
-                            <a:srgbClr val="14213D"/>
+                            <a:srgbClr val="CBD5E1"/>
                           </a:solidFill>
                           <a:latin typeface="Calibri" pitchFamily="34" charset="0"/>
                           <a:ea typeface="Calibri" pitchFamily="34" charset="-122"/>
@@ -5049,7 +5106,7 @@
                   <a:tcPr marL="109728" marR="109728" marT="0" marB="0" anchor="ctr">
                     <a:lnL w="12700" cap="flat" cmpd="sng" algn="ctr">
                       <a:solidFill>
-                        <a:srgbClr val="C9D0E0"/>
+                        <a:srgbClr val="263044"/>
                       </a:solidFill>
                       <a:prstDash val="solid"/>
                       <a:round/>
@@ -5058,7 +5115,7 @@
                     </a:lnL>
                     <a:lnR w="12700" cap="flat" cmpd="sng" algn="ctr">
                       <a:solidFill>
-                        <a:srgbClr val="C9D0E0"/>
+                        <a:srgbClr val="263044"/>
                       </a:solidFill>
                       <a:prstDash val="solid"/>
                       <a:round/>
@@ -5067,7 +5124,7 @@
                     </a:lnR>
                     <a:lnT w="12700" cap="flat" cmpd="sng" algn="ctr">
                       <a:solidFill>
-                        <a:srgbClr val="C9D0E0"/>
+                        <a:srgbClr val="263044"/>
                       </a:solidFill>
                       <a:prstDash val="solid"/>
                       <a:round/>
@@ -5076,7 +5133,7 @@
                     </a:lnT>
                     <a:lnB w="12700" cap="flat" cmpd="sng" algn="ctr">
                       <a:solidFill>
-                        <a:srgbClr val="C9D0E0"/>
+                        <a:srgbClr val="263044"/>
                       </a:solidFill>
                       <a:prstDash val="solid"/>
                       <a:round/>
@@ -5084,7 +5141,7 @@
                       <a:tailEnd type="none" w="med" len="med"/>
                     </a:lnB>
                     <a:solidFill>
-                      <a:srgbClr val="FFFFFF"/>
+                      <a:srgbClr val="0E1420"/>
                     </a:solidFill>
                   </a:tcPr>
                 </a:tc>
@@ -5095,7 +5152,7 @@
       </p:graphicFrame>
       <p:sp>
         <p:nvSpPr>
-          <p:cNvPr id="89" name="Text 85"/>
+          <p:cNvPr id="91" name="Text 86"/>
           <p:cNvSpPr/>
           <p:nvPr/>
         </p:nvSpPr>
@@ -5120,7 +5177,7 @@
             <a:r>
               <a:rPr lang="en-US" sz="1600" dirty="0">
                 <a:solidFill>
-                  <a:srgbClr val="5B6B8C"/>
+                  <a:srgbClr val="94A3B8"/>
                 </a:solidFill>
                 <a:latin typeface="Calibri" pitchFamily="34" charset="0"/>
                 <a:ea typeface="Calibri" pitchFamily="34" charset="-122"/>

</xml_diff>

<commit_message>
Poster: roadmap update (contacts kept and live checks done, Mac mini in progress, no journals line)
Co-Authored-By: Claude Sonnet 5.5 <noreply@anthropic.com>
</commit_message>
<xml_diff>
--- a/docs/poster/Sprint5_Poster_AgentFactory.pptx
+++ b/docs/poster/Sprint5_Poster_AgentFactory.pptx
@@ -3825,11 +3825,11 @@
         <p:spPr>
           <a:xfrm>
             <a:off x="20299680" y="5715000"/>
-            <a:ext cx="9235440" cy="3246120"/>
+            <a:ext cx="9235440" cy="4114800"/>
           </a:xfrm>
           <a:prstGeom prst="roundRect">
             <a:avLst>
-              <a:gd name="adj" fmla="val 3380"/>
+              <a:gd name="adj" fmla="val 2667"/>
             </a:avLst>
           </a:prstGeom>
           <a:solidFill>
@@ -3891,7 +3891,7 @@
         <p:spPr>
           <a:xfrm>
             <a:off x="20574000" y="6446520"/>
-            <a:ext cx="8686800" cy="2423160"/>
+            <a:ext cx="8686800" cy="3291840"/>
           </a:xfrm>
           <a:prstGeom prst="rect">
             <a:avLst/>
@@ -4007,6 +4007,48 @@
             </a:r>
             <a:endParaRPr lang="en-US" sz="2200" dirty="0"/>
           </a:p>
+          <a:p>
+            <a:pPr marL="342900" indent="-342900">
+              <a:spcAft>
+                <a:spcPts val="500"/>
+              </a:spcAft>
+              <a:buSzPct val="100000"/>
+              <a:buChar char="•"/>
+            </a:pPr>
+            <a:r>
+              <a:rPr lang="en-US" sz="2200" dirty="0">
+                <a:solidFill>
+                  <a:srgbClr val="CBD5E1"/>
+                </a:solidFill>
+                <a:latin typeface="Calibri" pitchFamily="34" charset="0"/>
+                <a:ea typeface="Calibri" pitchFamily="34" charset="-122"/>
+                <a:cs typeface="Calibri" pitchFamily="34" charset="-120"/>
+              </a:rPr>
+              <a:t>Contacts kept across restarts</a:t>
+            </a:r>
+            <a:endParaRPr lang="en-US" sz="2200" dirty="0"/>
+          </a:p>
+          <a:p>
+            <a:pPr marL="342900" indent="-342900">
+              <a:spcAft>
+                <a:spcPts val="500"/>
+              </a:spcAft>
+              <a:buSzPct val="100000"/>
+              <a:buChar char="•"/>
+            </a:pPr>
+            <a:r>
+              <a:rPr lang="en-US" sz="2200" dirty="0">
+                <a:solidFill>
+                  <a:srgbClr val="CBD5E1"/>
+                </a:solidFill>
+                <a:latin typeface="Calibri" pitchFamily="34" charset="0"/>
+                <a:ea typeface="Calibri" pitchFamily="34" charset="-122"/>
+                <a:cs typeface="Calibri" pitchFamily="34" charset="-120"/>
+              </a:rPr>
+              <a:t>Final checks with a live call</a:t>
+            </a:r>
+            <a:endParaRPr lang="en-US" sz="2200" dirty="0"/>
+          </a:p>
         </p:txBody>
       </p:sp>
       <p:sp>
@@ -4017,12 +4059,12 @@
         </p:nvSpPr>
         <p:spPr>
           <a:xfrm>
-            <a:off x="20299680" y="9144000"/>
-            <a:ext cx="9235440" cy="2423160"/>
+            <a:off x="20299680" y="10012680"/>
+            <a:ext cx="9235440" cy="2011680"/>
           </a:xfrm>
           <a:prstGeom prst="roundRect">
             <a:avLst>
-              <a:gd name="adj" fmla="val 4528"/>
+              <a:gd name="adj" fmla="val 5455"/>
             </a:avLst>
           </a:prstGeom>
           <a:solidFill>
@@ -4044,7 +4086,7 @@
         </p:nvSpPr>
         <p:spPr>
           <a:xfrm>
-            <a:off x="20574000" y="9253728"/>
+            <a:off x="20574000" y="10122408"/>
             <a:ext cx="8686800" cy="502920"/>
           </a:xfrm>
           <a:prstGeom prst="rect">
@@ -4083,8 +4125,8 @@
         </p:nvSpPr>
         <p:spPr>
           <a:xfrm>
-            <a:off x="20574000" y="9875520"/>
-            <a:ext cx="8686800" cy="1600200"/>
+            <a:off x="20574000" y="10744200"/>
+            <a:ext cx="8686800" cy="1188720"/>
           </a:xfrm>
           <a:prstGeom prst="rect">
             <a:avLst/>
@@ -4133,31 +4175,10 @@
                 <a:ea typeface="Calibri" pitchFamily="34" charset="-122"/>
                 <a:cs typeface="Calibri" pitchFamily="34" charset="-120"/>
               </a:rPr>
-              <a:t>Contacts kept across restarts</a:t>
+              <a:t>Mac mini installation in process</a:t>
             </a:r>
             <a:endParaRPr lang="en-US" sz="2200" dirty="0"/>
           </a:p>
-          <a:p>
-            <a:pPr marL="342900" indent="-342900">
-              <a:spcAft>
-                <a:spcPts val="500"/>
-              </a:spcAft>
-              <a:buSzPct val="100000"/>
-              <a:buChar char="•"/>
-            </a:pPr>
-            <a:r>
-              <a:rPr lang="en-US" sz="2200" dirty="0">
-                <a:solidFill>
-                  <a:srgbClr val="CBD5E1"/>
-                </a:solidFill>
-                <a:latin typeface="Calibri" pitchFamily="34" charset="0"/>
-                <a:ea typeface="Calibri" pitchFamily="34" charset="-122"/>
-                <a:cs typeface="Calibri" pitchFamily="34" charset="-120"/>
-              </a:rPr>
-              <a:t>Final checks with a live call</a:t>
-            </a:r>
-            <a:endParaRPr lang="en-US" sz="2200" dirty="0"/>
-          </a:p>
         </p:txBody>
       </p:sp>
       <p:sp>
@@ -4168,12 +4189,12 @@
         </p:nvSpPr>
         <p:spPr>
           <a:xfrm>
-            <a:off x="20299680" y="11750040"/>
-            <a:ext cx="9235440" cy="2423160"/>
+            <a:off x="20299680" y="12207240"/>
+            <a:ext cx="9235440" cy="2011680"/>
           </a:xfrm>
           <a:prstGeom prst="roundRect">
             <a:avLst>
-              <a:gd name="adj" fmla="val 4528"/>
+              <a:gd name="adj" fmla="val 5455"/>
             </a:avLst>
           </a:prstGeom>
           <a:solidFill>
@@ -4195,7 +4216,7 @@
         </p:nvSpPr>
         <p:spPr>
           <a:xfrm>
-            <a:off x="20574000" y="11859768"/>
+            <a:off x="20574000" y="12316968"/>
             <a:ext cx="8686800" cy="502920"/>
           </a:xfrm>
           <a:prstGeom prst="rect">
@@ -4234,8 +4255,8 @@
         </p:nvSpPr>
         <p:spPr>
           <a:xfrm>
-            <a:off x="20574000" y="12481560"/>
-            <a:ext cx="8686800" cy="1600200"/>
+            <a:off x="20574000" y="12938760"/>
+            <a:ext cx="8686800" cy="1188720"/>
           </a:xfrm>
           <a:prstGeom prst="rect">
             <a:avLst/>
@@ -4285,27 +4306,6 @@
                 <a:cs typeface="Calibri" pitchFamily="34" charset="-120"/>
               </a:rPr>
               <a:t>Client feedback</a:t>
-            </a:r>
-            <a:endParaRPr lang="en-US" sz="2200" dirty="0"/>
-          </a:p>
-          <a:p>
-            <a:pPr marL="342900" indent="-342900">
-              <a:spcAft>
-                <a:spcPts val="500"/>
-              </a:spcAft>
-              <a:buSzPct val="100000"/>
-              <a:buChar char="•"/>
-            </a:pPr>
-            <a:r>
-              <a:rPr lang="en-US" sz="2200" dirty="0">
-                <a:solidFill>
-                  <a:srgbClr val="CBD5E1"/>
-                </a:solidFill>
-                <a:latin typeface="Calibri" pitchFamily="34" charset="0"/>
-                <a:ea typeface="Calibri" pitchFamily="34" charset="-122"/>
-                <a:cs typeface="Calibri" pitchFamily="34" charset="-120"/>
-              </a:rPr>
-              <a:t>Journals and interviews</a:t>
             </a:r>
             <a:endParaRPr lang="en-US" sz="2200" dirty="0"/>
           </a:p>
@@ -4385,7 +4385,7 @@
                 <a:ea typeface="Calibri" pitchFamily="34" charset="-122"/>
                 <a:cs typeface="Calibri" pitchFamily="34" charset="-120"/>
               </a:rPr>
-              <a:t>live test call (Dilraj)  →  SMS approval (Prabhjot)  →  recordings and handover pack (all)  →  journals and interviews (everyone)</a:t>
+              <a:t>SMS approval (Prabhjot)  →  Mac mini installation (Dilraj)  →  recordings and handover pack (all)</a:t>
             </a:r>
             <a:endParaRPr lang="en-US" sz="2100" dirty="0"/>
           </a:p>

</xml_diff>